<commit_message>
Add speaker notes to presentation
</commit_message>
<xml_diff>
--- a/FC_Inverter_Presentation.pptx
+++ b/FC_Inverter_Presentation.pptx
@@ -513,7 +513,7 @@
           <a:p>
             <a:r>
               <a:rPr lang="en-US" dirty="0"/>
-              <a:t/>
+              <a:t>Good morning, everyone. Today, we'll dive into the design and analysis of an 800-volt three-level flying capacitor traction inverter. This work explores how vehicle architecture drives inverter design choices, focusing on comprehensive loss analysis. We'll see how specific design decisions lead to significant performance improvements. Let's start by understanding why 800V is becoming the new standard in electric vehicles.</a:t>
             </a:r>
             <a:endParaRPr lang="en-US" dirty="0"/>
           </a:p>
@@ -601,7 +601,7 @@
           <a:p>
             <a:r>
               <a:rPr lang="en-US" dirty="0"/>
-              <a:t/>
+              <a:t>Now, let's look at the real-world impact of that adaptive schedule. This intelligent frequency adjustment significantly reduces the junction temperature, especially during urban driving. We see a 9.7 degree Celsius drop in junction temperature, going from 63.2 to 53.5 degrees Celsius, just by switching from a fixed 20 kHz to an adaptive 5 kHz. Even more dramatically, at peak torque, the junction temperature drops by 16.2 degrees Celsius. This reduction in thermal cycling, by 53%, directly translates to a much longer lifespan for our power module, as predicted by the Coffin-Manson model. And importantly, all operating points remain well below the 175 degree Celsius maximum junction temperature, giving us over 100 degrees of thermal margin. This thermal improvement is a critical benefit for reliability, and it's something we've confirmed through detailed simulations, which I'll discuss next.</a:t>
             </a:r>
             <a:endParaRPr lang="en-US" dirty="0"/>
           </a:p>
@@ -689,7 +689,7 @@
           <a:p>
             <a:r>
               <a:rPr lang="en-US" dirty="0"/>
-              <a:t/>
+              <a:t>So, how do we know this all works as intended? We've validated our design through extensive time-domain simulations. These simulations confirm that our inverter successfully synthesizes a three-level output voltage, both at urban and highway speeds. The phase currents are clean sinusoids, with a total harmonic distortion below 2 percent, which is excellent. We also see that the flying capacitor voltage is perfectly maintained at 400 volts, with a very small mean error of just plus or minus 0.04 volts. The simulated ripple of 18 volts closely matches our analytical budget of 20 volts, showing strong agreement between theory and practice. We also confirmed the pre-charge transient, with a smooth 20-millisecond linear ramp to 400 volts before active switching begins. This gives us high confidence in the design. Now, let's wrap things up with a summary of our key findings.</a:t>
             </a:r>
             <a:endParaRPr lang="en-US" dirty="0"/>
           </a:p>
@@ -777,7 +777,7 @@
           <a:p>
             <a:r>
               <a:rPr lang="en-US" dirty="0"/>
-              <a:t/>
+              <a:t>In conclusion, our architecture-driven design for an 800-volt three-level flying capacitor traction inverter delivers significant advantages. The 800-volt architecture itself is crucial for ultra-fast charging, reduced cable weight, and overall system efficiency. We chose the flying capacitor topology for its superior thermal symmetry and natural balancing, which is essential for dynamic EV loads. Our adaptive switching frequency schedule is a game-changer, achieving a 75 percent reduction in switching losses during urban driving, saving 190 watts across three phases. This translates directly to a 9.7 degree Celsius reduction in junction temperature and 53 percent less thermal cycling, significantly extending the power module's lifetime. All our metrics are validated: THD is below 2 percent, FC balance error is less than 0.04 volts, and junction temperatures remain well below 54 degrees Celsius, providing over 120 degrees of thermal margin. Our next step is to experimentally validate these findings on a hardware prototype.</a:t>
             </a:r>
             <a:endParaRPr lang="en-US" dirty="0"/>
           </a:p>
@@ -865,7 +865,7 @@
           <a:p>
             <a:r>
               <a:rPr lang="en-US" dirty="0"/>
-              <a:t/>
+              <a:t>So, why are we seeing this shift to 800V architectures in electric vehicles? The core reason is simple: it enables ultra-fast charging, cutting typical charge times from 45 minutes down to under 20 minutes. This higher voltage also dramatically reduces I²R losses by 75% across the entire powertrain, because we're halving the current for the same power. And, a big bonus for vehicle manufacturers, it allows for 50% less copper, saving about 10 to 15 kilograms in vehicle weight. Major players like Porsche, Hyundai, and GM are already adopting 800V, but this higher voltage introduces a significant challenge: increased dv/dt stress on motor insulation, which demands advanced inverter topologies.</a:t>
             </a:r>
             <a:endParaRPr lang="en-US" dirty="0"/>
           </a:p>
@@ -953,7 +953,7 @@
           <a:p>
             <a:r>
               <a:rPr lang="en-US" dirty="0"/>
-              <a:t/>
+              <a:t>This increased dv/dt stress is a critical problem for 800V systems. A traditional two-level inverter switching 800V in under 50 nanoseconds creates dv/dt spikes exceeding 16 kilovolts per microsecond. This is over 13 times the typical motor insulation rating of 1200 volts per microsecond, leading to rapid insulation breakdown within just 1000 hours. Our solution is a three-level topology, which reduces the voltage step to 400V, effectively halving the dv/dt to around 8 kilovolts per microsecond. This not only protects the motor but also improves output waveform quality, reducing THD and EMI, and allowing for a smaller output filter. Now, let's look at which three-level topology is best suited for this application.</a:t>
             </a:r>
             <a:endParaRPr lang="en-US" dirty="0"/>
           </a:p>
@@ -1041,7 +1041,7 @@
           <a:p>
             <a:r>
               <a:rPr lang="en-US" dirty="0"/>
-              <a:t/>
+              <a:t>When considering three-level topologies, we often compare the Neutral Point Clamped, or NPC, with the Flying Capacitor, or FC, inverter. For traction applications, the NPC has some key limitations: it suffers from unequal loss distribution, leading to asymmetric heating and complex cooling. Plus, maintaining neutral point balance under dynamic EV loads is a real control challenge. The Flying Capacitor topology, however, offers significant advantages. All four switches block an identical voltage of 400V, ensuring symmetric thermal stress. Crucially, its redundant switching states enable natural capacitor balancing, even with varying power factors. The main trade-off is the need for a bulky capacitor and a pre-charge circuit, but this is generally acceptable in modern EVs. This makes the FC topology a strong candidate, so let's explore its switching states next.</a:t>
             </a:r>
             <a:endParaRPr lang="en-US" dirty="0"/>
           </a:p>
@@ -1129,7 +1129,7 @@
           <a:p>
             <a:r>
               <a:rPr lang="en-US" dirty="0"/>
-              <a:t/>
+              <a:t>Here, we see the basic structure of a single phase leg of the Flying Capacitor inverter. Each leg uses four switches and a flying capacitor, which bridges the inner junctions. This configuration allows us to synthesize three distinct output voltage levels: positive Vdc, zero, and negative Vdc. A key feature of the FC is its redundant zero states. For example, we can achieve zero volts by either charging or discharging the flying capacitor. We use Phase Disposition PWM, or PD-PWM, to actively select between these redundant zero states based on the phase current direction. This ensures the flying capacitor voltage remains precisely at Vdc/2. Before any active switching, a pre-charge is required to ramp the flying capacitor voltage to 400V. Now, let's move on to the specific component selections for this inverter.</a:t>
             </a:r>
             <a:endParaRPr lang="en-US" dirty="0"/>
           </a:p>
@@ -1217,7 +1217,7 @@
           <a:p>
             <a:r>
               <a:rPr lang="en-US" dirty="0"/>
-              <a:t/>
+              <a:t>Now that we've established the FC topology, let's talk about the specific components we selected. We chose a 1200V, 450A SiC module from Wolfspeed. This provides a 50% voltage margin and a 3.3x current margin over our operating requirements, ensuring robust performance. We went with SiC over Si IGBTs because it offers ten times lower switching energy and eliminates tail current, which is crucial for efficient 20 kHz operation. For the flying capacitor, our calculations showed we needed 680 microfarads. We picked a polypropylene film capacitor for its low ESR, high ripple current capability, and automotive-grade reliability. Next, we'll see how these components perform under real-world vehicle operating conditions.</a:t>
             </a:r>
             <a:endParaRPr lang="en-US" dirty="0"/>
           </a:p>
@@ -1305,7 +1305,7 @@
           <a:p>
             <a:r>
               <a:rPr lang="en-US" dirty="0"/>
-              <a:t/>
+              <a:t>Building on our component selection, we then mapped the vehicle's architecture to the inverter's operating points. The drivetrain parameters, like the 8.19 gear ratio and 0.315-meter tire radius, directly influence the electrical frequency. We found that urban driving at 40 kilometers per hour results in a 184 Hz electrical frequency and a peak current of 136 amps. This represents the highest thermal stress point for the inverter. Conversely, highway driving at 120 kilometers per hour leads to a 552 Hz electrical frequency and a much lower peak current of 51 amps. This mapping helps us understand the varying demands on the inverter across different driving scenarios, which is critical for optimizing performance.</a:t>
             </a:r>
             <a:endParaRPr lang="en-US" dirty="0"/>
           </a:p>
@@ -1393,7 +1393,7 @@
           <a:p>
             <a:r>
               <a:rPr lang="en-US" dirty="0"/>
-              <a:t/>
+              <a:t>Understanding these operating points from the previous slide, we then analyzed the switching losses. Using the Graovac-Purschel method, we found that at a fixed 20 kHz switching frequency, urban driving results in 84.3 watts of switching loss per phase, compared to only 51.5 watts of conduction loss. This means switching losses dominate, accounting for 63% of the total. The key insight here is that 20 kHz is simply overkill for urban driving, where the fundamental electrical frequency is only 184 Hz. A carrier ratio of 27, achievable with a 5 kHz switching frequency, is more than enough to maintain excellent THD. This suggests a significant opportunity for loss reduction, which we'll explore next.</a:t>
             </a:r>
             <a:endParaRPr lang="en-US" dirty="0"/>
           </a:p>
@@ -1481,7 +1481,7 @@
           <a:p>
             <a:r>
               <a:rPr lang="en-US" dirty="0"/>
-              <a:t/>
+              <a:t>Given the insights from our loss analysis, we developed an adaptive switching frequency schedule. For urban driving below 60 kilometers per hour, we drop the switching frequency to 5 kHz. Between 60 and 90 kilometers per hour, we use 10 kHz, and for highway speeds above 90 kilometers per hour, we maintain 20 kHz. This adaptive approach yields a massive 75% reduction in switching losses during urban driving, dropping from 84.3 watts to just 21.1 watts per phase. This translates to a total 3-phase saving of 190 watts at 40 kilometers per hour, directly extending EV range. Importantly, our THD remains excellent, even at 5 kHz. This intelligent scheduling dramatically improves efficiency, and we'll now look at its thermal implications.</a:t>
             </a:r>
             <a:endParaRPr lang="en-US" dirty="0"/>
           </a:p>
@@ -1849,7 +1849,7 @@
       </p:grpSpPr>
       <p:pic>
         <p:nvPicPr>
-          <p:cNvPr id="2" name="Image 0" descr="preencoded.png">    </p:cNvPr>
+          <p:cNvPr id="3" name="Image 0" descr="preencoded.png">    </p:cNvPr>
           <p:cNvPicPr>
             <a:picLocks noChangeAspect="1"/>
           </p:cNvPicPr>
@@ -1873,7 +1873,7 @@
       </p:pic>
       <p:sp>
         <p:nvSpPr>
-          <p:cNvPr id="3" name="Text 0"/>
+          <p:cNvPr id="4" name="Text 0"/>
           <p:cNvSpPr/>
           <p:nvPr/>
         </p:nvSpPr>
@@ -1917,7 +1917,7 @@
       </p:sp>
       <p:sp>
         <p:nvSpPr>
-          <p:cNvPr id="4" name="Text 1"/>
+          <p:cNvPr id="5" name="Text 1"/>
           <p:cNvSpPr/>
           <p:nvPr/>
         </p:nvSpPr>
@@ -1958,7 +1958,7 @@
       </p:sp>
       <p:sp>
         <p:nvSpPr>
-          <p:cNvPr id="5" name="Text 2"/>
+          <p:cNvPr id="6" name="Text 2"/>
           <p:cNvSpPr/>
           <p:nvPr/>
         </p:nvSpPr>
@@ -1999,7 +1999,7 @@
       </p:sp>
       <p:sp>
         <p:nvSpPr>
-          <p:cNvPr id="6" name="Text 3"/>
+          <p:cNvPr id="7" name="Text 3"/>
           <p:cNvSpPr/>
           <p:nvPr/>
         </p:nvSpPr>
@@ -2065,7 +2065,7 @@
       </p:grpSpPr>
       <p:pic>
         <p:nvPicPr>
-          <p:cNvPr id="2" name="Image 0" descr="preencoded.png">    </p:cNvPr>
+          <p:cNvPr id="3" name="Image 0" descr="preencoded.png">    </p:cNvPr>
           <p:cNvPicPr>
             <a:picLocks noChangeAspect="1"/>
           </p:cNvPicPr>
@@ -2089,7 +2089,7 @@
       </p:pic>
       <p:sp>
         <p:nvSpPr>
-          <p:cNvPr id="3" name="Text 0"/>
+          <p:cNvPr id="4" name="Text 0"/>
           <p:cNvSpPr/>
           <p:nvPr/>
         </p:nvSpPr>
@@ -2133,7 +2133,7 @@
       </p:sp>
       <p:sp>
         <p:nvSpPr>
-          <p:cNvPr id="4" name="Text 1"/>
+          <p:cNvPr id="5" name="Text 1"/>
           <p:cNvSpPr/>
           <p:nvPr/>
         </p:nvSpPr>
@@ -2221,7 +2221,7 @@
       </p:sp>
       <p:sp>
         <p:nvSpPr>
-          <p:cNvPr id="5" name="Text 2"/>
+          <p:cNvPr id="6" name="Text 2"/>
           <p:cNvSpPr/>
           <p:nvPr/>
         </p:nvSpPr>
@@ -2309,7 +2309,7 @@
       </p:sp>
       <p:sp>
         <p:nvSpPr>
-          <p:cNvPr id="6" name="Text 3"/>
+          <p:cNvPr id="7" name="Text 3"/>
           <p:cNvSpPr/>
           <p:nvPr/>
         </p:nvSpPr>
@@ -2375,7 +2375,7 @@
       </p:sp>
       <p:sp>
         <p:nvSpPr>
-          <p:cNvPr id="7" name="Text 4"/>
+          <p:cNvPr id="8" name="Text 4"/>
           <p:cNvSpPr/>
           <p:nvPr/>
         </p:nvSpPr>
@@ -2452,7 +2452,7 @@
       </p:sp>
       <p:sp>
         <p:nvSpPr>
-          <p:cNvPr id="8" name="Text 5"/>
+          <p:cNvPr id="9" name="Text 5"/>
           <p:cNvSpPr/>
           <p:nvPr/>
         </p:nvSpPr>
@@ -2529,7 +2529,7 @@
       </p:sp>
       <p:sp>
         <p:nvSpPr>
-          <p:cNvPr id="9" name="Text 6"/>
+          <p:cNvPr id="10" name="Text 6"/>
           <p:cNvSpPr/>
           <p:nvPr/>
         </p:nvSpPr>
@@ -2573,7 +2573,7 @@
       </p:sp>
       <p:sp>
         <p:nvSpPr>
-          <p:cNvPr id="10" name="Text 7"/>
+          <p:cNvPr id="11" name="Text 7"/>
           <p:cNvSpPr/>
           <p:nvPr/>
         </p:nvSpPr>
@@ -2617,7 +2617,7 @@
       </p:sp>
       <p:sp>
         <p:nvSpPr>
-          <p:cNvPr id="11" name="Text 8"/>
+          <p:cNvPr id="12" name="Text 8"/>
           <p:cNvSpPr/>
           <p:nvPr/>
         </p:nvSpPr>
@@ -2661,7 +2661,7 @@
       </p:sp>
       <p:sp>
         <p:nvSpPr>
-          <p:cNvPr id="12" name="Text 9"/>
+          <p:cNvPr id="13" name="Text 9"/>
           <p:cNvSpPr/>
           <p:nvPr/>
         </p:nvSpPr>
@@ -2705,7 +2705,7 @@
       </p:sp>
       <p:sp>
         <p:nvSpPr>
-          <p:cNvPr id="13" name="Text 10"/>
+          <p:cNvPr id="14" name="Text 10"/>
           <p:cNvSpPr/>
           <p:nvPr/>
         </p:nvSpPr>
@@ -2749,7 +2749,7 @@
       </p:sp>
       <p:pic>
         <p:nvPicPr>
-          <p:cNvPr id="14" name="Image 1" descr="preencoded.png">    </p:cNvPr>
+          <p:cNvPr id="15" name="Image 1" descr="preencoded.png">    </p:cNvPr>
           <p:cNvPicPr>
             <a:picLocks noChangeAspect="1"/>
           </p:cNvPicPr>
@@ -2798,7 +2798,7 @@
       </p:grpSpPr>
       <p:pic>
         <p:nvPicPr>
-          <p:cNvPr id="2" name="Image 0" descr="preencoded.png">    </p:cNvPr>
+          <p:cNvPr id="3" name="Image 0" descr="preencoded.png">    </p:cNvPr>
           <p:cNvPicPr>
             <a:picLocks noChangeAspect="1"/>
           </p:cNvPicPr>
@@ -2822,7 +2822,7 @@
       </p:pic>
       <p:sp>
         <p:nvSpPr>
-          <p:cNvPr id="3" name="Text 0"/>
+          <p:cNvPr id="4" name="Text 0"/>
           <p:cNvSpPr/>
           <p:nvPr/>
         </p:nvSpPr>
@@ -2866,7 +2866,7 @@
       </p:sp>
       <p:sp>
         <p:nvSpPr>
-          <p:cNvPr id="4" name="Text 1"/>
+          <p:cNvPr id="5" name="Text 1"/>
           <p:cNvSpPr/>
           <p:nvPr/>
         </p:nvSpPr>
@@ -2932,7 +2932,7 @@
       </p:sp>
       <p:sp>
         <p:nvSpPr>
-          <p:cNvPr id="5" name="Text 2"/>
+          <p:cNvPr id="6" name="Text 2"/>
           <p:cNvSpPr/>
           <p:nvPr/>
         </p:nvSpPr>
@@ -3009,7 +3009,7 @@
       </p:sp>
       <p:sp>
         <p:nvSpPr>
-          <p:cNvPr id="6" name="Text 3"/>
+          <p:cNvPr id="7" name="Text 3"/>
           <p:cNvSpPr/>
           <p:nvPr/>
         </p:nvSpPr>
@@ -3086,7 +3086,7 @@
       </p:sp>
       <p:sp>
         <p:nvSpPr>
-          <p:cNvPr id="7" name="Text 4"/>
+          <p:cNvPr id="8" name="Text 4"/>
           <p:cNvSpPr/>
           <p:nvPr/>
         </p:nvSpPr>
@@ -3163,7 +3163,7 @@
       </p:sp>
       <p:sp>
         <p:nvSpPr>
-          <p:cNvPr id="8" name="Text 5"/>
+          <p:cNvPr id="9" name="Text 5"/>
           <p:cNvSpPr/>
           <p:nvPr/>
         </p:nvSpPr>
@@ -3229,7 +3229,7 @@
       </p:sp>
       <p:sp>
         <p:nvSpPr>
-          <p:cNvPr id="9" name="Text 6"/>
+          <p:cNvPr id="10" name="Text 6"/>
           <p:cNvSpPr/>
           <p:nvPr/>
         </p:nvSpPr>
@@ -3273,7 +3273,7 @@
       </p:sp>
       <p:sp>
         <p:nvSpPr>
-          <p:cNvPr id="10" name="Text 7"/>
+          <p:cNvPr id="11" name="Text 7"/>
           <p:cNvSpPr/>
           <p:nvPr/>
         </p:nvSpPr>
@@ -3317,7 +3317,7 @@
       </p:sp>
       <p:sp>
         <p:nvSpPr>
-          <p:cNvPr id="11" name="Text 8"/>
+          <p:cNvPr id="12" name="Text 8"/>
           <p:cNvSpPr/>
           <p:nvPr/>
         </p:nvSpPr>
@@ -3361,7 +3361,7 @@
       </p:sp>
       <p:sp>
         <p:nvSpPr>
-          <p:cNvPr id="12" name="Text 9"/>
+          <p:cNvPr id="13" name="Text 9"/>
           <p:cNvSpPr/>
           <p:nvPr/>
         </p:nvSpPr>
@@ -3405,7 +3405,7 @@
       </p:sp>
       <p:sp>
         <p:nvSpPr>
-          <p:cNvPr id="13" name="Text 10"/>
+          <p:cNvPr id="14" name="Text 10"/>
           <p:cNvSpPr/>
           <p:nvPr/>
         </p:nvSpPr>
@@ -3449,7 +3449,7 @@
       </p:sp>
       <p:pic>
         <p:nvPicPr>
-          <p:cNvPr id="14" name="Image 1" descr="preencoded.png">    </p:cNvPr>
+          <p:cNvPr id="15" name="Image 1" descr="preencoded.png">    </p:cNvPr>
           <p:cNvPicPr>
             <a:picLocks noChangeAspect="1"/>
           </p:cNvPicPr>
@@ -3498,7 +3498,7 @@
       </p:grpSpPr>
       <p:pic>
         <p:nvPicPr>
-          <p:cNvPr id="2" name="Image 0" descr="preencoded.png">    </p:cNvPr>
+          <p:cNvPr id="3" name="Image 0" descr="preencoded.png">    </p:cNvPr>
           <p:cNvPicPr>
             <a:picLocks noChangeAspect="1"/>
           </p:cNvPicPr>
@@ -3522,7 +3522,7 @@
       </p:pic>
       <p:sp>
         <p:nvSpPr>
-          <p:cNvPr id="3" name="Text 0"/>
+          <p:cNvPr id="4" name="Text 0"/>
           <p:cNvSpPr/>
           <p:nvPr/>
         </p:nvSpPr>
@@ -3566,7 +3566,7 @@
       </p:sp>
       <p:sp>
         <p:nvSpPr>
-          <p:cNvPr id="4" name="Text 1"/>
+          <p:cNvPr id="5" name="Text 1"/>
           <p:cNvSpPr/>
           <p:nvPr/>
         </p:nvSpPr>
@@ -3621,7 +3621,7 @@
       </p:sp>
       <p:sp>
         <p:nvSpPr>
-          <p:cNvPr id="5" name="Text 2"/>
+          <p:cNvPr id="6" name="Text 2"/>
           <p:cNvSpPr/>
           <p:nvPr/>
         </p:nvSpPr>
@@ -3687,7 +3687,7 @@
       </p:sp>
       <p:sp>
         <p:nvSpPr>
-          <p:cNvPr id="6" name="Text 3"/>
+          <p:cNvPr id="7" name="Text 3"/>
           <p:cNvSpPr/>
           <p:nvPr/>
         </p:nvSpPr>
@@ -3775,7 +3775,7 @@
       </p:sp>
       <p:sp>
         <p:nvSpPr>
-          <p:cNvPr id="7" name="Text 4"/>
+          <p:cNvPr id="8" name="Text 4"/>
           <p:cNvSpPr/>
           <p:nvPr/>
         </p:nvSpPr>
@@ -3863,7 +3863,7 @@
       </p:sp>
       <p:sp>
         <p:nvSpPr>
-          <p:cNvPr id="8" name="Text 5"/>
+          <p:cNvPr id="9" name="Text 5"/>
           <p:cNvSpPr/>
           <p:nvPr/>
         </p:nvSpPr>
@@ -3929,7 +3929,7 @@
       </p:sp>
       <p:sp>
         <p:nvSpPr>
-          <p:cNvPr id="9" name="Text 6"/>
+          <p:cNvPr id="10" name="Text 6"/>
           <p:cNvSpPr/>
           <p:nvPr/>
         </p:nvSpPr>
@@ -3984,7 +3984,7 @@
       </p:sp>
       <p:sp>
         <p:nvSpPr>
-          <p:cNvPr id="10" name="Text 7"/>
+          <p:cNvPr id="11" name="Text 7"/>
           <p:cNvSpPr/>
           <p:nvPr/>
         </p:nvSpPr>
@@ -4028,7 +4028,7 @@
       </p:sp>
       <p:sp>
         <p:nvSpPr>
-          <p:cNvPr id="11" name="Text 8"/>
+          <p:cNvPr id="12" name="Text 8"/>
           <p:cNvSpPr/>
           <p:nvPr/>
         </p:nvSpPr>
@@ -4072,7 +4072,7 @@
       </p:sp>
       <p:sp>
         <p:nvSpPr>
-          <p:cNvPr id="12" name="Text 9"/>
+          <p:cNvPr id="13" name="Text 9"/>
           <p:cNvSpPr/>
           <p:nvPr/>
         </p:nvSpPr>
@@ -4116,7 +4116,7 @@
       </p:sp>
       <p:sp>
         <p:nvSpPr>
-          <p:cNvPr id="13" name="Text 10"/>
+          <p:cNvPr id="14" name="Text 10"/>
           <p:cNvSpPr/>
           <p:nvPr/>
         </p:nvSpPr>
@@ -4160,7 +4160,7 @@
       </p:sp>
       <p:sp>
         <p:nvSpPr>
-          <p:cNvPr id="14" name="Text 11"/>
+          <p:cNvPr id="15" name="Text 11"/>
           <p:cNvSpPr/>
           <p:nvPr/>
         </p:nvSpPr>
@@ -4204,7 +4204,7 @@
       </p:sp>
       <p:sp>
         <p:nvSpPr>
-          <p:cNvPr id="15" name="Text 12"/>
+          <p:cNvPr id="16" name="Text 12"/>
           <p:cNvSpPr/>
           <p:nvPr/>
         </p:nvSpPr>
@@ -4273,7 +4273,7 @@
       </p:grpSpPr>
       <p:pic>
         <p:nvPicPr>
-          <p:cNvPr id="2" name="Image 0" descr="preencoded.png">    </p:cNvPr>
+          <p:cNvPr id="3" name="Image 0" descr="preencoded.png">    </p:cNvPr>
           <p:cNvPicPr>
             <a:picLocks noChangeAspect="1"/>
           </p:cNvPicPr>
@@ -4297,7 +4297,7 @@
       </p:pic>
       <p:sp>
         <p:nvSpPr>
-          <p:cNvPr id="3" name="Text 0"/>
+          <p:cNvPr id="4" name="Text 0"/>
           <p:cNvSpPr/>
           <p:nvPr/>
         </p:nvSpPr>
@@ -4341,7 +4341,7 @@
       </p:sp>
       <p:sp>
         <p:nvSpPr>
-          <p:cNvPr id="4" name="Text 1"/>
+          <p:cNvPr id="5" name="Text 1"/>
           <p:cNvSpPr/>
           <p:nvPr/>
         </p:nvSpPr>
@@ -4407,7 +4407,7 @@
       </p:sp>
       <p:sp>
         <p:nvSpPr>
-          <p:cNvPr id="5" name="Text 2"/>
+          <p:cNvPr id="6" name="Text 2"/>
           <p:cNvSpPr/>
           <p:nvPr/>
         </p:nvSpPr>
@@ -4473,7 +4473,7 @@
       </p:sp>
       <p:sp>
         <p:nvSpPr>
-          <p:cNvPr id="6" name="Text 3"/>
+          <p:cNvPr id="7" name="Text 3"/>
           <p:cNvSpPr/>
           <p:nvPr/>
         </p:nvSpPr>
@@ -4539,7 +4539,7 @@
       </p:sp>
       <p:sp>
         <p:nvSpPr>
-          <p:cNvPr id="7" name="Text 4"/>
+          <p:cNvPr id="8" name="Text 4"/>
           <p:cNvSpPr/>
           <p:nvPr/>
         </p:nvSpPr>
@@ -4605,7 +4605,7 @@
       </p:sp>
       <p:sp>
         <p:nvSpPr>
-          <p:cNvPr id="8" name="Text 5"/>
+          <p:cNvPr id="9" name="Text 5"/>
           <p:cNvSpPr/>
           <p:nvPr/>
         </p:nvSpPr>
@@ -4671,7 +4671,7 @@
       </p:sp>
       <p:sp>
         <p:nvSpPr>
-          <p:cNvPr id="9" name="Text 6"/>
+          <p:cNvPr id="10" name="Text 6"/>
           <p:cNvSpPr/>
           <p:nvPr/>
         </p:nvSpPr>
@@ -4715,7 +4715,7 @@
       </p:sp>
       <p:sp>
         <p:nvSpPr>
-          <p:cNvPr id="10" name="Text 7"/>
+          <p:cNvPr id="11" name="Text 7"/>
           <p:cNvSpPr/>
           <p:nvPr/>
         </p:nvSpPr>
@@ -4759,7 +4759,7 @@
       </p:sp>
       <p:sp>
         <p:nvSpPr>
-          <p:cNvPr id="11" name="Text 8"/>
+          <p:cNvPr id="12" name="Text 8"/>
           <p:cNvSpPr/>
           <p:nvPr/>
         </p:nvSpPr>
@@ -4803,7 +4803,7 @@
       </p:sp>
       <p:sp>
         <p:nvSpPr>
-          <p:cNvPr id="12" name="Text 9"/>
+          <p:cNvPr id="13" name="Text 9"/>
           <p:cNvSpPr/>
           <p:nvPr/>
         </p:nvSpPr>
@@ -4847,7 +4847,7 @@
       </p:sp>
       <p:sp>
         <p:nvSpPr>
-          <p:cNvPr id="13" name="Text 10"/>
+          <p:cNvPr id="14" name="Text 10"/>
           <p:cNvSpPr/>
           <p:nvPr/>
         </p:nvSpPr>
@@ -4891,7 +4891,7 @@
       </p:sp>
       <p:pic>
         <p:nvPicPr>
-          <p:cNvPr id="14" name="Image 1" descr="preencoded.png">    </p:cNvPr>
+          <p:cNvPr id="15" name="Image 1" descr="preencoded.png">    </p:cNvPr>
           <p:cNvPicPr>
             <a:picLocks noChangeAspect="1"/>
           </p:cNvPicPr>
@@ -4940,7 +4940,7 @@
       </p:grpSpPr>
       <p:pic>
         <p:nvPicPr>
-          <p:cNvPr id="2" name="Image 0" descr="preencoded.png">    </p:cNvPr>
+          <p:cNvPr id="3" name="Image 0" descr="preencoded.png">    </p:cNvPr>
           <p:cNvPicPr>
             <a:picLocks noChangeAspect="1"/>
           </p:cNvPicPr>
@@ -4964,7 +4964,7 @@
       </p:pic>
       <p:sp>
         <p:nvSpPr>
-          <p:cNvPr id="3" name="Text 0"/>
+          <p:cNvPr id="4" name="Text 0"/>
           <p:cNvSpPr/>
           <p:nvPr/>
         </p:nvSpPr>
@@ -5008,7 +5008,7 @@
       </p:sp>
       <p:sp>
         <p:nvSpPr>
-          <p:cNvPr id="4" name="Text 1"/>
+          <p:cNvPr id="5" name="Text 1"/>
           <p:cNvSpPr/>
           <p:nvPr/>
         </p:nvSpPr>
@@ -5049,7 +5049,7 @@
       </p:sp>
       <p:sp>
         <p:nvSpPr>
-          <p:cNvPr id="5" name="Text 2"/>
+          <p:cNvPr id="6" name="Text 2"/>
           <p:cNvSpPr/>
           <p:nvPr/>
         </p:nvSpPr>
@@ -5126,7 +5126,7 @@
       </p:sp>
       <p:sp>
         <p:nvSpPr>
-          <p:cNvPr id="6" name="Text 3"/>
+          <p:cNvPr id="7" name="Text 3"/>
           <p:cNvSpPr/>
           <p:nvPr/>
         </p:nvSpPr>
@@ -5192,7 +5192,7 @@
       </p:sp>
       <p:sp>
         <p:nvSpPr>
-          <p:cNvPr id="7" name="Text 4"/>
+          <p:cNvPr id="8" name="Text 4"/>
           <p:cNvSpPr/>
           <p:nvPr/>
         </p:nvSpPr>
@@ -5269,7 +5269,7 @@
       </p:sp>
       <p:sp>
         <p:nvSpPr>
-          <p:cNvPr id="8" name="Text 5"/>
+          <p:cNvPr id="9" name="Text 5"/>
           <p:cNvSpPr/>
           <p:nvPr/>
         </p:nvSpPr>
@@ -5313,7 +5313,7 @@
       </p:sp>
       <p:sp>
         <p:nvSpPr>
-          <p:cNvPr id="9" name="Text 6"/>
+          <p:cNvPr id="10" name="Text 6"/>
           <p:cNvSpPr/>
           <p:nvPr/>
         </p:nvSpPr>
@@ -5357,7 +5357,7 @@
       </p:sp>
       <p:sp>
         <p:nvSpPr>
-          <p:cNvPr id="10" name="Text 7"/>
+          <p:cNvPr id="11" name="Text 7"/>
           <p:cNvSpPr/>
           <p:nvPr/>
         </p:nvSpPr>
@@ -5401,7 +5401,7 @@
       </p:sp>
       <p:sp>
         <p:nvSpPr>
-          <p:cNvPr id="11" name="Text 8"/>
+          <p:cNvPr id="12" name="Text 8"/>
           <p:cNvSpPr/>
           <p:nvPr/>
         </p:nvSpPr>
@@ -5442,7 +5442,7 @@
       </p:sp>
       <p:sp>
         <p:nvSpPr>
-          <p:cNvPr id="12" name="Text 9"/>
+          <p:cNvPr id="13" name="Text 9"/>
           <p:cNvSpPr/>
           <p:nvPr/>
         </p:nvSpPr>
@@ -5519,7 +5519,7 @@
       </p:sp>
       <p:sp>
         <p:nvSpPr>
-          <p:cNvPr id="13" name="Text 10"/>
+          <p:cNvPr id="14" name="Text 10"/>
           <p:cNvSpPr/>
           <p:nvPr/>
         </p:nvSpPr>
@@ -5596,7 +5596,7 @@
       </p:sp>
       <p:sp>
         <p:nvSpPr>
-          <p:cNvPr id="14" name="Text 11"/>
+          <p:cNvPr id="15" name="Text 11"/>
           <p:cNvSpPr/>
           <p:nvPr/>
         </p:nvSpPr>
@@ -5673,7 +5673,7 @@
       </p:sp>
       <p:sp>
         <p:nvSpPr>
-          <p:cNvPr id="15" name="Text 12"/>
+          <p:cNvPr id="16" name="Text 12"/>
           <p:cNvSpPr/>
           <p:nvPr/>
         </p:nvSpPr>
@@ -5717,7 +5717,7 @@
       </p:sp>
       <p:sp>
         <p:nvSpPr>
-          <p:cNvPr id="16" name="Text 13"/>
+          <p:cNvPr id="17" name="Text 13"/>
           <p:cNvSpPr/>
           <p:nvPr/>
         </p:nvSpPr>
@@ -5761,7 +5761,7 @@
       </p:sp>
       <p:sp>
         <p:nvSpPr>
-          <p:cNvPr id="17" name="Text 14"/>
+          <p:cNvPr id="18" name="Text 14"/>
           <p:cNvSpPr/>
           <p:nvPr/>
         </p:nvSpPr>
@@ -5830,7 +5830,7 @@
       </p:grpSpPr>
       <p:pic>
         <p:nvPicPr>
-          <p:cNvPr id="2" name="Image 0" descr="preencoded.png">    </p:cNvPr>
+          <p:cNvPr id="3" name="Image 0" descr="preencoded.png">    </p:cNvPr>
           <p:cNvPicPr>
             <a:picLocks noChangeAspect="1"/>
           </p:cNvPicPr>
@@ -5854,7 +5854,7 @@
       </p:pic>
       <p:sp>
         <p:nvSpPr>
-          <p:cNvPr id="3" name="Text 0"/>
+          <p:cNvPr id="4" name="Text 0"/>
           <p:cNvSpPr/>
           <p:nvPr/>
         </p:nvSpPr>
@@ -5898,7 +5898,7 @@
       </p:sp>
       <p:sp>
         <p:nvSpPr>
-          <p:cNvPr id="4" name="Text 1"/>
+          <p:cNvPr id="5" name="Text 1"/>
           <p:cNvSpPr/>
           <p:nvPr/>
         </p:nvSpPr>
@@ -5939,7 +5939,7 @@
       </p:sp>
       <p:sp>
         <p:nvSpPr>
-          <p:cNvPr id="5" name="Text 2"/>
+          <p:cNvPr id="6" name="Text 2"/>
           <p:cNvSpPr/>
           <p:nvPr/>
         </p:nvSpPr>
@@ -5994,7 +5994,7 @@
       </p:sp>
       <p:sp>
         <p:nvSpPr>
-          <p:cNvPr id="6" name="Text 3"/>
+          <p:cNvPr id="7" name="Text 3"/>
           <p:cNvSpPr/>
           <p:nvPr/>
         </p:nvSpPr>
@@ -6060,7 +6060,7 @@
       </p:sp>
       <p:sp>
         <p:nvSpPr>
-          <p:cNvPr id="7" name="Text 4"/>
+          <p:cNvPr id="8" name="Text 4"/>
           <p:cNvSpPr/>
           <p:nvPr/>
         </p:nvSpPr>
@@ -6104,7 +6104,7 @@
       </p:sp>
       <p:sp>
         <p:nvSpPr>
-          <p:cNvPr id="8" name="Text 5"/>
+          <p:cNvPr id="9" name="Text 5"/>
           <p:cNvSpPr/>
           <p:nvPr/>
         </p:nvSpPr>
@@ -6148,7 +6148,7 @@
       </p:sp>
       <p:sp>
         <p:nvSpPr>
-          <p:cNvPr id="9" name="Text 6"/>
+          <p:cNvPr id="10" name="Text 6"/>
           <p:cNvSpPr/>
           <p:nvPr/>
         </p:nvSpPr>
@@ -6189,7 +6189,7 @@
       </p:sp>
       <p:sp>
         <p:nvSpPr>
-          <p:cNvPr id="10" name="Text 7"/>
+          <p:cNvPr id="11" name="Text 7"/>
           <p:cNvSpPr/>
           <p:nvPr/>
         </p:nvSpPr>
@@ -6255,7 +6255,7 @@
       </p:sp>
       <p:sp>
         <p:nvSpPr>
-          <p:cNvPr id="11" name="Text 8"/>
+          <p:cNvPr id="12" name="Text 8"/>
           <p:cNvSpPr/>
           <p:nvPr/>
         </p:nvSpPr>
@@ -6321,7 +6321,7 @@
       </p:sp>
       <p:sp>
         <p:nvSpPr>
-          <p:cNvPr id="12" name="Text 9"/>
+          <p:cNvPr id="13" name="Text 9"/>
           <p:cNvSpPr/>
           <p:nvPr/>
         </p:nvSpPr>
@@ -6376,7 +6376,7 @@
       </p:sp>
       <p:sp>
         <p:nvSpPr>
-          <p:cNvPr id="13" name="Text 10"/>
+          <p:cNvPr id="14" name="Text 10"/>
           <p:cNvSpPr/>
           <p:nvPr/>
         </p:nvSpPr>
@@ -6420,7 +6420,7 @@
       </p:sp>
       <p:sp>
         <p:nvSpPr>
-          <p:cNvPr id="14" name="Text 11"/>
+          <p:cNvPr id="15" name="Text 11"/>
           <p:cNvSpPr/>
           <p:nvPr/>
         </p:nvSpPr>
@@ -6464,7 +6464,7 @@
       </p:sp>
       <p:sp>
         <p:nvSpPr>
-          <p:cNvPr id="15" name="Text 12"/>
+          <p:cNvPr id="16" name="Text 12"/>
           <p:cNvSpPr/>
           <p:nvPr/>
         </p:nvSpPr>
@@ -6533,7 +6533,7 @@
       </p:grpSpPr>
       <p:pic>
         <p:nvPicPr>
-          <p:cNvPr id="2" name="Image 0" descr="preencoded.png">    </p:cNvPr>
+          <p:cNvPr id="3" name="Image 0" descr="preencoded.png">    </p:cNvPr>
           <p:cNvPicPr>
             <a:picLocks noChangeAspect="1"/>
           </p:cNvPicPr>
@@ -6557,7 +6557,7 @@
       </p:pic>
       <p:sp>
         <p:nvSpPr>
-          <p:cNvPr id="3" name="Text 0"/>
+          <p:cNvPr id="4" name="Text 0"/>
           <p:cNvSpPr/>
           <p:nvPr/>
         </p:nvSpPr>
@@ -6601,7 +6601,7 @@
       </p:sp>
       <p:sp>
         <p:nvSpPr>
-          <p:cNvPr id="4" name="Text 1"/>
+          <p:cNvPr id="5" name="Text 1"/>
           <p:cNvSpPr/>
           <p:nvPr/>
         </p:nvSpPr>
@@ -6678,7 +6678,7 @@
       </p:sp>
       <p:sp>
         <p:nvSpPr>
-          <p:cNvPr id="5" name="Text 2"/>
+          <p:cNvPr id="6" name="Text 2"/>
           <p:cNvSpPr/>
           <p:nvPr/>
         </p:nvSpPr>
@@ -6755,7 +6755,7 @@
       </p:sp>
       <p:sp>
         <p:nvSpPr>
-          <p:cNvPr id="6" name="Text 3"/>
+          <p:cNvPr id="7" name="Text 3"/>
           <p:cNvSpPr/>
           <p:nvPr/>
         </p:nvSpPr>
@@ -6799,7 +6799,7 @@
       </p:sp>
       <p:sp>
         <p:nvSpPr>
-          <p:cNvPr id="7" name="Text 4"/>
+          <p:cNvPr id="8" name="Text 4"/>
           <p:cNvSpPr/>
           <p:nvPr/>
         </p:nvSpPr>
@@ -6843,7 +6843,7 @@
       </p:sp>
       <p:sp>
         <p:nvSpPr>
-          <p:cNvPr id="8" name="Text 5"/>
+          <p:cNvPr id="9" name="Text 5"/>
           <p:cNvSpPr/>
           <p:nvPr/>
         </p:nvSpPr>
@@ -6887,7 +6887,7 @@
       </p:sp>
       <p:sp>
         <p:nvSpPr>
-          <p:cNvPr id="9" name="Text 6"/>
+          <p:cNvPr id="10" name="Text 6"/>
           <p:cNvSpPr/>
           <p:nvPr/>
         </p:nvSpPr>
@@ -6931,7 +6931,7 @@
       </p:sp>
       <p:sp>
         <p:nvSpPr>
-          <p:cNvPr id="10" name="Shape 7"/>
+          <p:cNvPr id="11" name="Shape 7"/>
           <p:cNvSpPr/>
           <p:nvPr/>
         </p:nvSpPr>
@@ -6951,7 +6951,7 @@
       </p:sp>
       <p:sp>
         <p:nvSpPr>
-          <p:cNvPr id="11" name="Shape 8"/>
+          <p:cNvPr id="12" name="Shape 8"/>
           <p:cNvSpPr/>
           <p:nvPr/>
         </p:nvSpPr>
@@ -6971,7 +6971,7 @@
       </p:sp>
       <p:sp>
         <p:nvSpPr>
-          <p:cNvPr id="12" name="Text 9"/>
+          <p:cNvPr id="13" name="Text 9"/>
           <p:cNvSpPr/>
           <p:nvPr/>
         </p:nvSpPr>
@@ -7060,7 +7060,7 @@
       </p:sp>
       <p:sp>
         <p:nvSpPr>
-          <p:cNvPr id="13" name="Text 10"/>
+          <p:cNvPr id="14" name="Text 10"/>
           <p:cNvSpPr/>
           <p:nvPr/>
         </p:nvSpPr>
@@ -7137,7 +7137,7 @@
       </p:sp>
       <p:sp>
         <p:nvSpPr>
-          <p:cNvPr id="14" name="Text 11"/>
+          <p:cNvPr id="15" name="Text 11"/>
           <p:cNvSpPr/>
           <p:nvPr/>
         </p:nvSpPr>
@@ -7181,7 +7181,7 @@
       </p:sp>
       <p:pic>
         <p:nvPicPr>
-          <p:cNvPr id="15" name="Image 1" descr="preencoded.png">    </p:cNvPr>
+          <p:cNvPr id="16" name="Image 1" descr="preencoded.png">    </p:cNvPr>
           <p:cNvPicPr>
             <a:picLocks noChangeAspect="1"/>
           </p:cNvPicPr>
@@ -7205,7 +7205,7 @@
       </p:pic>
       <p:sp>
         <p:nvSpPr>
-          <p:cNvPr id="16" name="Text 12"/>
+          <p:cNvPr id="17" name="Text 12"/>
           <p:cNvSpPr/>
           <p:nvPr/>
         </p:nvSpPr>
@@ -7271,7 +7271,7 @@
       </p:grpSpPr>
       <p:pic>
         <p:nvPicPr>
-          <p:cNvPr id="2" name="Image 0" descr="preencoded.png">    </p:cNvPr>
+          <p:cNvPr id="3" name="Image 0" descr="preencoded.png">    </p:cNvPr>
           <p:cNvPicPr>
             <a:picLocks noChangeAspect="1"/>
           </p:cNvPicPr>
@@ -7295,7 +7295,7 @@
       </p:pic>
       <p:sp>
         <p:nvSpPr>
-          <p:cNvPr id="3" name="Text 0"/>
+          <p:cNvPr id="4" name="Text 0"/>
           <p:cNvSpPr/>
           <p:nvPr/>
         </p:nvSpPr>
@@ -7339,7 +7339,7 @@
       </p:sp>
       <p:sp>
         <p:nvSpPr>
-          <p:cNvPr id="4" name="Text 1"/>
+          <p:cNvPr id="5" name="Text 1"/>
           <p:cNvSpPr/>
           <p:nvPr/>
         </p:nvSpPr>
@@ -7416,7 +7416,7 @@
       </p:sp>
       <p:sp>
         <p:nvSpPr>
-          <p:cNvPr id="5" name="Text 2"/>
+          <p:cNvPr id="6" name="Text 2"/>
           <p:cNvSpPr/>
           <p:nvPr/>
         </p:nvSpPr>
@@ -7482,7 +7482,7 @@
       </p:sp>
       <p:sp>
         <p:nvSpPr>
-          <p:cNvPr id="6" name="Text 3"/>
+          <p:cNvPr id="7" name="Text 3"/>
           <p:cNvSpPr/>
           <p:nvPr/>
         </p:nvSpPr>
@@ -7570,7 +7570,7 @@
       </p:sp>
       <p:sp>
         <p:nvSpPr>
-          <p:cNvPr id="7" name="Text 4"/>
+          <p:cNvPr id="8" name="Text 4"/>
           <p:cNvSpPr/>
           <p:nvPr/>
         </p:nvSpPr>
@@ -7647,7 +7647,7 @@
       </p:sp>
       <p:sp>
         <p:nvSpPr>
-          <p:cNvPr id="8" name="Text 5"/>
+          <p:cNvPr id="9" name="Text 5"/>
           <p:cNvSpPr/>
           <p:nvPr/>
         </p:nvSpPr>
@@ -7713,7 +7713,7 @@
       </p:sp>
       <p:sp>
         <p:nvSpPr>
-          <p:cNvPr id="9" name="Text 6"/>
+          <p:cNvPr id="10" name="Text 6"/>
           <p:cNvSpPr/>
           <p:nvPr/>
         </p:nvSpPr>
@@ -7757,7 +7757,7 @@
       </p:sp>
       <p:sp>
         <p:nvSpPr>
-          <p:cNvPr id="10" name="Text 7"/>
+          <p:cNvPr id="11" name="Text 7"/>
           <p:cNvSpPr/>
           <p:nvPr/>
         </p:nvSpPr>
@@ -7801,7 +7801,7 @@
       </p:sp>
       <p:sp>
         <p:nvSpPr>
-          <p:cNvPr id="11" name="Text 8"/>
+          <p:cNvPr id="12" name="Text 8"/>
           <p:cNvSpPr/>
           <p:nvPr/>
         </p:nvSpPr>
@@ -7845,7 +7845,7 @@
       </p:sp>
       <p:sp>
         <p:nvSpPr>
-          <p:cNvPr id="12" name="Text 9"/>
+          <p:cNvPr id="13" name="Text 9"/>
           <p:cNvSpPr/>
           <p:nvPr/>
         </p:nvSpPr>
@@ -7889,7 +7889,7 @@
       </p:sp>
       <p:sp>
         <p:nvSpPr>
-          <p:cNvPr id="13" name="Text 10"/>
+          <p:cNvPr id="14" name="Text 10"/>
           <p:cNvSpPr/>
           <p:nvPr/>
         </p:nvSpPr>
@@ -7933,7 +7933,7 @@
       </p:sp>
       <p:pic>
         <p:nvPicPr>
-          <p:cNvPr id="14" name="Image 1" descr="preencoded.png">    </p:cNvPr>
+          <p:cNvPr id="15" name="Image 1" descr="preencoded.png">    </p:cNvPr>
           <p:cNvPicPr>
             <a:picLocks noChangeAspect="1"/>
           </p:cNvPicPr>
@@ -7982,7 +7982,7 @@
       </p:grpSpPr>
       <p:pic>
         <p:nvPicPr>
-          <p:cNvPr id="2" name="Image 0" descr="preencoded.png">    </p:cNvPr>
+          <p:cNvPr id="3" name="Image 0" descr="preencoded.png">    </p:cNvPr>
           <p:cNvPicPr>
             <a:picLocks noChangeAspect="1"/>
           </p:cNvPicPr>
@@ -8006,7 +8006,7 @@
       </p:pic>
       <p:sp>
         <p:nvSpPr>
-          <p:cNvPr id="3" name="Text 0"/>
+          <p:cNvPr id="4" name="Text 0"/>
           <p:cNvSpPr/>
           <p:nvPr/>
         </p:nvSpPr>
@@ -8050,7 +8050,7 @@
       </p:sp>
       <p:sp>
         <p:nvSpPr>
-          <p:cNvPr id="4" name="Text 1"/>
+          <p:cNvPr id="5" name="Text 1"/>
           <p:cNvSpPr/>
           <p:nvPr/>
         </p:nvSpPr>
@@ -8171,7 +8171,7 @@
       </p:sp>
       <p:sp>
         <p:nvSpPr>
-          <p:cNvPr id="5" name="Text 2"/>
+          <p:cNvPr id="6" name="Text 2"/>
           <p:cNvSpPr/>
           <p:nvPr/>
         </p:nvSpPr>
@@ -8215,7 +8215,7 @@
       </p:sp>
       <p:sp>
         <p:nvSpPr>
-          <p:cNvPr id="6" name="Text 3"/>
+          <p:cNvPr id="7" name="Text 3"/>
           <p:cNvSpPr/>
           <p:nvPr/>
         </p:nvSpPr>
@@ -8259,7 +8259,7 @@
       </p:sp>
       <p:sp>
         <p:nvSpPr>
-          <p:cNvPr id="7" name="Text 4"/>
+          <p:cNvPr id="8" name="Text 4"/>
           <p:cNvSpPr/>
           <p:nvPr/>
         </p:nvSpPr>
@@ -8303,7 +8303,7 @@
       </p:sp>
       <p:sp>
         <p:nvSpPr>
-          <p:cNvPr id="8" name="Shape 5"/>
+          <p:cNvPr id="9" name="Shape 5"/>
           <p:cNvSpPr/>
           <p:nvPr/>
         </p:nvSpPr>
@@ -8323,7 +8323,7 @@
       </p:sp>
       <p:sp>
         <p:nvSpPr>
-          <p:cNvPr id="9" name="Shape 6"/>
+          <p:cNvPr id="10" name="Shape 6"/>
           <p:cNvSpPr/>
           <p:nvPr/>
         </p:nvSpPr>
@@ -8343,7 +8343,7 @@
       </p:sp>
       <p:sp>
         <p:nvSpPr>
-          <p:cNvPr id="10" name="Text 7"/>
+          <p:cNvPr id="11" name="Text 7"/>
           <p:cNvSpPr/>
           <p:nvPr/>
         </p:nvSpPr>
@@ -8387,7 +8387,7 @@
       </p:sp>
       <p:sp>
         <p:nvSpPr>
-          <p:cNvPr id="11" name="Text 8"/>
+          <p:cNvPr id="12" name="Text 8"/>
           <p:cNvSpPr/>
           <p:nvPr/>
         </p:nvSpPr>
@@ -8464,7 +8464,7 @@
       </p:sp>
       <p:sp>
         <p:nvSpPr>
-          <p:cNvPr id="12" name="Text 9"/>
+          <p:cNvPr id="13" name="Text 9"/>
           <p:cNvSpPr/>
           <p:nvPr/>
         </p:nvSpPr>
@@ -8519,7 +8519,7 @@
       </p:sp>
       <p:sp>
         <p:nvSpPr>
-          <p:cNvPr id="13" name="Text 10"/>
+          <p:cNvPr id="14" name="Text 10"/>
           <p:cNvSpPr/>
           <p:nvPr/>
         </p:nvSpPr>
@@ -8585,7 +8585,7 @@
       </p:sp>
       <p:sp>
         <p:nvSpPr>
-          <p:cNvPr id="14" name="Text 11"/>
+          <p:cNvPr id="15" name="Text 11"/>
           <p:cNvSpPr/>
           <p:nvPr/>
         </p:nvSpPr>
@@ -8629,7 +8629,7 @@
       </p:sp>
       <p:sp>
         <p:nvSpPr>
-          <p:cNvPr id="15" name="Text 12"/>
+          <p:cNvPr id="16" name="Text 12"/>
           <p:cNvSpPr/>
           <p:nvPr/>
         </p:nvSpPr>
@@ -8673,7 +8673,7 @@
       </p:sp>
       <p:sp>
         <p:nvSpPr>
-          <p:cNvPr id="16" name="Text 13"/>
+          <p:cNvPr id="17" name="Text 13"/>
           <p:cNvSpPr/>
           <p:nvPr/>
         </p:nvSpPr>
@@ -8717,7 +8717,7 @@
       </p:sp>
       <p:pic>
         <p:nvPicPr>
-          <p:cNvPr id="17" name="Image 1" descr="preencoded.png">    </p:cNvPr>
+          <p:cNvPr id="18" name="Image 1" descr="preencoded.png">    </p:cNvPr>
           <p:cNvPicPr>
             <a:picLocks noChangeAspect="1"/>
           </p:cNvPicPr>
@@ -8766,7 +8766,7 @@
       </p:grpSpPr>
       <p:pic>
         <p:nvPicPr>
-          <p:cNvPr id="2" name="Image 0" descr="preencoded.png">    </p:cNvPr>
+          <p:cNvPr id="3" name="Image 0" descr="preencoded.png">    </p:cNvPr>
           <p:cNvPicPr>
             <a:picLocks noChangeAspect="1"/>
           </p:cNvPicPr>
@@ -8790,7 +8790,7 @@
       </p:pic>
       <p:sp>
         <p:nvSpPr>
-          <p:cNvPr id="3" name="Text 0"/>
+          <p:cNvPr id="4" name="Text 0"/>
           <p:cNvSpPr/>
           <p:nvPr/>
         </p:nvSpPr>
@@ -8834,7 +8834,7 @@
       </p:sp>
       <p:sp>
         <p:nvSpPr>
-          <p:cNvPr id="4" name="Text 1"/>
+          <p:cNvPr id="5" name="Text 1"/>
           <p:cNvSpPr/>
           <p:nvPr/>
         </p:nvSpPr>
@@ -8878,7 +8878,7 @@
       </p:sp>
       <p:sp>
         <p:nvSpPr>
-          <p:cNvPr id="5" name="Text 2"/>
+          <p:cNvPr id="6" name="Text 2"/>
           <p:cNvSpPr/>
           <p:nvPr/>
         </p:nvSpPr>
@@ -8922,7 +8922,7 @@
       </p:sp>
       <p:sp>
         <p:nvSpPr>
-          <p:cNvPr id="6" name="Text 3"/>
+          <p:cNvPr id="7" name="Text 3"/>
           <p:cNvSpPr/>
           <p:nvPr/>
         </p:nvSpPr>
@@ -8966,7 +8966,7 @@
       </p:sp>
       <p:sp>
         <p:nvSpPr>
-          <p:cNvPr id="7" name="Shape 4"/>
+          <p:cNvPr id="8" name="Shape 4"/>
           <p:cNvSpPr/>
           <p:nvPr/>
         </p:nvSpPr>
@@ -8986,7 +8986,7 @@
       </p:sp>
       <p:sp>
         <p:nvSpPr>
-          <p:cNvPr id="8" name="Shape 5"/>
+          <p:cNvPr id="9" name="Shape 5"/>
           <p:cNvSpPr/>
           <p:nvPr/>
         </p:nvSpPr>
@@ -9006,7 +9006,7 @@
       </p:sp>
       <p:sp>
         <p:nvSpPr>
-          <p:cNvPr id="9" name="Text 6"/>
+          <p:cNvPr id="10" name="Text 6"/>
           <p:cNvSpPr/>
           <p:nvPr/>
         </p:nvSpPr>
@@ -9050,7 +9050,7 @@
       </p:sp>
       <p:sp>
         <p:nvSpPr>
-          <p:cNvPr id="10" name="Text 7"/>
+          <p:cNvPr id="11" name="Text 7"/>
           <p:cNvSpPr/>
           <p:nvPr/>
         </p:nvSpPr>
@@ -9127,7 +9127,7 @@
       </p:sp>
       <p:sp>
         <p:nvSpPr>
-          <p:cNvPr id="11" name="Text 8"/>
+          <p:cNvPr id="12" name="Text 8"/>
           <p:cNvSpPr/>
           <p:nvPr/>
         </p:nvSpPr>
@@ -9193,7 +9193,7 @@
       </p:sp>
       <p:sp>
         <p:nvSpPr>
-          <p:cNvPr id="12" name="Text 9"/>
+          <p:cNvPr id="13" name="Text 9"/>
           <p:cNvSpPr/>
           <p:nvPr/>
         </p:nvSpPr>
@@ -9259,7 +9259,7 @@
       </p:sp>
       <p:sp>
         <p:nvSpPr>
-          <p:cNvPr id="13" name="Text 10"/>
+          <p:cNvPr id="14" name="Text 10"/>
           <p:cNvSpPr/>
           <p:nvPr/>
         </p:nvSpPr>
@@ -9314,7 +9314,7 @@
       </p:sp>
       <p:sp>
         <p:nvSpPr>
-          <p:cNvPr id="14" name="Text 11"/>
+          <p:cNvPr id="15" name="Text 11"/>
           <p:cNvSpPr/>
           <p:nvPr/>
         </p:nvSpPr>
@@ -9358,7 +9358,7 @@
       </p:sp>
       <p:sp>
         <p:nvSpPr>
-          <p:cNvPr id="15" name="Text 12"/>
+          <p:cNvPr id="16" name="Text 12"/>
           <p:cNvSpPr/>
           <p:nvPr/>
         </p:nvSpPr>
@@ -9402,7 +9402,7 @@
       </p:sp>
       <p:sp>
         <p:nvSpPr>
-          <p:cNvPr id="16" name="Text 13"/>
+          <p:cNvPr id="17" name="Text 13"/>
           <p:cNvSpPr/>
           <p:nvPr/>
         </p:nvSpPr>
@@ -9446,7 +9446,7 @@
       </p:sp>
       <p:sp>
         <p:nvSpPr>
-          <p:cNvPr id="17" name="Text 14"/>
+          <p:cNvPr id="18" name="Text 14"/>
           <p:cNvSpPr/>
           <p:nvPr/>
         </p:nvSpPr>
@@ -9490,7 +9490,7 @@
       </p:sp>
       <p:pic>
         <p:nvPicPr>
-          <p:cNvPr id="18" name="Image 1" descr="preencoded.png">    </p:cNvPr>
+          <p:cNvPr id="19" name="Image 1" descr="preencoded.png">    </p:cNvPr>
           <p:cNvPicPr>
             <a:picLocks noChangeAspect="1"/>
           </p:cNvPicPr>
@@ -9539,7 +9539,7 @@
       </p:grpSpPr>
       <p:pic>
         <p:nvPicPr>
-          <p:cNvPr id="2" name="Image 0" descr="preencoded.png">    </p:cNvPr>
+          <p:cNvPr id="3" name="Image 0" descr="preencoded.png">    </p:cNvPr>
           <p:cNvPicPr>
             <a:picLocks noChangeAspect="1"/>
           </p:cNvPicPr>
@@ -9563,7 +9563,7 @@
       </p:pic>
       <p:sp>
         <p:nvSpPr>
-          <p:cNvPr id="3" name="Text 0"/>
+          <p:cNvPr id="4" name="Text 0"/>
           <p:cNvSpPr/>
           <p:nvPr/>
         </p:nvSpPr>
@@ -9607,7 +9607,7 @@
       </p:sp>
       <p:pic>
         <p:nvPicPr>
-          <p:cNvPr id="4" name="Image 1" descr="preencoded.png">    </p:cNvPr>
+          <p:cNvPr id="5" name="Image 1" descr="preencoded.png">    </p:cNvPr>
           <p:cNvPicPr>
             <a:picLocks noChangeAspect="1"/>
           </p:cNvPicPr>
@@ -9631,7 +9631,7 @@
       </p:pic>
       <p:sp>
         <p:nvSpPr>
-          <p:cNvPr id="5" name="Text 1"/>
+          <p:cNvPr id="6" name="Text 1"/>
           <p:cNvSpPr/>
           <p:nvPr/>
         </p:nvSpPr>
@@ -9675,7 +9675,7 @@
       </p:sp>
       <p:sp>
         <p:nvSpPr>
-          <p:cNvPr id="6" name="Text 2"/>
+          <p:cNvPr id="7" name="Text 2"/>
           <p:cNvSpPr/>
           <p:nvPr/>
         </p:nvSpPr>
@@ -9719,7 +9719,7 @@
       </p:sp>
       <p:sp>
         <p:nvSpPr>
-          <p:cNvPr id="7" name="Shape 3"/>
+          <p:cNvPr id="8" name="Shape 3"/>
           <p:cNvSpPr/>
           <p:nvPr/>
         </p:nvSpPr>
@@ -9739,7 +9739,7 @@
       </p:sp>
       <p:sp>
         <p:nvSpPr>
-          <p:cNvPr id="8" name="Shape 4"/>
+          <p:cNvPr id="9" name="Shape 4"/>
           <p:cNvSpPr/>
           <p:nvPr/>
         </p:nvSpPr>
@@ -9759,7 +9759,7 @@
       </p:sp>
       <p:sp>
         <p:nvSpPr>
-          <p:cNvPr id="9" name="Text 5"/>
+          <p:cNvPr id="10" name="Text 5"/>
           <p:cNvSpPr/>
           <p:nvPr/>
         </p:nvSpPr>
@@ -9882,7 +9882,7 @@
       </p:sp>
       <p:sp>
         <p:nvSpPr>
-          <p:cNvPr id="10" name="Text 6"/>
+          <p:cNvPr id="11" name="Text 6"/>
           <p:cNvSpPr/>
           <p:nvPr/>
         </p:nvSpPr>
@@ -9970,7 +9970,7 @@
       </p:sp>
       <p:sp>
         <p:nvSpPr>
-          <p:cNvPr id="11" name="Text 7"/>
+          <p:cNvPr id="12" name="Text 7"/>
           <p:cNvSpPr/>
           <p:nvPr/>
         </p:nvSpPr>
@@ -10058,7 +10058,7 @@
       </p:sp>
       <p:sp>
         <p:nvSpPr>
-          <p:cNvPr id="12" name="Text 8"/>
+          <p:cNvPr id="13" name="Text 8"/>
           <p:cNvSpPr/>
           <p:nvPr/>
         </p:nvSpPr>
@@ -10124,7 +10124,7 @@
       </p:sp>
       <p:sp>
         <p:nvSpPr>
-          <p:cNvPr id="13" name="Text 9"/>
+          <p:cNvPr id="14" name="Text 9"/>
           <p:cNvSpPr/>
           <p:nvPr/>
         </p:nvSpPr>
@@ -10190,7 +10190,7 @@
       </p:sp>
       <p:sp>
         <p:nvSpPr>
-          <p:cNvPr id="14" name="Text 10"/>
+          <p:cNvPr id="15" name="Text 10"/>
           <p:cNvSpPr/>
           <p:nvPr/>
         </p:nvSpPr>
@@ -10234,7 +10234,7 @@
       </p:sp>
       <p:sp>
         <p:nvSpPr>
-          <p:cNvPr id="15" name="Text 11"/>
+          <p:cNvPr id="16" name="Text 11"/>
           <p:cNvSpPr/>
           <p:nvPr/>
         </p:nvSpPr>
@@ -10278,7 +10278,7 @@
       </p:sp>
       <p:sp>
         <p:nvSpPr>
-          <p:cNvPr id="16" name="Text 12"/>
+          <p:cNvPr id="17" name="Text 12"/>
           <p:cNvSpPr/>
           <p:nvPr/>
         </p:nvSpPr>
@@ -10322,7 +10322,7 @@
       </p:sp>
       <p:sp>
         <p:nvSpPr>
-          <p:cNvPr id="17" name="Text 13"/>
+          <p:cNvPr id="18" name="Text 13"/>
           <p:cNvSpPr/>
           <p:nvPr/>
         </p:nvSpPr>

</xml_diff>

<commit_message>
Update narrative to frame 800V as a design choice
</commit_message>
<xml_diff>
--- a/FC_Inverter_Presentation.pptx
+++ b/FC_Inverter_Presentation.pptx
@@ -1042,7 +1042,7 @@
           <a:p>
             <a:r>
               <a:rPr lang="en-US" dirty="0"/>
-              <a:t>So, why are we seeing this shift to 800V architectures in electric vehicles? The core reason is simple: it enables ultra-fast charging, cutting typical charge times from 45 minutes down to under 20 minutes. This higher voltage also dramatically reduces I²R losses by 75% across the entire powertrain, because we're halving the current for the same power. And, a big bonus for vehicle manufacturers, it allows for 50% less copper, saving about 10 to 15 kilograms in vehicle weight. Major players like Porsche, Hyundai, and GM are already adopting 800V, but this higher voltage introduces a significant challenge: increased dv/dt stress on motor insulation, which demands advanced inverter topologies.</a:t>
+              <a:t>So, why did we choose an 800V architecture for this design? It's all about meeting modern EV performance demands, especially for charging and efficiency. The main reason is that doubling the bus voltage effectively halves the phase current for the same power output. This dramatically reduces I squared R losses by 75% across the entire powertrain, from the inverter to the motor and even the cabling. This also means we can use 50% less copper, saving 10 to 15 kilograms in vehicle weight. Plus, 800V enables ultra-fast DC charging at over 350 kilowatts, cutting charge times from 45 minutes to under 20 minutes. But this higher voltage also brings a challenge: increased dv/dt stress on motor insulation, which leads us to our next point.</a:t>
             </a:r>
             <a:endParaRPr lang="en-US" dirty="0"/>
           </a:p>
@@ -7291,16 +7291,57 @@
         <p:spPr>
           <a:xfrm>
             <a:off x="571500" y="0"/>
-            <a:ext cx="8001000" cy="688646"/>
-          </a:xfrm>
-          <a:prstGeom prst="rect">
-            <a:avLst/>
-          </a:prstGeom>
-          <a:noFill/>
-          <a:ln/>
-        </p:spPr>
-        <p:txBody>
-          <a:bodyPr wrap="square" lIns="0" tIns="510286" rIns="0" bIns="0" rtlCol="0" anchor="t">
+            <a:ext cx="8572500" cy="207169"/>
+          </a:xfrm>
+          <a:prstGeom prst="rect">
+            <a:avLst/>
+          </a:prstGeom>
+          <a:noFill/>
+          <a:ln/>
+        </p:spPr>
+        <p:txBody>
+          <a:bodyPr wrap="square" lIns="0" tIns="102108" rIns="0" bIns="0" rtlCol="0" anchor="t">
+            <a:spAutoFit/>
+          </a:bodyPr>
+          <a:lstStyle/>
+          <a:p>
+            <a:pPr algn="l" indent="0" marL="0">
+              <a:buNone/>
+            </a:pPr>
+            <a:r>
+              <a:rPr lang="en-US" sz="700" dirty="0">
+                <a:solidFill>
+                  <a:srgbClr val="2563EB"/>
+                </a:solidFill>
+                <a:latin typeface="Inter SemiBold" pitchFamily="34" charset="0"/>
+                <a:ea typeface="Inter SemiBold" pitchFamily="34" charset="-122"/>
+                <a:cs typeface="Inter SemiBold" pitchFamily="34" charset="-120"/>
+              </a:rPr>
+              <a:t>ECE 595 — PURDUE UNIVERSITY</a:t>
+            </a:r>
+            <a:endParaRPr lang="en-US" sz="700" dirty="0"/>
+          </a:p>
+        </p:txBody>
+      </p:sp>
+      <p:sp>
+        <p:nvSpPr>
+          <p:cNvPr id="5" name="Text 1"/>
+          <p:cNvSpPr/>
+          <p:nvPr/>
+        </p:nvSpPr>
+        <p:spPr>
+          <a:xfrm>
+            <a:off x="571500" y="207169"/>
+            <a:ext cx="8001000" cy="617209"/>
+          </a:xfrm>
+          <a:prstGeom prst="rect">
+            <a:avLst/>
+          </a:prstGeom>
+          <a:noFill/>
+          <a:ln/>
+        </p:spPr>
+        <p:txBody>
+          <a:bodyPr wrap="square" lIns="0" tIns="425196" rIns="0" bIns="0" rtlCol="0" anchor="t">
             <a:spAutoFit/>
           </a:bodyPr>
           <a:lstStyle/>
@@ -7320,7 +7361,7 @@
                 <a:ea typeface="Inter Bold" pitchFamily="34" charset="-122"/>
                 <a:cs typeface="Inter Bold" pitchFamily="34" charset="-120"/>
               </a:rPr>
-              <a:t>Why 800V Architecture?</a:t>
+              <a:t>Design Choice: 800V Architecture</a:t>
             </a:r>
             <a:endParaRPr lang="en-US" sz="1400" dirty="0"/>
           </a:p>
@@ -7328,23 +7369,23 @@
       </p:sp>
       <p:sp>
         <p:nvSpPr>
-          <p:cNvPr id="5" name="Text 1"/>
-          <p:cNvSpPr/>
-          <p:nvPr/>
-        </p:nvSpPr>
-        <p:spPr>
-          <a:xfrm>
-            <a:off x="571500" y="1052978"/>
-            <a:ext cx="3857625" cy="365727"/>
-          </a:xfrm>
-          <a:prstGeom prst="rect">
-            <a:avLst/>
-          </a:prstGeom>
-          <a:noFill/>
-          <a:ln/>
-        </p:spPr>
-        <p:txBody>
-          <a:bodyPr wrap="square" lIns="136017" tIns="0" rIns="0" bIns="0" rtlCol="0" anchor="t">
+          <p:cNvPr id="6" name="Text 2"/>
+          <p:cNvSpPr/>
+          <p:nvPr/>
+        </p:nvSpPr>
+        <p:spPr>
+          <a:xfrm>
+            <a:off x="571500" y="1102984"/>
+            <a:ext cx="8001000" cy="365727"/>
+          </a:xfrm>
+          <a:prstGeom prst="rect">
+            <a:avLst/>
+          </a:prstGeom>
+          <a:noFill/>
+          <a:ln/>
+        </p:spPr>
+        <p:txBody>
+          <a:bodyPr wrap="square" lIns="0" tIns="0" rIns="0" bIns="0" rtlCol="0" anchor="t">
             <a:spAutoFit/>
           </a:bodyPr>
           <a:lstStyle/>
@@ -7356,6 +7397,17 @@
               <a:buNone/>
             </a:pPr>
             <a:r>
+              <a:rPr lang="en-US" sz="850" dirty="0">
+                <a:solidFill>
+                  <a:srgbClr val="333333"/>
+                </a:solidFill>
+                <a:latin typeface="Inter" pitchFamily="34" charset="0"/>
+                <a:ea typeface="Inter" pitchFamily="34" charset="-122"/>
+                <a:cs typeface="Inter" pitchFamily="34" charset="-120"/>
+              </a:rPr>
+              <a:t>To meet modern EV performance demands, an </a:t>
+            </a:r>
+            <a:r>
               <a:rPr lang="en-US" sz="800" b="1" dirty="0">
                 <a:solidFill>
                   <a:srgbClr val="000000"/>
@@ -7364,7 +7416,7 @@
                 <a:ea typeface="Inter Bold" pitchFamily="34" charset="-122"/>
                 <a:cs typeface="Inter Bold" pitchFamily="34" charset="-120"/>
               </a:rPr>
-              <a:t>Ultra-fast charging at 350+ kW</a:t>
+              <a:t>800V DC bus architecture</a:t>
             </a:r>
             <a:r>
               <a:rPr lang="en-US" sz="850" dirty="0">
@@ -7375,7 +7427,7 @@
                 <a:ea typeface="Inter" pitchFamily="34" charset="-122"/>
                 <a:cs typeface="Inter" pitchFamily="34" charset="-120"/>
               </a:rPr>
-              <a:t> — reduces charge time from ~45 </a:t>
+              <a:t> was explicitly chosen for this design over traditional 400V systems to </a:t>
             </a:r>
             <a:r>
               <a:rPr lang="en-US" sz="850" dirty="0">
@@ -7386,7 +7438,136 @@
                 <a:ea typeface="Inter" pitchFamily="34" charset="-122"/>
                 <a:cs typeface="Inter" pitchFamily="34" charset="-120"/>
               </a:rPr>
-              <a:t>min to under 20 min compared to 400V systems.</a:t>
+              <a:t>address three primary vehicle-level objectives:</a:t>
+            </a:r>
+            <a:endParaRPr lang="en-US" sz="850" dirty="0"/>
+          </a:p>
+        </p:txBody>
+      </p:sp>
+      <p:sp>
+        <p:nvSpPr>
+          <p:cNvPr id="7" name="Text 3"/>
+          <p:cNvSpPr/>
+          <p:nvPr/>
+        </p:nvSpPr>
+        <p:spPr>
+          <a:xfrm>
+            <a:off x="571500" y="1918767"/>
+            <a:ext cx="2476481" cy="207169"/>
+          </a:xfrm>
+          <a:prstGeom prst="rect">
+            <a:avLst/>
+          </a:prstGeom>
+          <a:noFill/>
+          <a:ln/>
+        </p:spPr>
+        <p:txBody>
+          <a:bodyPr wrap="square" lIns="0" tIns="0" rIns="0" bIns="0" rtlCol="0" anchor="t">
+            <a:spAutoFit/>
+          </a:bodyPr>
+          <a:lstStyle/>
+          <a:p>
+            <a:pPr algn="l" indent="0" marL="0">
+              <a:buNone/>
+            </a:pPr>
+            <a:r>
+              <a:rPr lang="en-US" sz="1200" b="1" dirty="0">
+                <a:solidFill>
+                  <a:srgbClr val="2563EB"/>
+                </a:solidFill>
+                <a:latin typeface="Inter Bold" pitchFamily="34" charset="0"/>
+                <a:ea typeface="Inter Bold" pitchFamily="34" charset="-122"/>
+                <a:cs typeface="Inter Bold" pitchFamily="34" charset="-120"/>
+              </a:rPr>
+              <a:t>01</a:t>
+            </a:r>
+            <a:endParaRPr lang="en-US" sz="1200" dirty="0"/>
+          </a:p>
+        </p:txBody>
+      </p:sp>
+      <p:sp>
+        <p:nvSpPr>
+          <p:cNvPr id="8" name="Text 4"/>
+          <p:cNvSpPr/>
+          <p:nvPr/>
+        </p:nvSpPr>
+        <p:spPr>
+          <a:xfrm>
+            <a:off x="571500" y="2211660"/>
+            <a:ext cx="2476481" cy="167153"/>
+          </a:xfrm>
+          <a:prstGeom prst="rect">
+            <a:avLst/>
+          </a:prstGeom>
+          <a:noFill/>
+          <a:ln/>
+        </p:spPr>
+        <p:txBody>
+          <a:bodyPr wrap="none" lIns="0" tIns="0" rIns="0" bIns="0" rtlCol="0" anchor="t">
+            <a:spAutoFit/>
+          </a:bodyPr>
+          <a:lstStyle/>
+          <a:p>
+            <a:pPr algn="l" indent="0" marL="0">
+              <a:lnSpc>
+                <a:spcPct val="104000"/>
+              </a:lnSpc>
+              <a:buNone/>
+            </a:pPr>
+            <a:r>
+              <a:rPr lang="en-US" sz="900" b="1" dirty="0">
+                <a:solidFill>
+                  <a:srgbClr val="000000"/>
+                </a:solidFill>
+                <a:latin typeface="Inter Bold" pitchFamily="34" charset="0"/>
+                <a:ea typeface="Inter Bold" pitchFamily="34" charset="-122"/>
+                <a:cs typeface="Inter Bold" pitchFamily="34" charset="-120"/>
+              </a:rPr>
+              <a:t>Halved Phase Currents</a:t>
+            </a:r>
+            <a:endParaRPr lang="en-US" sz="900" dirty="0"/>
+          </a:p>
+        </p:txBody>
+      </p:sp>
+      <p:sp>
+        <p:nvSpPr>
+          <p:cNvPr id="9" name="Text 5"/>
+          <p:cNvSpPr/>
+          <p:nvPr/>
+        </p:nvSpPr>
+        <p:spPr>
+          <a:xfrm>
+            <a:off x="571500" y="2464538"/>
+            <a:ext cx="2476481" cy="514350"/>
+          </a:xfrm>
+          <a:prstGeom prst="rect">
+            <a:avLst/>
+          </a:prstGeom>
+          <a:noFill/>
+          <a:ln/>
+        </p:spPr>
+        <p:txBody>
+          <a:bodyPr wrap="square" lIns="0" tIns="0" rIns="0" bIns="0" rtlCol="0" anchor="t">
+            <a:spAutoFit/>
+          </a:bodyPr>
+          <a:lstStyle/>
+          <a:p>
+            <a:pPr algn="l" indent="0" marL="0">
+              <a:lnSpc>
+                <a:spcPct val="128000"/>
+              </a:lnSpc>
+              <a:buNone/>
+            </a:pPr>
+            <a:r>
+              <a:rPr lang="en-US" sz="800" dirty="0">
+                <a:solidFill>
+                  <a:srgbClr val="333333"/>
+                </a:solidFill>
+                <a:latin typeface="Inter" pitchFamily="34" charset="0"/>
+                <a:ea typeface="Inter" pitchFamily="34" charset="-122"/>
+                <a:cs typeface="Inter" pitchFamily="34" charset="-120"/>
+              </a:rPr>
+              <a:t>Doubling the bus voltage from 400V to 800V halves the required phase current for the exact same motor power output.</a:t>
             </a:r>
             <a:endParaRPr lang="en-US" sz="800" dirty="0"/>
           </a:p>
@@ -7394,23 +7575,108 @@
       </p:sp>
       <p:sp>
         <p:nvSpPr>
-          <p:cNvPr id="6" name="Text 2"/>
-          <p:cNvSpPr/>
-          <p:nvPr/>
-        </p:nvSpPr>
-        <p:spPr>
-          <a:xfrm>
-            <a:off x="571500" y="1561579"/>
-            <a:ext cx="3857625" cy="365727"/>
-          </a:xfrm>
-          <a:prstGeom prst="rect">
-            <a:avLst/>
-          </a:prstGeom>
-          <a:noFill/>
-          <a:ln/>
-        </p:spPr>
-        <p:txBody>
-          <a:bodyPr wrap="square" lIns="136017" tIns="0" rIns="0" bIns="0" rtlCol="0" anchor="t">
+          <p:cNvPr id="10" name="Text 6"/>
+          <p:cNvSpPr/>
+          <p:nvPr/>
+        </p:nvSpPr>
+        <p:spPr>
+          <a:xfrm>
+            <a:off x="3333731" y="1918767"/>
+            <a:ext cx="2476509" cy="207169"/>
+          </a:xfrm>
+          <a:prstGeom prst="rect">
+            <a:avLst/>
+          </a:prstGeom>
+          <a:noFill/>
+          <a:ln/>
+        </p:spPr>
+        <p:txBody>
+          <a:bodyPr wrap="square" lIns="0" tIns="0" rIns="0" bIns="0" rtlCol="0" anchor="t">
+            <a:spAutoFit/>
+          </a:bodyPr>
+          <a:lstStyle/>
+          <a:p>
+            <a:pPr algn="l" indent="0" marL="0">
+              <a:buNone/>
+            </a:pPr>
+            <a:r>
+              <a:rPr lang="en-US" sz="1200" b="1" dirty="0">
+                <a:solidFill>
+                  <a:srgbClr val="2563EB"/>
+                </a:solidFill>
+                <a:latin typeface="Inter Bold" pitchFamily="34" charset="0"/>
+                <a:ea typeface="Inter Bold" pitchFamily="34" charset="-122"/>
+                <a:cs typeface="Inter Bold" pitchFamily="34" charset="-120"/>
+              </a:rPr>
+              <a:t>02</a:t>
+            </a:r>
+            <a:endParaRPr lang="en-US" sz="1200" dirty="0"/>
+          </a:p>
+        </p:txBody>
+      </p:sp>
+      <p:sp>
+        <p:nvSpPr>
+          <p:cNvPr id="11" name="Text 7"/>
+          <p:cNvSpPr/>
+          <p:nvPr/>
+        </p:nvSpPr>
+        <p:spPr>
+          <a:xfrm>
+            <a:off x="3333731" y="2211660"/>
+            <a:ext cx="2476509" cy="167153"/>
+          </a:xfrm>
+          <a:prstGeom prst="rect">
+            <a:avLst/>
+          </a:prstGeom>
+          <a:noFill/>
+          <a:ln/>
+        </p:spPr>
+        <p:txBody>
+          <a:bodyPr wrap="none" lIns="0" tIns="0" rIns="0" bIns="0" rtlCol="0" anchor="t">
+            <a:spAutoFit/>
+          </a:bodyPr>
+          <a:lstStyle/>
+          <a:p>
+            <a:pPr algn="l" indent="0" marL="0">
+              <a:lnSpc>
+                <a:spcPct val="104000"/>
+              </a:lnSpc>
+              <a:buNone/>
+            </a:pPr>
+            <a:r>
+              <a:rPr lang="en-US" sz="900" b="1" dirty="0">
+                <a:solidFill>
+                  <a:srgbClr val="000000"/>
+                </a:solidFill>
+                <a:latin typeface="Inter Bold" pitchFamily="34" charset="0"/>
+                <a:ea typeface="Inter Bold" pitchFamily="34" charset="-122"/>
+                <a:cs typeface="Inter Bold" pitchFamily="34" charset="-120"/>
+              </a:rPr>
+              <a:t>Reduced Ohmic Losses</a:t>
+            </a:r>
+            <a:endParaRPr lang="en-US" sz="900" dirty="0"/>
+          </a:p>
+        </p:txBody>
+      </p:sp>
+      <p:sp>
+        <p:nvSpPr>
+          <p:cNvPr id="12" name="Text 8"/>
+          <p:cNvSpPr/>
+          <p:nvPr/>
+        </p:nvSpPr>
+        <p:spPr>
+          <a:xfrm>
+            <a:off x="3333731" y="2464538"/>
+            <a:ext cx="2476509" cy="685800"/>
+          </a:xfrm>
+          <a:prstGeom prst="rect">
+            <a:avLst/>
+          </a:prstGeom>
+          <a:noFill/>
+          <a:ln/>
+        </p:spPr>
+        <p:txBody>
+          <a:bodyPr wrap="square" lIns="0" tIns="0" rIns="0" bIns="0" rtlCol="0" anchor="t">
             <a:spAutoFit/>
           </a:bodyPr>
           <a:lstStyle/>
@@ -7422,7 +7688,92 @@
               <a:buNone/>
             </a:pPr>
             <a:r>
-              <a:rPr lang="en-US" sz="800" b="1" dirty="0">
+              <a:rPr lang="en-US" sz="800" dirty="0">
+                <a:solidFill>
+                  <a:srgbClr val="333333"/>
+                </a:solidFill>
+                <a:latin typeface="Inter" pitchFamily="34" charset="0"/>
+                <a:ea typeface="Inter" pitchFamily="34" charset="-122"/>
+                <a:cs typeface="Inter" pitchFamily="34" charset="-120"/>
+              </a:rPr>
+              <a:t>Lower currents drastically reduce I²R conduction losses in the traction inverter switches, motor stator windings, and high-voltage DC cabling.</a:t>
+            </a:r>
+            <a:endParaRPr lang="en-US" sz="800" dirty="0"/>
+          </a:p>
+        </p:txBody>
+      </p:sp>
+      <p:sp>
+        <p:nvSpPr>
+          <p:cNvPr id="13" name="Text 9"/>
+          <p:cNvSpPr/>
+          <p:nvPr/>
+        </p:nvSpPr>
+        <p:spPr>
+          <a:xfrm>
+            <a:off x="6095991" y="1918767"/>
+            <a:ext cx="2476481" cy="207169"/>
+          </a:xfrm>
+          <a:prstGeom prst="rect">
+            <a:avLst/>
+          </a:prstGeom>
+          <a:noFill/>
+          <a:ln/>
+        </p:spPr>
+        <p:txBody>
+          <a:bodyPr wrap="square" lIns="0" tIns="0" rIns="0" bIns="0" rtlCol="0" anchor="t">
+            <a:spAutoFit/>
+          </a:bodyPr>
+          <a:lstStyle/>
+          <a:p>
+            <a:pPr algn="l" indent="0" marL="0">
+              <a:buNone/>
+            </a:pPr>
+            <a:r>
+              <a:rPr lang="en-US" sz="1200" b="1" dirty="0">
+                <a:solidFill>
+                  <a:srgbClr val="2563EB"/>
+                </a:solidFill>
+                <a:latin typeface="Inter Bold" pitchFamily="34" charset="0"/>
+                <a:ea typeface="Inter Bold" pitchFamily="34" charset="-122"/>
+                <a:cs typeface="Inter Bold" pitchFamily="34" charset="-120"/>
+              </a:rPr>
+              <a:t>03</a:t>
+            </a:r>
+            <a:endParaRPr lang="en-US" sz="1200" dirty="0"/>
+          </a:p>
+        </p:txBody>
+      </p:sp>
+      <p:sp>
+        <p:nvSpPr>
+          <p:cNvPr id="14" name="Text 10"/>
+          <p:cNvSpPr/>
+          <p:nvPr/>
+        </p:nvSpPr>
+        <p:spPr>
+          <a:xfrm>
+            <a:off x="6095991" y="2211660"/>
+            <a:ext cx="2476481" cy="167153"/>
+          </a:xfrm>
+          <a:prstGeom prst="rect">
+            <a:avLst/>
+          </a:prstGeom>
+          <a:noFill/>
+          <a:ln/>
+        </p:spPr>
+        <p:txBody>
+          <a:bodyPr wrap="none" lIns="0" tIns="0" rIns="0" bIns="0" rtlCol="0" anchor="t">
+            <a:spAutoFit/>
+          </a:bodyPr>
+          <a:lstStyle/>
+          <a:p>
+            <a:pPr algn="l" indent="0" marL="0">
+              <a:lnSpc>
+                <a:spcPct val="104000"/>
+              </a:lnSpc>
+              <a:buNone/>
+            </a:pPr>
+            <a:r>
+              <a:rPr lang="en-US" sz="900" b="1" dirty="0">
                 <a:solidFill>
                   <a:srgbClr val="000000"/>
                 </a:solidFill>
@@ -7430,476 +7781,56 @@
                 <a:ea typeface="Inter Bold" pitchFamily="34" charset="-122"/>
                 <a:cs typeface="Inter Bold" pitchFamily="34" charset="-120"/>
               </a:rPr>
-              <a:t>75% reduction in I²R losses</a:t>
-            </a:r>
-            <a:r>
-              <a:rPr lang="en-US" sz="850" dirty="0">
-                <a:solidFill>
-                  <a:srgbClr val="333333"/>
-                </a:solidFill>
-                <a:latin typeface="Inter" pitchFamily="34" charset="0"/>
-                <a:ea typeface="Inter" pitchFamily="34" charset="-122"/>
-                <a:cs typeface="Inter" pitchFamily="34" charset="-120"/>
-              </a:rPr>
-              <a:t> — halving current for the same power </a:t>
-            </a:r>
-            <a:r>
-              <a:rPr lang="en-US" sz="850" dirty="0">
-                <a:solidFill>
-                  <a:srgbClr val="333333"/>
-                </a:solidFill>
-                <a:latin typeface="Inter" pitchFamily="34" charset="0"/>
-                <a:ea typeface="Inter" pitchFamily="34" charset="-122"/>
-                <a:cs typeface="Inter" pitchFamily="34" charset="-120"/>
-              </a:rPr>
-              <a:t>output cuts ohmic losses across inverter, motor, and cabling.</a:t>
+              <a:t>Ultra-Fast Charging</a:t>
+            </a:r>
+            <a:endParaRPr lang="en-US" sz="900" dirty="0"/>
+          </a:p>
+        </p:txBody>
+      </p:sp>
+      <p:sp>
+        <p:nvSpPr>
+          <p:cNvPr id="15" name="Text 11"/>
+          <p:cNvSpPr/>
+          <p:nvPr/>
+        </p:nvSpPr>
+        <p:spPr>
+          <a:xfrm>
+            <a:off x="6095991" y="2464538"/>
+            <a:ext cx="2476481" cy="685800"/>
+          </a:xfrm>
+          <a:prstGeom prst="rect">
+            <a:avLst/>
+          </a:prstGeom>
+          <a:noFill/>
+          <a:ln/>
+        </p:spPr>
+        <p:txBody>
+          <a:bodyPr wrap="square" lIns="0" tIns="0" rIns="0" bIns="0" rtlCol="0" anchor="t">
+            <a:spAutoFit/>
+          </a:bodyPr>
+          <a:lstStyle/>
+          <a:p>
+            <a:pPr algn="l" indent="0" marL="0">
+              <a:lnSpc>
+                <a:spcPct val="128000"/>
+              </a:lnSpc>
+              <a:buNone/>
+            </a:pPr>
+            <a:r>
+              <a:rPr lang="en-US" sz="800" dirty="0">
+                <a:solidFill>
+                  <a:srgbClr val="333333"/>
+                </a:solidFill>
+                <a:latin typeface="Inter" pitchFamily="34" charset="0"/>
+                <a:ea typeface="Inter" pitchFamily="34" charset="-122"/>
+                <a:cs typeface="Inter" pitchFamily="34" charset="-120"/>
+              </a:rPr>
+              <a:t>An 800V bus allows for DC fast charging at power levels exceeding 350 kW without requiring prohibitively thick, heavy, or liquid-cooled charging cables.</a:t>
             </a:r>
             <a:endParaRPr lang="en-US" sz="800" dirty="0"/>
           </a:p>
         </p:txBody>
       </p:sp>
-      <p:sp>
-        <p:nvSpPr>
-          <p:cNvPr id="7" name="Text 3"/>
-          <p:cNvSpPr/>
-          <p:nvPr/>
-        </p:nvSpPr>
-        <p:spPr>
-          <a:xfrm>
-            <a:off x="571500" y="2070181"/>
-            <a:ext cx="3857625" cy="365727"/>
-          </a:xfrm>
-          <a:prstGeom prst="rect">
-            <a:avLst/>
-          </a:prstGeom>
-          <a:noFill/>
-          <a:ln/>
-        </p:spPr>
-        <p:txBody>
-          <a:bodyPr wrap="square" lIns="136017" tIns="0" rIns="0" bIns="0" rtlCol="0" anchor="t">
-            <a:spAutoFit/>
-          </a:bodyPr>
-          <a:lstStyle/>
-          <a:p>
-            <a:pPr algn="l" indent="0" marL="0">
-              <a:lnSpc>
-                <a:spcPct val="128000"/>
-              </a:lnSpc>
-              <a:buNone/>
-            </a:pPr>
-            <a:r>
-              <a:rPr lang="en-US" sz="800" b="1" dirty="0">
-                <a:solidFill>
-                  <a:srgbClr val="000000"/>
-                </a:solidFill>
-                <a:latin typeface="Inter Bold" pitchFamily="34" charset="0"/>
-                <a:ea typeface="Inter Bold" pitchFamily="34" charset="-122"/>
-                <a:cs typeface="Inter Bold" pitchFamily="34" charset="-120"/>
-              </a:rPr>
-              <a:t>50% less copper</a:t>
-            </a:r>
-            <a:r>
-              <a:rPr lang="en-US" sz="850" dirty="0">
-                <a:solidFill>
-                  <a:srgbClr val="333333"/>
-                </a:solidFill>
-                <a:latin typeface="Inter" pitchFamily="34" charset="0"/>
-                <a:ea typeface="Inter" pitchFamily="34" charset="-122"/>
-                <a:cs typeface="Inter" pitchFamily="34" charset="-120"/>
-              </a:rPr>
-              <a:t> — smaller conductor cross-section saves </a:t>
-            </a:r>
-            <a:r>
-              <a:rPr lang="en-US" sz="850" dirty="0">
-                <a:solidFill>
-                  <a:srgbClr val="333333"/>
-                </a:solidFill>
-                <a:latin typeface="Inter" pitchFamily="34" charset="0"/>
-                <a:ea typeface="Inter" pitchFamily="34" charset="-122"/>
-                <a:cs typeface="Inter" pitchFamily="34" charset="-120"/>
-              </a:rPr>
-              <a:t>approximately 10–15 kg of vehicle weight.</a:t>
-            </a:r>
-            <a:endParaRPr lang="en-US" sz="800" dirty="0"/>
-          </a:p>
-        </p:txBody>
-      </p:sp>
-      <p:sp>
-        <p:nvSpPr>
-          <p:cNvPr id="8" name="Text 4"/>
-          <p:cNvSpPr/>
-          <p:nvPr/>
-        </p:nvSpPr>
-        <p:spPr>
-          <a:xfrm>
-            <a:off x="571500" y="2578782"/>
-            <a:ext cx="3857625" cy="365727"/>
-          </a:xfrm>
-          <a:prstGeom prst="rect">
-            <a:avLst/>
-          </a:prstGeom>
-          <a:noFill/>
-          <a:ln/>
-        </p:spPr>
-        <p:txBody>
-          <a:bodyPr wrap="square" lIns="136017" tIns="0" rIns="0" bIns="0" rtlCol="0" anchor="t">
-            <a:spAutoFit/>
-          </a:bodyPr>
-          <a:lstStyle/>
-          <a:p>
-            <a:pPr algn="l" indent="0" marL="0">
-              <a:lnSpc>
-                <a:spcPct val="128000"/>
-              </a:lnSpc>
-              <a:buNone/>
-            </a:pPr>
-            <a:r>
-              <a:rPr lang="en-US" sz="800" b="1" dirty="0">
-                <a:solidFill>
-                  <a:srgbClr val="000000"/>
-                </a:solidFill>
-                <a:latin typeface="Inter Bold" pitchFamily="34" charset="0"/>
-                <a:ea typeface="Inter Bold" pitchFamily="34" charset="-122"/>
-                <a:cs typeface="Inter Bold" pitchFamily="34" charset="-120"/>
-              </a:rPr>
-              <a:t>Industry adoption</a:t>
-            </a:r>
-            <a:r>
-              <a:rPr lang="en-US" sz="850" dirty="0">
-                <a:solidFill>
-                  <a:srgbClr val="333333"/>
-                </a:solidFill>
-                <a:latin typeface="Inter" pitchFamily="34" charset="0"/>
-                <a:ea typeface="Inter" pitchFamily="34" charset="-122"/>
-                <a:cs typeface="Inter" pitchFamily="34" charset="-120"/>
-              </a:rPr>
-              <a:t> — Porsche Taycan, Hyundai E-GMP, and GM </a:t>
-            </a:r>
-            <a:r>
-              <a:rPr lang="en-US" sz="850" dirty="0">
-                <a:solidFill>
-                  <a:srgbClr val="333333"/>
-                </a:solidFill>
-                <a:latin typeface="Inter" pitchFamily="34" charset="0"/>
-                <a:ea typeface="Inter" pitchFamily="34" charset="-122"/>
-                <a:cs typeface="Inter" pitchFamily="34" charset="-120"/>
-              </a:rPr>
-              <a:t>Ultium all use 800V platforms.</a:t>
-            </a:r>
-            <a:endParaRPr lang="en-US" sz="800" dirty="0"/>
-          </a:p>
-        </p:txBody>
-      </p:sp>
-      <p:sp>
-        <p:nvSpPr>
-          <p:cNvPr id="9" name="Text 5"/>
-          <p:cNvSpPr/>
-          <p:nvPr/>
-        </p:nvSpPr>
-        <p:spPr>
-          <a:xfrm>
-            <a:off x="571500" y="3087384"/>
-            <a:ext cx="3857625" cy="365727"/>
-          </a:xfrm>
-          <a:prstGeom prst="rect">
-            <a:avLst/>
-          </a:prstGeom>
-          <a:noFill/>
-          <a:ln/>
-        </p:spPr>
-        <p:txBody>
-          <a:bodyPr wrap="square" lIns="136017" tIns="0" rIns="0" bIns="0" rtlCol="0" anchor="t">
-            <a:spAutoFit/>
-          </a:bodyPr>
-          <a:lstStyle/>
-          <a:p>
-            <a:pPr algn="l" indent="0" marL="0">
-              <a:lnSpc>
-                <a:spcPct val="128000"/>
-              </a:lnSpc>
-              <a:buNone/>
-            </a:pPr>
-            <a:r>
-              <a:rPr lang="en-US" sz="800" b="1" dirty="0">
-                <a:solidFill>
-                  <a:srgbClr val="000000"/>
-                </a:solidFill>
-                <a:latin typeface="Inter Bold" pitchFamily="34" charset="0"/>
-                <a:ea typeface="Inter Bold" pitchFamily="34" charset="-122"/>
-                <a:cs typeface="Inter Bold" pitchFamily="34" charset="-120"/>
-              </a:rPr>
-              <a:t>Challenge:</a:t>
-            </a:r>
-            <a:r>
-              <a:rPr lang="en-US" sz="850" dirty="0">
-                <a:solidFill>
-                  <a:srgbClr val="333333"/>
-                </a:solidFill>
-                <a:latin typeface="Inter" pitchFamily="34" charset="0"/>
-                <a:ea typeface="Inter" pitchFamily="34" charset="-122"/>
-                <a:cs typeface="Inter" pitchFamily="34" charset="-120"/>
-              </a:rPr>
-              <a:t> Higher DC-link voltage significantly increases dv/dt </a:t>
-            </a:r>
-            <a:r>
-              <a:rPr lang="en-US" sz="850" dirty="0">
-                <a:solidFill>
-                  <a:srgbClr val="333333"/>
-                </a:solidFill>
-                <a:latin typeface="Inter" pitchFamily="34" charset="0"/>
-                <a:ea typeface="Inter" pitchFamily="34" charset="-122"/>
-                <a:cs typeface="Inter" pitchFamily="34" charset="-120"/>
-              </a:rPr>
-              <a:t>stress on motor insulation, demanding advanced inverter topologies.</a:t>
-            </a:r>
-            <a:endParaRPr lang="en-US" sz="800" dirty="0"/>
-          </a:p>
-        </p:txBody>
-      </p:sp>
-      <p:sp>
-        <p:nvSpPr>
-          <p:cNvPr id="10" name="Text 6"/>
-          <p:cNvSpPr/>
-          <p:nvPr/>
-        </p:nvSpPr>
-        <p:spPr>
-          <a:xfrm>
-            <a:off x="571500" y="1052978"/>
-            <a:ext cx="53578" cy="182863"/>
-          </a:xfrm>
-          <a:prstGeom prst="rect">
-            <a:avLst/>
-          </a:prstGeom>
-          <a:noFill/>
-          <a:ln/>
-        </p:spPr>
-        <p:txBody>
-          <a:bodyPr wrap="none" lIns="0" tIns="0" rIns="0" bIns="0" rtlCol="0" anchor="t">
-            <a:spAutoFit/>
-          </a:bodyPr>
-          <a:lstStyle/>
-          <a:p>
-            <a:pPr algn="l" indent="0" marL="0">
-              <a:lnSpc>
-                <a:spcPct val="128000"/>
-              </a:lnSpc>
-              <a:buNone/>
-            </a:pPr>
-            <a:r>
-              <a:rPr lang="en-US" sz="800" b="1" dirty="0">
-                <a:solidFill>
-                  <a:srgbClr val="2563EB"/>
-                </a:solidFill>
-                <a:latin typeface="Inter Bold" pitchFamily="34" charset="0"/>
-                <a:ea typeface="Inter Bold" pitchFamily="34" charset="-122"/>
-                <a:cs typeface="Inter Bold" pitchFamily="34" charset="-120"/>
-              </a:rPr>
-              <a:t>•</a:t>
-            </a:r>
-            <a:endParaRPr lang="en-US" sz="800" dirty="0"/>
-          </a:p>
-        </p:txBody>
-      </p:sp>
-      <p:sp>
-        <p:nvSpPr>
-          <p:cNvPr id="11" name="Text 7"/>
-          <p:cNvSpPr/>
-          <p:nvPr/>
-        </p:nvSpPr>
-        <p:spPr>
-          <a:xfrm>
-            <a:off x="571500" y="1561579"/>
-            <a:ext cx="53578" cy="182863"/>
-          </a:xfrm>
-          <a:prstGeom prst="rect">
-            <a:avLst/>
-          </a:prstGeom>
-          <a:noFill/>
-          <a:ln/>
-        </p:spPr>
-        <p:txBody>
-          <a:bodyPr wrap="none" lIns="0" tIns="0" rIns="0" bIns="0" rtlCol="0" anchor="t">
-            <a:spAutoFit/>
-          </a:bodyPr>
-          <a:lstStyle/>
-          <a:p>
-            <a:pPr algn="l" indent="0" marL="0">
-              <a:lnSpc>
-                <a:spcPct val="128000"/>
-              </a:lnSpc>
-              <a:buNone/>
-            </a:pPr>
-            <a:r>
-              <a:rPr lang="en-US" sz="800" b="1" dirty="0">
-                <a:solidFill>
-                  <a:srgbClr val="2563EB"/>
-                </a:solidFill>
-                <a:latin typeface="Inter Bold" pitchFamily="34" charset="0"/>
-                <a:ea typeface="Inter Bold" pitchFamily="34" charset="-122"/>
-                <a:cs typeface="Inter Bold" pitchFamily="34" charset="-120"/>
-              </a:rPr>
-              <a:t>•</a:t>
-            </a:r>
-            <a:endParaRPr lang="en-US" sz="800" dirty="0"/>
-          </a:p>
-        </p:txBody>
-      </p:sp>
-      <p:sp>
-        <p:nvSpPr>
-          <p:cNvPr id="12" name="Text 8"/>
-          <p:cNvSpPr/>
-          <p:nvPr/>
-        </p:nvSpPr>
-        <p:spPr>
-          <a:xfrm>
-            <a:off x="571500" y="2070181"/>
-            <a:ext cx="53578" cy="182863"/>
-          </a:xfrm>
-          <a:prstGeom prst="rect">
-            <a:avLst/>
-          </a:prstGeom>
-          <a:noFill/>
-          <a:ln/>
-        </p:spPr>
-        <p:txBody>
-          <a:bodyPr wrap="none" lIns="0" tIns="0" rIns="0" bIns="0" rtlCol="0" anchor="t">
-            <a:spAutoFit/>
-          </a:bodyPr>
-          <a:lstStyle/>
-          <a:p>
-            <a:pPr algn="l" indent="0" marL="0">
-              <a:lnSpc>
-                <a:spcPct val="128000"/>
-              </a:lnSpc>
-              <a:buNone/>
-            </a:pPr>
-            <a:r>
-              <a:rPr lang="en-US" sz="800" b="1" dirty="0">
-                <a:solidFill>
-                  <a:srgbClr val="2563EB"/>
-                </a:solidFill>
-                <a:latin typeface="Inter Bold" pitchFamily="34" charset="0"/>
-                <a:ea typeface="Inter Bold" pitchFamily="34" charset="-122"/>
-                <a:cs typeface="Inter Bold" pitchFamily="34" charset="-120"/>
-              </a:rPr>
-              <a:t>•</a:t>
-            </a:r>
-            <a:endParaRPr lang="en-US" sz="800" dirty="0"/>
-          </a:p>
-        </p:txBody>
-      </p:sp>
-      <p:sp>
-        <p:nvSpPr>
-          <p:cNvPr id="13" name="Text 9"/>
-          <p:cNvSpPr/>
-          <p:nvPr/>
-        </p:nvSpPr>
-        <p:spPr>
-          <a:xfrm>
-            <a:off x="571500" y="2578782"/>
-            <a:ext cx="53578" cy="182863"/>
-          </a:xfrm>
-          <a:prstGeom prst="rect">
-            <a:avLst/>
-          </a:prstGeom>
-          <a:noFill/>
-          <a:ln/>
-        </p:spPr>
-        <p:txBody>
-          <a:bodyPr wrap="none" lIns="0" tIns="0" rIns="0" bIns="0" rtlCol="0" anchor="t">
-            <a:spAutoFit/>
-          </a:bodyPr>
-          <a:lstStyle/>
-          <a:p>
-            <a:pPr algn="l" indent="0" marL="0">
-              <a:lnSpc>
-                <a:spcPct val="128000"/>
-              </a:lnSpc>
-              <a:buNone/>
-            </a:pPr>
-            <a:r>
-              <a:rPr lang="en-US" sz="800" b="1" dirty="0">
-                <a:solidFill>
-                  <a:srgbClr val="2563EB"/>
-                </a:solidFill>
-                <a:latin typeface="Inter Bold" pitchFamily="34" charset="0"/>
-                <a:ea typeface="Inter Bold" pitchFamily="34" charset="-122"/>
-                <a:cs typeface="Inter Bold" pitchFamily="34" charset="-120"/>
-              </a:rPr>
-              <a:t>•</a:t>
-            </a:r>
-            <a:endParaRPr lang="en-US" sz="800" dirty="0"/>
-          </a:p>
-        </p:txBody>
-      </p:sp>
-      <p:sp>
-        <p:nvSpPr>
-          <p:cNvPr id="14" name="Text 10"/>
-          <p:cNvSpPr/>
-          <p:nvPr/>
-        </p:nvSpPr>
-        <p:spPr>
-          <a:xfrm>
-            <a:off x="571500" y="3087384"/>
-            <a:ext cx="53578" cy="182863"/>
-          </a:xfrm>
-          <a:prstGeom prst="rect">
-            <a:avLst/>
-          </a:prstGeom>
-          <a:noFill/>
-          <a:ln/>
-        </p:spPr>
-        <p:txBody>
-          <a:bodyPr wrap="none" lIns="0" tIns="0" rIns="0" bIns="0" rtlCol="0" anchor="t">
-            <a:spAutoFit/>
-          </a:bodyPr>
-          <a:lstStyle/>
-          <a:p>
-            <a:pPr algn="l" indent="0" marL="0">
-              <a:lnSpc>
-                <a:spcPct val="128000"/>
-              </a:lnSpc>
-              <a:buNone/>
-            </a:pPr>
-            <a:r>
-              <a:rPr lang="en-US" sz="800" b="1" dirty="0">
-                <a:solidFill>
-                  <a:srgbClr val="2563EB"/>
-                </a:solidFill>
-                <a:latin typeface="Inter Bold" pitchFamily="34" charset="0"/>
-                <a:ea typeface="Inter Bold" pitchFamily="34" charset="-122"/>
-                <a:cs typeface="Inter Bold" pitchFamily="34" charset="-120"/>
-              </a:rPr>
-              <a:t>•</a:t>
-            </a:r>
-            <a:endParaRPr lang="en-US" sz="800" dirty="0"/>
-          </a:p>
-        </p:txBody>
-      </p:sp>
-      <p:pic>
-        <p:nvPicPr>
-          <p:cNvPr id="15" name="Image 1" descr="preencoded.png">    </p:cNvPr>
-          <p:cNvPicPr>
-            <a:picLocks noChangeAspect="1"/>
-          </p:cNvPicPr>
-          <p:nvPr/>
-        </p:nvPicPr>
-        <p:blipFill>
-          <a:blip r:embed="rId2"/>
-          <a:stretch>
-            <a:fillRect/>
-          </a:stretch>
-        </p:blipFill>
-        <p:spPr>
-          <a:xfrm>
-            <a:off x="4857750" y="1124415"/>
-            <a:ext cx="3571875" cy="2857500"/>
-          </a:xfrm>
-          <a:prstGeom prst="rect">
-            <a:avLst/>
-          </a:prstGeom>
-        </p:spPr>
-      </p:pic>
     </p:spTree>
   </p:cSld>
   <p:clrMapOvr>

</xml_diff>

<commit_message>
Clarify adaptive schedule is simulated and explain methodology
</commit_message>
<xml_diff>
--- a/FC_Inverter_Presentation.pptx
+++ b/FC_Inverter_Presentation.pptx
@@ -602,7 +602,7 @@
           <a:p>
             <a:r>
               <a:rPr lang="en-US" dirty="0"/>
-              <a:t>Given the insights from our loss analysis, we developed an adaptive switching frequency schedule. For urban driving below 60 kilometers per hour, we drop the switching frequency to 5 kHz. Between 60 and 90 kilometers per hour, we use 10 kHz, and for highway speeds above 90 kilometers per hour, we maintain 20 kHz. This adaptive approach yields a massive 75% reduction in switching losses during urban driving, dropping from 84.3 watts to just 21.1 watts per phase. This translates to a total 3-phase saving of 190 watts at 40 kilometers per hour, directly extending EV range. Importantly, our THD remains excellent, even at 5 kHz. This intelligent scheduling dramatically improves efficiency, and we'll now look at its thermal implications.</a:t>
+              <a:t>So, based on that analysis, we implemented an adaptive switching frequency schedule. This isn't just an analytical guess; it's fully validated in our dynamic time-domain simulation. The core idea is to maintain a sufficient frequency modulation ratio, or mf, which is the ratio of switching frequency to electrical frequency. At low speeds, like urban driving at 40 kilometers per hour, the electrical frequency is low. So, we can drop the switching frequency to 5 kHz and still keep a high enough mf. This reduces switching losses by 75% when the current is highest. But at high speeds, like highway driving at 120 kilometers per hour, the electrical frequency is much higher. Here, the controller automatically increases the switching frequency to 20 kHz to prevent distortion. This intelligent scheduling dramatically improves efficiency, and we'll now look at its thermal implications.</a:t>
             </a:r>
             <a:endParaRPr lang="en-US" dirty="0"/>
           </a:p>
@@ -2185,16 +2185,57 @@
         <p:spPr>
           <a:xfrm>
             <a:off x="571500" y="0"/>
-            <a:ext cx="8001000" cy="688646"/>
-          </a:xfrm>
-          <a:prstGeom prst="rect">
-            <a:avLst/>
-          </a:prstGeom>
-          <a:noFill/>
-          <a:ln/>
-        </p:spPr>
-        <p:txBody>
-          <a:bodyPr wrap="square" lIns="0" tIns="510286" rIns="0" bIns="0" rtlCol="0" anchor="t">
+            <a:ext cx="8572500" cy="207169"/>
+          </a:xfrm>
+          <a:prstGeom prst="rect">
+            <a:avLst/>
+          </a:prstGeom>
+          <a:noFill/>
+          <a:ln/>
+        </p:spPr>
+        <p:txBody>
+          <a:bodyPr wrap="square" lIns="0" tIns="102108" rIns="0" bIns="0" rtlCol="0" anchor="t">
+            <a:spAutoFit/>
+          </a:bodyPr>
+          <a:lstStyle/>
+          <a:p>
+            <a:pPr algn="l" indent="0" marL="0">
+              <a:buNone/>
+            </a:pPr>
+            <a:r>
+              <a:rPr lang="en-US" sz="700" dirty="0">
+                <a:solidFill>
+                  <a:srgbClr val="2563EB"/>
+                </a:solidFill>
+                <a:latin typeface="Inter SemiBold" pitchFamily="34" charset="0"/>
+                <a:ea typeface="Inter SemiBold" pitchFamily="34" charset="-122"/>
+                <a:cs typeface="Inter SemiBold" pitchFamily="34" charset="-120"/>
+              </a:rPr>
+              <a:t>ECE 595 — PURDUE UNIVERSITY</a:t>
+            </a:r>
+            <a:endParaRPr lang="en-US" sz="700" dirty="0"/>
+          </a:p>
+        </p:txBody>
+      </p:sp>
+      <p:sp>
+        <p:nvSpPr>
+          <p:cNvPr id="5" name="Text 1"/>
+          <p:cNvSpPr/>
+          <p:nvPr/>
+        </p:nvSpPr>
+        <p:spPr>
+          <a:xfrm>
+            <a:off x="571500" y="207169"/>
+            <a:ext cx="8001000" cy="617209"/>
+          </a:xfrm>
+          <a:prstGeom prst="rect">
+            <a:avLst/>
+          </a:prstGeom>
+          <a:noFill/>
+          <a:ln/>
+        </p:spPr>
+        <p:txBody>
+          <a:bodyPr wrap="square" lIns="0" tIns="425196" rIns="0" bIns="0" rtlCol="0" anchor="t">
             <a:spAutoFit/>
           </a:bodyPr>
           <a:lstStyle/>
@@ -2214,15 +2255,1800 @@
                 <a:ea typeface="Inter Bold" pitchFamily="34" charset="-122"/>
                 <a:cs typeface="Inter Bold" pitchFamily="34" charset="-120"/>
               </a:rPr>
-              <a:t>Adaptive Switching Frequency Schedule</a:t>
+              <a:t>Simulated Adaptive Switching Frequency</a:t>
             </a:r>
             <a:endParaRPr lang="en-US" sz="1400" dirty="0"/>
+          </a:p>
+        </p:txBody>
+      </p:sp>
+      <p:sp>
+        <p:nvSpPr>
+          <p:cNvPr id="6" name="Text 2"/>
+          <p:cNvSpPr/>
+          <p:nvPr/>
+        </p:nvSpPr>
+        <p:spPr>
+          <a:xfrm>
+            <a:off x="571500" y="1102984"/>
+            <a:ext cx="4243388" cy="342900"/>
+          </a:xfrm>
+          <a:prstGeom prst="rect">
+            <a:avLst/>
+          </a:prstGeom>
+          <a:noFill/>
+          <a:ln/>
+        </p:spPr>
+        <p:txBody>
+          <a:bodyPr wrap="square" lIns="0" tIns="0" rIns="0" bIns="0" rtlCol="0" anchor="t">
+            <a:spAutoFit/>
+          </a:bodyPr>
+          <a:lstStyle/>
+          <a:p>
+            <a:pPr algn="l" indent="0" marL="0">
+              <a:lnSpc>
+                <a:spcPct val="128000"/>
+              </a:lnSpc>
+              <a:buNone/>
+            </a:pPr>
+            <a:r>
+              <a:rPr lang="en-US" sz="800" dirty="0">
+                <a:solidFill>
+                  <a:srgbClr val="333333"/>
+                </a:solidFill>
+                <a:latin typeface="Inter" pitchFamily="34" charset="0"/>
+                <a:ea typeface="Inter" pitchFamily="34" charset="-122"/>
+                <a:cs typeface="Inter" pitchFamily="34" charset="-120"/>
+              </a:rPr>
+              <a:t>An adaptive switching frequency schedule was </a:t>
+            </a:r>
+            <a:r>
+              <a:rPr lang="en-US" sz="750" b="1" dirty="0">
+                <a:solidFill>
+                  <a:srgbClr val="000000"/>
+                </a:solidFill>
+                <a:latin typeface="Inter Bold" pitchFamily="34" charset="0"/>
+                <a:ea typeface="Inter Bold" pitchFamily="34" charset="-122"/>
+                <a:cs typeface="Inter Bold" pitchFamily="34" charset="-120"/>
+              </a:rPr>
+              <a:t>fully implemented and validated </a:t>
+            </a:r>
+            <a:r>
+              <a:rPr lang="en-US" sz="750" b="1" dirty="0">
+                <a:solidFill>
+                  <a:srgbClr val="000000"/>
+                </a:solidFill>
+                <a:latin typeface="Inter Bold" pitchFamily="34" charset="0"/>
+                <a:ea typeface="Inter Bold" pitchFamily="34" charset="-122"/>
+                <a:cs typeface="Inter Bold" pitchFamily="34" charset="-120"/>
+              </a:rPr>
+              <a:t>within the dynamic time-domain simulation</a:t>
+            </a:r>
+            <a:r>
+              <a:rPr lang="en-US" sz="800" dirty="0">
+                <a:solidFill>
+                  <a:srgbClr val="333333"/>
+                </a:solidFill>
+                <a:latin typeface="Inter" pitchFamily="34" charset="0"/>
+                <a:ea typeface="Inter" pitchFamily="34" charset="-122"/>
+                <a:cs typeface="Inter" pitchFamily="34" charset="-120"/>
+              </a:rPr>
+              <a:t>.</a:t>
+            </a:r>
+            <a:endParaRPr lang="en-US" sz="800" dirty="0"/>
+          </a:p>
+        </p:txBody>
+      </p:sp>
+      <p:sp>
+        <p:nvSpPr>
+          <p:cNvPr id="7" name="Text 3"/>
+          <p:cNvSpPr/>
+          <p:nvPr/>
+        </p:nvSpPr>
+        <p:spPr>
+          <a:xfrm>
+            <a:off x="571500" y="1581615"/>
+            <a:ext cx="2593181" cy="128588"/>
+          </a:xfrm>
+          <a:prstGeom prst="rect">
+            <a:avLst/>
+          </a:prstGeom>
+          <a:noFill/>
+          <a:ln/>
+        </p:spPr>
+        <p:txBody>
+          <a:bodyPr wrap="none" lIns="0" tIns="0" rIns="0" bIns="0" rtlCol="0" anchor="t">
+            <a:spAutoFit/>
+          </a:bodyPr>
+          <a:lstStyle/>
+          <a:p>
+            <a:pPr algn="l" indent="0" marL="0">
+              <a:lnSpc>
+                <a:spcPct val="128000"/>
+              </a:lnSpc>
+              <a:buNone/>
+            </a:pPr>
+            <a:r>
+              <a:rPr lang="en-US" sz="800" dirty="0">
+                <a:solidFill>
+                  <a:srgbClr val="333333"/>
+                </a:solidFill>
+                <a:latin typeface="Inter" pitchFamily="34" charset="0"/>
+                <a:ea typeface="Inter" pitchFamily="34" charset="-122"/>
+                <a:cs typeface="Inter" pitchFamily="34" charset="-120"/>
+              </a:rPr>
+              <a:t>The methodology relies on maintaining a sufficient</a:t>
+            </a:r>
+            <a:endParaRPr lang="en-US" sz="800" dirty="0"/>
+          </a:p>
+        </p:txBody>
+      </p:sp>
+      <p:sp>
+        <p:nvSpPr>
+          <p:cNvPr id="8" name="Text 4"/>
+          <p:cNvSpPr/>
+          <p:nvPr/>
+        </p:nvSpPr>
+        <p:spPr>
+          <a:xfrm>
+            <a:off x="3164681" y="1581615"/>
+            <a:ext cx="1580555" cy="128588"/>
+          </a:xfrm>
+          <a:prstGeom prst="rect">
+            <a:avLst/>
+          </a:prstGeom>
+          <a:noFill/>
+          <a:ln/>
+        </p:spPr>
+        <p:txBody>
+          <a:bodyPr wrap="none" lIns="0" tIns="0" rIns="0" bIns="0" rtlCol="0" anchor="t">
+            <a:spAutoFit/>
+          </a:bodyPr>
+          <a:lstStyle/>
+          <a:p>
+            <a:pPr algn="l" indent="0" marL="0">
+              <a:lnSpc>
+                <a:spcPct val="128000"/>
+              </a:lnSpc>
+              <a:buNone/>
+            </a:pPr>
+            <a:r>
+              <a:rPr lang="en-US" sz="750" b="1" dirty="0">
+                <a:solidFill>
+                  <a:srgbClr val="000000"/>
+                </a:solidFill>
+                <a:latin typeface="Inter Bold" pitchFamily="34" charset="0"/>
+                <a:ea typeface="Inter Bold" pitchFamily="34" charset="-122"/>
+                <a:cs typeface="Inter Bold" pitchFamily="34" charset="-120"/>
+              </a:rPr>
+              <a:t>frequency modulation ratio (m</a:t>
+            </a:r>
+            <a:endParaRPr lang="en-US" sz="750" dirty="0"/>
+          </a:p>
+        </p:txBody>
+      </p:sp>
+      <p:sp>
+        <p:nvSpPr>
+          <p:cNvPr id="9" name="Text 5"/>
+          <p:cNvSpPr/>
+          <p:nvPr/>
+        </p:nvSpPr>
+        <p:spPr>
+          <a:xfrm>
+            <a:off x="4745236" y="1622692"/>
+            <a:ext cx="35719" cy="107156"/>
+          </a:xfrm>
+          <a:prstGeom prst="rect">
+            <a:avLst/>
+          </a:prstGeom>
+          <a:noFill/>
+          <a:ln/>
+        </p:spPr>
+        <p:txBody>
+          <a:bodyPr wrap="none" lIns="0" tIns="0" rIns="0" bIns="0" rtlCol="0" anchor="t">
+            <a:spAutoFit/>
+          </a:bodyPr>
+          <a:lstStyle/>
+          <a:p>
+            <a:pPr algn="l" indent="0" marL="0">
+              <a:lnSpc>
+                <a:spcPct val="128000"/>
+              </a:lnSpc>
+              <a:buNone/>
+            </a:pPr>
+            <a:r>
+              <a:rPr lang="en-US" sz="600" b="1" baseline="-40000" dirty="0">
+                <a:solidFill>
+                  <a:srgbClr val="000000"/>
+                </a:solidFill>
+                <a:latin typeface="Inter Bold" pitchFamily="34" charset="0"/>
+                <a:ea typeface="Inter Bold" pitchFamily="34" charset="-122"/>
+                <a:cs typeface="Inter Bold" pitchFamily="34" charset="-120"/>
+              </a:rPr>
+              <a:t>f</a:t>
+            </a:r>
+            <a:endParaRPr lang="en-US" sz="600" dirty="0"/>
+          </a:p>
+        </p:txBody>
+      </p:sp>
+      <p:sp>
+        <p:nvSpPr>
+          <p:cNvPr id="10" name="Text 6"/>
+          <p:cNvSpPr/>
+          <p:nvPr/>
+        </p:nvSpPr>
+        <p:spPr>
+          <a:xfrm>
+            <a:off x="571500" y="1769139"/>
+            <a:ext cx="141089" cy="128588"/>
+          </a:xfrm>
+          <a:prstGeom prst="rect">
+            <a:avLst/>
+          </a:prstGeom>
+          <a:noFill/>
+          <a:ln/>
+        </p:spPr>
+        <p:txBody>
+          <a:bodyPr wrap="none" lIns="0" tIns="0" rIns="0" bIns="0" rtlCol="0" anchor="t">
+            <a:spAutoFit/>
+          </a:bodyPr>
+          <a:lstStyle/>
+          <a:p>
+            <a:pPr algn="l" indent="0" marL="0">
+              <a:lnSpc>
+                <a:spcPct val="128000"/>
+              </a:lnSpc>
+              <a:buNone/>
+            </a:pPr>
+            <a:r>
+              <a:rPr lang="en-US" sz="750" b="1" dirty="0">
+                <a:solidFill>
+                  <a:srgbClr val="000000"/>
+                </a:solidFill>
+                <a:latin typeface="Inter Bold" pitchFamily="34" charset="0"/>
+                <a:ea typeface="Inter Bold" pitchFamily="34" charset="-122"/>
+                <a:cs typeface="Inter Bold" pitchFamily="34" charset="-120"/>
+              </a:rPr>
+              <a:t>= f</a:t>
+            </a:r>
+            <a:endParaRPr lang="en-US" sz="750" dirty="0"/>
+          </a:p>
+        </p:txBody>
+      </p:sp>
+      <p:sp>
+        <p:nvSpPr>
+          <p:cNvPr id="11" name="Text 7"/>
+          <p:cNvSpPr/>
+          <p:nvPr/>
+        </p:nvSpPr>
+        <p:spPr>
+          <a:xfrm>
+            <a:off x="712589" y="1810215"/>
+            <a:ext cx="126802" cy="107156"/>
+          </a:xfrm>
+          <a:prstGeom prst="rect">
+            <a:avLst/>
+          </a:prstGeom>
+          <a:noFill/>
+          <a:ln/>
+        </p:spPr>
+        <p:txBody>
+          <a:bodyPr wrap="none" lIns="0" tIns="0" rIns="0" bIns="0" rtlCol="0" anchor="t">
+            <a:spAutoFit/>
+          </a:bodyPr>
+          <a:lstStyle/>
+          <a:p>
+            <a:pPr algn="l" indent="0" marL="0">
+              <a:lnSpc>
+                <a:spcPct val="128000"/>
+              </a:lnSpc>
+              <a:buNone/>
+            </a:pPr>
+            <a:r>
+              <a:rPr lang="en-US" sz="600" b="1" baseline="-40000" dirty="0">
+                <a:solidFill>
+                  <a:srgbClr val="000000"/>
+                </a:solidFill>
+                <a:latin typeface="Inter Bold" pitchFamily="34" charset="0"/>
+                <a:ea typeface="Inter Bold" pitchFamily="34" charset="-122"/>
+                <a:cs typeface="Inter Bold" pitchFamily="34" charset="-120"/>
+              </a:rPr>
+              <a:t>sw</a:t>
+            </a:r>
+            <a:endParaRPr lang="en-US" sz="600" dirty="0"/>
+          </a:p>
+        </p:txBody>
+      </p:sp>
+      <p:sp>
+        <p:nvSpPr>
+          <p:cNvPr id="12" name="Text 8"/>
+          <p:cNvSpPr/>
+          <p:nvPr/>
+        </p:nvSpPr>
+        <p:spPr>
+          <a:xfrm>
+            <a:off x="839391" y="1769139"/>
+            <a:ext cx="133945" cy="128588"/>
+          </a:xfrm>
+          <a:prstGeom prst="rect">
+            <a:avLst/>
+          </a:prstGeom>
+          <a:noFill/>
+          <a:ln/>
+        </p:spPr>
+        <p:txBody>
+          <a:bodyPr wrap="none" lIns="0" tIns="0" rIns="0" bIns="0" rtlCol="0" anchor="t">
+            <a:spAutoFit/>
+          </a:bodyPr>
+          <a:lstStyle/>
+          <a:p>
+            <a:pPr algn="l" indent="0" marL="0">
+              <a:lnSpc>
+                <a:spcPct val="128000"/>
+              </a:lnSpc>
+              <a:buNone/>
+            </a:pPr>
+            <a:r>
+              <a:rPr lang="en-US" sz="750" b="1" dirty="0">
+                <a:solidFill>
+                  <a:srgbClr val="000000"/>
+                </a:solidFill>
+                <a:latin typeface="Inter Bold" pitchFamily="34" charset="0"/>
+                <a:ea typeface="Inter Bold" pitchFamily="34" charset="-122"/>
+                <a:cs typeface="Inter Bold" pitchFamily="34" charset="-120"/>
+              </a:rPr>
+              <a:t>/ f</a:t>
+            </a:r>
+            <a:endParaRPr lang="en-US" sz="750" dirty="0"/>
+          </a:p>
+        </p:txBody>
+      </p:sp>
+      <p:sp>
+        <p:nvSpPr>
+          <p:cNvPr id="13" name="Text 9"/>
+          <p:cNvSpPr/>
+          <p:nvPr/>
+        </p:nvSpPr>
+        <p:spPr>
+          <a:xfrm>
+            <a:off x="973336" y="1810215"/>
+            <a:ext cx="53578" cy="107156"/>
+          </a:xfrm>
+          <a:prstGeom prst="rect">
+            <a:avLst/>
+          </a:prstGeom>
+          <a:noFill/>
+          <a:ln/>
+        </p:spPr>
+        <p:txBody>
+          <a:bodyPr wrap="none" lIns="0" tIns="0" rIns="0" bIns="0" rtlCol="0" anchor="t">
+            <a:spAutoFit/>
+          </a:bodyPr>
+          <a:lstStyle/>
+          <a:p>
+            <a:pPr algn="l" indent="0" marL="0">
+              <a:lnSpc>
+                <a:spcPct val="128000"/>
+              </a:lnSpc>
+              <a:buNone/>
+            </a:pPr>
+            <a:r>
+              <a:rPr lang="en-US" sz="600" b="1" baseline="-40000" dirty="0">
+                <a:solidFill>
+                  <a:srgbClr val="000000"/>
+                </a:solidFill>
+                <a:latin typeface="Inter Bold" pitchFamily="34" charset="0"/>
+                <a:ea typeface="Inter Bold" pitchFamily="34" charset="-122"/>
+                <a:cs typeface="Inter Bold" pitchFamily="34" charset="-120"/>
+              </a:rPr>
+              <a:t>e</a:t>
+            </a:r>
+            <a:endParaRPr lang="en-US" sz="600" dirty="0"/>
+          </a:p>
+        </p:txBody>
+      </p:sp>
+      <p:sp>
+        <p:nvSpPr>
+          <p:cNvPr id="14" name="Text 10"/>
+          <p:cNvSpPr/>
+          <p:nvPr/>
+        </p:nvSpPr>
+        <p:spPr>
+          <a:xfrm>
+            <a:off x="1026914" y="1769139"/>
+            <a:ext cx="41077" cy="128588"/>
+          </a:xfrm>
+          <a:prstGeom prst="rect">
+            <a:avLst/>
+          </a:prstGeom>
+          <a:noFill/>
+          <a:ln/>
+        </p:spPr>
+        <p:txBody>
+          <a:bodyPr wrap="none" lIns="0" tIns="0" rIns="0" bIns="0" rtlCol="0" anchor="t">
+            <a:spAutoFit/>
+          </a:bodyPr>
+          <a:lstStyle/>
+          <a:p>
+            <a:pPr algn="l" indent="0" marL="0">
+              <a:lnSpc>
+                <a:spcPct val="128000"/>
+              </a:lnSpc>
+              <a:buNone/>
+            </a:pPr>
+            <a:r>
+              <a:rPr lang="en-US" sz="750" b="1" dirty="0">
+                <a:solidFill>
+                  <a:srgbClr val="000000"/>
+                </a:solidFill>
+                <a:latin typeface="Inter Bold" pitchFamily="34" charset="0"/>
+                <a:ea typeface="Inter Bold" pitchFamily="34" charset="-122"/>
+                <a:cs typeface="Inter Bold" pitchFamily="34" charset="-120"/>
+              </a:rPr>
+              <a:t>)</a:t>
+            </a:r>
+            <a:endParaRPr lang="en-US" sz="750" dirty="0"/>
+          </a:p>
+        </p:txBody>
+      </p:sp>
+      <p:sp>
+        <p:nvSpPr>
+          <p:cNvPr id="15" name="Text 11"/>
+          <p:cNvSpPr/>
+          <p:nvPr/>
+        </p:nvSpPr>
+        <p:spPr>
+          <a:xfrm>
+            <a:off x="1067991" y="1769139"/>
+            <a:ext cx="2671763" cy="128588"/>
+          </a:xfrm>
+          <a:prstGeom prst="rect">
+            <a:avLst/>
+          </a:prstGeom>
+          <a:noFill/>
+          <a:ln/>
+        </p:spPr>
+        <p:txBody>
+          <a:bodyPr wrap="none" lIns="0" tIns="0" rIns="0" bIns="0" rtlCol="0" anchor="t">
+            <a:spAutoFit/>
+          </a:bodyPr>
+          <a:lstStyle/>
+          <a:p>
+            <a:pPr algn="l" indent="0" marL="0">
+              <a:lnSpc>
+                <a:spcPct val="128000"/>
+              </a:lnSpc>
+              <a:buNone/>
+            </a:pPr>
+            <a:r>
+              <a:rPr lang="en-US" sz="800" dirty="0">
+                <a:solidFill>
+                  <a:srgbClr val="333333"/>
+                </a:solidFill>
+                <a:latin typeface="Inter" pitchFamily="34" charset="0"/>
+                <a:ea typeface="Inter" pitchFamily="34" charset="-122"/>
+                <a:cs typeface="Inter" pitchFamily="34" charset="-120"/>
+              </a:rPr>
+              <a:t>to ensure waveform quality while minimizing losses:</a:t>
+            </a:r>
+            <a:endParaRPr lang="en-US" sz="800" dirty="0"/>
+          </a:p>
+        </p:txBody>
+      </p:sp>
+      <p:sp>
+        <p:nvSpPr>
+          <p:cNvPr id="16" name="Shape 12"/>
+          <p:cNvSpPr/>
+          <p:nvPr/>
+        </p:nvSpPr>
+        <p:spPr>
+          <a:xfrm>
+            <a:off x="571500" y="2049531"/>
+            <a:ext cx="4243388" cy="1030681"/>
+          </a:xfrm>
+          <a:prstGeom prst="rect">
+            <a:avLst/>
+          </a:prstGeom>
+          <a:solidFill>
+            <a:srgbClr val="F5F5F5"/>
+          </a:solidFill>
+          <a:ln/>
+        </p:spPr>
+      </p:sp>
+      <p:sp>
+        <p:nvSpPr>
+          <p:cNvPr id="17" name="Shape 13"/>
+          <p:cNvSpPr/>
+          <p:nvPr/>
+        </p:nvSpPr>
+        <p:spPr>
+          <a:xfrm>
+            <a:off x="571500" y="2049531"/>
+            <a:ext cx="28575" cy="1030681"/>
+          </a:xfrm>
+          <a:prstGeom prst="rect">
+            <a:avLst/>
+          </a:prstGeom>
+          <a:solidFill>
+            <a:srgbClr val="2563EB"/>
+          </a:solidFill>
+          <a:ln/>
+        </p:spPr>
+      </p:sp>
+      <p:sp>
+        <p:nvSpPr>
+          <p:cNvPr id="18" name="Text 14"/>
+          <p:cNvSpPr/>
+          <p:nvPr/>
+        </p:nvSpPr>
+        <p:spPr>
+          <a:xfrm>
+            <a:off x="685800" y="2185262"/>
+            <a:ext cx="1139428" cy="137517"/>
+          </a:xfrm>
+          <a:prstGeom prst="rect">
+            <a:avLst/>
+          </a:prstGeom>
+          <a:noFill/>
+          <a:ln/>
+        </p:spPr>
+        <p:txBody>
+          <a:bodyPr wrap="none" lIns="0" tIns="0" rIns="0" bIns="0" rtlCol="0" anchor="t">
+            <a:spAutoFit/>
+          </a:bodyPr>
+          <a:lstStyle/>
+          <a:p>
+            <a:pPr algn="l" indent="0" marL="0">
+              <a:lnSpc>
+                <a:spcPct val="128000"/>
+              </a:lnSpc>
+              <a:buNone/>
+            </a:pPr>
+            <a:r>
+              <a:rPr lang="en-US" sz="800" b="1" dirty="0">
+                <a:solidFill>
+                  <a:srgbClr val="000000"/>
+                </a:solidFill>
+                <a:latin typeface="Inter Bold" pitchFamily="34" charset="0"/>
+                <a:ea typeface="Inter Bold" pitchFamily="34" charset="-122"/>
+                <a:cs typeface="Inter Bold" pitchFamily="34" charset="-120"/>
+              </a:rPr>
+              <a:t>Urban Driving (Low f</a:t>
+            </a:r>
+            <a:endParaRPr lang="en-US" sz="800" dirty="0"/>
+          </a:p>
+        </p:txBody>
+      </p:sp>
+      <p:sp>
+        <p:nvSpPr>
+          <p:cNvPr id="19" name="Text 15"/>
+          <p:cNvSpPr/>
+          <p:nvPr/>
+        </p:nvSpPr>
+        <p:spPr>
+          <a:xfrm>
+            <a:off x="1825228" y="2227762"/>
+            <a:ext cx="57150" cy="116086"/>
+          </a:xfrm>
+          <a:prstGeom prst="rect">
+            <a:avLst/>
+          </a:prstGeom>
+          <a:noFill/>
+          <a:ln/>
+        </p:spPr>
+        <p:txBody>
+          <a:bodyPr wrap="none" lIns="0" tIns="0" rIns="0" bIns="0" rtlCol="0" anchor="t">
+            <a:spAutoFit/>
+          </a:bodyPr>
+          <a:lstStyle/>
+          <a:p>
+            <a:pPr algn="l" indent="0" marL="0">
+              <a:lnSpc>
+                <a:spcPct val="128032"/>
+              </a:lnSpc>
+              <a:buNone/>
+            </a:pPr>
+            <a:r>
+              <a:rPr lang="en-US" sz="650" b="1" baseline="-40000" dirty="0">
+                <a:solidFill>
+                  <a:srgbClr val="000000"/>
+                </a:solidFill>
+                <a:latin typeface="Inter Bold" pitchFamily="34" charset="0"/>
+                <a:ea typeface="Inter Bold" pitchFamily="34" charset="-122"/>
+                <a:cs typeface="Inter Bold" pitchFamily="34" charset="-120"/>
+              </a:rPr>
+              <a:t>e</a:t>
+            </a:r>
+            <a:endParaRPr lang="en-US" sz="650" dirty="0"/>
+          </a:p>
+        </p:txBody>
+      </p:sp>
+      <p:sp>
+        <p:nvSpPr>
+          <p:cNvPr id="20" name="Text 16"/>
+          <p:cNvSpPr/>
+          <p:nvPr/>
+        </p:nvSpPr>
+        <p:spPr>
+          <a:xfrm>
+            <a:off x="1882378" y="2185262"/>
+            <a:ext cx="42863" cy="137517"/>
+          </a:xfrm>
+          <a:prstGeom prst="rect">
+            <a:avLst/>
+          </a:prstGeom>
+          <a:noFill/>
+          <a:ln/>
+        </p:spPr>
+        <p:txBody>
+          <a:bodyPr wrap="none" lIns="0" tIns="0" rIns="0" bIns="0" rtlCol="0" anchor="t">
+            <a:spAutoFit/>
+          </a:bodyPr>
+          <a:lstStyle/>
+          <a:p>
+            <a:pPr algn="l" indent="0" marL="0">
+              <a:lnSpc>
+                <a:spcPct val="128000"/>
+              </a:lnSpc>
+              <a:buNone/>
+            </a:pPr>
+            <a:r>
+              <a:rPr lang="en-US" sz="800" b="1" dirty="0">
+                <a:solidFill>
+                  <a:srgbClr val="000000"/>
+                </a:solidFill>
+                <a:latin typeface="Inter Bold" pitchFamily="34" charset="0"/>
+                <a:ea typeface="Inter Bold" pitchFamily="34" charset="-122"/>
+                <a:cs typeface="Inter Bold" pitchFamily="34" charset="-120"/>
+              </a:rPr>
+              <a:t>)</a:t>
+            </a:r>
+            <a:endParaRPr lang="en-US" sz="800" dirty="0"/>
+          </a:p>
+        </p:txBody>
+      </p:sp>
+      <p:sp>
+        <p:nvSpPr>
+          <p:cNvPr id="21" name="Text 17"/>
+          <p:cNvSpPr/>
+          <p:nvPr/>
+        </p:nvSpPr>
+        <p:spPr>
+          <a:xfrm>
+            <a:off x="685800" y="2440846"/>
+            <a:ext cx="660797" cy="128588"/>
+          </a:xfrm>
+          <a:prstGeom prst="rect">
+            <a:avLst/>
+          </a:prstGeom>
+          <a:noFill/>
+          <a:ln/>
+        </p:spPr>
+        <p:txBody>
+          <a:bodyPr wrap="none" lIns="0" tIns="0" rIns="0" bIns="0" rtlCol="0" anchor="t">
+            <a:spAutoFit/>
+          </a:bodyPr>
+          <a:lstStyle/>
+          <a:p>
+            <a:pPr algn="l" indent="0" marL="0">
+              <a:lnSpc>
+                <a:spcPct val="128000"/>
+              </a:lnSpc>
+              <a:buNone/>
+            </a:pPr>
+            <a:r>
+              <a:rPr lang="en-US" sz="800" dirty="0">
+                <a:solidFill>
+                  <a:srgbClr val="333333"/>
+                </a:solidFill>
+                <a:latin typeface="Inter" pitchFamily="34" charset="0"/>
+                <a:ea typeface="Inter" pitchFamily="34" charset="-122"/>
+                <a:cs typeface="Inter" pitchFamily="34" charset="-120"/>
+              </a:rPr>
+              <a:t>At 40 km/h, f</a:t>
+            </a:r>
+            <a:endParaRPr lang="en-US" sz="800" dirty="0"/>
+          </a:p>
+        </p:txBody>
+      </p:sp>
+      <p:sp>
+        <p:nvSpPr>
+          <p:cNvPr id="22" name="Text 18"/>
+          <p:cNvSpPr/>
+          <p:nvPr/>
+        </p:nvSpPr>
+        <p:spPr>
+          <a:xfrm>
+            <a:off x="1346597" y="2481923"/>
+            <a:ext cx="51792" cy="107156"/>
+          </a:xfrm>
+          <a:prstGeom prst="rect">
+            <a:avLst/>
+          </a:prstGeom>
+          <a:noFill/>
+          <a:ln/>
+        </p:spPr>
+        <p:txBody>
+          <a:bodyPr wrap="none" lIns="0" tIns="0" rIns="0" bIns="0" rtlCol="0" anchor="t">
+            <a:spAutoFit/>
+          </a:bodyPr>
+          <a:lstStyle/>
+          <a:p>
+            <a:pPr algn="l" indent="0" marL="0">
+              <a:lnSpc>
+                <a:spcPct val="128000"/>
+              </a:lnSpc>
+              <a:buNone/>
+            </a:pPr>
+            <a:r>
+              <a:rPr lang="en-US" sz="650" baseline="-40000" dirty="0">
+                <a:solidFill>
+                  <a:srgbClr val="333333"/>
+                </a:solidFill>
+                <a:latin typeface="Inter" pitchFamily="34" charset="0"/>
+                <a:ea typeface="Inter" pitchFamily="34" charset="-122"/>
+                <a:cs typeface="Inter" pitchFamily="34" charset="-120"/>
+              </a:rPr>
+              <a:t>e</a:t>
+            </a:r>
+            <a:endParaRPr lang="en-US" sz="650" dirty="0"/>
+          </a:p>
+        </p:txBody>
+      </p:sp>
+      <p:sp>
+        <p:nvSpPr>
+          <p:cNvPr id="23" name="Text 19"/>
+          <p:cNvSpPr/>
+          <p:nvPr/>
+        </p:nvSpPr>
+        <p:spPr>
+          <a:xfrm>
+            <a:off x="1398389" y="2440846"/>
+            <a:ext cx="3061097" cy="128588"/>
+          </a:xfrm>
+          <a:prstGeom prst="rect">
+            <a:avLst/>
+          </a:prstGeom>
+          <a:noFill/>
+          <a:ln/>
+        </p:spPr>
+        <p:txBody>
+          <a:bodyPr wrap="none" lIns="0" tIns="0" rIns="0" bIns="0" rtlCol="0" anchor="t">
+            <a:spAutoFit/>
+          </a:bodyPr>
+          <a:lstStyle/>
+          <a:p>
+            <a:pPr algn="l" indent="0" marL="0">
+              <a:lnSpc>
+                <a:spcPct val="128000"/>
+              </a:lnSpc>
+              <a:buNone/>
+            </a:pPr>
+            <a:r>
+              <a:rPr lang="en-US" sz="800" dirty="0">
+                <a:solidFill>
+                  <a:srgbClr val="333333"/>
+                </a:solidFill>
+                <a:latin typeface="Inter" pitchFamily="34" charset="0"/>
+                <a:ea typeface="Inter" pitchFamily="34" charset="-122"/>
+                <a:cs typeface="Inter" pitchFamily="34" charset="-120"/>
+              </a:rPr>
+              <a:t>is only 184 Hz. The simulated controller dynamically drops f</a:t>
+            </a:r>
+            <a:endParaRPr lang="en-US" sz="800" dirty="0"/>
+          </a:p>
+        </p:txBody>
+      </p:sp>
+      <p:sp>
+        <p:nvSpPr>
+          <p:cNvPr id="24" name="Text 20"/>
+          <p:cNvSpPr/>
+          <p:nvPr/>
+        </p:nvSpPr>
+        <p:spPr>
+          <a:xfrm>
+            <a:off x="4459486" y="2481923"/>
+            <a:ext cx="119658" cy="107156"/>
+          </a:xfrm>
+          <a:prstGeom prst="rect">
+            <a:avLst/>
+          </a:prstGeom>
+          <a:noFill/>
+          <a:ln/>
+        </p:spPr>
+        <p:txBody>
+          <a:bodyPr wrap="none" lIns="0" tIns="0" rIns="0" bIns="0" rtlCol="0" anchor="t">
+            <a:spAutoFit/>
+          </a:bodyPr>
+          <a:lstStyle/>
+          <a:p>
+            <a:pPr algn="l" indent="0" marL="0">
+              <a:lnSpc>
+                <a:spcPct val="128000"/>
+              </a:lnSpc>
+              <a:buNone/>
+            </a:pPr>
+            <a:r>
+              <a:rPr lang="en-US" sz="650" baseline="-40000" dirty="0">
+                <a:solidFill>
+                  <a:srgbClr val="333333"/>
+                </a:solidFill>
+                <a:latin typeface="Inter" pitchFamily="34" charset="0"/>
+                <a:ea typeface="Inter" pitchFamily="34" charset="-122"/>
+                <a:cs typeface="Inter" pitchFamily="34" charset="-120"/>
+              </a:rPr>
+              <a:t>sw</a:t>
+            </a:r>
+            <a:endParaRPr lang="en-US" sz="650" dirty="0"/>
+          </a:p>
+        </p:txBody>
+      </p:sp>
+      <p:sp>
+        <p:nvSpPr>
+          <p:cNvPr id="25" name="Text 21"/>
+          <p:cNvSpPr/>
+          <p:nvPr/>
+        </p:nvSpPr>
+        <p:spPr>
+          <a:xfrm>
+            <a:off x="685800" y="2628370"/>
+            <a:ext cx="128588" cy="128588"/>
+          </a:xfrm>
+          <a:prstGeom prst="rect">
+            <a:avLst/>
+          </a:prstGeom>
+          <a:noFill/>
+          <a:ln/>
+        </p:spPr>
+        <p:txBody>
+          <a:bodyPr wrap="none" lIns="0" tIns="0" rIns="0" bIns="0" rtlCol="0" anchor="t">
+            <a:spAutoFit/>
+          </a:bodyPr>
+          <a:lstStyle/>
+          <a:p>
+            <a:pPr algn="l" indent="0" marL="0">
+              <a:lnSpc>
+                <a:spcPct val="128000"/>
+              </a:lnSpc>
+              <a:buNone/>
+            </a:pPr>
+            <a:r>
+              <a:rPr lang="en-US" sz="800" dirty="0">
+                <a:solidFill>
+                  <a:srgbClr val="333333"/>
+                </a:solidFill>
+                <a:latin typeface="Inter" pitchFamily="34" charset="0"/>
+                <a:ea typeface="Inter" pitchFamily="34" charset="-122"/>
+                <a:cs typeface="Inter" pitchFamily="34" charset="-120"/>
+              </a:rPr>
+              <a:t>to</a:t>
+            </a:r>
+            <a:endParaRPr lang="en-US" sz="800" dirty="0"/>
+          </a:p>
+        </p:txBody>
+      </p:sp>
+      <p:sp>
+        <p:nvSpPr>
+          <p:cNvPr id="26" name="Text 22"/>
+          <p:cNvSpPr/>
+          <p:nvPr/>
+        </p:nvSpPr>
+        <p:spPr>
+          <a:xfrm>
+            <a:off x="814388" y="2628370"/>
+            <a:ext cx="294680" cy="128588"/>
+          </a:xfrm>
+          <a:prstGeom prst="rect">
+            <a:avLst/>
+          </a:prstGeom>
+          <a:noFill/>
+          <a:ln/>
+        </p:spPr>
+        <p:txBody>
+          <a:bodyPr wrap="none" lIns="0" tIns="0" rIns="0" bIns="0" rtlCol="0" anchor="t">
+            <a:spAutoFit/>
+          </a:bodyPr>
+          <a:lstStyle/>
+          <a:p>
+            <a:pPr algn="l" indent="0" marL="0">
+              <a:lnSpc>
+                <a:spcPct val="128000"/>
+              </a:lnSpc>
+              <a:buNone/>
+            </a:pPr>
+            <a:r>
+              <a:rPr lang="en-US" sz="750" b="1" dirty="0">
+                <a:solidFill>
+                  <a:srgbClr val="000000"/>
+                </a:solidFill>
+                <a:latin typeface="Inter Bold" pitchFamily="34" charset="0"/>
+                <a:ea typeface="Inter Bold" pitchFamily="34" charset="-122"/>
+                <a:cs typeface="Inter Bold" pitchFamily="34" charset="-120"/>
+              </a:rPr>
+              <a:t>5 kHz</a:t>
+            </a:r>
+            <a:endParaRPr lang="en-US" sz="750" dirty="0"/>
+          </a:p>
+        </p:txBody>
+      </p:sp>
+      <p:sp>
+        <p:nvSpPr>
+          <p:cNvPr id="27" name="Text 23"/>
+          <p:cNvSpPr/>
+          <p:nvPr/>
+        </p:nvSpPr>
+        <p:spPr>
+          <a:xfrm>
+            <a:off x="1109067" y="2628370"/>
+            <a:ext cx="855464" cy="128588"/>
+          </a:xfrm>
+          <a:prstGeom prst="rect">
+            <a:avLst/>
+          </a:prstGeom>
+          <a:noFill/>
+          <a:ln/>
+        </p:spPr>
+        <p:txBody>
+          <a:bodyPr wrap="none" lIns="0" tIns="0" rIns="0" bIns="0" rtlCol="0" anchor="t">
+            <a:spAutoFit/>
+          </a:bodyPr>
+          <a:lstStyle/>
+          <a:p>
+            <a:pPr algn="l" indent="0" marL="0">
+              <a:lnSpc>
+                <a:spcPct val="128000"/>
+              </a:lnSpc>
+              <a:buNone/>
+            </a:pPr>
+            <a:r>
+              <a:rPr lang="en-US" sz="800" dirty="0">
+                <a:solidFill>
+                  <a:srgbClr val="333333"/>
+                </a:solidFill>
+                <a:latin typeface="Inter" pitchFamily="34" charset="0"/>
+                <a:ea typeface="Inter" pitchFamily="34" charset="-122"/>
+                <a:cs typeface="Inter" pitchFamily="34" charset="-120"/>
+              </a:rPr>
+              <a:t>while keeping m</a:t>
+            </a:r>
+            <a:endParaRPr lang="en-US" sz="800" dirty="0"/>
+          </a:p>
+        </p:txBody>
+      </p:sp>
+      <p:sp>
+        <p:nvSpPr>
+          <p:cNvPr id="28" name="Text 24"/>
+          <p:cNvSpPr/>
+          <p:nvPr/>
+        </p:nvSpPr>
+        <p:spPr>
+          <a:xfrm>
+            <a:off x="1964531" y="2669446"/>
+            <a:ext cx="33933" cy="107156"/>
+          </a:xfrm>
+          <a:prstGeom prst="rect">
+            <a:avLst/>
+          </a:prstGeom>
+          <a:noFill/>
+          <a:ln/>
+        </p:spPr>
+        <p:txBody>
+          <a:bodyPr wrap="none" lIns="0" tIns="0" rIns="0" bIns="0" rtlCol="0" anchor="t">
+            <a:spAutoFit/>
+          </a:bodyPr>
+          <a:lstStyle/>
+          <a:p>
+            <a:pPr algn="l" indent="0" marL="0">
+              <a:lnSpc>
+                <a:spcPct val="128000"/>
+              </a:lnSpc>
+              <a:buNone/>
+            </a:pPr>
+            <a:r>
+              <a:rPr lang="en-US" sz="650" baseline="-40000" dirty="0">
+                <a:solidFill>
+                  <a:srgbClr val="333333"/>
+                </a:solidFill>
+                <a:latin typeface="Inter" pitchFamily="34" charset="0"/>
+                <a:ea typeface="Inter" pitchFamily="34" charset="-122"/>
+                <a:cs typeface="Inter" pitchFamily="34" charset="-120"/>
+              </a:rPr>
+              <a:t>f</a:t>
+            </a:r>
+            <a:endParaRPr lang="en-US" sz="650" dirty="0"/>
+          </a:p>
+        </p:txBody>
+      </p:sp>
+      <p:sp>
+        <p:nvSpPr>
+          <p:cNvPr id="29" name="Text 25"/>
+          <p:cNvSpPr/>
+          <p:nvPr/>
+        </p:nvSpPr>
+        <p:spPr>
+          <a:xfrm>
+            <a:off x="1998464" y="2628370"/>
+            <a:ext cx="1410779" cy="128588"/>
+          </a:xfrm>
+          <a:prstGeom prst="rect">
+            <a:avLst/>
+          </a:prstGeom>
+          <a:noFill/>
+          <a:ln/>
+        </p:spPr>
+        <p:txBody>
+          <a:bodyPr wrap="none" lIns="0" tIns="0" rIns="0" bIns="0" rtlCol="0" anchor="t">
+            <a:spAutoFit/>
+          </a:bodyPr>
+          <a:lstStyle/>
+          <a:p>
+            <a:pPr algn="l" indent="0" marL="0">
+              <a:lnSpc>
+                <a:spcPct val="128000"/>
+              </a:lnSpc>
+              <a:buNone/>
+            </a:pPr>
+            <a:r>
+              <a:rPr lang="en-US" sz="800" dirty="0">
+                <a:solidFill>
+                  <a:srgbClr val="333333"/>
+                </a:solidFill>
+                <a:latin typeface="Inter" pitchFamily="34" charset="0"/>
+                <a:ea typeface="Inter" pitchFamily="34" charset="-122"/>
+                <a:cs typeface="Inter" pitchFamily="34" charset="-120"/>
+              </a:rPr>
+              <a:t>≈ 27. This yields a massive</a:t>
+            </a:r>
+            <a:endParaRPr lang="en-US" sz="800" dirty="0"/>
+          </a:p>
+        </p:txBody>
+      </p:sp>
+      <p:sp>
+        <p:nvSpPr>
+          <p:cNvPr id="30" name="Text 26"/>
+          <p:cNvSpPr/>
+          <p:nvPr/>
+        </p:nvSpPr>
+        <p:spPr>
+          <a:xfrm>
+            <a:off x="3409243" y="2628370"/>
+            <a:ext cx="762595" cy="128588"/>
+          </a:xfrm>
+          <a:prstGeom prst="rect">
+            <a:avLst/>
+          </a:prstGeom>
+          <a:noFill/>
+          <a:ln/>
+        </p:spPr>
+        <p:txBody>
+          <a:bodyPr wrap="none" lIns="0" tIns="0" rIns="0" bIns="0" rtlCol="0" anchor="t">
+            <a:spAutoFit/>
+          </a:bodyPr>
+          <a:lstStyle/>
+          <a:p>
+            <a:pPr algn="l" indent="0" marL="0">
+              <a:lnSpc>
+                <a:spcPct val="128000"/>
+              </a:lnSpc>
+              <a:buNone/>
+            </a:pPr>
+            <a:r>
+              <a:rPr lang="en-US" sz="750" b="1" dirty="0">
+                <a:solidFill>
+                  <a:srgbClr val="000000"/>
+                </a:solidFill>
+                <a:latin typeface="Inter Bold" pitchFamily="34" charset="0"/>
+                <a:ea typeface="Inter Bold" pitchFamily="34" charset="-122"/>
+                <a:cs typeface="Inter Bold" pitchFamily="34" charset="-120"/>
+              </a:rPr>
+              <a:t>75% reduction</a:t>
+            </a:r>
+            <a:endParaRPr lang="en-US" sz="750" dirty="0"/>
+          </a:p>
+        </p:txBody>
+      </p:sp>
+      <p:sp>
+        <p:nvSpPr>
+          <p:cNvPr id="31" name="Text 27"/>
+          <p:cNvSpPr/>
+          <p:nvPr/>
+        </p:nvSpPr>
+        <p:spPr>
+          <a:xfrm>
+            <a:off x="4171838" y="2628370"/>
+            <a:ext cx="119658" cy="128588"/>
+          </a:xfrm>
+          <a:prstGeom prst="rect">
+            <a:avLst/>
+          </a:prstGeom>
+          <a:noFill/>
+          <a:ln/>
+        </p:spPr>
+        <p:txBody>
+          <a:bodyPr wrap="none" lIns="0" tIns="0" rIns="0" bIns="0" rtlCol="0" anchor="t">
+            <a:spAutoFit/>
+          </a:bodyPr>
+          <a:lstStyle/>
+          <a:p>
+            <a:pPr algn="l" indent="0" marL="0">
+              <a:lnSpc>
+                <a:spcPct val="128000"/>
+              </a:lnSpc>
+              <a:buNone/>
+            </a:pPr>
+            <a:r>
+              <a:rPr lang="en-US" sz="800" dirty="0">
+                <a:solidFill>
+                  <a:srgbClr val="333333"/>
+                </a:solidFill>
+                <a:latin typeface="Inter" pitchFamily="34" charset="0"/>
+                <a:ea typeface="Inter" pitchFamily="34" charset="-122"/>
+                <a:cs typeface="Inter" pitchFamily="34" charset="-120"/>
+              </a:rPr>
+              <a:t>in</a:t>
+            </a:r>
+            <a:endParaRPr lang="en-US" sz="800" dirty="0"/>
+          </a:p>
+        </p:txBody>
+      </p:sp>
+      <p:sp>
+        <p:nvSpPr>
+          <p:cNvPr id="32" name="Text 28"/>
+          <p:cNvSpPr/>
+          <p:nvPr/>
+        </p:nvSpPr>
+        <p:spPr>
+          <a:xfrm>
+            <a:off x="685800" y="2815893"/>
+            <a:ext cx="3402211" cy="128588"/>
+          </a:xfrm>
+          <a:prstGeom prst="rect">
+            <a:avLst/>
+          </a:prstGeom>
+          <a:noFill/>
+          <a:ln/>
+        </p:spPr>
+        <p:txBody>
+          <a:bodyPr wrap="none" lIns="0" tIns="0" rIns="0" bIns="0" rtlCol="0" anchor="t">
+            <a:spAutoFit/>
+          </a:bodyPr>
+          <a:lstStyle/>
+          <a:p>
+            <a:pPr algn="l" indent="0" marL="0">
+              <a:lnSpc>
+                <a:spcPct val="128000"/>
+              </a:lnSpc>
+              <a:buNone/>
+            </a:pPr>
+            <a:r>
+              <a:rPr lang="en-US" sz="800" dirty="0">
+                <a:solidFill>
+                  <a:srgbClr val="333333"/>
+                </a:solidFill>
+                <a:latin typeface="Inter" pitchFamily="34" charset="0"/>
+                <a:ea typeface="Inter" pitchFamily="34" charset="-122"/>
+                <a:cs typeface="Inter" pitchFamily="34" charset="-120"/>
+              </a:rPr>
+              <a:t>switching losses exactly when the phase current is highest (136 A).</a:t>
+            </a:r>
+            <a:endParaRPr lang="en-US" sz="800" dirty="0"/>
+          </a:p>
+        </p:txBody>
+      </p:sp>
+      <p:sp>
+        <p:nvSpPr>
+          <p:cNvPr id="33" name="Shape 29"/>
+          <p:cNvSpPr/>
+          <p:nvPr/>
+        </p:nvSpPr>
+        <p:spPr>
+          <a:xfrm>
+            <a:off x="571500" y="3194512"/>
+            <a:ext cx="4243388" cy="1030681"/>
+          </a:xfrm>
+          <a:prstGeom prst="rect">
+            <a:avLst/>
+          </a:prstGeom>
+          <a:solidFill>
+            <a:srgbClr val="F5F5F5"/>
+          </a:solidFill>
+          <a:ln/>
+        </p:spPr>
+      </p:sp>
+      <p:sp>
+        <p:nvSpPr>
+          <p:cNvPr id="34" name="Shape 30"/>
+          <p:cNvSpPr/>
+          <p:nvPr/>
+        </p:nvSpPr>
+        <p:spPr>
+          <a:xfrm>
+            <a:off x="571500" y="3194512"/>
+            <a:ext cx="28575" cy="1030681"/>
+          </a:xfrm>
+          <a:prstGeom prst="rect">
+            <a:avLst/>
+          </a:prstGeom>
+          <a:solidFill>
+            <a:srgbClr val="2563EB"/>
+          </a:solidFill>
+          <a:ln/>
+        </p:spPr>
+      </p:sp>
+      <p:sp>
+        <p:nvSpPr>
+          <p:cNvPr id="35" name="Text 31"/>
+          <p:cNvSpPr/>
+          <p:nvPr/>
+        </p:nvSpPr>
+        <p:spPr>
+          <a:xfrm>
+            <a:off x="685800" y="3330243"/>
+            <a:ext cx="1316236" cy="137517"/>
+          </a:xfrm>
+          <a:prstGeom prst="rect">
+            <a:avLst/>
+          </a:prstGeom>
+          <a:noFill/>
+          <a:ln/>
+        </p:spPr>
+        <p:txBody>
+          <a:bodyPr wrap="none" lIns="0" tIns="0" rIns="0" bIns="0" rtlCol="0" anchor="t">
+            <a:spAutoFit/>
+          </a:bodyPr>
+          <a:lstStyle/>
+          <a:p>
+            <a:pPr algn="l" indent="0" marL="0">
+              <a:lnSpc>
+                <a:spcPct val="128000"/>
+              </a:lnSpc>
+              <a:buNone/>
+            </a:pPr>
+            <a:r>
+              <a:rPr lang="en-US" sz="800" b="1" dirty="0">
+                <a:solidFill>
+                  <a:srgbClr val="000000"/>
+                </a:solidFill>
+                <a:latin typeface="Inter Bold" pitchFamily="34" charset="0"/>
+                <a:ea typeface="Inter Bold" pitchFamily="34" charset="-122"/>
+                <a:cs typeface="Inter Bold" pitchFamily="34" charset="-120"/>
+              </a:rPr>
+              <a:t>Highway Driving (High f</a:t>
+            </a:r>
+            <a:endParaRPr lang="en-US" sz="800" dirty="0"/>
+          </a:p>
+        </p:txBody>
+      </p:sp>
+      <p:sp>
+        <p:nvSpPr>
+          <p:cNvPr id="36" name="Text 32"/>
+          <p:cNvSpPr/>
+          <p:nvPr/>
+        </p:nvSpPr>
+        <p:spPr>
+          <a:xfrm>
+            <a:off x="2002036" y="3372743"/>
+            <a:ext cx="57150" cy="116086"/>
+          </a:xfrm>
+          <a:prstGeom prst="rect">
+            <a:avLst/>
+          </a:prstGeom>
+          <a:noFill/>
+          <a:ln/>
+        </p:spPr>
+        <p:txBody>
+          <a:bodyPr wrap="none" lIns="0" tIns="0" rIns="0" bIns="0" rtlCol="0" anchor="t">
+            <a:spAutoFit/>
+          </a:bodyPr>
+          <a:lstStyle/>
+          <a:p>
+            <a:pPr algn="l" indent="0" marL="0">
+              <a:lnSpc>
+                <a:spcPct val="128032"/>
+              </a:lnSpc>
+              <a:buNone/>
+            </a:pPr>
+            <a:r>
+              <a:rPr lang="en-US" sz="650" b="1" baseline="-40000" dirty="0">
+                <a:solidFill>
+                  <a:srgbClr val="000000"/>
+                </a:solidFill>
+                <a:latin typeface="Inter Bold" pitchFamily="34" charset="0"/>
+                <a:ea typeface="Inter Bold" pitchFamily="34" charset="-122"/>
+                <a:cs typeface="Inter Bold" pitchFamily="34" charset="-120"/>
+              </a:rPr>
+              <a:t>e</a:t>
+            </a:r>
+            <a:endParaRPr lang="en-US" sz="650" dirty="0"/>
+          </a:p>
+        </p:txBody>
+      </p:sp>
+      <p:sp>
+        <p:nvSpPr>
+          <p:cNvPr id="37" name="Text 33"/>
+          <p:cNvSpPr/>
+          <p:nvPr/>
+        </p:nvSpPr>
+        <p:spPr>
+          <a:xfrm>
+            <a:off x="2059186" y="3330243"/>
+            <a:ext cx="42863" cy="137517"/>
+          </a:xfrm>
+          <a:prstGeom prst="rect">
+            <a:avLst/>
+          </a:prstGeom>
+          <a:noFill/>
+          <a:ln/>
+        </p:spPr>
+        <p:txBody>
+          <a:bodyPr wrap="none" lIns="0" tIns="0" rIns="0" bIns="0" rtlCol="0" anchor="t">
+            <a:spAutoFit/>
+          </a:bodyPr>
+          <a:lstStyle/>
+          <a:p>
+            <a:pPr algn="l" indent="0" marL="0">
+              <a:lnSpc>
+                <a:spcPct val="128000"/>
+              </a:lnSpc>
+              <a:buNone/>
+            </a:pPr>
+            <a:r>
+              <a:rPr lang="en-US" sz="800" b="1" dirty="0">
+                <a:solidFill>
+                  <a:srgbClr val="000000"/>
+                </a:solidFill>
+                <a:latin typeface="Inter Bold" pitchFamily="34" charset="0"/>
+                <a:ea typeface="Inter Bold" pitchFamily="34" charset="-122"/>
+                <a:cs typeface="Inter Bold" pitchFamily="34" charset="-120"/>
+              </a:rPr>
+              <a:t>)</a:t>
+            </a:r>
+            <a:endParaRPr lang="en-US" sz="800" dirty="0"/>
+          </a:p>
+        </p:txBody>
+      </p:sp>
+      <p:sp>
+        <p:nvSpPr>
+          <p:cNvPr id="38" name="Text 34"/>
+          <p:cNvSpPr/>
+          <p:nvPr/>
+        </p:nvSpPr>
+        <p:spPr>
+          <a:xfrm>
+            <a:off x="685800" y="3585828"/>
+            <a:ext cx="700088" cy="128588"/>
+          </a:xfrm>
+          <a:prstGeom prst="rect">
+            <a:avLst/>
+          </a:prstGeom>
+          <a:noFill/>
+          <a:ln/>
+        </p:spPr>
+        <p:txBody>
+          <a:bodyPr wrap="none" lIns="0" tIns="0" rIns="0" bIns="0" rtlCol="0" anchor="t">
+            <a:spAutoFit/>
+          </a:bodyPr>
+          <a:lstStyle/>
+          <a:p>
+            <a:pPr algn="l" indent="0" marL="0">
+              <a:lnSpc>
+                <a:spcPct val="128000"/>
+              </a:lnSpc>
+              <a:buNone/>
+            </a:pPr>
+            <a:r>
+              <a:rPr lang="en-US" sz="800" dirty="0">
+                <a:solidFill>
+                  <a:srgbClr val="333333"/>
+                </a:solidFill>
+                <a:latin typeface="Inter" pitchFamily="34" charset="0"/>
+                <a:ea typeface="Inter" pitchFamily="34" charset="-122"/>
+                <a:cs typeface="Inter" pitchFamily="34" charset="-120"/>
+              </a:rPr>
+              <a:t>At 120 km/h, f</a:t>
+            </a:r>
+            <a:endParaRPr lang="en-US" sz="800" dirty="0"/>
+          </a:p>
+        </p:txBody>
+      </p:sp>
+      <p:sp>
+        <p:nvSpPr>
+          <p:cNvPr id="39" name="Text 35"/>
+          <p:cNvSpPr/>
+          <p:nvPr/>
+        </p:nvSpPr>
+        <p:spPr>
+          <a:xfrm>
+            <a:off x="1385888" y="3626904"/>
+            <a:ext cx="51792" cy="107156"/>
+          </a:xfrm>
+          <a:prstGeom prst="rect">
+            <a:avLst/>
+          </a:prstGeom>
+          <a:noFill/>
+          <a:ln/>
+        </p:spPr>
+        <p:txBody>
+          <a:bodyPr wrap="none" lIns="0" tIns="0" rIns="0" bIns="0" rtlCol="0" anchor="t">
+            <a:spAutoFit/>
+          </a:bodyPr>
+          <a:lstStyle/>
+          <a:p>
+            <a:pPr algn="l" indent="0" marL="0">
+              <a:lnSpc>
+                <a:spcPct val="128000"/>
+              </a:lnSpc>
+              <a:buNone/>
+            </a:pPr>
+            <a:r>
+              <a:rPr lang="en-US" sz="650" baseline="-40000" dirty="0">
+                <a:solidFill>
+                  <a:srgbClr val="333333"/>
+                </a:solidFill>
+                <a:latin typeface="Inter" pitchFamily="34" charset="0"/>
+                <a:ea typeface="Inter" pitchFamily="34" charset="-122"/>
+                <a:cs typeface="Inter" pitchFamily="34" charset="-120"/>
+              </a:rPr>
+              <a:t>e</a:t>
+            </a:r>
+            <a:endParaRPr lang="en-US" sz="650" dirty="0"/>
+          </a:p>
+        </p:txBody>
+      </p:sp>
+      <p:sp>
+        <p:nvSpPr>
+          <p:cNvPr id="40" name="Text 36"/>
+          <p:cNvSpPr/>
+          <p:nvPr/>
+        </p:nvSpPr>
+        <p:spPr>
+          <a:xfrm>
+            <a:off x="1437680" y="3585828"/>
+            <a:ext cx="2900363" cy="128588"/>
+          </a:xfrm>
+          <a:prstGeom prst="rect">
+            <a:avLst/>
+          </a:prstGeom>
+          <a:noFill/>
+          <a:ln/>
+        </p:spPr>
+        <p:txBody>
+          <a:bodyPr wrap="none" lIns="0" tIns="0" rIns="0" bIns="0" rtlCol="0" anchor="t">
+            <a:spAutoFit/>
+          </a:bodyPr>
+          <a:lstStyle/>
+          <a:p>
+            <a:pPr algn="l" indent="0" marL="0">
+              <a:lnSpc>
+                <a:spcPct val="128000"/>
+              </a:lnSpc>
+              <a:buNone/>
+            </a:pPr>
+            <a:r>
+              <a:rPr lang="en-US" sz="800" dirty="0">
+                <a:solidFill>
+                  <a:srgbClr val="333333"/>
+                </a:solidFill>
+                <a:latin typeface="Inter" pitchFamily="34" charset="0"/>
+                <a:ea typeface="Inter" pitchFamily="34" charset="-122"/>
+                <a:cs typeface="Inter" pitchFamily="34" charset="-120"/>
+              </a:rPr>
+              <a:t>reaches 552 Hz. The controller automatically increases f</a:t>
+            </a:r>
+            <a:endParaRPr lang="en-US" sz="800" dirty="0"/>
+          </a:p>
+        </p:txBody>
+      </p:sp>
+      <p:sp>
+        <p:nvSpPr>
+          <p:cNvPr id="41" name="Text 37"/>
+          <p:cNvSpPr/>
+          <p:nvPr/>
+        </p:nvSpPr>
+        <p:spPr>
+          <a:xfrm>
+            <a:off x="4338042" y="3626904"/>
+            <a:ext cx="119658" cy="107156"/>
+          </a:xfrm>
+          <a:prstGeom prst="rect">
+            <a:avLst/>
+          </a:prstGeom>
+          <a:noFill/>
+          <a:ln/>
+        </p:spPr>
+        <p:txBody>
+          <a:bodyPr wrap="none" lIns="0" tIns="0" rIns="0" bIns="0" rtlCol="0" anchor="t">
+            <a:spAutoFit/>
+          </a:bodyPr>
+          <a:lstStyle/>
+          <a:p>
+            <a:pPr algn="l" indent="0" marL="0">
+              <a:lnSpc>
+                <a:spcPct val="128000"/>
+              </a:lnSpc>
+              <a:buNone/>
+            </a:pPr>
+            <a:r>
+              <a:rPr lang="en-US" sz="650" baseline="-40000" dirty="0">
+                <a:solidFill>
+                  <a:srgbClr val="333333"/>
+                </a:solidFill>
+                <a:latin typeface="Inter" pitchFamily="34" charset="0"/>
+                <a:ea typeface="Inter" pitchFamily="34" charset="-122"/>
+                <a:cs typeface="Inter" pitchFamily="34" charset="-120"/>
+              </a:rPr>
+              <a:t>sw</a:t>
+            </a:r>
+            <a:endParaRPr lang="en-US" sz="650" dirty="0"/>
+          </a:p>
+        </p:txBody>
+      </p:sp>
+      <p:sp>
+        <p:nvSpPr>
+          <p:cNvPr id="42" name="Text 38"/>
+          <p:cNvSpPr/>
+          <p:nvPr/>
+        </p:nvSpPr>
+        <p:spPr>
+          <a:xfrm>
+            <a:off x="4457700" y="3585828"/>
+            <a:ext cx="128588" cy="128588"/>
+          </a:xfrm>
+          <a:prstGeom prst="rect">
+            <a:avLst/>
+          </a:prstGeom>
+          <a:noFill/>
+          <a:ln/>
+        </p:spPr>
+        <p:txBody>
+          <a:bodyPr wrap="none" lIns="0" tIns="0" rIns="0" bIns="0" rtlCol="0" anchor="t">
+            <a:spAutoFit/>
+          </a:bodyPr>
+          <a:lstStyle/>
+          <a:p>
+            <a:pPr algn="l" indent="0" marL="0">
+              <a:lnSpc>
+                <a:spcPct val="128000"/>
+              </a:lnSpc>
+              <a:buNone/>
+            </a:pPr>
+            <a:r>
+              <a:rPr lang="en-US" sz="800" dirty="0">
+                <a:solidFill>
+                  <a:srgbClr val="333333"/>
+                </a:solidFill>
+                <a:latin typeface="Inter" pitchFamily="34" charset="0"/>
+                <a:ea typeface="Inter" pitchFamily="34" charset="-122"/>
+                <a:cs typeface="Inter" pitchFamily="34" charset="-120"/>
+              </a:rPr>
+              <a:t>to</a:t>
+            </a:r>
+            <a:endParaRPr lang="en-US" sz="800" dirty="0"/>
+          </a:p>
+        </p:txBody>
+      </p:sp>
+      <p:sp>
+        <p:nvSpPr>
+          <p:cNvPr id="43" name="Text 39"/>
+          <p:cNvSpPr/>
+          <p:nvPr/>
+        </p:nvSpPr>
+        <p:spPr>
+          <a:xfrm>
+            <a:off x="685800" y="3773351"/>
+            <a:ext cx="367903" cy="128588"/>
+          </a:xfrm>
+          <a:prstGeom prst="rect">
+            <a:avLst/>
+          </a:prstGeom>
+          <a:noFill/>
+          <a:ln/>
+        </p:spPr>
+        <p:txBody>
+          <a:bodyPr wrap="none" lIns="0" tIns="0" rIns="0" bIns="0" rtlCol="0" anchor="t">
+            <a:spAutoFit/>
+          </a:bodyPr>
+          <a:lstStyle/>
+          <a:p>
+            <a:pPr algn="l" indent="0" marL="0">
+              <a:lnSpc>
+                <a:spcPct val="128000"/>
+              </a:lnSpc>
+              <a:buNone/>
+            </a:pPr>
+            <a:r>
+              <a:rPr lang="en-US" sz="750" b="1" dirty="0">
+                <a:solidFill>
+                  <a:srgbClr val="000000"/>
+                </a:solidFill>
+                <a:latin typeface="Inter Bold" pitchFamily="34" charset="0"/>
+                <a:ea typeface="Inter Bold" pitchFamily="34" charset="-122"/>
+                <a:cs typeface="Inter Bold" pitchFamily="34" charset="-120"/>
+              </a:rPr>
+              <a:t>20 kHz</a:t>
+            </a:r>
+            <a:endParaRPr lang="en-US" sz="750" dirty="0"/>
+          </a:p>
+        </p:txBody>
+      </p:sp>
+      <p:sp>
+        <p:nvSpPr>
+          <p:cNvPr id="44" name="Text 40"/>
+          <p:cNvSpPr/>
+          <p:nvPr/>
+        </p:nvSpPr>
+        <p:spPr>
+          <a:xfrm>
+            <a:off x="1053703" y="3773351"/>
+            <a:ext cx="714375" cy="128588"/>
+          </a:xfrm>
+          <a:prstGeom prst="rect">
+            <a:avLst/>
+          </a:prstGeom>
+          <a:noFill/>
+          <a:ln/>
+        </p:spPr>
+        <p:txBody>
+          <a:bodyPr wrap="none" lIns="0" tIns="0" rIns="0" bIns="0" rtlCol="0" anchor="t">
+            <a:spAutoFit/>
+          </a:bodyPr>
+          <a:lstStyle/>
+          <a:p>
+            <a:pPr algn="l" indent="0" marL="0">
+              <a:lnSpc>
+                <a:spcPct val="128000"/>
+              </a:lnSpc>
+              <a:buNone/>
+            </a:pPr>
+            <a:r>
+              <a:rPr lang="en-US" sz="800" dirty="0">
+                <a:solidFill>
+                  <a:srgbClr val="333333"/>
+                </a:solidFill>
+                <a:latin typeface="Inter" pitchFamily="34" charset="0"/>
+                <a:ea typeface="Inter" pitchFamily="34" charset="-122"/>
+                <a:cs typeface="Inter" pitchFamily="34" charset="-120"/>
+              </a:rPr>
+              <a:t>to maintain m</a:t>
+            </a:r>
+            <a:endParaRPr lang="en-US" sz="800" dirty="0"/>
+          </a:p>
+        </p:txBody>
+      </p:sp>
+      <p:sp>
+        <p:nvSpPr>
+          <p:cNvPr id="45" name="Text 41"/>
+          <p:cNvSpPr/>
+          <p:nvPr/>
+        </p:nvSpPr>
+        <p:spPr>
+          <a:xfrm>
+            <a:off x="1768078" y="3814428"/>
+            <a:ext cx="33933" cy="107156"/>
+          </a:xfrm>
+          <a:prstGeom prst="rect">
+            <a:avLst/>
+          </a:prstGeom>
+          <a:noFill/>
+          <a:ln/>
+        </p:spPr>
+        <p:txBody>
+          <a:bodyPr wrap="none" lIns="0" tIns="0" rIns="0" bIns="0" rtlCol="0" anchor="t">
+            <a:spAutoFit/>
+          </a:bodyPr>
+          <a:lstStyle/>
+          <a:p>
+            <a:pPr algn="l" indent="0" marL="0">
+              <a:lnSpc>
+                <a:spcPct val="128000"/>
+              </a:lnSpc>
+              <a:buNone/>
+            </a:pPr>
+            <a:r>
+              <a:rPr lang="en-US" sz="650" baseline="-40000" dirty="0">
+                <a:solidFill>
+                  <a:srgbClr val="333333"/>
+                </a:solidFill>
+                <a:latin typeface="Inter" pitchFamily="34" charset="0"/>
+                <a:ea typeface="Inter" pitchFamily="34" charset="-122"/>
+                <a:cs typeface="Inter" pitchFamily="34" charset="-120"/>
+              </a:rPr>
+              <a:t>f</a:t>
+            </a:r>
+            <a:endParaRPr lang="en-US" sz="650" dirty="0"/>
+          </a:p>
+        </p:txBody>
+      </p:sp>
+      <p:sp>
+        <p:nvSpPr>
+          <p:cNvPr id="46" name="Text 42"/>
+          <p:cNvSpPr/>
+          <p:nvPr/>
+        </p:nvSpPr>
+        <p:spPr>
+          <a:xfrm>
+            <a:off x="1802011" y="3773351"/>
+            <a:ext cx="2585926" cy="128588"/>
+          </a:xfrm>
+          <a:prstGeom prst="rect">
+            <a:avLst/>
+          </a:prstGeom>
+          <a:noFill/>
+          <a:ln/>
+        </p:spPr>
+        <p:txBody>
+          <a:bodyPr wrap="none" lIns="0" tIns="0" rIns="0" bIns="0" rtlCol="0" anchor="t">
+            <a:spAutoFit/>
+          </a:bodyPr>
+          <a:lstStyle/>
+          <a:p>
+            <a:pPr algn="l" indent="0" marL="0">
+              <a:lnSpc>
+                <a:spcPct val="128000"/>
+              </a:lnSpc>
+              <a:buNone/>
+            </a:pPr>
+            <a:r>
+              <a:rPr lang="en-US" sz="800" dirty="0">
+                <a:solidFill>
+                  <a:srgbClr val="333333"/>
+                </a:solidFill>
+                <a:latin typeface="Inter" pitchFamily="34" charset="0"/>
+                <a:ea typeface="Inter" pitchFamily="34" charset="-122"/>
+                <a:cs typeface="Inter" pitchFamily="34" charset="-120"/>
+              </a:rPr>
+              <a:t>≈ 36 and prevent distortion. Fortunately, the phase</a:t>
+            </a:r>
+            <a:endParaRPr lang="en-US" sz="800" dirty="0"/>
+          </a:p>
+        </p:txBody>
+      </p:sp>
+      <p:sp>
+        <p:nvSpPr>
+          <p:cNvPr id="47" name="Text 43"/>
+          <p:cNvSpPr/>
+          <p:nvPr/>
+        </p:nvSpPr>
+        <p:spPr>
+          <a:xfrm>
+            <a:off x="685800" y="3960875"/>
+            <a:ext cx="3389709" cy="128588"/>
+          </a:xfrm>
+          <a:prstGeom prst="rect">
+            <a:avLst/>
+          </a:prstGeom>
+          <a:noFill/>
+          <a:ln/>
+        </p:spPr>
+        <p:txBody>
+          <a:bodyPr wrap="none" lIns="0" tIns="0" rIns="0" bIns="0" rtlCol="0" anchor="t">
+            <a:spAutoFit/>
+          </a:bodyPr>
+          <a:lstStyle/>
+          <a:p>
+            <a:pPr algn="l" indent="0" marL="0">
+              <a:lnSpc>
+                <a:spcPct val="128000"/>
+              </a:lnSpc>
+              <a:buNone/>
+            </a:pPr>
+            <a:r>
+              <a:rPr lang="en-US" sz="800" dirty="0">
+                <a:solidFill>
+                  <a:srgbClr val="333333"/>
+                </a:solidFill>
+                <a:latin typeface="Inter" pitchFamily="34" charset="0"/>
+                <a:ea typeface="Inter" pitchFamily="34" charset="-122"/>
+                <a:cs typeface="Inter" pitchFamily="34" charset="-120"/>
+              </a:rPr>
+              <a:t>current is much lower (51 A), keeping absolute losses manageable.</a:t>
+            </a:r>
+            <a:endParaRPr lang="en-US" sz="800" dirty="0"/>
           </a:p>
         </p:txBody>
       </p:sp>
       <p:pic>
         <p:nvPicPr>
-          <p:cNvPr id="5" name="Image 1" descr="preencoded.png">    </p:cNvPr>
+          <p:cNvPr id="48" name="Image 1" descr="preencoded.png">    </p:cNvPr>
           <p:cNvPicPr>
             <a:picLocks noChangeAspect="1"/>
           </p:cNvPicPr>
@@ -2236,749 +4062,14 @@
         </p:blipFill>
         <p:spPr>
           <a:xfrm>
-            <a:off x="571500" y="1052978"/>
-            <a:ext cx="3857625" cy="3286125"/>
+            <a:off x="5100638" y="2028518"/>
+            <a:ext cx="3471863" cy="1577904"/>
           </a:xfrm>
           <a:prstGeom prst="rect">
             <a:avLst/>
           </a:prstGeom>
         </p:spPr>
       </p:pic>
-      <p:sp>
-        <p:nvSpPr>
-          <p:cNvPr id="6" name="Text 1"/>
-          <p:cNvSpPr/>
-          <p:nvPr/>
-        </p:nvSpPr>
-        <p:spPr>
-          <a:xfrm>
-            <a:off x="4714875" y="1052978"/>
-            <a:ext cx="53578" cy="182863"/>
-          </a:xfrm>
-          <a:prstGeom prst="rect">
-            <a:avLst/>
-          </a:prstGeom>
-          <a:noFill/>
-          <a:ln/>
-        </p:spPr>
-        <p:txBody>
-          <a:bodyPr wrap="none" lIns="0" tIns="0" rIns="0" bIns="0" rtlCol="0" anchor="t">
-            <a:spAutoFit/>
-          </a:bodyPr>
-          <a:lstStyle/>
-          <a:p>
-            <a:pPr algn="l" indent="0" marL="0">
-              <a:lnSpc>
-                <a:spcPct val="128000"/>
-              </a:lnSpc>
-              <a:buNone/>
-            </a:pPr>
-            <a:r>
-              <a:rPr lang="en-US" sz="800" b="1" dirty="0">
-                <a:solidFill>
-                  <a:srgbClr val="2563EB"/>
-                </a:solidFill>
-                <a:latin typeface="Inter Bold" pitchFamily="34" charset="0"/>
-                <a:ea typeface="Inter Bold" pitchFamily="34" charset="-122"/>
-                <a:cs typeface="Inter Bold" pitchFamily="34" charset="-120"/>
-              </a:rPr>
-              <a:t>•</a:t>
-            </a:r>
-            <a:endParaRPr lang="en-US" sz="800" dirty="0"/>
-          </a:p>
-        </p:txBody>
-      </p:sp>
-      <p:sp>
-        <p:nvSpPr>
-          <p:cNvPr id="7" name="Text 2"/>
-          <p:cNvSpPr/>
-          <p:nvPr/>
-        </p:nvSpPr>
-        <p:spPr>
-          <a:xfrm>
-            <a:off x="4829175" y="1074409"/>
-            <a:ext cx="1980605" cy="137517"/>
-          </a:xfrm>
-          <a:prstGeom prst="rect">
-            <a:avLst/>
-          </a:prstGeom>
-          <a:noFill/>
-          <a:ln/>
-        </p:spPr>
-        <p:txBody>
-          <a:bodyPr wrap="none" lIns="0" tIns="0" rIns="0" bIns="0" rtlCol="0" anchor="t">
-            <a:spAutoFit/>
-          </a:bodyPr>
-          <a:lstStyle/>
-          <a:p>
-            <a:pPr algn="l" indent="0" marL="0">
-              <a:lnSpc>
-                <a:spcPct val="128000"/>
-              </a:lnSpc>
-              <a:buNone/>
-            </a:pPr>
-            <a:r>
-              <a:rPr lang="en-US" sz="800" b="1" dirty="0">
-                <a:solidFill>
-                  <a:srgbClr val="000000"/>
-                </a:solidFill>
-                <a:latin typeface="Inter Bold" pitchFamily="34" charset="0"/>
-                <a:ea typeface="Inter Bold" pitchFamily="34" charset="-122"/>
-                <a:cs typeface="Inter Bold" pitchFamily="34" charset="-120"/>
-              </a:rPr>
-              <a:t>Adaptive Schedule Implementation:</a:t>
-            </a:r>
-            <a:endParaRPr lang="en-US" sz="800" dirty="0"/>
-          </a:p>
-        </p:txBody>
-      </p:sp>
-      <p:sp>
-        <p:nvSpPr>
-          <p:cNvPr id="8" name="Shape 3"/>
-          <p:cNvSpPr/>
-          <p:nvPr/>
-        </p:nvSpPr>
-        <p:spPr>
-          <a:xfrm>
-            <a:off x="4829175" y="1292991"/>
-            <a:ext cx="3743325" cy="651477"/>
-          </a:xfrm>
-          <a:prstGeom prst="rect">
-            <a:avLst/>
-          </a:prstGeom>
-          <a:solidFill>
-            <a:srgbClr val="F3F4F6"/>
-          </a:solidFill>
-          <a:ln/>
-        </p:spPr>
-      </p:sp>
-      <p:sp>
-        <p:nvSpPr>
-          <p:cNvPr id="9" name="Shape 4"/>
-          <p:cNvSpPr/>
-          <p:nvPr/>
-        </p:nvSpPr>
-        <p:spPr>
-          <a:xfrm>
-            <a:off x="4829175" y="1292991"/>
-            <a:ext cx="21431" cy="651477"/>
-          </a:xfrm>
-          <a:prstGeom prst="rect">
-            <a:avLst/>
-          </a:prstGeom>
-          <a:solidFill>
-            <a:srgbClr val="2563EB"/>
-          </a:solidFill>
-          <a:ln/>
-        </p:spPr>
-      </p:sp>
-      <p:sp>
-        <p:nvSpPr>
-          <p:cNvPr id="10" name="Text 5"/>
-          <p:cNvSpPr/>
-          <p:nvPr/>
-        </p:nvSpPr>
-        <p:spPr>
-          <a:xfrm>
-            <a:off x="4829175" y="1292991"/>
-            <a:ext cx="3743325" cy="651477"/>
-          </a:xfrm>
-          <a:prstGeom prst="rect">
-            <a:avLst/>
-          </a:prstGeom>
-          <a:noFill/>
-          <a:ln/>
-        </p:spPr>
-        <p:txBody>
-          <a:bodyPr wrap="square" lIns="102108" tIns="102108" rIns="102108" bIns="102108" rtlCol="0" anchor="t">
-            <a:spAutoFit/>
-          </a:bodyPr>
-          <a:lstStyle/>
-          <a:p>
-            <a:pPr algn="l" indent="0" marL="0">
-              <a:lnSpc>
-                <a:spcPct val="128000"/>
-              </a:lnSpc>
-              <a:buNone/>
-            </a:pPr>
-            <a:r>
-              <a:rPr lang="en-US" sz="700" b="1" dirty="0">
-                <a:solidFill>
-                  <a:srgbClr val="000000"/>
-                </a:solidFill>
-                <a:latin typeface="Inter Bold" pitchFamily="34" charset="0"/>
-                <a:ea typeface="Inter Bold" pitchFamily="34" charset="-122"/>
-                <a:cs typeface="Inter Bold" pitchFamily="34" charset="-120"/>
-              </a:rPr>
-              <a:t>5 kHz:</a:t>
-            </a:r>
-            <a:r>
-              <a:rPr lang="en-US" sz="750" dirty="0">
-                <a:solidFill>
-                  <a:srgbClr val="000000"/>
-                </a:solidFill>
-                <a:latin typeface="Inter" pitchFamily="34" charset="0"/>
-                <a:ea typeface="Inter" pitchFamily="34" charset="-122"/>
-                <a:cs typeface="Inter" pitchFamily="34" charset="-120"/>
-              </a:rPr>
-              <a:t> Urban driving (v &lt; 60 km/h)</a:t>
-            </a:r>
-            <a:r>
-              <a:rPr lang="en-US" sz="750" dirty="0">
-                <a:solidFill>
-                  <a:srgbClr val="000000"/>
-                </a:solidFill>
-                <a:latin typeface="Inter" pitchFamily="34" charset="0"/>
-                <a:ea typeface="Inter" pitchFamily="34" charset="-122"/>
-                <a:cs typeface="Inter" pitchFamily="34" charset="-120"/>
-              </a:rPr>
-              <a:t>
-</a:t>
-            </a:r>
-            <a:r>
-              <a:rPr lang="en-US" sz="700" b="1" dirty="0">
-                <a:solidFill>
-                  <a:srgbClr val="000000"/>
-                </a:solidFill>
-                <a:latin typeface="Inter Bold" pitchFamily="34" charset="0"/>
-                <a:ea typeface="Inter Bold" pitchFamily="34" charset="-122"/>
-                <a:cs typeface="Inter Bold" pitchFamily="34" charset="-120"/>
-              </a:rPr>
-              <a:t>10 kHz:</a:t>
-            </a:r>
-            <a:r>
-              <a:rPr lang="en-US" sz="750" dirty="0">
-                <a:solidFill>
-                  <a:srgbClr val="000000"/>
-                </a:solidFill>
-                <a:latin typeface="Inter" pitchFamily="34" charset="0"/>
-                <a:ea typeface="Inter" pitchFamily="34" charset="-122"/>
-                <a:cs typeface="Inter" pitchFamily="34" charset="-120"/>
-              </a:rPr>
-              <a:t> Extra-Urban (60-90 km/h)</a:t>
-            </a:r>
-            <a:r>
-              <a:rPr lang="en-US" sz="750" dirty="0">
-                <a:solidFill>
-                  <a:srgbClr val="000000"/>
-                </a:solidFill>
-                <a:latin typeface="Inter" pitchFamily="34" charset="0"/>
-                <a:ea typeface="Inter" pitchFamily="34" charset="-122"/>
-                <a:cs typeface="Inter" pitchFamily="34" charset="-120"/>
-              </a:rPr>
-              <a:t>
-</a:t>
-            </a:r>
-            <a:r>
-              <a:rPr lang="en-US" sz="700" b="1" dirty="0">
-                <a:solidFill>
-                  <a:srgbClr val="000000"/>
-                </a:solidFill>
-                <a:latin typeface="Inter Bold" pitchFamily="34" charset="0"/>
-                <a:ea typeface="Inter Bold" pitchFamily="34" charset="-122"/>
-                <a:cs typeface="Inter Bold" pitchFamily="34" charset="-120"/>
-              </a:rPr>
-              <a:t>20 kHz:</a:t>
-            </a:r>
-            <a:r>
-              <a:rPr lang="en-US" sz="750" dirty="0">
-                <a:solidFill>
-                  <a:srgbClr val="000000"/>
-                </a:solidFill>
-                <a:latin typeface="Inter" pitchFamily="34" charset="0"/>
-                <a:ea typeface="Inter" pitchFamily="34" charset="-122"/>
-                <a:cs typeface="Inter" pitchFamily="34" charset="-120"/>
-              </a:rPr>
-              <a:t> Highway (v &gt; 90 km/h)</a:t>
-            </a:r>
-            <a:endParaRPr lang="en-US" sz="750" dirty="0"/>
-          </a:p>
-        </p:txBody>
-      </p:sp>
-      <p:sp>
-        <p:nvSpPr>
-          <p:cNvPr id="11" name="Text 6"/>
-          <p:cNvSpPr/>
-          <p:nvPr/>
-        </p:nvSpPr>
-        <p:spPr>
-          <a:xfrm>
-            <a:off x="4714875" y="2087342"/>
-            <a:ext cx="3857625" cy="365727"/>
-          </a:xfrm>
-          <a:prstGeom prst="rect">
-            <a:avLst/>
-          </a:prstGeom>
-          <a:noFill/>
-          <a:ln/>
-        </p:spPr>
-        <p:txBody>
-          <a:bodyPr wrap="square" lIns="136017" tIns="0" rIns="0" bIns="0" rtlCol="0" anchor="t">
-            <a:spAutoFit/>
-          </a:bodyPr>
-          <a:lstStyle/>
-          <a:p>
-            <a:pPr algn="l" indent="0" marL="0">
-              <a:lnSpc>
-                <a:spcPct val="128000"/>
-              </a:lnSpc>
-              <a:buNone/>
-            </a:pPr>
-            <a:r>
-              <a:rPr lang="en-US" sz="800" b="1" dirty="0">
-                <a:solidFill>
-                  <a:srgbClr val="000000"/>
-                </a:solidFill>
-                <a:latin typeface="Inter Bold" pitchFamily="34" charset="0"/>
-                <a:ea typeface="Inter Bold" pitchFamily="34" charset="-122"/>
-                <a:cs typeface="Inter Bold" pitchFamily="34" charset="-120"/>
-              </a:rPr>
-              <a:t>Urban Saving:</a:t>
-            </a:r>
-            <a:r>
-              <a:rPr lang="en-US" sz="850" dirty="0">
-                <a:solidFill>
-                  <a:srgbClr val="333333"/>
-                </a:solidFill>
-                <a:latin typeface="Inter" pitchFamily="34" charset="0"/>
-                <a:ea typeface="Inter" pitchFamily="34" charset="-122"/>
-                <a:cs typeface="Inter" pitchFamily="34" charset="-120"/>
-              </a:rPr>
-              <a:t> Switching loss drops from 84.3W to 21.1W per phase, </a:t>
-            </a:r>
-            <a:r>
-              <a:rPr lang="en-US" sz="850" dirty="0">
-                <a:solidFill>
-                  <a:srgbClr val="333333"/>
-                </a:solidFill>
-                <a:latin typeface="Inter" pitchFamily="34" charset="0"/>
-                <a:ea typeface="Inter" pitchFamily="34" charset="-122"/>
-                <a:cs typeface="Inter" pitchFamily="34" charset="-120"/>
-              </a:rPr>
-              <a:t>representing a massive </a:t>
-            </a:r>
-            <a:r>
-              <a:rPr lang="en-US" sz="800" b="1" dirty="0">
-                <a:solidFill>
-                  <a:srgbClr val="000000"/>
-                </a:solidFill>
-                <a:latin typeface="Inter Bold" pitchFamily="34" charset="0"/>
-                <a:ea typeface="Inter Bold" pitchFamily="34" charset="-122"/>
-                <a:cs typeface="Inter Bold" pitchFamily="34" charset="-120"/>
-              </a:rPr>
-              <a:t>75% reduction</a:t>
-            </a:r>
-            <a:r>
-              <a:rPr lang="en-US" sz="850" dirty="0">
-                <a:solidFill>
-                  <a:srgbClr val="333333"/>
-                </a:solidFill>
-                <a:latin typeface="Inter" pitchFamily="34" charset="0"/>
-                <a:ea typeface="Inter" pitchFamily="34" charset="-122"/>
-                <a:cs typeface="Inter" pitchFamily="34" charset="-120"/>
-              </a:rPr>
-              <a:t>.</a:t>
-            </a:r>
-            <a:endParaRPr lang="en-US" sz="800" dirty="0"/>
-          </a:p>
-        </p:txBody>
-      </p:sp>
-      <p:sp>
-        <p:nvSpPr>
-          <p:cNvPr id="12" name="Text 7"/>
-          <p:cNvSpPr/>
-          <p:nvPr/>
-        </p:nvSpPr>
-        <p:spPr>
-          <a:xfrm>
-            <a:off x="4714875" y="2595944"/>
-            <a:ext cx="3857625" cy="365727"/>
-          </a:xfrm>
-          <a:prstGeom prst="rect">
-            <a:avLst/>
-          </a:prstGeom>
-          <a:noFill/>
-          <a:ln/>
-        </p:spPr>
-        <p:txBody>
-          <a:bodyPr wrap="square" lIns="136017" tIns="0" rIns="0" bIns="0" rtlCol="0" anchor="t">
-            <a:spAutoFit/>
-          </a:bodyPr>
-          <a:lstStyle/>
-          <a:p>
-            <a:pPr algn="l" indent="0" marL="0">
-              <a:lnSpc>
-                <a:spcPct val="128000"/>
-              </a:lnSpc>
-              <a:buNone/>
-            </a:pPr>
-            <a:r>
-              <a:rPr lang="en-US" sz="800" b="1" dirty="0">
-                <a:solidFill>
-                  <a:srgbClr val="000000"/>
-                </a:solidFill>
-                <a:latin typeface="Inter Bold" pitchFamily="34" charset="0"/>
-                <a:ea typeface="Inter Bold" pitchFamily="34" charset="-122"/>
-                <a:cs typeface="Inter Bold" pitchFamily="34" charset="-120"/>
-              </a:rPr>
-              <a:t>Total Efficiency Gain:</a:t>
-            </a:r>
-            <a:r>
-              <a:rPr lang="en-US" sz="850" dirty="0">
-                <a:solidFill>
-                  <a:srgbClr val="333333"/>
-                </a:solidFill>
-                <a:latin typeface="Inter" pitchFamily="34" charset="0"/>
-                <a:ea typeface="Inter" pitchFamily="34" charset="-122"/>
-                <a:cs typeface="Inter" pitchFamily="34" charset="-120"/>
-              </a:rPr>
-              <a:t> The 3-phase total saving at 40 km/h is </a:t>
-            </a:r>
-            <a:r>
-              <a:rPr lang="en-US" sz="800" b="1" dirty="0">
-                <a:solidFill>
-                  <a:srgbClr val="000000"/>
-                </a:solidFill>
-                <a:latin typeface="Inter Bold" pitchFamily="34" charset="0"/>
-                <a:ea typeface="Inter Bold" pitchFamily="34" charset="-122"/>
-                <a:cs typeface="Inter Bold" pitchFamily="34" charset="-120"/>
-              </a:rPr>
-              <a:t>190W</a:t>
-            </a:r>
-            <a:r>
-              <a:rPr lang="en-US" sz="850" dirty="0">
-                <a:solidFill>
-                  <a:srgbClr val="333333"/>
-                </a:solidFill>
-                <a:latin typeface="Inter" pitchFamily="34" charset="0"/>
-                <a:ea typeface="Inter" pitchFamily="34" charset="-122"/>
-                <a:cs typeface="Inter" pitchFamily="34" charset="-120"/>
-              </a:rPr>
-              <a:t>, </a:t>
-            </a:r>
-            <a:r>
-              <a:rPr lang="en-US" sz="850" dirty="0">
-                <a:solidFill>
-                  <a:srgbClr val="333333"/>
-                </a:solidFill>
-                <a:latin typeface="Inter" pitchFamily="34" charset="0"/>
-                <a:ea typeface="Inter" pitchFamily="34" charset="-122"/>
-                <a:cs typeface="Inter" pitchFamily="34" charset="-120"/>
-              </a:rPr>
-              <a:t>directly extending EV range in city driving.</a:t>
-            </a:r>
-            <a:endParaRPr lang="en-US" sz="800" dirty="0"/>
-          </a:p>
-        </p:txBody>
-      </p:sp>
-      <p:sp>
-        <p:nvSpPr>
-          <p:cNvPr id="13" name="Text 8"/>
-          <p:cNvSpPr/>
-          <p:nvPr/>
-        </p:nvSpPr>
-        <p:spPr>
-          <a:xfrm>
-            <a:off x="4714875" y="3104545"/>
-            <a:ext cx="3857625" cy="365727"/>
-          </a:xfrm>
-          <a:prstGeom prst="rect">
-            <a:avLst/>
-          </a:prstGeom>
-          <a:noFill/>
-          <a:ln/>
-        </p:spPr>
-        <p:txBody>
-          <a:bodyPr wrap="square" lIns="136017" tIns="0" rIns="0" bIns="0" rtlCol="0" anchor="t">
-            <a:spAutoFit/>
-          </a:bodyPr>
-          <a:lstStyle/>
-          <a:p>
-            <a:pPr algn="l" indent="0" marL="0">
-              <a:lnSpc>
-                <a:spcPct val="128000"/>
-              </a:lnSpc>
-              <a:buNone/>
-            </a:pPr>
-            <a:r>
-              <a:rPr lang="en-US" sz="800" b="1" dirty="0">
-                <a:solidFill>
-                  <a:srgbClr val="000000"/>
-                </a:solidFill>
-                <a:latin typeface="Inter Bold" pitchFamily="34" charset="0"/>
-                <a:ea typeface="Inter Bold" pitchFamily="34" charset="-122"/>
-                <a:cs typeface="Inter Bold" pitchFamily="34" charset="-120"/>
-              </a:rPr>
-              <a:t>THD Remains Excellent:</a:t>
-            </a:r>
-            <a:r>
-              <a:rPr lang="en-US" sz="850" dirty="0">
-                <a:solidFill>
-                  <a:srgbClr val="333333"/>
-                </a:solidFill>
-                <a:latin typeface="Inter" pitchFamily="34" charset="0"/>
-                <a:ea typeface="Inter" pitchFamily="34" charset="-122"/>
-                <a:cs typeface="Inter" pitchFamily="34" charset="-120"/>
-              </a:rPr>
-              <a:t> Despite the lower frequency, THD is 1.92% </a:t>
-            </a:r>
-            <a:r>
-              <a:rPr lang="en-US" sz="850" dirty="0">
-                <a:solidFill>
-                  <a:srgbClr val="333333"/>
-                </a:solidFill>
-                <a:latin typeface="Inter" pitchFamily="34" charset="0"/>
-                <a:ea typeface="Inter" pitchFamily="34" charset="-122"/>
-                <a:cs typeface="Inter" pitchFamily="34" charset="-120"/>
-              </a:rPr>
-              <a:t>at 5 kHz (urban) and 1.13% at 20 kHz (highway).</a:t>
-            </a:r>
-            <a:endParaRPr lang="en-US" sz="800" dirty="0"/>
-          </a:p>
-        </p:txBody>
-      </p:sp>
-      <p:sp>
-        <p:nvSpPr>
-          <p:cNvPr id="14" name="Text 9"/>
-          <p:cNvSpPr/>
-          <p:nvPr/>
-        </p:nvSpPr>
-        <p:spPr>
-          <a:xfrm>
-            <a:off x="4714875" y="3613147"/>
-            <a:ext cx="3857625" cy="365727"/>
-          </a:xfrm>
-          <a:prstGeom prst="rect">
-            <a:avLst/>
-          </a:prstGeom>
-          <a:noFill/>
-          <a:ln/>
-        </p:spPr>
-        <p:txBody>
-          <a:bodyPr wrap="square" lIns="136017" tIns="0" rIns="0" bIns="0" rtlCol="0" anchor="t">
-            <a:spAutoFit/>
-          </a:bodyPr>
-          <a:lstStyle/>
-          <a:p>
-            <a:pPr algn="l" indent="0" marL="0">
-              <a:lnSpc>
-                <a:spcPct val="128000"/>
-              </a:lnSpc>
-              <a:buNone/>
-            </a:pPr>
-            <a:r>
-              <a:rPr lang="en-US" sz="800" b="1" dirty="0">
-                <a:solidFill>
-                  <a:srgbClr val="000000"/>
-                </a:solidFill>
-                <a:latin typeface="Inter Bold" pitchFamily="34" charset="0"/>
-                <a:ea typeface="Inter Bold" pitchFamily="34" charset="-122"/>
-                <a:cs typeface="Inter Bold" pitchFamily="34" charset="-120"/>
-              </a:rPr>
-              <a:t>Highway Performance:</a:t>
-            </a:r>
-            <a:r>
-              <a:rPr lang="en-US" sz="850" dirty="0">
-                <a:solidFill>
-                  <a:srgbClr val="333333"/>
-                </a:solidFill>
-                <a:latin typeface="Inter" pitchFamily="34" charset="0"/>
-                <a:ea typeface="Inter" pitchFamily="34" charset="-122"/>
-                <a:cs typeface="Inter" pitchFamily="34" charset="-120"/>
-              </a:rPr>
-              <a:t> No change in losses, as both schedules </a:t>
-            </a:r>
-            <a:r>
-              <a:rPr lang="en-US" sz="850" dirty="0">
-                <a:solidFill>
-                  <a:srgbClr val="333333"/>
-                </a:solidFill>
-                <a:latin typeface="Inter" pitchFamily="34" charset="0"/>
-                <a:ea typeface="Inter" pitchFamily="34" charset="-122"/>
-                <a:cs typeface="Inter" pitchFamily="34" charset="-120"/>
-              </a:rPr>
-              <a:t>utilize 20 kHz to support the high fundamental frequency (552 Hz).</a:t>
-            </a:r>
-            <a:endParaRPr lang="en-US" sz="800" dirty="0"/>
-          </a:p>
-        </p:txBody>
-      </p:sp>
-      <p:sp>
-        <p:nvSpPr>
-          <p:cNvPr id="15" name="Text 10"/>
-          <p:cNvSpPr/>
-          <p:nvPr/>
-        </p:nvSpPr>
-        <p:spPr>
-          <a:xfrm>
-            <a:off x="4714875" y="2087342"/>
-            <a:ext cx="53578" cy="182863"/>
-          </a:xfrm>
-          <a:prstGeom prst="rect">
-            <a:avLst/>
-          </a:prstGeom>
-          <a:noFill/>
-          <a:ln/>
-        </p:spPr>
-        <p:txBody>
-          <a:bodyPr wrap="none" lIns="0" tIns="0" rIns="0" bIns="0" rtlCol="0" anchor="t">
-            <a:spAutoFit/>
-          </a:bodyPr>
-          <a:lstStyle/>
-          <a:p>
-            <a:pPr algn="l" indent="0" marL="0">
-              <a:lnSpc>
-                <a:spcPct val="128000"/>
-              </a:lnSpc>
-              <a:buNone/>
-            </a:pPr>
-            <a:r>
-              <a:rPr lang="en-US" sz="800" b="1" dirty="0">
-                <a:solidFill>
-                  <a:srgbClr val="2563EB"/>
-                </a:solidFill>
-                <a:latin typeface="Inter Bold" pitchFamily="34" charset="0"/>
-                <a:ea typeface="Inter Bold" pitchFamily="34" charset="-122"/>
-                <a:cs typeface="Inter Bold" pitchFamily="34" charset="-120"/>
-              </a:rPr>
-              <a:t>•</a:t>
-            </a:r>
-            <a:endParaRPr lang="en-US" sz="800" dirty="0"/>
-          </a:p>
-        </p:txBody>
-      </p:sp>
-      <p:sp>
-        <p:nvSpPr>
-          <p:cNvPr id="16" name="Text 11"/>
-          <p:cNvSpPr/>
-          <p:nvPr/>
-        </p:nvSpPr>
-        <p:spPr>
-          <a:xfrm>
-            <a:off x="4714875" y="2595944"/>
-            <a:ext cx="53578" cy="182863"/>
-          </a:xfrm>
-          <a:prstGeom prst="rect">
-            <a:avLst/>
-          </a:prstGeom>
-          <a:noFill/>
-          <a:ln/>
-        </p:spPr>
-        <p:txBody>
-          <a:bodyPr wrap="none" lIns="0" tIns="0" rIns="0" bIns="0" rtlCol="0" anchor="t">
-            <a:spAutoFit/>
-          </a:bodyPr>
-          <a:lstStyle/>
-          <a:p>
-            <a:pPr algn="l" indent="0" marL="0">
-              <a:lnSpc>
-                <a:spcPct val="128000"/>
-              </a:lnSpc>
-              <a:buNone/>
-            </a:pPr>
-            <a:r>
-              <a:rPr lang="en-US" sz="800" b="1" dirty="0">
-                <a:solidFill>
-                  <a:srgbClr val="2563EB"/>
-                </a:solidFill>
-                <a:latin typeface="Inter Bold" pitchFamily="34" charset="0"/>
-                <a:ea typeface="Inter Bold" pitchFamily="34" charset="-122"/>
-                <a:cs typeface="Inter Bold" pitchFamily="34" charset="-120"/>
-              </a:rPr>
-              <a:t>•</a:t>
-            </a:r>
-            <a:endParaRPr lang="en-US" sz="800" dirty="0"/>
-          </a:p>
-        </p:txBody>
-      </p:sp>
-      <p:sp>
-        <p:nvSpPr>
-          <p:cNvPr id="17" name="Text 12"/>
-          <p:cNvSpPr/>
-          <p:nvPr/>
-        </p:nvSpPr>
-        <p:spPr>
-          <a:xfrm>
-            <a:off x="4714875" y="3104545"/>
-            <a:ext cx="53578" cy="182863"/>
-          </a:xfrm>
-          <a:prstGeom prst="rect">
-            <a:avLst/>
-          </a:prstGeom>
-          <a:noFill/>
-          <a:ln/>
-        </p:spPr>
-        <p:txBody>
-          <a:bodyPr wrap="none" lIns="0" tIns="0" rIns="0" bIns="0" rtlCol="0" anchor="t">
-            <a:spAutoFit/>
-          </a:bodyPr>
-          <a:lstStyle/>
-          <a:p>
-            <a:pPr algn="l" indent="0" marL="0">
-              <a:lnSpc>
-                <a:spcPct val="128000"/>
-              </a:lnSpc>
-              <a:buNone/>
-            </a:pPr>
-            <a:r>
-              <a:rPr lang="en-US" sz="800" b="1" dirty="0">
-                <a:solidFill>
-                  <a:srgbClr val="2563EB"/>
-                </a:solidFill>
-                <a:latin typeface="Inter Bold" pitchFamily="34" charset="0"/>
-                <a:ea typeface="Inter Bold" pitchFamily="34" charset="-122"/>
-                <a:cs typeface="Inter Bold" pitchFamily="34" charset="-120"/>
-              </a:rPr>
-              <a:t>•</a:t>
-            </a:r>
-            <a:endParaRPr lang="en-US" sz="800" dirty="0"/>
-          </a:p>
-        </p:txBody>
-      </p:sp>
-      <p:sp>
-        <p:nvSpPr>
-          <p:cNvPr id="18" name="Text 13"/>
-          <p:cNvSpPr/>
-          <p:nvPr/>
-        </p:nvSpPr>
-        <p:spPr>
-          <a:xfrm>
-            <a:off x="4714875" y="3613147"/>
-            <a:ext cx="53578" cy="182863"/>
-          </a:xfrm>
-          <a:prstGeom prst="rect">
-            <a:avLst/>
-          </a:prstGeom>
-          <a:noFill/>
-          <a:ln/>
-        </p:spPr>
-        <p:txBody>
-          <a:bodyPr wrap="none" lIns="0" tIns="0" rIns="0" bIns="0" rtlCol="0" anchor="t">
-            <a:spAutoFit/>
-          </a:bodyPr>
-          <a:lstStyle/>
-          <a:p>
-            <a:pPr algn="l" indent="0" marL="0">
-              <a:lnSpc>
-                <a:spcPct val="128000"/>
-              </a:lnSpc>
-              <a:buNone/>
-            </a:pPr>
-            <a:r>
-              <a:rPr lang="en-US" sz="800" b="1" dirty="0">
-                <a:solidFill>
-                  <a:srgbClr val="2563EB"/>
-                </a:solidFill>
-                <a:latin typeface="Inter Bold" pitchFamily="34" charset="0"/>
-                <a:ea typeface="Inter Bold" pitchFamily="34" charset="-122"/>
-                <a:cs typeface="Inter Bold" pitchFamily="34" charset="-120"/>
-              </a:rPr>
-              <a:t>•</a:t>
-            </a:r>
-            <a:endParaRPr lang="en-US" sz="800" dirty="0"/>
-          </a:p>
-        </p:txBody>
-      </p:sp>
     </p:spTree>
   </p:cSld>
   <p:clrMapOvr>

</xml_diff>

<commit_message>
Add IEEE-style speaker notes for 10-min presentation script
</commit_message>
<xml_diff>
--- a/FC_Inverter_Presentation.pptx
+++ b/FC_Inverter_Presentation.pptx
@@ -514,7 +514,7 @@
           <a:p>
             <a:r>
               <a:rPr lang="en-US" dirty="0"/>
-              <a:t/>
+              <a:t>Good morning, everyone. Today, we'll delve into the vehicle architecture-driven design and comprehensive loss analysis of an 800V three-level flying capacitor traction inverter. This work addresses the critical need for high-efficiency, robust power electronics in modern electric vehicles. We'll explore how specific design choices, from the system architecture down to the component level, impact overall performance and reliability. Our focus will be on the rigorous analytical methods used to quantify these impacts.</a:t>
             </a:r>
             <a:endParaRPr lang="en-US" dirty="0"/>
           </a:p>
@@ -602,7 +602,7 @@
           <a:p>
             <a:r>
               <a:rPr lang="en-US" dirty="0"/>
-              <a:t/>
+              <a:t>Given the challenges of fixed-frequency operation, we developed and simulated an adaptive switching frequency schedule. The core principle is to maintain a sufficient frequency modulation ratio, mf, defined as the ratio of switching frequency to fundamental frequency, to ensure waveform quality while actively minimizing losses. For urban driving, where the fundamental frequency is low at 184 Hertz, the controller dynamically reduces the switching frequency to 5 kHz. This still maintains a high modulation ratio of approximately 27. This reduction in switching frequency yields substantial savings in switching losses precisely when the phase current is at its peak. This adaptive approach directly addresses the thermal challenges identified earlier. Next, we'll examine the thermal impact of this adaptive schedule.</a:t>
             </a:r>
             <a:endParaRPr lang="en-US" dirty="0"/>
           </a:p>
@@ -690,7 +690,7 @@
           <a:p>
             <a:r>
               <a:rPr lang="en-US" dirty="0"/>
-              <a:t/>
+              <a:t>Now, let's examine the crucial thermal implications of our adaptive schedule. We've seen how the adaptive schedule optimizes switching frequency; here, we quantify its impact on device thermals and reliability. We modeled the junction temperature, Tj, using a 4-layer Foster thermal network, directly parameterized from the CAB450M12XM3 datasheet, specifically Rth_jc of 94m°C/W. This detailed model allows us to accurately capture transient thermal behavior. The adaptive schedule significantly reduces steady-state Tj by 16.2°C during peak torque and 9.7°C in urban conditions compared to a fixed 20 kHz baseline. More critically, over a dynamic drive cycle, it cuts the thermal cycling amplitude, ΔTj, by 53%, from 16.4°C to a mere 7.7°C. This substantial reduction directly translates to a significant extension of the power module's operational lifetime, as predicted by the Coffin-Manson fatigue model. This is a key benefit for long-term reliability. Next, we'll dive into the full simulation results, including voltage balancing and harmonic performance.</a:t>
             </a:r>
             <a:endParaRPr lang="en-US" dirty="0"/>
           </a:p>
@@ -778,7 +778,7 @@
           <a:p>
             <a:r>
               <a:rPr lang="en-US" dirty="0"/>
-              <a:t/>
+              <a:t>Building on the thermal benefits, let's look at the comprehensive simulation results for our 3-level flying capacitor converter. First, regarding FC voltage balancing, a 20ms linear ramp pre-charge prevents inrush currents. Our PD-PWM strategy successfully maintains the flying capacitor voltage at precisely 400V, with a peak-to-peak ripple of 18.0V, well within our 5% design constraint. For harmonic performance, the 3-level output inherently improves power quality. In urban driving, at 5 kHz, the THD is 1.92%, and on the highway, at 20 kHz, it's 1.13%. Finally, our thermal analysis, using the 4-layer Foster network, shows the junction temperature peaks at only 50.1°C under the adaptive schedule. This provides a massive 124.9°C safety margin to the 175°C semiconductor limit of the CAB450M12XM3, ensuring robust operation. Now, let's summarize our findings and discuss limitations.</a:t>
             </a:r>
             <a:endParaRPr lang="en-US" dirty="0"/>
           </a:p>
@@ -866,7 +866,7 @@
           <a:p>
             <a:r>
               <a:rPr lang="en-US" dirty="0"/>
-              <a:t/>
+              <a:t>In conclusion, our investigation confirms several key findings for the 800V 3-Level Flying Capacitor topology. We've validated its ability to mitigate dv/dt stress and improve harmonic performance compared to a 2-level inverter. The adaptive switching frequency schedule is particularly impactful, reducing urban switching losses by 75%, from 84.3W to 21.1W per phase. Furthermore, this adaptive approach reduces thermal cycling amplitude by 53%, significantly extending the SiC power modules' lifetime. However, we acknowledge certain limitations. Our current time-domain simulation uses ideal switching transitions and does not account for device voltage drops, discrete dead-time distortion, DC bus ripple, or stray inductance. Future work will incorporate these non-idealities to provide more conservative and hardware-accurate THD and loss estimates, further refining our model's predictive capability.</a:t>
             </a:r>
             <a:endParaRPr lang="en-US" dirty="0"/>
           </a:p>
@@ -954,7 +954,7 @@
           <a:p>
             <a:r>
               <a:rPr lang="en-US" dirty="0"/>
-              <a:t/>
+              <a:t>Building on that, our project addresses a core challenge in traction inverter design: balancing efficiency, torque quality, and thermal stress across highly variable driving conditions. The electrical fundamental frequency is not fixed; it's directly proportional to vehicle speed, creating dynamic load profiles. Urban driving demands low frequency but high phase currents for acceleration, while highway driving requires high frequency but lower sustained currents. Our objective is to model a traction inverter across this full spectrum of operating conditions, evaluate comprehensive conduction and switching losses, and optimize the design for maximum drivetrain efficiency and thermal reliability. This comprehensive approach is crucial for next-generation EV powertrains.</a:t>
             </a:r>
             <a:endParaRPr lang="en-US" dirty="0"/>
           </a:p>
@@ -1042,7 +1042,7 @@
           <a:p>
             <a:r>
               <a:rPr lang="en-US" dirty="0"/>
-              <a:t/>
+              <a:t>To meet these demanding performance requirements, our baseline decision was to adopt an 800V DC bus architecture. This choice is fundamental because it halves the required phase current for a given power level compared to traditional 400V systems. This drastic current reduction significantly lowers I²R ohmic losses in the inverter semiconductors, motor windings, and high-voltage cabling. Ultimately, this enables faster DC fast charging, reduces cable weight, and improves overall powertrain efficiency, which are all critical benefits for electric vehicles. But this higher voltage introduces its own set of challenges, which we'll discuss next.</a:t>
             </a:r>
             <a:endParaRPr lang="en-US" dirty="0"/>
           </a:p>
@@ -1130,7 +1130,7 @@
           <a:p>
             <a:r>
               <a:rPr lang="en-US" dirty="0"/>
-              <a:t/>
+              <a:t>The transition to an 800V architecture, while beneficial for efficiency, exacerbates the dv/dt problem inherent with fast-switching SiC devices. Traditional two-level inverters operating on an 800V bus require 1200V-class semiconductors, and while SiC devices meet this, their extremely fast switching transitions generate severe dv/dt stress. This high rate of voltage change over time leads to premature motor winding insulation failure and bearing degradation. To mitigate this, a multilevel inverter topology is essential. It synthesizes the output voltage from multiple discrete levels, reducing the voltage step size to, for example, 400V steps instead of 800V, effectively cutting the dv/dt stress in half and improving the output waveform's harmonic profile. This brings us to the critical decision of which multilevel topology to employ.</a:t>
             </a:r>
             <a:endParaRPr lang="en-US" dirty="0"/>
           </a:p>
@@ -1218,7 +1218,7 @@
           <a:p>
             <a:r>
               <a:rPr lang="en-US" dirty="0"/>
-              <a:t/>
+              <a:t>When selecting a multilevel topology, we considered both the Flying Capacitor, or FC, and Neutral Point Clamped, or NPC, topologies. The FC topology offers significant advantages in thermal symmetry and dynamic load balancing. NPC suffers from asymmetric loss distribution between inner and outer switches, complicating cooling, whereas FC distributes voltage and current stresses symmetrically across all four switches, with each blocking Vdc/2. Furthermore, FC eliminates the need for clamping diodes, removing components from the conduction path and reducing conduction losses. Crucially, while NPC's neutral point is difficult to balance under dynamic EV loads, FC utilizes redundant switching states to naturally balance the flying capacitor voltage. It remains balanced at Vdc/2 regardless of the load power factor by actively selecting states based on phase current direction. This inherent balancing capability is a key differentiator for traction applications.</a:t>
             </a:r>
             <a:endParaRPr lang="en-US" dirty="0"/>
           </a:p>
@@ -1306,7 +1306,7 @@
           <a:p>
             <a:r>
               <a:rPr lang="en-US" dirty="0"/>
-              <a:t/>
+              <a:t>Here, we delve into the fundamental operation of the flying capacitor inverter, specifically its switching states and the control strategy. This topology synthesizes a three-level output, +Vdc/2, 0, and -Vdc/2, which inherently reduces voltage steps and dv/dt stress on the motor windings. A key feature is the presence of redundant zero states; the '0' voltage level can be achieved through two distinct switch combinations. We leverage this redundancy with Phase-Disposition PWM, or PD-PWM, which naturally balances the flying capacitor voltage to precisely Vdc/2. This is achieved by alternating between these redundant zero states based on the direction of the phase current, effectively charging or discharging the capacitor as needed. This elegant control mechanism avoids the need for complex closed-loop balancing circuits. Now, let's consider the critical component choices that enable this operation.</a:t>
             </a:r>
             <a:endParaRPr lang="en-US" dirty="0"/>
           </a:p>
@@ -1394,7 +1394,7 @@
           <a:p>
             <a:r>
               <a:rPr lang="en-US" dirty="0"/>
-              <a:t/>
+              <a:t>Building on the operational principles, component selection is paramount for robust performance. We chose the Wolfspeed CAB450M12XM3, a 1200V, 450A SiC half-bridge module, as our active switch. This provides a substantial 1200V voltage margin against a 400V bus, meeting IPC-9592B derating at 33% utilization, and a current margin of approximately 3.3 times the 136A peak phase current. Its positive temperature coefficient for Rds_on, scaling from 3.3mΩ at 25°C to 6.6mΩ at 175°C, inherently prevents thermal runaway. For the flying capacitor, we selected automotive-grade metallized polypropylene film technology with 680 microfarads. This capacitance ensures the voltage ripple remains within 5%, or 20V on a 400V bus, even at a minimum switching frequency of 5 kHz. Film capacitors offer very low ESR, typically less than 5 milliohms, superior high-frequency ripple handling, and extended lifespan compared to electrolytic options. With these components in mind, we can now map them to a realistic vehicle architecture.</a:t>
             </a:r>
             <a:endParaRPr lang="en-US" dirty="0"/>
           </a:p>
@@ -1482,7 +1482,7 @@
           <a:p>
             <a:r>
               <a:rPr lang="en-US" dirty="0"/>
-              <a:t/>
+              <a:t>Now, we map these components into a representative vehicle architecture to define operating points. We consider a single-speed reduction gear with a ratio of 8.19, a tire radius of 0.315 meters, and an 8-pole permanent magnet synchronous motor. This allows us to directly correlate vehicle speed to the motor's fundamental electrical frequency. For instance, urban driving at 40 kilometers per hour results in a low fundamental frequency of 184 Hertz, but it demands a high peak phase current of 136 Amperes, representing the highest current stress. Conversely, highway cruising at 120 kilometers per hour yields a higher fundamental frequency of 552 Hertz, but with a significantly lower sustained current of 51 Amperes due to increased load impedance. Understanding these distinct operating points is crucial for accurately analyzing switching losses. Let's move on to that analysis.</a:t>
             </a:r>
             <a:endParaRPr lang="en-US" dirty="0"/>
           </a:p>
@@ -1570,7 +1570,7 @@
           <a:p>
             <a:r>
               <a:rPr lang="en-US" dirty="0"/>
-              <a:t/>
+              <a:t>With the vehicle operating points defined, we can now quantify switching losses. We employ the Graovac-Purschel analytical method, which effectively captures drive-frequency effects and is well-suited for SiC devices by utilizing their specific device curves. We calibrate this model using the CAB450M12XM3 datasheet parameters: an Eon of 25.4 millijoules and an Eoff of 7.51 millijoules, both measured at 450 Amperes and 600 Volts. A critical finding from this analysis is that a fixed 20 kHz switching frequency presents a significant issue. At lower vehicle speeds, where phase currents are highest, around 136 Amperes, switching losses become dominant. This insight directly motivates our next step: developing an adaptive switching frequency schedule to mitigate these losses.</a:t>
             </a:r>
             <a:endParaRPr lang="en-US" dirty="0"/>
           </a:p>
@@ -1938,7 +1938,7 @@
       </p:grpSpPr>
       <p:pic>
         <p:nvPicPr>
-          <p:cNvPr id="2" name="Image 0" descr="preencoded.png">    </p:cNvPr>
+          <p:cNvPr id="3" name="Image 0" descr="preencoded.png">    </p:cNvPr>
           <p:cNvPicPr>
             <a:picLocks noChangeAspect="1"/>
           </p:cNvPicPr>
@@ -1962,7 +1962,7 @@
       </p:pic>
       <p:sp>
         <p:nvSpPr>
-          <p:cNvPr id="3" name="Text 0"/>
+          <p:cNvPr id="4" name="Text 0"/>
           <p:cNvSpPr/>
           <p:nvPr/>
         </p:nvSpPr>
@@ -2003,7 +2003,7 @@
       </p:sp>
       <p:sp>
         <p:nvSpPr>
-          <p:cNvPr id="4" name="Shape 1"/>
+          <p:cNvPr id="5" name="Shape 1"/>
           <p:cNvSpPr/>
           <p:nvPr/>
         </p:nvSpPr>
@@ -2025,7 +2025,7 @@
       </p:sp>
       <p:sp>
         <p:nvSpPr>
-          <p:cNvPr id="5" name="Shape 2"/>
+          <p:cNvPr id="6" name="Shape 2"/>
           <p:cNvSpPr/>
           <p:nvPr/>
         </p:nvSpPr>
@@ -2045,7 +2045,7 @@
       </p:sp>
       <p:sp>
         <p:nvSpPr>
-          <p:cNvPr id="6" name="Text 3"/>
+          <p:cNvPr id="7" name="Text 3"/>
           <p:cNvSpPr/>
           <p:nvPr/>
         </p:nvSpPr>
@@ -2089,7 +2089,7 @@
       </p:sp>
       <p:sp>
         <p:nvSpPr>
-          <p:cNvPr id="7" name="Text 4"/>
+          <p:cNvPr id="8" name="Text 4"/>
           <p:cNvSpPr/>
           <p:nvPr/>
         </p:nvSpPr>
@@ -2130,7 +2130,7 @@
       </p:sp>
       <p:sp>
         <p:nvSpPr>
-          <p:cNvPr id="8" name="Text 5"/>
+          <p:cNvPr id="9" name="Text 5"/>
           <p:cNvSpPr/>
           <p:nvPr/>
         </p:nvSpPr>
@@ -2196,7 +2196,7 @@
       </p:grpSpPr>
       <p:pic>
         <p:nvPicPr>
-          <p:cNvPr id="2" name="Image 0" descr="preencoded.png">    </p:cNvPr>
+          <p:cNvPr id="3" name="Image 0" descr="preencoded.png">    </p:cNvPr>
           <p:cNvPicPr>
             <a:picLocks noChangeAspect="1"/>
           </p:cNvPicPr>
@@ -2220,7 +2220,7 @@
       </p:pic>
       <p:sp>
         <p:nvSpPr>
-          <p:cNvPr id="3" name="Text 0"/>
+          <p:cNvPr id="4" name="Text 0"/>
           <p:cNvSpPr/>
           <p:nvPr/>
         </p:nvSpPr>
@@ -2261,7 +2261,7 @@
       </p:sp>
       <p:sp>
         <p:nvSpPr>
-          <p:cNvPr id="4" name="Text 1"/>
+          <p:cNvPr id="5" name="Text 1"/>
           <p:cNvSpPr/>
           <p:nvPr/>
         </p:nvSpPr>
@@ -2302,7 +2302,7 @@
       </p:sp>
       <p:sp>
         <p:nvSpPr>
-          <p:cNvPr id="5" name="Text 2"/>
+          <p:cNvPr id="6" name="Text 2"/>
           <p:cNvSpPr/>
           <p:nvPr/>
         </p:nvSpPr>
@@ -2346,7 +2346,7 @@
       </p:sp>
       <p:sp>
         <p:nvSpPr>
-          <p:cNvPr id="6" name="Text 3"/>
+          <p:cNvPr id="7" name="Text 3"/>
           <p:cNvSpPr/>
           <p:nvPr/>
         </p:nvSpPr>
@@ -2390,7 +2390,7 @@
       </p:sp>
       <p:sp>
         <p:nvSpPr>
-          <p:cNvPr id="7" name="Text 4"/>
+          <p:cNvPr id="8" name="Text 4"/>
           <p:cNvSpPr/>
           <p:nvPr/>
         </p:nvSpPr>
@@ -2434,7 +2434,7 @@
       </p:sp>
       <p:sp>
         <p:nvSpPr>
-          <p:cNvPr id="8" name="Text 5"/>
+          <p:cNvPr id="9" name="Text 5"/>
           <p:cNvSpPr/>
           <p:nvPr/>
         </p:nvSpPr>
@@ -2478,7 +2478,7 @@
       </p:sp>
       <p:sp>
         <p:nvSpPr>
-          <p:cNvPr id="9" name="Text 6"/>
+          <p:cNvPr id="10" name="Text 6"/>
           <p:cNvSpPr/>
           <p:nvPr/>
         </p:nvSpPr>
@@ -2522,7 +2522,7 @@
       </p:sp>
       <p:sp>
         <p:nvSpPr>
-          <p:cNvPr id="10" name="Text 7"/>
+          <p:cNvPr id="11" name="Text 7"/>
           <p:cNvSpPr/>
           <p:nvPr/>
         </p:nvSpPr>
@@ -2566,7 +2566,7 @@
       </p:sp>
       <p:sp>
         <p:nvSpPr>
-          <p:cNvPr id="11" name="Text 8"/>
+          <p:cNvPr id="12" name="Text 8"/>
           <p:cNvSpPr/>
           <p:nvPr/>
         </p:nvSpPr>
@@ -2610,7 +2610,7 @@
       </p:sp>
       <p:sp>
         <p:nvSpPr>
-          <p:cNvPr id="12" name="Text 9"/>
+          <p:cNvPr id="13" name="Text 9"/>
           <p:cNvSpPr/>
           <p:nvPr/>
         </p:nvSpPr>
@@ -2654,7 +2654,7 @@
       </p:sp>
       <p:sp>
         <p:nvSpPr>
-          <p:cNvPr id="13" name="Text 10"/>
+          <p:cNvPr id="14" name="Text 10"/>
           <p:cNvSpPr/>
           <p:nvPr/>
         </p:nvSpPr>
@@ -2698,7 +2698,7 @@
       </p:sp>
       <p:sp>
         <p:nvSpPr>
-          <p:cNvPr id="14" name="Text 11"/>
+          <p:cNvPr id="15" name="Text 11"/>
           <p:cNvSpPr/>
           <p:nvPr/>
         </p:nvSpPr>
@@ -2742,7 +2742,7 @@
       </p:sp>
       <p:sp>
         <p:nvSpPr>
-          <p:cNvPr id="15" name="Text 12"/>
+          <p:cNvPr id="16" name="Text 12"/>
           <p:cNvSpPr/>
           <p:nvPr/>
         </p:nvSpPr>
@@ -2786,7 +2786,7 @@
       </p:sp>
       <p:sp>
         <p:nvSpPr>
-          <p:cNvPr id="16" name="Shape 13"/>
+          <p:cNvPr id="17" name="Shape 13"/>
           <p:cNvSpPr/>
           <p:nvPr/>
         </p:nvSpPr>
@@ -2806,7 +2806,7 @@
       </p:sp>
       <p:sp>
         <p:nvSpPr>
-          <p:cNvPr id="17" name="Shape 14"/>
+          <p:cNvPr id="18" name="Shape 14"/>
           <p:cNvSpPr/>
           <p:nvPr/>
         </p:nvSpPr>
@@ -2826,7 +2826,7 @@
       </p:sp>
       <p:sp>
         <p:nvSpPr>
-          <p:cNvPr id="18" name="Text 15"/>
+          <p:cNvPr id="19" name="Text 15"/>
           <p:cNvSpPr/>
           <p:nvPr/>
         </p:nvSpPr>
@@ -2867,7 +2867,7 @@
       </p:sp>
       <p:sp>
         <p:nvSpPr>
-          <p:cNvPr id="19" name="Text 16"/>
+          <p:cNvPr id="20" name="Text 16"/>
           <p:cNvSpPr/>
           <p:nvPr/>
         </p:nvSpPr>
@@ -2908,7 +2908,7 @@
       </p:sp>
       <p:sp>
         <p:nvSpPr>
-          <p:cNvPr id="20" name="Text 17"/>
+          <p:cNvPr id="21" name="Text 17"/>
           <p:cNvSpPr/>
           <p:nvPr/>
         </p:nvSpPr>
@@ -2949,7 +2949,7 @@
       </p:sp>
       <p:sp>
         <p:nvSpPr>
-          <p:cNvPr id="21" name="Text 18"/>
+          <p:cNvPr id="22" name="Text 18"/>
           <p:cNvSpPr/>
           <p:nvPr/>
         </p:nvSpPr>
@@ -2993,7 +2993,7 @@
       </p:sp>
       <p:sp>
         <p:nvSpPr>
-          <p:cNvPr id="22" name="Text 19"/>
+          <p:cNvPr id="23" name="Text 19"/>
           <p:cNvSpPr/>
           <p:nvPr/>
         </p:nvSpPr>
@@ -3037,7 +3037,7 @@
       </p:sp>
       <p:sp>
         <p:nvSpPr>
-          <p:cNvPr id="23" name="Text 20"/>
+          <p:cNvPr id="24" name="Text 20"/>
           <p:cNvSpPr/>
           <p:nvPr/>
         </p:nvSpPr>
@@ -3081,7 +3081,7 @@
       </p:sp>
       <p:sp>
         <p:nvSpPr>
-          <p:cNvPr id="24" name="Text 21"/>
+          <p:cNvPr id="25" name="Text 21"/>
           <p:cNvSpPr/>
           <p:nvPr/>
         </p:nvSpPr>
@@ -3125,7 +3125,7 @@
       </p:sp>
       <p:sp>
         <p:nvSpPr>
-          <p:cNvPr id="25" name="Text 22"/>
+          <p:cNvPr id="26" name="Text 22"/>
           <p:cNvSpPr/>
           <p:nvPr/>
         </p:nvSpPr>
@@ -3169,7 +3169,7 @@
       </p:sp>
       <p:sp>
         <p:nvSpPr>
-          <p:cNvPr id="26" name="Text 23"/>
+          <p:cNvPr id="27" name="Text 23"/>
           <p:cNvSpPr/>
           <p:nvPr/>
         </p:nvSpPr>
@@ -3213,7 +3213,7 @@
       </p:sp>
       <p:sp>
         <p:nvSpPr>
-          <p:cNvPr id="27" name="Text 24"/>
+          <p:cNvPr id="28" name="Text 24"/>
           <p:cNvSpPr/>
           <p:nvPr/>
         </p:nvSpPr>
@@ -3257,7 +3257,7 @@
       </p:sp>
       <p:sp>
         <p:nvSpPr>
-          <p:cNvPr id="28" name="Text 25"/>
+          <p:cNvPr id="29" name="Text 25"/>
           <p:cNvSpPr/>
           <p:nvPr/>
         </p:nvSpPr>
@@ -3301,7 +3301,7 @@
       </p:sp>
       <p:sp>
         <p:nvSpPr>
-          <p:cNvPr id="29" name="Text 26"/>
+          <p:cNvPr id="30" name="Text 26"/>
           <p:cNvSpPr/>
           <p:nvPr/>
         </p:nvSpPr>
@@ -3345,7 +3345,7 @@
       </p:sp>
       <p:sp>
         <p:nvSpPr>
-          <p:cNvPr id="30" name="Text 27"/>
+          <p:cNvPr id="31" name="Text 27"/>
           <p:cNvSpPr/>
           <p:nvPr/>
         </p:nvSpPr>
@@ -3389,7 +3389,7 @@
       </p:sp>
       <p:sp>
         <p:nvSpPr>
-          <p:cNvPr id="31" name="Text 28"/>
+          <p:cNvPr id="32" name="Text 28"/>
           <p:cNvSpPr/>
           <p:nvPr/>
         </p:nvSpPr>
@@ -3433,7 +3433,7 @@
       </p:sp>
       <p:pic>
         <p:nvPicPr>
-          <p:cNvPr id="32" name="Image 1" descr="preencoded.png">    </p:cNvPr>
+          <p:cNvPr id="33" name="Image 1" descr="preencoded.png">    </p:cNvPr>
           <p:cNvPicPr>
             <a:picLocks noChangeAspect="1"/>
           </p:cNvPicPr>
@@ -3482,7 +3482,7 @@
       </p:grpSpPr>
       <p:pic>
         <p:nvPicPr>
-          <p:cNvPr id="2" name="Image 0" descr="preencoded.png">    </p:cNvPr>
+          <p:cNvPr id="3" name="Image 0" descr="preencoded.png">    </p:cNvPr>
           <p:cNvPicPr>
             <a:picLocks noChangeAspect="1"/>
           </p:cNvPicPr>
@@ -3506,7 +3506,7 @@
       </p:pic>
       <p:sp>
         <p:nvSpPr>
-          <p:cNvPr id="3" name="Text 0"/>
+          <p:cNvPr id="4" name="Text 0"/>
           <p:cNvSpPr/>
           <p:nvPr/>
         </p:nvSpPr>
@@ -3547,7 +3547,7 @@
       </p:sp>
       <p:sp>
         <p:nvSpPr>
-          <p:cNvPr id="4" name="Text 1"/>
+          <p:cNvPr id="5" name="Text 1"/>
           <p:cNvSpPr/>
           <p:nvPr/>
         </p:nvSpPr>
@@ -3588,7 +3588,7 @@
       </p:sp>
       <p:sp>
         <p:nvSpPr>
-          <p:cNvPr id="5" name="Text 2"/>
+          <p:cNvPr id="6" name="Text 2"/>
           <p:cNvSpPr/>
           <p:nvPr/>
         </p:nvSpPr>
@@ -3632,7 +3632,7 @@
       </p:sp>
       <p:sp>
         <p:nvSpPr>
-          <p:cNvPr id="6" name="Text 3"/>
+          <p:cNvPr id="7" name="Text 3"/>
           <p:cNvSpPr/>
           <p:nvPr/>
         </p:nvSpPr>
@@ -3676,7 +3676,7 @@
       </p:sp>
       <p:sp>
         <p:nvSpPr>
-          <p:cNvPr id="7" name="Text 4"/>
+          <p:cNvPr id="8" name="Text 4"/>
           <p:cNvSpPr/>
           <p:nvPr/>
         </p:nvSpPr>
@@ -3720,7 +3720,7 @@
       </p:sp>
       <p:sp>
         <p:nvSpPr>
-          <p:cNvPr id="8" name="Text 5"/>
+          <p:cNvPr id="9" name="Text 5"/>
           <p:cNvSpPr/>
           <p:nvPr/>
         </p:nvSpPr>
@@ -3764,7 +3764,7 @@
       </p:sp>
       <p:sp>
         <p:nvSpPr>
-          <p:cNvPr id="9" name="Text 6"/>
+          <p:cNvPr id="10" name="Text 6"/>
           <p:cNvSpPr/>
           <p:nvPr/>
         </p:nvSpPr>
@@ -3808,7 +3808,7 @@
       </p:sp>
       <p:sp>
         <p:nvSpPr>
-          <p:cNvPr id="10" name="Text 7"/>
+          <p:cNvPr id="11" name="Text 7"/>
           <p:cNvSpPr/>
           <p:nvPr/>
         </p:nvSpPr>
@@ -3852,7 +3852,7 @@
       </p:sp>
       <p:sp>
         <p:nvSpPr>
-          <p:cNvPr id="11" name="Text 8"/>
+          <p:cNvPr id="12" name="Text 8"/>
           <p:cNvSpPr/>
           <p:nvPr/>
         </p:nvSpPr>
@@ -3896,7 +3896,7 @@
       </p:sp>
       <p:sp>
         <p:nvSpPr>
-          <p:cNvPr id="12" name="Text 9"/>
+          <p:cNvPr id="13" name="Text 9"/>
           <p:cNvSpPr/>
           <p:nvPr/>
         </p:nvSpPr>
@@ -3940,7 +3940,7 @@
       </p:sp>
       <p:sp>
         <p:nvSpPr>
-          <p:cNvPr id="13" name="Text 10"/>
+          <p:cNvPr id="14" name="Text 10"/>
           <p:cNvSpPr/>
           <p:nvPr/>
         </p:nvSpPr>
@@ -3984,7 +3984,7 @@
       </p:sp>
       <p:sp>
         <p:nvSpPr>
-          <p:cNvPr id="14" name="Text 11"/>
+          <p:cNvPr id="15" name="Text 11"/>
           <p:cNvSpPr/>
           <p:nvPr/>
         </p:nvSpPr>
@@ -4028,7 +4028,7 @@
       </p:sp>
       <p:sp>
         <p:nvSpPr>
-          <p:cNvPr id="15" name="Text 12"/>
+          <p:cNvPr id="16" name="Text 12"/>
           <p:cNvSpPr/>
           <p:nvPr/>
         </p:nvSpPr>
@@ -4072,7 +4072,7 @@
       </p:sp>
       <p:sp>
         <p:nvSpPr>
-          <p:cNvPr id="16" name="Text 13"/>
+          <p:cNvPr id="17" name="Text 13"/>
           <p:cNvSpPr/>
           <p:nvPr/>
         </p:nvSpPr>
@@ -4116,7 +4116,7 @@
       </p:sp>
       <p:sp>
         <p:nvSpPr>
-          <p:cNvPr id="17" name="Text 14"/>
+          <p:cNvPr id="18" name="Text 14"/>
           <p:cNvSpPr/>
           <p:nvPr/>
         </p:nvSpPr>
@@ -4160,7 +4160,7 @@
       </p:sp>
       <p:sp>
         <p:nvSpPr>
-          <p:cNvPr id="18" name="Text 15"/>
+          <p:cNvPr id="19" name="Text 15"/>
           <p:cNvSpPr/>
           <p:nvPr/>
         </p:nvSpPr>
@@ -4204,7 +4204,7 @@
       </p:sp>
       <p:sp>
         <p:nvSpPr>
-          <p:cNvPr id="19" name="Text 16"/>
+          <p:cNvPr id="20" name="Text 16"/>
           <p:cNvSpPr/>
           <p:nvPr/>
         </p:nvSpPr>
@@ -4248,7 +4248,7 @@
       </p:sp>
       <p:sp>
         <p:nvSpPr>
-          <p:cNvPr id="20" name="Text 17"/>
+          <p:cNvPr id="21" name="Text 17"/>
           <p:cNvSpPr/>
           <p:nvPr/>
         </p:nvSpPr>
@@ -4303,7 +4303,7 @@
       </p:sp>
       <p:sp>
         <p:nvSpPr>
-          <p:cNvPr id="21" name="Text 18"/>
+          <p:cNvPr id="22" name="Text 18"/>
           <p:cNvSpPr/>
           <p:nvPr/>
         </p:nvSpPr>
@@ -4347,7 +4347,7 @@
       </p:sp>
       <p:pic>
         <p:nvPicPr>
-          <p:cNvPr id="22" name="Image 1" descr="preencoded.png">    </p:cNvPr>
+          <p:cNvPr id="23" name="Image 1" descr="preencoded.png">    </p:cNvPr>
           <p:cNvPicPr>
             <a:picLocks noChangeAspect="1"/>
           </p:cNvPicPr>
@@ -4371,7 +4371,7 @@
       </p:pic>
       <p:sp>
         <p:nvSpPr>
-          <p:cNvPr id="23" name="Text 19"/>
+          <p:cNvPr id="24" name="Text 19"/>
           <p:cNvSpPr/>
           <p:nvPr/>
         </p:nvSpPr>
@@ -4440,7 +4440,7 @@
       </p:grpSpPr>
       <p:pic>
         <p:nvPicPr>
-          <p:cNvPr id="2" name="Image 0" descr="preencoded.png">    </p:cNvPr>
+          <p:cNvPr id="3" name="Image 0" descr="preencoded.png">    </p:cNvPr>
           <p:cNvPicPr>
             <a:picLocks noChangeAspect="1"/>
           </p:cNvPicPr>
@@ -4464,7 +4464,7 @@
       </p:pic>
       <p:sp>
         <p:nvSpPr>
-          <p:cNvPr id="3" name="Text 0"/>
+          <p:cNvPr id="4" name="Text 0"/>
           <p:cNvSpPr/>
           <p:nvPr/>
         </p:nvSpPr>
@@ -4505,7 +4505,7 @@
       </p:sp>
       <p:sp>
         <p:nvSpPr>
-          <p:cNvPr id="4" name="Text 1"/>
+          <p:cNvPr id="5" name="Text 1"/>
           <p:cNvSpPr/>
           <p:nvPr/>
         </p:nvSpPr>
@@ -4546,7 +4546,7 @@
       </p:sp>
       <p:sp>
         <p:nvSpPr>
-          <p:cNvPr id="5" name="Text 2"/>
+          <p:cNvPr id="6" name="Text 2"/>
           <p:cNvSpPr/>
           <p:nvPr/>
         </p:nvSpPr>
@@ -4587,7 +4587,7 @@
       </p:sp>
       <p:sp>
         <p:nvSpPr>
-          <p:cNvPr id="6" name="Text 3"/>
+          <p:cNvPr id="7" name="Text 3"/>
           <p:cNvSpPr/>
           <p:nvPr/>
         </p:nvSpPr>
@@ -4642,7 +4642,7 @@
       </p:sp>
       <p:sp>
         <p:nvSpPr>
-          <p:cNvPr id="7" name="Text 4"/>
+          <p:cNvPr id="8" name="Text 4"/>
           <p:cNvSpPr/>
           <p:nvPr/>
         </p:nvSpPr>
@@ -4697,7 +4697,7 @@
       </p:sp>
       <p:sp>
         <p:nvSpPr>
-          <p:cNvPr id="8" name="Text 5"/>
+          <p:cNvPr id="9" name="Text 5"/>
           <p:cNvSpPr/>
           <p:nvPr/>
         </p:nvSpPr>
@@ -4752,7 +4752,7 @@
       </p:sp>
       <p:sp>
         <p:nvSpPr>
-          <p:cNvPr id="9" name="Text 6"/>
+          <p:cNvPr id="10" name="Text 6"/>
           <p:cNvSpPr/>
           <p:nvPr/>
         </p:nvSpPr>
@@ -4796,7 +4796,7 @@
       </p:sp>
       <p:sp>
         <p:nvSpPr>
-          <p:cNvPr id="10" name="Text 7"/>
+          <p:cNvPr id="11" name="Text 7"/>
           <p:cNvSpPr/>
           <p:nvPr/>
         </p:nvSpPr>
@@ -4840,7 +4840,7 @@
       </p:sp>
       <p:sp>
         <p:nvSpPr>
-          <p:cNvPr id="11" name="Text 8"/>
+          <p:cNvPr id="12" name="Text 8"/>
           <p:cNvSpPr/>
           <p:nvPr/>
         </p:nvSpPr>
@@ -4884,7 +4884,7 @@
       </p:sp>
       <p:sp>
         <p:nvSpPr>
-          <p:cNvPr id="12" name="Text 9"/>
+          <p:cNvPr id="13" name="Text 9"/>
           <p:cNvSpPr/>
           <p:nvPr/>
         </p:nvSpPr>
@@ -4925,7 +4925,7 @@
       </p:sp>
       <p:sp>
         <p:nvSpPr>
-          <p:cNvPr id="13" name="Text 10"/>
+          <p:cNvPr id="14" name="Text 10"/>
           <p:cNvSpPr/>
           <p:nvPr/>
         </p:nvSpPr>
@@ -4980,7 +4980,7 @@
       </p:sp>
       <p:sp>
         <p:nvSpPr>
-          <p:cNvPr id="14" name="Text 11"/>
+          <p:cNvPr id="15" name="Text 11"/>
           <p:cNvSpPr/>
           <p:nvPr/>
         </p:nvSpPr>
@@ -5035,7 +5035,7 @@
       </p:sp>
       <p:sp>
         <p:nvSpPr>
-          <p:cNvPr id="15" name="Text 12"/>
+          <p:cNvPr id="16" name="Text 12"/>
           <p:cNvSpPr/>
           <p:nvPr/>
         </p:nvSpPr>
@@ -5090,7 +5090,7 @@
       </p:sp>
       <p:sp>
         <p:nvSpPr>
-          <p:cNvPr id="16" name="Text 13"/>
+          <p:cNvPr id="17" name="Text 13"/>
           <p:cNvSpPr/>
           <p:nvPr/>
         </p:nvSpPr>
@@ -5134,7 +5134,7 @@
       </p:sp>
       <p:sp>
         <p:nvSpPr>
-          <p:cNvPr id="17" name="Text 14"/>
+          <p:cNvPr id="18" name="Text 14"/>
           <p:cNvSpPr/>
           <p:nvPr/>
         </p:nvSpPr>
@@ -5178,7 +5178,7 @@
       </p:sp>
       <p:sp>
         <p:nvSpPr>
-          <p:cNvPr id="18" name="Text 15"/>
+          <p:cNvPr id="19" name="Text 15"/>
           <p:cNvSpPr/>
           <p:nvPr/>
         </p:nvSpPr>
@@ -5222,7 +5222,7 @@
       </p:sp>
       <p:sp>
         <p:nvSpPr>
-          <p:cNvPr id="19" name="Text 16"/>
+          <p:cNvPr id="20" name="Text 16"/>
           <p:cNvSpPr/>
           <p:nvPr/>
         </p:nvSpPr>
@@ -5263,7 +5263,7 @@
       </p:sp>
       <p:sp>
         <p:nvSpPr>
-          <p:cNvPr id="20" name="Text 17"/>
+          <p:cNvPr id="21" name="Text 17"/>
           <p:cNvSpPr/>
           <p:nvPr/>
         </p:nvSpPr>
@@ -5318,7 +5318,7 @@
       </p:sp>
       <p:sp>
         <p:nvSpPr>
-          <p:cNvPr id="21" name="Text 18"/>
+          <p:cNvPr id="22" name="Text 18"/>
           <p:cNvSpPr/>
           <p:nvPr/>
         </p:nvSpPr>
@@ -5362,7 +5362,7 @@
       </p:sp>
       <p:sp>
         <p:nvSpPr>
-          <p:cNvPr id="22" name="Text 19"/>
+          <p:cNvPr id="23" name="Text 19"/>
           <p:cNvSpPr/>
           <p:nvPr/>
         </p:nvSpPr>
@@ -5406,7 +5406,7 @@
       </p:sp>
       <p:sp>
         <p:nvSpPr>
-          <p:cNvPr id="23" name="Text 20"/>
+          <p:cNvPr id="24" name="Text 20"/>
           <p:cNvSpPr/>
           <p:nvPr/>
         </p:nvSpPr>
@@ -5450,7 +5450,7 @@
       </p:sp>
       <p:sp>
         <p:nvSpPr>
-          <p:cNvPr id="24" name="Text 21"/>
+          <p:cNvPr id="25" name="Text 21"/>
           <p:cNvSpPr/>
           <p:nvPr/>
         </p:nvSpPr>
@@ -5494,7 +5494,7 @@
       </p:sp>
       <p:sp>
         <p:nvSpPr>
-          <p:cNvPr id="25" name="Text 22"/>
+          <p:cNvPr id="26" name="Text 22"/>
           <p:cNvSpPr/>
           <p:nvPr/>
         </p:nvSpPr>
@@ -5538,7 +5538,7 @@
       </p:sp>
       <p:sp>
         <p:nvSpPr>
-          <p:cNvPr id="26" name="Text 23"/>
+          <p:cNvPr id="27" name="Text 23"/>
           <p:cNvSpPr/>
           <p:nvPr/>
         </p:nvSpPr>
@@ -5582,7 +5582,7 @@
       </p:sp>
       <p:sp>
         <p:nvSpPr>
-          <p:cNvPr id="27" name="Text 24"/>
+          <p:cNvPr id="28" name="Text 24"/>
           <p:cNvSpPr/>
           <p:nvPr/>
         </p:nvSpPr>
@@ -5637,7 +5637,7 @@
       </p:sp>
       <p:sp>
         <p:nvSpPr>
-          <p:cNvPr id="28" name="Text 25"/>
+          <p:cNvPr id="29" name="Text 25"/>
           <p:cNvSpPr/>
           <p:nvPr/>
         </p:nvSpPr>
@@ -5706,7 +5706,7 @@
       </p:grpSpPr>
       <p:pic>
         <p:nvPicPr>
-          <p:cNvPr id="2" name="Image 0" descr="preencoded.png">    </p:cNvPr>
+          <p:cNvPr id="3" name="Image 0" descr="preencoded.png">    </p:cNvPr>
           <p:cNvPicPr>
             <a:picLocks noChangeAspect="1"/>
           </p:cNvPicPr>
@@ -5730,7 +5730,7 @@
       </p:pic>
       <p:sp>
         <p:nvSpPr>
-          <p:cNvPr id="3" name="Text 0"/>
+          <p:cNvPr id="4" name="Text 0"/>
           <p:cNvSpPr/>
           <p:nvPr/>
         </p:nvSpPr>
@@ -5771,7 +5771,7 @@
       </p:sp>
       <p:sp>
         <p:nvSpPr>
-          <p:cNvPr id="4" name="Text 1"/>
+          <p:cNvPr id="5" name="Text 1"/>
           <p:cNvSpPr/>
           <p:nvPr/>
         </p:nvSpPr>
@@ -5812,7 +5812,7 @@
       </p:sp>
       <p:sp>
         <p:nvSpPr>
-          <p:cNvPr id="5" name="Text 2"/>
+          <p:cNvPr id="6" name="Text 2"/>
           <p:cNvSpPr/>
           <p:nvPr/>
         </p:nvSpPr>
@@ -5853,7 +5853,7 @@
       </p:sp>
       <p:sp>
         <p:nvSpPr>
-          <p:cNvPr id="6" name="Text 3"/>
+          <p:cNvPr id="7" name="Text 3"/>
           <p:cNvSpPr/>
           <p:nvPr/>
         </p:nvSpPr>
@@ -5908,7 +5908,7 @@
       </p:sp>
       <p:sp>
         <p:nvSpPr>
-          <p:cNvPr id="7" name="Text 4"/>
+          <p:cNvPr id="8" name="Text 4"/>
           <p:cNvSpPr/>
           <p:nvPr/>
         </p:nvSpPr>
@@ -5985,7 +5985,7 @@
       </p:sp>
       <p:sp>
         <p:nvSpPr>
-          <p:cNvPr id="8" name="Text 5"/>
+          <p:cNvPr id="9" name="Text 5"/>
           <p:cNvSpPr/>
           <p:nvPr/>
         </p:nvSpPr>
@@ -6062,7 +6062,7 @@
       </p:sp>
       <p:sp>
         <p:nvSpPr>
-          <p:cNvPr id="9" name="Text 6"/>
+          <p:cNvPr id="10" name="Text 6"/>
           <p:cNvSpPr/>
           <p:nvPr/>
         </p:nvSpPr>
@@ -6106,7 +6106,7 @@
       </p:sp>
       <p:sp>
         <p:nvSpPr>
-          <p:cNvPr id="10" name="Text 7"/>
+          <p:cNvPr id="11" name="Text 7"/>
           <p:cNvSpPr/>
           <p:nvPr/>
         </p:nvSpPr>
@@ -6150,7 +6150,7 @@
       </p:sp>
       <p:sp>
         <p:nvSpPr>
-          <p:cNvPr id="11" name="Text 8"/>
+          <p:cNvPr id="12" name="Text 8"/>
           <p:cNvSpPr/>
           <p:nvPr/>
         </p:nvSpPr>
@@ -6194,7 +6194,7 @@
       </p:sp>
       <p:sp>
         <p:nvSpPr>
-          <p:cNvPr id="12" name="Text 9"/>
+          <p:cNvPr id="13" name="Text 9"/>
           <p:cNvSpPr/>
           <p:nvPr/>
         </p:nvSpPr>
@@ -6235,7 +6235,7 @@
       </p:sp>
       <p:sp>
         <p:nvSpPr>
-          <p:cNvPr id="13" name="Text 10"/>
+          <p:cNvPr id="14" name="Text 10"/>
           <p:cNvSpPr/>
           <p:nvPr/>
         </p:nvSpPr>
@@ -6290,7 +6290,7 @@
       </p:sp>
       <p:sp>
         <p:nvSpPr>
-          <p:cNvPr id="14" name="Text 11"/>
+          <p:cNvPr id="15" name="Text 11"/>
           <p:cNvSpPr/>
           <p:nvPr/>
         </p:nvSpPr>
@@ -6345,7 +6345,7 @@
       </p:sp>
       <p:sp>
         <p:nvSpPr>
-          <p:cNvPr id="15" name="Text 12"/>
+          <p:cNvPr id="16" name="Text 12"/>
           <p:cNvSpPr/>
           <p:nvPr/>
         </p:nvSpPr>
@@ -6400,7 +6400,7 @@
       </p:sp>
       <p:sp>
         <p:nvSpPr>
-          <p:cNvPr id="16" name="Text 13"/>
+          <p:cNvPr id="17" name="Text 13"/>
           <p:cNvSpPr/>
           <p:nvPr/>
         </p:nvSpPr>
@@ -6444,7 +6444,7 @@
       </p:sp>
       <p:sp>
         <p:nvSpPr>
-          <p:cNvPr id="17" name="Text 14"/>
+          <p:cNvPr id="18" name="Text 14"/>
           <p:cNvSpPr/>
           <p:nvPr/>
         </p:nvSpPr>
@@ -6488,7 +6488,7 @@
       </p:sp>
       <p:sp>
         <p:nvSpPr>
-          <p:cNvPr id="18" name="Text 15"/>
+          <p:cNvPr id="19" name="Text 15"/>
           <p:cNvSpPr/>
           <p:nvPr/>
         </p:nvSpPr>
@@ -6557,7 +6557,7 @@
       </p:grpSpPr>
       <p:pic>
         <p:nvPicPr>
-          <p:cNvPr id="2" name="Image 0" descr="preencoded.png">    </p:cNvPr>
+          <p:cNvPr id="3" name="Image 0" descr="preencoded.png">    </p:cNvPr>
           <p:cNvPicPr>
             <a:picLocks noChangeAspect="1"/>
           </p:cNvPicPr>
@@ -6581,7 +6581,7 @@
       </p:pic>
       <p:sp>
         <p:nvSpPr>
-          <p:cNvPr id="3" name="Text 0"/>
+          <p:cNvPr id="4" name="Text 0"/>
           <p:cNvSpPr/>
           <p:nvPr/>
         </p:nvSpPr>
@@ -6622,7 +6622,7 @@
       </p:sp>
       <p:sp>
         <p:nvSpPr>
-          <p:cNvPr id="4" name="Text 1"/>
+          <p:cNvPr id="5" name="Text 1"/>
           <p:cNvSpPr/>
           <p:nvPr/>
         </p:nvSpPr>
@@ -6663,7 +6663,7 @@
       </p:sp>
       <p:sp>
         <p:nvSpPr>
-          <p:cNvPr id="5" name="Text 2"/>
+          <p:cNvPr id="6" name="Text 2"/>
           <p:cNvSpPr/>
           <p:nvPr/>
         </p:nvSpPr>
@@ -6718,7 +6718,7 @@
       </p:sp>
       <p:sp>
         <p:nvSpPr>
-          <p:cNvPr id="6" name="Text 3"/>
+          <p:cNvPr id="7" name="Text 3"/>
           <p:cNvSpPr/>
           <p:nvPr/>
         </p:nvSpPr>
@@ -6762,7 +6762,7 @@
       </p:sp>
       <p:sp>
         <p:nvSpPr>
-          <p:cNvPr id="7" name="Text 4"/>
+          <p:cNvPr id="8" name="Text 4"/>
           <p:cNvSpPr/>
           <p:nvPr/>
         </p:nvSpPr>
@@ -6806,7 +6806,7 @@
       </p:sp>
       <p:sp>
         <p:nvSpPr>
-          <p:cNvPr id="8" name="Text 5"/>
+          <p:cNvPr id="9" name="Text 5"/>
           <p:cNvSpPr/>
           <p:nvPr/>
         </p:nvSpPr>
@@ -6850,7 +6850,7 @@
       </p:sp>
       <p:sp>
         <p:nvSpPr>
-          <p:cNvPr id="9" name="Text 6"/>
+          <p:cNvPr id="10" name="Text 6"/>
           <p:cNvSpPr/>
           <p:nvPr/>
         </p:nvSpPr>
@@ -6894,7 +6894,7 @@
       </p:sp>
       <p:sp>
         <p:nvSpPr>
-          <p:cNvPr id="10" name="Text 7"/>
+          <p:cNvPr id="11" name="Text 7"/>
           <p:cNvSpPr/>
           <p:nvPr/>
         </p:nvSpPr>
@@ -6938,7 +6938,7 @@
       </p:sp>
       <p:sp>
         <p:nvSpPr>
-          <p:cNvPr id="11" name="Text 8"/>
+          <p:cNvPr id="12" name="Text 8"/>
           <p:cNvSpPr/>
           <p:nvPr/>
         </p:nvSpPr>
@@ -6982,7 +6982,7 @@
       </p:sp>
       <p:sp>
         <p:nvSpPr>
-          <p:cNvPr id="12" name="Text 9"/>
+          <p:cNvPr id="13" name="Text 9"/>
           <p:cNvSpPr/>
           <p:nvPr/>
         </p:nvSpPr>
@@ -7037,7 +7037,7 @@
       </p:sp>
       <p:sp>
         <p:nvSpPr>
-          <p:cNvPr id="13" name="Text 10"/>
+          <p:cNvPr id="14" name="Text 10"/>
           <p:cNvSpPr/>
           <p:nvPr/>
         </p:nvSpPr>
@@ -7081,7 +7081,7 @@
       </p:sp>
       <p:sp>
         <p:nvSpPr>
-          <p:cNvPr id="14" name="Shape 11"/>
+          <p:cNvPr id="15" name="Shape 11"/>
           <p:cNvSpPr/>
           <p:nvPr/>
         </p:nvSpPr>
@@ -7101,7 +7101,7 @@
       </p:sp>
       <p:sp>
         <p:nvSpPr>
-          <p:cNvPr id="15" name="Shape 12"/>
+          <p:cNvPr id="16" name="Shape 12"/>
           <p:cNvSpPr/>
           <p:nvPr/>
         </p:nvSpPr>
@@ -7121,7 +7121,7 @@
       </p:sp>
       <p:sp>
         <p:nvSpPr>
-          <p:cNvPr id="16" name="Text 13"/>
+          <p:cNvPr id="17" name="Text 13"/>
           <p:cNvSpPr/>
           <p:nvPr/>
         </p:nvSpPr>
@@ -7162,7 +7162,7 @@
       </p:sp>
       <p:sp>
         <p:nvSpPr>
-          <p:cNvPr id="17" name="Text 14"/>
+          <p:cNvPr id="18" name="Text 14"/>
           <p:cNvSpPr/>
           <p:nvPr/>
         </p:nvSpPr>
@@ -7231,7 +7231,7 @@
       </p:grpSpPr>
       <p:pic>
         <p:nvPicPr>
-          <p:cNvPr id="2" name="Image 0" descr="preencoded.png">    </p:cNvPr>
+          <p:cNvPr id="3" name="Image 0" descr="preencoded.png">    </p:cNvPr>
           <p:cNvPicPr>
             <a:picLocks noChangeAspect="1"/>
           </p:cNvPicPr>
@@ -7255,7 +7255,7 @@
       </p:pic>
       <p:sp>
         <p:nvSpPr>
-          <p:cNvPr id="3" name="Text 0"/>
+          <p:cNvPr id="4" name="Text 0"/>
           <p:cNvSpPr/>
           <p:nvPr/>
         </p:nvSpPr>
@@ -7296,7 +7296,7 @@
       </p:sp>
       <p:sp>
         <p:nvSpPr>
-          <p:cNvPr id="4" name="Text 1"/>
+          <p:cNvPr id="5" name="Text 1"/>
           <p:cNvSpPr/>
           <p:nvPr/>
         </p:nvSpPr>
@@ -7337,7 +7337,7 @@
       </p:sp>
       <p:sp>
         <p:nvSpPr>
-          <p:cNvPr id="5" name="Text 2"/>
+          <p:cNvPr id="6" name="Text 2"/>
           <p:cNvSpPr/>
           <p:nvPr/>
         </p:nvSpPr>
@@ -7392,7 +7392,7 @@
       </p:sp>
       <p:sp>
         <p:nvSpPr>
-          <p:cNvPr id="6" name="Text 3"/>
+          <p:cNvPr id="7" name="Text 3"/>
           <p:cNvSpPr/>
           <p:nvPr/>
         </p:nvSpPr>
@@ -7447,7 +7447,7 @@
       </p:sp>
       <p:sp>
         <p:nvSpPr>
-          <p:cNvPr id="7" name="Text 4"/>
+          <p:cNvPr id="8" name="Text 4"/>
           <p:cNvSpPr/>
           <p:nvPr/>
         </p:nvSpPr>
@@ -7502,7 +7502,7 @@
       </p:sp>
       <p:sp>
         <p:nvSpPr>
-          <p:cNvPr id="8" name="Text 5"/>
+          <p:cNvPr id="9" name="Text 5"/>
           <p:cNvSpPr/>
           <p:nvPr/>
         </p:nvSpPr>
@@ -7557,7 +7557,7 @@
       </p:sp>
       <p:sp>
         <p:nvSpPr>
-          <p:cNvPr id="9" name="Text 6"/>
+          <p:cNvPr id="10" name="Text 6"/>
           <p:cNvSpPr/>
           <p:nvPr/>
         </p:nvSpPr>
@@ -7601,7 +7601,7 @@
       </p:sp>
       <p:sp>
         <p:nvSpPr>
-          <p:cNvPr id="10" name="Text 7"/>
+          <p:cNvPr id="11" name="Text 7"/>
           <p:cNvSpPr/>
           <p:nvPr/>
         </p:nvSpPr>
@@ -7645,7 +7645,7 @@
       </p:sp>
       <p:sp>
         <p:nvSpPr>
-          <p:cNvPr id="11" name="Text 8"/>
+          <p:cNvPr id="12" name="Text 8"/>
           <p:cNvSpPr/>
           <p:nvPr/>
         </p:nvSpPr>
@@ -7689,7 +7689,7 @@
       </p:sp>
       <p:sp>
         <p:nvSpPr>
-          <p:cNvPr id="12" name="Text 9"/>
+          <p:cNvPr id="13" name="Text 9"/>
           <p:cNvSpPr/>
           <p:nvPr/>
         </p:nvSpPr>
@@ -7733,7 +7733,7 @@
       </p:sp>
       <p:sp>
         <p:nvSpPr>
-          <p:cNvPr id="13" name="Shape 10"/>
+          <p:cNvPr id="14" name="Shape 10"/>
           <p:cNvSpPr/>
           <p:nvPr/>
         </p:nvSpPr>
@@ -7758,7 +7758,7 @@
       </p:sp>
       <p:pic>
         <p:nvPicPr>
-          <p:cNvPr id="14" name="Image 1" descr="preencoded.png">    </p:cNvPr>
+          <p:cNvPr id="15" name="Image 1" descr="preencoded.png">    </p:cNvPr>
           <p:cNvPicPr>
             <a:picLocks noChangeAspect="1"/>
           </p:cNvPicPr>
@@ -7782,7 +7782,7 @@
       </p:pic>
       <p:sp>
         <p:nvSpPr>
-          <p:cNvPr id="15" name="Shape 11"/>
+          <p:cNvPr id="16" name="Shape 11"/>
           <p:cNvSpPr/>
           <p:nvPr/>
         </p:nvSpPr>
@@ -7807,7 +7807,7 @@
       </p:sp>
       <p:pic>
         <p:nvPicPr>
-          <p:cNvPr id="16" name="Image 2" descr="preencoded.png">    </p:cNvPr>
+          <p:cNvPr id="17" name="Image 2" descr="preencoded.png">    </p:cNvPr>
           <p:cNvPicPr>
             <a:picLocks noChangeAspect="1"/>
           </p:cNvPicPr>
@@ -7856,7 +7856,7 @@
       </p:grpSpPr>
       <p:pic>
         <p:nvPicPr>
-          <p:cNvPr id="2" name="Image 0" descr="preencoded.png">    </p:cNvPr>
+          <p:cNvPr id="3" name="Image 0" descr="preencoded.png">    </p:cNvPr>
           <p:cNvPicPr>
             <a:picLocks noChangeAspect="1"/>
           </p:cNvPicPr>
@@ -7880,7 +7880,7 @@
       </p:pic>
       <p:sp>
         <p:nvSpPr>
-          <p:cNvPr id="3" name="Text 0"/>
+          <p:cNvPr id="4" name="Text 0"/>
           <p:cNvSpPr/>
           <p:nvPr/>
         </p:nvSpPr>
@@ -7921,7 +7921,7 @@
       </p:sp>
       <p:sp>
         <p:nvSpPr>
-          <p:cNvPr id="4" name="Text 1"/>
+          <p:cNvPr id="5" name="Text 1"/>
           <p:cNvSpPr/>
           <p:nvPr/>
         </p:nvSpPr>
@@ -7962,7 +7962,7 @@
       </p:sp>
       <p:sp>
         <p:nvSpPr>
-          <p:cNvPr id="5" name="Text 2"/>
+          <p:cNvPr id="6" name="Text 2"/>
           <p:cNvSpPr/>
           <p:nvPr/>
         </p:nvSpPr>
@@ -8017,7 +8017,7 @@
       </p:sp>
       <p:sp>
         <p:nvSpPr>
-          <p:cNvPr id="6" name="Text 3"/>
+          <p:cNvPr id="7" name="Text 3"/>
           <p:cNvSpPr/>
           <p:nvPr/>
         </p:nvSpPr>
@@ -8094,7 +8094,7 @@
       </p:sp>
       <p:sp>
         <p:nvSpPr>
-          <p:cNvPr id="7" name="Text 4"/>
+          <p:cNvPr id="8" name="Text 4"/>
           <p:cNvSpPr/>
           <p:nvPr/>
         </p:nvSpPr>
@@ -8149,7 +8149,7 @@
       </p:sp>
       <p:sp>
         <p:nvSpPr>
-          <p:cNvPr id="8" name="Text 5"/>
+          <p:cNvPr id="9" name="Text 5"/>
           <p:cNvSpPr/>
           <p:nvPr/>
         </p:nvSpPr>
@@ -8193,7 +8193,7 @@
       </p:sp>
       <p:sp>
         <p:nvSpPr>
-          <p:cNvPr id="9" name="Text 6"/>
+          <p:cNvPr id="10" name="Text 6"/>
           <p:cNvSpPr/>
           <p:nvPr/>
         </p:nvSpPr>
@@ -8237,7 +8237,7 @@
       </p:sp>
       <p:sp>
         <p:nvSpPr>
-          <p:cNvPr id="10" name="Text 7"/>
+          <p:cNvPr id="11" name="Text 7"/>
           <p:cNvSpPr/>
           <p:nvPr/>
         </p:nvSpPr>
@@ -8281,7 +8281,7 @@
       </p:sp>
       <p:sp>
         <p:nvSpPr>
-          <p:cNvPr id="11" name="Shape 8"/>
+          <p:cNvPr id="12" name="Shape 8"/>
           <p:cNvSpPr/>
           <p:nvPr/>
         </p:nvSpPr>
@@ -8301,7 +8301,7 @@
       </p:sp>
       <p:sp>
         <p:nvSpPr>
-          <p:cNvPr id="12" name="Shape 9"/>
+          <p:cNvPr id="13" name="Shape 9"/>
           <p:cNvSpPr/>
           <p:nvPr/>
         </p:nvSpPr>
@@ -8321,7 +8321,7 @@
       </p:sp>
       <p:sp>
         <p:nvSpPr>
-          <p:cNvPr id="13" name="Text 10"/>
+          <p:cNvPr id="14" name="Text 10"/>
           <p:cNvSpPr/>
           <p:nvPr/>
         </p:nvSpPr>
@@ -8362,7 +8362,7 @@
       </p:sp>
       <p:sp>
         <p:nvSpPr>
-          <p:cNvPr id="14" name="Text 11"/>
+          <p:cNvPr id="15" name="Text 11"/>
           <p:cNvSpPr/>
           <p:nvPr/>
         </p:nvSpPr>
@@ -8428,7 +8428,7 @@
       </p:sp>
       <p:sp>
         <p:nvSpPr>
-          <p:cNvPr id="15" name="Text 12"/>
+          <p:cNvPr id="16" name="Text 12"/>
           <p:cNvSpPr/>
           <p:nvPr/>
         </p:nvSpPr>
@@ -8472,7 +8472,7 @@
       </p:sp>
       <p:sp>
         <p:nvSpPr>
-          <p:cNvPr id="16" name="Text 13"/>
+          <p:cNvPr id="17" name="Text 13"/>
           <p:cNvSpPr/>
           <p:nvPr/>
         </p:nvSpPr>
@@ -8516,7 +8516,7 @@
       </p:sp>
       <p:sp>
         <p:nvSpPr>
-          <p:cNvPr id="17" name="Text 14"/>
+          <p:cNvPr id="18" name="Text 14"/>
           <p:cNvSpPr/>
           <p:nvPr/>
         </p:nvSpPr>
@@ -8560,7 +8560,7 @@
       </p:sp>
       <p:sp>
         <p:nvSpPr>
-          <p:cNvPr id="18" name="Text 15"/>
+          <p:cNvPr id="19" name="Text 15"/>
           <p:cNvSpPr/>
           <p:nvPr/>
         </p:nvSpPr>
@@ -8604,7 +8604,7 @@
       </p:sp>
       <p:sp>
         <p:nvSpPr>
-          <p:cNvPr id="19" name="Text 16"/>
+          <p:cNvPr id="20" name="Text 16"/>
           <p:cNvSpPr/>
           <p:nvPr/>
         </p:nvSpPr>
@@ -8673,7 +8673,7 @@
       </p:grpSpPr>
       <p:pic>
         <p:nvPicPr>
-          <p:cNvPr id="2" name="Image 0" descr="preencoded.png">    </p:cNvPr>
+          <p:cNvPr id="3" name="Image 0" descr="preencoded.png">    </p:cNvPr>
           <p:cNvPicPr>
             <a:picLocks noChangeAspect="1"/>
           </p:cNvPicPr>
@@ -8697,7 +8697,7 @@
       </p:pic>
       <p:sp>
         <p:nvSpPr>
-          <p:cNvPr id="3" name="Text 0"/>
+          <p:cNvPr id="4" name="Text 0"/>
           <p:cNvSpPr/>
           <p:nvPr/>
         </p:nvSpPr>
@@ -8738,7 +8738,7 @@
       </p:sp>
       <p:sp>
         <p:nvSpPr>
-          <p:cNvPr id="4" name="Text 1"/>
+          <p:cNvPr id="5" name="Text 1"/>
           <p:cNvSpPr/>
           <p:nvPr/>
         </p:nvSpPr>
@@ -8779,7 +8779,7 @@
       </p:sp>
       <p:sp>
         <p:nvSpPr>
-          <p:cNvPr id="5" name="Text 2"/>
+          <p:cNvPr id="6" name="Text 2"/>
           <p:cNvSpPr/>
           <p:nvPr/>
         </p:nvSpPr>
@@ -8820,7 +8820,7 @@
       </p:sp>
       <p:sp>
         <p:nvSpPr>
-          <p:cNvPr id="6" name="Text 3"/>
+          <p:cNvPr id="7" name="Text 3"/>
           <p:cNvSpPr/>
           <p:nvPr/>
         </p:nvSpPr>
@@ -8875,7 +8875,7 @@
       </p:sp>
       <p:sp>
         <p:nvSpPr>
-          <p:cNvPr id="7" name="Text 4"/>
+          <p:cNvPr id="8" name="Text 4"/>
           <p:cNvSpPr/>
           <p:nvPr/>
         </p:nvSpPr>
@@ -8930,7 +8930,7 @@
       </p:sp>
       <p:sp>
         <p:nvSpPr>
-          <p:cNvPr id="8" name="Text 5"/>
+          <p:cNvPr id="9" name="Text 5"/>
           <p:cNvSpPr/>
           <p:nvPr/>
         </p:nvSpPr>
@@ -8985,7 +8985,7 @@
       </p:sp>
       <p:sp>
         <p:nvSpPr>
-          <p:cNvPr id="9" name="Text 6"/>
+          <p:cNvPr id="10" name="Text 6"/>
           <p:cNvSpPr/>
           <p:nvPr/>
         </p:nvSpPr>
@@ -9029,7 +9029,7 @@
       </p:sp>
       <p:sp>
         <p:nvSpPr>
-          <p:cNvPr id="10" name="Text 7"/>
+          <p:cNvPr id="11" name="Text 7"/>
           <p:cNvSpPr/>
           <p:nvPr/>
         </p:nvSpPr>
@@ -9073,7 +9073,7 @@
       </p:sp>
       <p:sp>
         <p:nvSpPr>
-          <p:cNvPr id="11" name="Text 8"/>
+          <p:cNvPr id="12" name="Text 8"/>
           <p:cNvSpPr/>
           <p:nvPr/>
         </p:nvSpPr>
@@ -9117,7 +9117,7 @@
       </p:sp>
       <p:sp>
         <p:nvSpPr>
-          <p:cNvPr id="12" name="Text 9"/>
+          <p:cNvPr id="13" name="Text 9"/>
           <p:cNvSpPr/>
           <p:nvPr/>
         </p:nvSpPr>
@@ -9158,7 +9158,7 @@
       </p:sp>
       <p:sp>
         <p:nvSpPr>
-          <p:cNvPr id="13" name="Text 10"/>
+          <p:cNvPr id="14" name="Text 10"/>
           <p:cNvSpPr/>
           <p:nvPr/>
         </p:nvSpPr>
@@ -9213,7 +9213,7 @@
       </p:sp>
       <p:sp>
         <p:nvSpPr>
-          <p:cNvPr id="14" name="Text 11"/>
+          <p:cNvPr id="15" name="Text 11"/>
           <p:cNvSpPr/>
           <p:nvPr/>
         </p:nvSpPr>
@@ -9268,7 +9268,7 @@
       </p:sp>
       <p:sp>
         <p:nvSpPr>
-          <p:cNvPr id="15" name="Text 12"/>
+          <p:cNvPr id="16" name="Text 12"/>
           <p:cNvSpPr/>
           <p:nvPr/>
         </p:nvSpPr>
@@ -9323,7 +9323,7 @@
       </p:sp>
       <p:sp>
         <p:nvSpPr>
-          <p:cNvPr id="16" name="Text 13"/>
+          <p:cNvPr id="17" name="Text 13"/>
           <p:cNvSpPr/>
           <p:nvPr/>
         </p:nvSpPr>
@@ -9367,7 +9367,7 @@
       </p:sp>
       <p:sp>
         <p:nvSpPr>
-          <p:cNvPr id="17" name="Text 14"/>
+          <p:cNvPr id="18" name="Text 14"/>
           <p:cNvSpPr/>
           <p:nvPr/>
         </p:nvSpPr>
@@ -9411,7 +9411,7 @@
       </p:sp>
       <p:sp>
         <p:nvSpPr>
-          <p:cNvPr id="18" name="Text 15"/>
+          <p:cNvPr id="19" name="Text 15"/>
           <p:cNvSpPr/>
           <p:nvPr/>
         </p:nvSpPr>
@@ -9480,7 +9480,7 @@
       </p:grpSpPr>
       <p:pic>
         <p:nvPicPr>
-          <p:cNvPr id="2" name="Image 0" descr="preencoded.png">    </p:cNvPr>
+          <p:cNvPr id="3" name="Image 0" descr="preencoded.png">    </p:cNvPr>
           <p:cNvPicPr>
             <a:picLocks noChangeAspect="1"/>
           </p:cNvPicPr>
@@ -9504,7 +9504,7 @@
       </p:pic>
       <p:sp>
         <p:nvSpPr>
-          <p:cNvPr id="3" name="Text 0"/>
+          <p:cNvPr id="4" name="Text 0"/>
           <p:cNvSpPr/>
           <p:nvPr/>
         </p:nvSpPr>
@@ -9545,7 +9545,7 @@
       </p:sp>
       <p:sp>
         <p:nvSpPr>
-          <p:cNvPr id="4" name="Text 1"/>
+          <p:cNvPr id="5" name="Text 1"/>
           <p:cNvSpPr/>
           <p:nvPr/>
         </p:nvSpPr>
@@ -9586,7 +9586,7 @@
       </p:sp>
       <p:sp>
         <p:nvSpPr>
-          <p:cNvPr id="5" name="Text 2"/>
+          <p:cNvPr id="6" name="Text 2"/>
           <p:cNvSpPr/>
           <p:nvPr/>
         </p:nvSpPr>
@@ -9630,7 +9630,7 @@
       </p:sp>
       <p:sp>
         <p:nvSpPr>
-          <p:cNvPr id="6" name="Text 3"/>
+          <p:cNvPr id="7" name="Text 3"/>
           <p:cNvSpPr/>
           <p:nvPr/>
         </p:nvSpPr>
@@ -9674,7 +9674,7 @@
       </p:sp>
       <p:sp>
         <p:nvSpPr>
-          <p:cNvPr id="7" name="Text 4"/>
+          <p:cNvPr id="8" name="Text 4"/>
           <p:cNvSpPr/>
           <p:nvPr/>
         </p:nvSpPr>
@@ -9718,7 +9718,7 @@
       </p:sp>
       <p:sp>
         <p:nvSpPr>
-          <p:cNvPr id="8" name="Text 5"/>
+          <p:cNvPr id="9" name="Text 5"/>
           <p:cNvSpPr/>
           <p:nvPr/>
         </p:nvSpPr>
@@ -9762,7 +9762,7 @@
       </p:sp>
       <p:sp>
         <p:nvSpPr>
-          <p:cNvPr id="9" name="Text 6"/>
+          <p:cNvPr id="10" name="Text 6"/>
           <p:cNvSpPr/>
           <p:nvPr/>
         </p:nvSpPr>
@@ -9806,7 +9806,7 @@
       </p:sp>
       <p:sp>
         <p:nvSpPr>
-          <p:cNvPr id="10" name="Text 7"/>
+          <p:cNvPr id="11" name="Text 7"/>
           <p:cNvSpPr/>
           <p:nvPr/>
         </p:nvSpPr>
@@ -9850,7 +9850,7 @@
       </p:sp>
       <p:sp>
         <p:nvSpPr>
-          <p:cNvPr id="11" name="Text 8"/>
+          <p:cNvPr id="12" name="Text 8"/>
           <p:cNvSpPr/>
           <p:nvPr/>
         </p:nvSpPr>
@@ -9894,7 +9894,7 @@
       </p:sp>
       <p:sp>
         <p:nvSpPr>
-          <p:cNvPr id="12" name="Text 9"/>
+          <p:cNvPr id="13" name="Text 9"/>
           <p:cNvSpPr/>
           <p:nvPr/>
         </p:nvSpPr>
@@ -9949,7 +9949,7 @@
       </p:sp>
       <p:sp>
         <p:nvSpPr>
-          <p:cNvPr id="13" name="Text 10"/>
+          <p:cNvPr id="14" name="Text 10"/>
           <p:cNvSpPr/>
           <p:nvPr/>
         </p:nvSpPr>
@@ -10004,7 +10004,7 @@
       </p:sp>
       <p:sp>
         <p:nvSpPr>
-          <p:cNvPr id="14" name="Text 11"/>
+          <p:cNvPr id="15" name="Text 11"/>
           <p:cNvSpPr/>
           <p:nvPr/>
         </p:nvSpPr>
@@ -10048,7 +10048,7 @@
       </p:sp>
       <p:sp>
         <p:nvSpPr>
-          <p:cNvPr id="15" name="Text 12"/>
+          <p:cNvPr id="16" name="Text 12"/>
           <p:cNvSpPr/>
           <p:nvPr/>
         </p:nvSpPr>
@@ -10092,7 +10092,7 @@
       </p:sp>
       <p:sp>
         <p:nvSpPr>
-          <p:cNvPr id="16" name="Text 13"/>
+          <p:cNvPr id="17" name="Text 13"/>
           <p:cNvSpPr/>
           <p:nvPr/>
         </p:nvSpPr>
@@ -10136,7 +10136,7 @@
       </p:sp>
       <p:sp>
         <p:nvSpPr>
-          <p:cNvPr id="17" name="Text 14"/>
+          <p:cNvPr id="18" name="Text 14"/>
           <p:cNvSpPr/>
           <p:nvPr/>
         </p:nvSpPr>
@@ -10180,7 +10180,7 @@
       </p:sp>
       <p:sp>
         <p:nvSpPr>
-          <p:cNvPr id="18" name="Text 15"/>
+          <p:cNvPr id="19" name="Text 15"/>
           <p:cNvSpPr/>
           <p:nvPr/>
         </p:nvSpPr>
@@ -10224,7 +10224,7 @@
       </p:sp>
       <p:sp>
         <p:nvSpPr>
-          <p:cNvPr id="19" name="Text 16"/>
+          <p:cNvPr id="20" name="Text 16"/>
           <p:cNvSpPr/>
           <p:nvPr/>
         </p:nvSpPr>
@@ -10268,7 +10268,7 @@
       </p:sp>
       <p:sp>
         <p:nvSpPr>
-          <p:cNvPr id="20" name="Text 17"/>
+          <p:cNvPr id="21" name="Text 17"/>
           <p:cNvSpPr/>
           <p:nvPr/>
         </p:nvSpPr>
@@ -10312,7 +10312,7 @@
       </p:sp>
       <p:pic>
         <p:nvPicPr>
-          <p:cNvPr id="21" name="Image 1" descr="preencoded.png">    </p:cNvPr>
+          <p:cNvPr id="22" name="Image 1" descr="preencoded.png">    </p:cNvPr>
           <p:cNvPicPr>
             <a:picLocks noChangeAspect="1"/>
           </p:cNvPicPr>
@@ -10336,7 +10336,7 @@
       </p:pic>
       <p:sp>
         <p:nvSpPr>
-          <p:cNvPr id="22" name="Text 18"/>
+          <p:cNvPr id="23" name="Text 18"/>
           <p:cNvSpPr/>
           <p:nvPr/>
         </p:nvSpPr>
@@ -10439,7 +10439,7 @@
       </p:grpSpPr>
       <p:pic>
         <p:nvPicPr>
-          <p:cNvPr id="2" name="Image 0" descr="preencoded.png">    </p:cNvPr>
+          <p:cNvPr id="3" name="Image 0" descr="preencoded.png">    </p:cNvPr>
           <p:cNvPicPr>
             <a:picLocks noChangeAspect="1"/>
           </p:cNvPicPr>
@@ -10463,7 +10463,7 @@
       </p:pic>
       <p:sp>
         <p:nvSpPr>
-          <p:cNvPr id="3" name="Text 0"/>
+          <p:cNvPr id="4" name="Text 0"/>
           <p:cNvSpPr/>
           <p:nvPr/>
         </p:nvSpPr>
@@ -10504,7 +10504,7 @@
       </p:sp>
       <p:sp>
         <p:nvSpPr>
-          <p:cNvPr id="4" name="Text 1"/>
+          <p:cNvPr id="5" name="Text 1"/>
           <p:cNvSpPr/>
           <p:nvPr/>
         </p:nvSpPr>
@@ -10545,7 +10545,7 @@
       </p:sp>
       <p:sp>
         <p:nvSpPr>
-          <p:cNvPr id="5" name="Text 2"/>
+          <p:cNvPr id="6" name="Text 2"/>
           <p:cNvSpPr/>
           <p:nvPr/>
         </p:nvSpPr>
@@ -10586,7 +10586,7 @@
       </p:sp>
       <p:sp>
         <p:nvSpPr>
-          <p:cNvPr id="6" name="Text 3"/>
+          <p:cNvPr id="7" name="Text 3"/>
           <p:cNvSpPr/>
           <p:nvPr/>
         </p:nvSpPr>
@@ -10641,7 +10641,7 @@
       </p:sp>
       <p:sp>
         <p:nvSpPr>
-          <p:cNvPr id="7" name="Text 4"/>
+          <p:cNvPr id="8" name="Text 4"/>
           <p:cNvSpPr/>
           <p:nvPr/>
         </p:nvSpPr>
@@ -10696,7 +10696,7 @@
       </p:sp>
       <p:sp>
         <p:nvSpPr>
-          <p:cNvPr id="8" name="Text 5"/>
+          <p:cNvPr id="9" name="Text 5"/>
           <p:cNvSpPr/>
           <p:nvPr/>
         </p:nvSpPr>
@@ -10751,7 +10751,7 @@
       </p:sp>
       <p:sp>
         <p:nvSpPr>
-          <p:cNvPr id="9" name="Text 6"/>
+          <p:cNvPr id="10" name="Text 6"/>
           <p:cNvSpPr/>
           <p:nvPr/>
         </p:nvSpPr>
@@ -10806,7 +10806,7 @@
       </p:sp>
       <p:sp>
         <p:nvSpPr>
-          <p:cNvPr id="10" name="Text 7"/>
+          <p:cNvPr id="11" name="Text 7"/>
           <p:cNvSpPr/>
           <p:nvPr/>
         </p:nvSpPr>
@@ -10850,7 +10850,7 @@
       </p:sp>
       <p:sp>
         <p:nvSpPr>
-          <p:cNvPr id="11" name="Text 8"/>
+          <p:cNvPr id="12" name="Text 8"/>
           <p:cNvSpPr/>
           <p:nvPr/>
         </p:nvSpPr>
@@ -10894,7 +10894,7 @@
       </p:sp>
       <p:sp>
         <p:nvSpPr>
-          <p:cNvPr id="12" name="Text 9"/>
+          <p:cNvPr id="13" name="Text 9"/>
           <p:cNvSpPr/>
           <p:nvPr/>
         </p:nvSpPr>
@@ -10938,7 +10938,7 @@
       </p:sp>
       <p:sp>
         <p:nvSpPr>
-          <p:cNvPr id="13" name="Text 10"/>
+          <p:cNvPr id="14" name="Text 10"/>
           <p:cNvSpPr/>
           <p:nvPr/>
         </p:nvSpPr>
@@ -10982,7 +10982,7 @@
       </p:sp>
       <p:sp>
         <p:nvSpPr>
-          <p:cNvPr id="14" name="Text 11"/>
+          <p:cNvPr id="15" name="Text 11"/>
           <p:cNvSpPr/>
           <p:nvPr/>
         </p:nvSpPr>
@@ -11023,7 +11023,7 @@
       </p:sp>
       <p:sp>
         <p:nvSpPr>
-          <p:cNvPr id="15" name="Text 12"/>
+          <p:cNvPr id="16" name="Text 12"/>
           <p:cNvSpPr/>
           <p:nvPr/>
         </p:nvSpPr>
@@ -11078,7 +11078,7 @@
       </p:sp>
       <p:sp>
         <p:nvSpPr>
-          <p:cNvPr id="16" name="Text 13"/>
+          <p:cNvPr id="17" name="Text 13"/>
           <p:cNvSpPr/>
           <p:nvPr/>
         </p:nvSpPr>
@@ -11133,7 +11133,7 @@
       </p:sp>
       <p:sp>
         <p:nvSpPr>
-          <p:cNvPr id="17" name="Text 14"/>
+          <p:cNvPr id="18" name="Text 14"/>
           <p:cNvSpPr/>
           <p:nvPr/>
         </p:nvSpPr>
@@ -11188,7 +11188,7 @@
       </p:sp>
       <p:sp>
         <p:nvSpPr>
-          <p:cNvPr id="18" name="Text 15"/>
+          <p:cNvPr id="19" name="Text 15"/>
           <p:cNvSpPr/>
           <p:nvPr/>
         </p:nvSpPr>
@@ -11232,7 +11232,7 @@
       </p:sp>
       <p:sp>
         <p:nvSpPr>
-          <p:cNvPr id="19" name="Text 16"/>
+          <p:cNvPr id="20" name="Text 16"/>
           <p:cNvSpPr/>
           <p:nvPr/>
         </p:nvSpPr>
@@ -11276,7 +11276,7 @@
       </p:sp>
       <p:sp>
         <p:nvSpPr>
-          <p:cNvPr id="20" name="Text 17"/>
+          <p:cNvPr id="21" name="Text 17"/>
           <p:cNvSpPr/>
           <p:nvPr/>
         </p:nvSpPr>
@@ -11345,7 +11345,7 @@
       </p:grpSpPr>
       <p:pic>
         <p:nvPicPr>
-          <p:cNvPr id="2" name="Image 0" descr="preencoded.png">    </p:cNvPr>
+          <p:cNvPr id="3" name="Image 0" descr="preencoded.png">    </p:cNvPr>
           <p:cNvPicPr>
             <a:picLocks noChangeAspect="1"/>
           </p:cNvPicPr>
@@ -11369,7 +11369,7 @@
       </p:pic>
       <p:sp>
         <p:nvSpPr>
-          <p:cNvPr id="3" name="Text 0"/>
+          <p:cNvPr id="4" name="Text 0"/>
           <p:cNvSpPr/>
           <p:nvPr/>
         </p:nvSpPr>
@@ -11410,7 +11410,7 @@
       </p:sp>
       <p:sp>
         <p:nvSpPr>
-          <p:cNvPr id="4" name="Text 1"/>
+          <p:cNvPr id="5" name="Text 1"/>
           <p:cNvSpPr/>
           <p:nvPr/>
         </p:nvSpPr>
@@ -11451,7 +11451,7 @@
       </p:sp>
       <p:sp>
         <p:nvSpPr>
-          <p:cNvPr id="5" name="Text 2"/>
+          <p:cNvPr id="6" name="Text 2"/>
           <p:cNvSpPr/>
           <p:nvPr/>
         </p:nvSpPr>
@@ -11506,7 +11506,7 @@
       </p:sp>
       <p:sp>
         <p:nvSpPr>
-          <p:cNvPr id="6" name="Text 3"/>
+          <p:cNvPr id="7" name="Text 3"/>
           <p:cNvSpPr/>
           <p:nvPr/>
         </p:nvSpPr>
@@ -11550,7 +11550,7 @@
       </p:sp>
       <p:sp>
         <p:nvSpPr>
-          <p:cNvPr id="7" name="Text 4"/>
+          <p:cNvPr id="8" name="Text 4"/>
           <p:cNvSpPr/>
           <p:nvPr/>
         </p:nvSpPr>
@@ -11594,7 +11594,7 @@
       </p:sp>
       <p:sp>
         <p:nvSpPr>
-          <p:cNvPr id="8" name="Text 5"/>
+          <p:cNvPr id="9" name="Text 5"/>
           <p:cNvSpPr/>
           <p:nvPr/>
         </p:nvSpPr>
@@ -11638,7 +11638,7 @@
       </p:sp>
       <p:sp>
         <p:nvSpPr>
-          <p:cNvPr id="9" name="Text 6"/>
+          <p:cNvPr id="10" name="Text 6"/>
           <p:cNvSpPr/>
           <p:nvPr/>
         </p:nvSpPr>
@@ -11682,7 +11682,7 @@
       </p:sp>
       <p:sp>
         <p:nvSpPr>
-          <p:cNvPr id="10" name="Text 7"/>
+          <p:cNvPr id="11" name="Text 7"/>
           <p:cNvSpPr/>
           <p:nvPr/>
         </p:nvSpPr>
@@ -11726,7 +11726,7 @@
       </p:sp>
       <p:sp>
         <p:nvSpPr>
-          <p:cNvPr id="11" name="Text 8"/>
+          <p:cNvPr id="12" name="Text 8"/>
           <p:cNvSpPr/>
           <p:nvPr/>
         </p:nvSpPr>
@@ -11770,7 +11770,7 @@
       </p:sp>
       <p:sp>
         <p:nvSpPr>
-          <p:cNvPr id="12" name="Shape 9"/>
+          <p:cNvPr id="13" name="Shape 9"/>
           <p:cNvSpPr/>
           <p:nvPr/>
         </p:nvSpPr>
@@ -11790,7 +11790,7 @@
       </p:sp>
       <p:sp>
         <p:nvSpPr>
-          <p:cNvPr id="13" name="Shape 10"/>
+          <p:cNvPr id="14" name="Shape 10"/>
           <p:cNvSpPr/>
           <p:nvPr/>
         </p:nvSpPr>
@@ -11810,7 +11810,7 @@
       </p:sp>
       <p:sp>
         <p:nvSpPr>
-          <p:cNvPr id="14" name="Text 11"/>
+          <p:cNvPr id="15" name="Text 11"/>
           <p:cNvSpPr/>
           <p:nvPr/>
         </p:nvSpPr>
@@ -11854,7 +11854,7 @@
       </p:sp>
       <p:sp>
         <p:nvSpPr>
-          <p:cNvPr id="15" name="Text 12"/>
+          <p:cNvPr id="16" name="Text 12"/>
           <p:cNvSpPr/>
           <p:nvPr/>
         </p:nvSpPr>
@@ -11898,7 +11898,7 @@
       </p:sp>
       <p:sp>
         <p:nvSpPr>
-          <p:cNvPr id="16" name="Text 13"/>
+          <p:cNvPr id="17" name="Text 13"/>
           <p:cNvSpPr/>
           <p:nvPr/>
         </p:nvSpPr>
@@ -11942,7 +11942,7 @@
       </p:sp>
       <p:sp>
         <p:nvSpPr>
-          <p:cNvPr id="17" name="Text 14"/>
+          <p:cNvPr id="18" name="Text 14"/>
           <p:cNvSpPr/>
           <p:nvPr/>
         </p:nvSpPr>
@@ -11997,7 +11997,7 @@
       </p:sp>
       <p:sp>
         <p:nvSpPr>
-          <p:cNvPr id="18" name="Text 15"/>
+          <p:cNvPr id="19" name="Text 15"/>
           <p:cNvSpPr/>
           <p:nvPr/>
         </p:nvSpPr>
@@ -12052,7 +12052,7 @@
       </p:sp>
       <p:sp>
         <p:nvSpPr>
-          <p:cNvPr id="19" name="Text 16"/>
+          <p:cNvPr id="20" name="Text 16"/>
           <p:cNvSpPr/>
           <p:nvPr/>
         </p:nvSpPr>
@@ -12096,7 +12096,7 @@
       </p:sp>
       <p:sp>
         <p:nvSpPr>
-          <p:cNvPr id="20" name="Text 17"/>
+          <p:cNvPr id="21" name="Text 17"/>
           <p:cNvSpPr/>
           <p:nvPr/>
         </p:nvSpPr>
@@ -12140,7 +12140,7 @@
       </p:sp>
       <p:pic>
         <p:nvPicPr>
-          <p:cNvPr id="21" name="Image 1" descr="preencoded.png">    </p:cNvPr>
+          <p:cNvPr id="22" name="Image 1" descr="preencoded.png">    </p:cNvPr>
           <p:cNvPicPr>
             <a:picLocks noChangeAspect="1"/>
           </p:cNvPicPr>
@@ -12189,7 +12189,7 @@
       </p:grpSpPr>
       <p:pic>
         <p:nvPicPr>
-          <p:cNvPr id="2" name="Image 0" descr="preencoded.png">    </p:cNvPr>
+          <p:cNvPr id="3" name="Image 0" descr="preencoded.png">    </p:cNvPr>
           <p:cNvPicPr>
             <a:picLocks noChangeAspect="1"/>
           </p:cNvPicPr>
@@ -12213,7 +12213,7 @@
       </p:pic>
       <p:sp>
         <p:nvSpPr>
-          <p:cNvPr id="3" name="Text 0"/>
+          <p:cNvPr id="4" name="Text 0"/>
           <p:cNvSpPr/>
           <p:nvPr/>
         </p:nvSpPr>
@@ -12254,7 +12254,7 @@
       </p:sp>
       <p:sp>
         <p:nvSpPr>
-          <p:cNvPr id="4" name="Text 1"/>
+          <p:cNvPr id="5" name="Text 1"/>
           <p:cNvSpPr/>
           <p:nvPr/>
         </p:nvSpPr>
@@ -12295,7 +12295,7 @@
       </p:sp>
       <p:sp>
         <p:nvSpPr>
-          <p:cNvPr id="5" name="Shape 2"/>
+          <p:cNvPr id="6" name="Shape 2"/>
           <p:cNvSpPr/>
           <p:nvPr/>
         </p:nvSpPr>
@@ -12315,7 +12315,7 @@
       </p:sp>
       <p:sp>
         <p:nvSpPr>
-          <p:cNvPr id="6" name="Shape 3"/>
+          <p:cNvPr id="7" name="Shape 3"/>
           <p:cNvSpPr/>
           <p:nvPr/>
         </p:nvSpPr>
@@ -12335,7 +12335,7 @@
       </p:sp>
       <p:sp>
         <p:nvSpPr>
-          <p:cNvPr id="7" name="Text 4"/>
+          <p:cNvPr id="8" name="Text 4"/>
           <p:cNvSpPr/>
           <p:nvPr/>
         </p:nvSpPr>
@@ -12376,7 +12376,7 @@
       </p:sp>
       <p:sp>
         <p:nvSpPr>
-          <p:cNvPr id="8" name="Text 5"/>
+          <p:cNvPr id="9" name="Text 5"/>
           <p:cNvSpPr/>
           <p:nvPr/>
         </p:nvSpPr>
@@ -12417,7 +12417,7 @@
       </p:sp>
       <p:sp>
         <p:nvSpPr>
-          <p:cNvPr id="9" name="Text 6"/>
+          <p:cNvPr id="10" name="Text 6"/>
           <p:cNvSpPr/>
           <p:nvPr/>
         </p:nvSpPr>
@@ -12458,7 +12458,7 @@
       </p:sp>
       <p:sp>
         <p:nvSpPr>
-          <p:cNvPr id="10" name="Text 7"/>
+          <p:cNvPr id="11" name="Text 7"/>
           <p:cNvSpPr/>
           <p:nvPr/>
         </p:nvSpPr>
@@ -12499,7 +12499,7 @@
       </p:sp>
       <p:sp>
         <p:nvSpPr>
-          <p:cNvPr id="11" name="Text 8"/>
+          <p:cNvPr id="12" name="Text 8"/>
           <p:cNvSpPr/>
           <p:nvPr/>
         </p:nvSpPr>
@@ -12540,7 +12540,7 @@
       </p:sp>
       <p:sp>
         <p:nvSpPr>
-          <p:cNvPr id="12" name="Text 9"/>
+          <p:cNvPr id="13" name="Text 9"/>
           <p:cNvSpPr/>
           <p:nvPr/>
         </p:nvSpPr>
@@ -12581,7 +12581,7 @@
       </p:sp>
       <p:sp>
         <p:nvSpPr>
-          <p:cNvPr id="13" name="Text 10"/>
+          <p:cNvPr id="14" name="Text 10"/>
           <p:cNvSpPr/>
           <p:nvPr/>
         </p:nvSpPr>
@@ -12622,7 +12622,7 @@
       </p:sp>
       <p:sp>
         <p:nvSpPr>
-          <p:cNvPr id="14" name="Text 11"/>
+          <p:cNvPr id="15" name="Text 11"/>
           <p:cNvSpPr/>
           <p:nvPr/>
         </p:nvSpPr>
@@ -12663,7 +12663,7 @@
       </p:sp>
       <p:sp>
         <p:nvSpPr>
-          <p:cNvPr id="15" name="Text 12"/>
+          <p:cNvPr id="16" name="Text 12"/>
           <p:cNvSpPr/>
           <p:nvPr/>
         </p:nvSpPr>
@@ -12704,7 +12704,7 @@
       </p:sp>
       <p:sp>
         <p:nvSpPr>
-          <p:cNvPr id="16" name="Text 13"/>
+          <p:cNvPr id="17" name="Text 13"/>
           <p:cNvSpPr/>
           <p:nvPr/>
         </p:nvSpPr>
@@ -12745,7 +12745,7 @@
       </p:sp>
       <p:sp>
         <p:nvSpPr>
-          <p:cNvPr id="17" name="Text 14"/>
+          <p:cNvPr id="18" name="Text 14"/>
           <p:cNvSpPr/>
           <p:nvPr/>
         </p:nvSpPr>
@@ -12786,7 +12786,7 @@
       </p:sp>
       <p:sp>
         <p:nvSpPr>
-          <p:cNvPr id="18" name="Text 15"/>
+          <p:cNvPr id="19" name="Text 15"/>
           <p:cNvSpPr/>
           <p:nvPr/>
         </p:nvSpPr>
@@ -12827,7 +12827,7 @@
       </p:sp>
       <p:sp>
         <p:nvSpPr>
-          <p:cNvPr id="19" name="Text 16"/>
+          <p:cNvPr id="20" name="Text 16"/>
           <p:cNvSpPr/>
           <p:nvPr/>
         </p:nvSpPr>
@@ -12868,7 +12868,7 @@
       </p:sp>
       <p:sp>
         <p:nvSpPr>
-          <p:cNvPr id="20" name="Text 17"/>
+          <p:cNvPr id="21" name="Text 17"/>
           <p:cNvSpPr/>
           <p:nvPr/>
         </p:nvSpPr>
@@ -12909,7 +12909,7 @@
       </p:sp>
       <p:sp>
         <p:nvSpPr>
-          <p:cNvPr id="21" name="Text 18"/>
+          <p:cNvPr id="22" name="Text 18"/>
           <p:cNvSpPr/>
           <p:nvPr/>
         </p:nvSpPr>
@@ -12950,7 +12950,7 @@
       </p:sp>
       <p:sp>
         <p:nvSpPr>
-          <p:cNvPr id="22" name="Text 19"/>
+          <p:cNvPr id="23" name="Text 19"/>
           <p:cNvSpPr/>
           <p:nvPr/>
         </p:nvSpPr>
@@ -12991,7 +12991,7 @@
       </p:sp>
       <p:sp>
         <p:nvSpPr>
-          <p:cNvPr id="23" name="Text 20"/>
+          <p:cNvPr id="24" name="Text 20"/>
           <p:cNvSpPr/>
           <p:nvPr/>
         </p:nvSpPr>
@@ -13032,7 +13032,7 @@
       </p:sp>
       <p:sp>
         <p:nvSpPr>
-          <p:cNvPr id="24" name="Text 21"/>
+          <p:cNvPr id="25" name="Text 21"/>
           <p:cNvSpPr/>
           <p:nvPr/>
         </p:nvSpPr>
@@ -13073,7 +13073,7 @@
       </p:sp>
       <p:sp>
         <p:nvSpPr>
-          <p:cNvPr id="25" name="Text 22"/>
+          <p:cNvPr id="26" name="Text 22"/>
           <p:cNvSpPr/>
           <p:nvPr/>
         </p:nvSpPr>
@@ -13128,7 +13128,7 @@
       </p:sp>
       <p:sp>
         <p:nvSpPr>
-          <p:cNvPr id="26" name="Text 23"/>
+          <p:cNvPr id="27" name="Text 23"/>
           <p:cNvSpPr/>
           <p:nvPr/>
         </p:nvSpPr>
@@ -13183,7 +13183,7 @@
       </p:sp>
       <p:sp>
         <p:nvSpPr>
-          <p:cNvPr id="27" name="Text 24"/>
+          <p:cNvPr id="28" name="Text 24"/>
           <p:cNvSpPr/>
           <p:nvPr/>
         </p:nvSpPr>
@@ -13238,7 +13238,7 @@
       </p:sp>
       <p:sp>
         <p:nvSpPr>
-          <p:cNvPr id="28" name="Text 25"/>
+          <p:cNvPr id="29" name="Text 25"/>
           <p:cNvSpPr/>
           <p:nvPr/>
         </p:nvSpPr>
@@ -13293,7 +13293,7 @@
       </p:sp>
       <p:sp>
         <p:nvSpPr>
-          <p:cNvPr id="29" name="Text 26"/>
+          <p:cNvPr id="30" name="Text 26"/>
           <p:cNvSpPr/>
           <p:nvPr/>
         </p:nvSpPr>
@@ -13337,7 +13337,7 @@
       </p:sp>
       <p:sp>
         <p:nvSpPr>
-          <p:cNvPr id="30" name="Text 27"/>
+          <p:cNvPr id="31" name="Text 27"/>
           <p:cNvSpPr/>
           <p:nvPr/>
         </p:nvSpPr>
@@ -13381,7 +13381,7 @@
       </p:sp>
       <p:sp>
         <p:nvSpPr>
-          <p:cNvPr id="31" name="Text 28"/>
+          <p:cNvPr id="32" name="Text 28"/>
           <p:cNvSpPr/>
           <p:nvPr/>
         </p:nvSpPr>
@@ -13425,7 +13425,7 @@
       </p:sp>
       <p:sp>
         <p:nvSpPr>
-          <p:cNvPr id="32" name="Text 29"/>
+          <p:cNvPr id="33" name="Text 29"/>
           <p:cNvSpPr/>
           <p:nvPr/>
         </p:nvSpPr>
@@ -13469,7 +13469,7 @@
       </p:sp>
       <p:pic>
         <p:nvPicPr>
-          <p:cNvPr id="33" name="Image 1" descr="preencoded.png">    </p:cNvPr>
+          <p:cNvPr id="34" name="Image 1" descr="preencoded.png">    </p:cNvPr>
           <p:cNvPicPr>
             <a:picLocks noChangeAspect="1"/>
           </p:cNvPicPr>

</xml_diff>

<commit_message>
Update slides and notes: fix voltage margin, Tj, THD claims; remove AI language
</commit_message>
<xml_diff>
--- a/FC_Inverter_Presentation.pptx
+++ b/FC_Inverter_Presentation.pptx
@@ -514,7 +514,7 @@
           <a:p>
             <a:r>
               <a:rPr lang="en-US" dirty="0"/>
-              <a:t>Good morning, everyone. Today, we'll delve into the vehicle architecture-driven design and comprehensive loss analysis of an 800V three-level flying capacitor traction inverter. This work addresses the critical need for high-efficiency, robust power electronics in modern electric vehicles. We'll explore how specific design choices, from the system architecture down to the component level, impact overall performance and reliability. Our focus will be on the rigorous analytical methods used to quantify these impacts.</a:t>
+              <a:t>This presentation details the vehicle architecture-driven design and comprehensive loss analysis of an 800V three-level flying capacitor traction inverter. This work addresses the critical need for high-efficiency, robust power electronics in modern electric vehicles. We'll explore how specific design choices, from the system architecture down to the component level, impact overall performance and reliability. Our focus will be on the rigorous analytical methods used to quantify these impacts. We'll examine the specific challenges and solutions associated with high-voltage systems and multilevel topologies. Next, we'll outline the project's scope and objectives.</a:t>
             </a:r>
             <a:endParaRPr lang="en-US" dirty="0"/>
           </a:p>
@@ -690,7 +690,7 @@
           <a:p>
             <a:r>
               <a:rPr lang="en-US" dirty="0"/>
-              <a:t>Now, let's examine the crucial thermal implications of our adaptive schedule. We've seen how the adaptive schedule optimizes switching frequency; here, we quantify its impact on device thermals and reliability. We modeled the junction temperature, Tj, using a 4-layer Foster thermal network, directly parameterized from the CAB450M12XM3 datasheet, specifically Rth_jc of 94m°C/W. This detailed model allows us to accurately capture transient thermal behavior. The adaptive schedule significantly reduces steady-state Tj by 16.2°C during peak torque and 9.7°C in urban conditions compared to a fixed 20 kHz baseline. More critically, over a dynamic drive cycle, it cuts the thermal cycling amplitude, ΔTj, by 53%, from 16.4°C to a mere 7.7°C. This substantial reduction directly translates to a significant extension of the power module's operational lifetime, as predicted by the Coffin-Manson fatigue model. This is a key benefit for long-term reliability. Next, we'll dive into the full simulation results, including voltage balancing and harmonic performance.</a:t>
+              <a:t>The adaptive schedule directly addresses thermal challenges, significantly enhancing device reliability. We modeled the junction temperature, Tj, using a 4-layer Foster thermal network, parameterized from the CAB450M12XM3 datasheet with an Rth_jc of 94 m°C/W. This detailed model captures transient thermal behavior accurately. The adaptive schedule reduces steady-state Tj by 16.2°C during peak torque and 9.7°C in urban conditions, compared to a fixed 20 kHz baseline. More critically, over a dynamic drive cycle, it cuts the thermal cycling amplitude, ΔTj, by 53%, from 16.4°C to 7.7°C. This reduction directly extends the power module's operational lifetime, as predicted by the Coffin-Manson fatigue model. This is a key benefit for long-term reliability. Next, we'll dive into the full simulation results, including voltage balancing and harmonic performance.</a:t>
             </a:r>
             <a:endParaRPr lang="en-US" dirty="0"/>
           </a:p>
@@ -778,7 +778,7 @@
           <a:p>
             <a:r>
               <a:rPr lang="en-US" dirty="0"/>
-              <a:t>Building on the thermal benefits, let's look at the comprehensive simulation results for our 3-level flying capacitor converter. First, regarding FC voltage balancing, a 20ms linear ramp pre-charge prevents inrush currents. Our PD-PWM strategy successfully maintains the flying capacitor voltage at precisely 400V, with a peak-to-peak ripple of 18.0V, well within our 5% design constraint. For harmonic performance, the 3-level output inherently improves power quality. In urban driving, at 5 kHz, the THD is 1.92%, and on the highway, at 20 kHz, it's 1.13%. Finally, our thermal analysis, using the 4-layer Foster network, shows the junction temperature peaks at only 50.1°C under the adaptive schedule. This provides a massive 124.9°C safety margin to the 175°C semiconductor limit of the CAB450M12XM3, ensuring robust operation. Now, let's summarize our findings and discuss limitations.</a:t>
+              <a:t>Building on the thermal benefits, let's look at the comprehensive simulation results for our 3-level flying capacitor converter. First, a 20ms linear ramp pre-charge prevents inrush currents. Our PD-PWM strategy successfully maintains the flying capacitor voltage at precisely 400V, with a peak-to-peak ripple of 18.0V, well within our 5% design constraint. For harmonic performance, the 3-level output inherently improves power quality. In urban driving, at 5 kHz, the THD is 1.92%, and on the highway, at 20 kHz, it's 1.13%. We acknowledge these are optimistic bounds due to the ideal switching model. Finally, our thermal analysis, using the 4-layer Foster network, shows the junction temperature peaks at 46.4°C with an ambient temperature of 40°C. This provides a 128.6°C safety margin to the 175°C semiconductor limit of the CAB450M12XM3, ensuring robust operation. Now, let's summarize our findings and discuss limitations.</a:t>
             </a:r>
             <a:endParaRPr lang="en-US" dirty="0"/>
           </a:p>
@@ -866,7 +866,7 @@
           <a:p>
             <a:r>
               <a:rPr lang="en-US" dirty="0"/>
-              <a:t>In conclusion, our investigation confirms several key findings for the 800V 3-Level Flying Capacitor topology. We've validated its ability to mitigate dv/dt stress and improve harmonic performance compared to a 2-level inverter. The adaptive switching frequency schedule is particularly impactful, reducing urban switching losses by 75%, from 84.3W to 21.1W per phase. Furthermore, this adaptive approach reduces thermal cycling amplitude by 53%, significantly extending the SiC power modules' lifetime. However, we acknowledge certain limitations. Our current time-domain simulation uses ideal switching transitions and does not account for device voltage drops, discrete dead-time distortion, DC bus ripple, or stray inductance. Future work will incorporate these non-idealities to provide more conservative and hardware-accurate THD and loss estimates, further refining our model's predictive capability.</a:t>
+              <a:t>In conclusion, our investigation confirms several key findings for the 800V 3-Level Flying Capacitor topology. We've validated its ability to mitigate dv/dt stress and improve harmonic performance compared to a 2-level inverter. The adaptive switching frequency schedule is particularly impactful, reducing urban switching losses by 75%, from 84.3W to 21.1W per phase. Furthermore, this adaptive approach reduces thermal cycling amplitude by 53%, from 16.4°C to 7.7°C, significantly extending the SiC power modules' lifetime. However, we acknowledge certain limitations. Our current time-domain simulation uses ideal switching transitions and does not account for device voltage drops, discrete dead-time distortion, DC bus ripple, or stray inductance. Hardware THD would likely be in the 3–8% range at 5 kHz. Future work will incorporate these non-idealities to provide more conservative and hardware-accurate THD and loss estimates, further refining our model's predictive capability.</a:t>
             </a:r>
             <a:endParaRPr lang="en-US" dirty="0"/>
           </a:p>
@@ -954,7 +954,7 @@
           <a:p>
             <a:r>
               <a:rPr lang="en-US" dirty="0"/>
-              <a:t>Building on that, our project addresses a core challenge in traction inverter design: balancing efficiency, torque quality, and thermal stress across highly variable driving conditions. The electrical fundamental frequency is not fixed; it's directly proportional to vehicle speed, creating dynamic load profiles. Urban driving demands low frequency but high phase currents for acceleration, while highway driving requires high frequency but lower sustained currents. Our objective is to model a traction inverter across this full spectrum of operating conditions, evaluate comprehensive conduction and switching losses, and optimize the design for maximum drivetrain efficiency and thermal reliability. This comprehensive approach is crucial for next-generation EV powertrains.</a:t>
+              <a:t>Building on that, our project addresses a core challenge in traction inverter design: balancing efficiency, torque quality, and thermal stress across highly variable driving conditions. The electrical fundamental frequency is not fixed; it's directly proportional to vehicle speed, creating dynamic load profiles. Urban driving demands low frequency but high phase currents for acceleration, while highway driving requires high frequency but lower sustained currents. Our objective is to model a traction inverter across this full spectrum of operating conditions, evaluate comprehensive conduction and switching losses, and optimize the design for maximum drivetrain efficiency and thermal reliability. This comprehensive approach is crucial for next-generation EV powertrains. To meet these demanding performance requirements, our baseline decision was to adopt an 800V DC bus architecture.</a:t>
             </a:r>
             <a:endParaRPr lang="en-US" dirty="0"/>
           </a:p>
@@ -3308,7 +3308,7 @@
         <p:spPr>
           <a:xfrm>
             <a:off x="2078831" y="3887260"/>
-            <a:ext cx="1816131" cy="173236"/>
+            <a:ext cx="2019728" cy="173236"/>
           </a:xfrm>
           <a:prstGeom prst="rect">
             <a:avLst/>
@@ -3337,7 +3337,7 @@
                 <a:ea typeface="Inter" pitchFamily="34" charset="-122"/>
                 <a:cs typeface="Inter" pitchFamily="34" charset="-120"/>
               </a:rPr>
-              <a:t>≈ 27). This yields massive</a:t>
+              <a:t>≈ 27). This reduces switching</a:t>
             </a:r>
             <a:endParaRPr lang="en-US" sz="1050" dirty="0"/>
           </a:p>
@@ -3351,17 +3351,17 @@
         </p:nvSpPr>
         <p:spPr>
           <a:xfrm>
-            <a:off x="728663" y="3887260"/>
-            <a:ext cx="3807451" cy="408980"/>
-          </a:xfrm>
-          <a:prstGeom prst="rect">
-            <a:avLst/>
-          </a:prstGeom>
-          <a:noFill/>
-          <a:ln/>
-        </p:spPr>
-        <p:txBody>
-          <a:bodyPr wrap="square" lIns="0" tIns="0" rIns="0" bIns="0" rtlCol="0" anchor="t">
+            <a:off x="728663" y="4123004"/>
+            <a:ext cx="3377208" cy="173236"/>
+          </a:xfrm>
+          <a:prstGeom prst="rect">
+            <a:avLst/>
+          </a:prstGeom>
+          <a:noFill/>
+          <a:ln/>
+        </p:spPr>
+        <p:txBody>
+          <a:bodyPr wrap="none" lIns="0" tIns="0" rIns="0" bIns="0" rtlCol="0" anchor="t">
             <a:spAutoFit/>
           </a:bodyPr>
           <a:lstStyle/>
@@ -3381,7 +3381,7 @@
                 <a:ea typeface="Inter" pitchFamily="34" charset="-122"/>
                 <a:cs typeface="Inter" pitchFamily="34" charset="-120"/>
               </a:rPr>
-              <a:t>switching loss savings exactly when the phase current</a:t>
+              <a:t>losses by 75% at the operating point where phase</a:t>
             </a:r>
             <a:endParaRPr lang="en-US" sz="1050" dirty="0"/>
           </a:p>
@@ -3395,8 +3395,8 @@
         </p:nvSpPr>
         <p:spPr>
           <a:xfrm>
-            <a:off x="3762970" y="4123004"/>
-            <a:ext cx="685800" cy="173236"/>
+            <a:off x="728663" y="4337317"/>
+            <a:ext cx="1693069" cy="173236"/>
           </a:xfrm>
           <a:prstGeom prst="rect">
             <a:avLst/>
@@ -3425,7 +3425,7 @@
                 <a:ea typeface="Inter" pitchFamily="34" charset="-122"/>
                 <a:cs typeface="Inter" pitchFamily="34" charset="-120"/>
               </a:rPr>
-              <a:t>is highest.</a:t>
+              <a:t>current is highest (136A).</a:t>
             </a:r>
             <a:endParaRPr lang="en-US" sz="1050" dirty="0"/>
           </a:p>
@@ -4254,17 +4254,61 @@
         </p:nvSpPr>
         <p:spPr>
           <a:xfrm>
-            <a:off x="571500" y="3848695"/>
-            <a:ext cx="4243388" cy="857250"/>
-          </a:xfrm>
-          <a:prstGeom prst="rect">
-            <a:avLst/>
-          </a:prstGeom>
-          <a:noFill/>
-          <a:ln/>
-        </p:spPr>
-        <p:txBody>
-          <a:bodyPr wrap="square" lIns="238125" tIns="0" rIns="0" bIns="0" rtlCol="0" anchor="t">
+            <a:off x="571500" y="3820120"/>
+            <a:ext cx="112514" cy="300038"/>
+          </a:xfrm>
+          <a:prstGeom prst="rect">
+            <a:avLst/>
+          </a:prstGeom>
+          <a:noFill/>
+          <a:ln/>
+        </p:spPr>
+        <p:txBody>
+          <a:bodyPr wrap="none" lIns="0" tIns="0" rIns="0" bIns="0" rtlCol="0" anchor="t">
+            <a:spAutoFit/>
+          </a:bodyPr>
+          <a:lstStyle/>
+          <a:p>
+            <a:pPr algn="l" indent="0" marL="0">
+              <a:lnSpc>
+                <a:spcPct val="120000"/>
+              </a:lnSpc>
+              <a:buNone/>
+            </a:pPr>
+            <a:r>
+              <a:rPr lang="en-US" sz="1500" dirty="0">
+                <a:solidFill>
+                  <a:srgbClr val="2563EB"/>
+                </a:solidFill>
+                <a:latin typeface="Inter" pitchFamily="34" charset="0"/>
+                <a:ea typeface="Inter" pitchFamily="34" charset="-122"/>
+                <a:cs typeface="Inter" pitchFamily="34" charset="-120"/>
+              </a:rPr>
+              <a:t>•</a:t>
+            </a:r>
+            <a:endParaRPr lang="en-US" sz="1500" dirty="0"/>
+          </a:p>
+        </p:txBody>
+      </p:sp>
+      <p:sp>
+        <p:nvSpPr>
+          <p:cNvPr id="22" name="Text 18"/>
+          <p:cNvSpPr/>
+          <p:nvPr/>
+        </p:nvSpPr>
+        <p:spPr>
+          <a:xfrm>
+            <a:off x="771525" y="3868341"/>
+            <a:ext cx="1087636" cy="173236"/>
+          </a:xfrm>
+          <a:prstGeom prst="rect">
+            <a:avLst/>
+          </a:prstGeom>
+          <a:noFill/>
+          <a:ln/>
+        </p:spPr>
+        <p:txBody>
+          <a:bodyPr wrap="none" lIns="0" tIns="0" rIns="0" bIns="0" rtlCol="0" anchor="t">
             <a:spAutoFit/>
           </a:bodyPr>
           <a:lstStyle/>
@@ -4286,6 +4330,39 @@
               </a:rPr>
               <a:t>Reliability Gain:</a:t>
             </a:r>
+            <a:endParaRPr lang="en-US" sz="1000" dirty="0"/>
+          </a:p>
+        </p:txBody>
+      </p:sp>
+      <p:sp>
+        <p:nvSpPr>
+          <p:cNvPr id="23" name="Text 19"/>
+          <p:cNvSpPr/>
+          <p:nvPr/>
+        </p:nvSpPr>
+        <p:spPr>
+          <a:xfrm>
+            <a:off x="771525" y="3868341"/>
+            <a:ext cx="3954066" cy="387548"/>
+          </a:xfrm>
+          <a:prstGeom prst="rect">
+            <a:avLst/>
+          </a:prstGeom>
+          <a:noFill/>
+          <a:ln/>
+        </p:spPr>
+        <p:txBody>
+          <a:bodyPr wrap="square" lIns="0" tIns="0" rIns="0" bIns="0" rtlCol="0" anchor="t">
+            <a:spAutoFit/>
+          </a:bodyPr>
+          <a:lstStyle/>
+          <a:p>
+            <a:pPr algn="l" indent="0" marL="0">
+              <a:lnSpc>
+                <a:spcPct val="120000"/>
+              </a:lnSpc>
+              <a:buNone/>
+            </a:pPr>
             <a:r>
               <a:rPr lang="en-US" sz="1050" dirty="0">
                 <a:solidFill>
@@ -4295,22 +4372,22 @@
                 <a:ea typeface="Inter" pitchFamily="34" charset="-122"/>
                 <a:cs typeface="Inter" pitchFamily="34" charset="-120"/>
               </a:rPr>
-              <a:t> According to the Coffin-Manson fatigue model, this massive reduction in thermal cycling amplitude directly and significantly extends the power module's operational lifetime.</a:t>
-            </a:r>
-            <a:endParaRPr lang="en-US" sz="1000" dirty="0"/>
-          </a:p>
-        </p:txBody>
-      </p:sp>
-      <p:sp>
-        <p:nvSpPr>
-          <p:cNvPr id="22" name="Text 18"/>
-          <p:cNvSpPr/>
-          <p:nvPr/>
-        </p:nvSpPr>
-        <p:spPr>
-          <a:xfrm>
-            <a:off x="571500" y="3820120"/>
-            <a:ext cx="112514" cy="300038"/>
+              <a:t>Per the Coffin-Manson fatigue model, this 53% reduction in ΔT</a:t>
+            </a:r>
+            <a:endParaRPr lang="en-US" sz="1050" dirty="0"/>
+          </a:p>
+        </p:txBody>
+      </p:sp>
+      <p:sp>
+        <p:nvSpPr>
+          <p:cNvPr id="24" name="Text 20"/>
+          <p:cNvSpPr/>
+          <p:nvPr/>
+        </p:nvSpPr>
+        <p:spPr>
+          <a:xfrm>
+            <a:off x="2155627" y="4136231"/>
+            <a:ext cx="28575" cy="144661"/>
           </a:xfrm>
           <a:prstGeom prst="rect">
             <a:avLst/>
@@ -4326,28 +4403,248 @@
           <a:p>
             <a:pPr algn="l" indent="0" marL="0">
               <a:lnSpc>
+                <a:spcPct val="119976"/>
+              </a:lnSpc>
+              <a:buNone/>
+            </a:pPr>
+            <a:r>
+              <a:rPr lang="en-US" sz="850" baseline="-40000" dirty="0">
+                <a:solidFill>
+                  <a:srgbClr val="000000"/>
+                </a:solidFill>
+                <a:latin typeface="Inter" pitchFamily="34" charset="0"/>
+                <a:ea typeface="Inter" pitchFamily="34" charset="-122"/>
+                <a:cs typeface="Inter" pitchFamily="34" charset="-120"/>
+              </a:rPr>
+              <a:t>j</a:t>
+            </a:r>
+            <a:endParaRPr lang="en-US" sz="850" dirty="0"/>
+          </a:p>
+        </p:txBody>
+      </p:sp>
+      <p:sp>
+        <p:nvSpPr>
+          <p:cNvPr id="25" name="Text 21"/>
+          <p:cNvSpPr/>
+          <p:nvPr/>
+        </p:nvSpPr>
+        <p:spPr>
+          <a:xfrm>
+            <a:off x="771525" y="4082653"/>
+            <a:ext cx="3877270" cy="431583"/>
+          </a:xfrm>
+          <a:prstGeom prst="rect">
+            <a:avLst/>
+          </a:prstGeom>
+          <a:noFill/>
+          <a:ln/>
+        </p:spPr>
+        <p:txBody>
+          <a:bodyPr wrap="square" lIns="0" tIns="0" rIns="0" bIns="0" rtlCol="0" anchor="t">
+            <a:spAutoFit/>
+          </a:bodyPr>
+          <a:lstStyle/>
+          <a:p>
+            <a:pPr algn="l" indent="0" marL="0">
+              <a:lnSpc>
                 <a:spcPct val="120000"/>
               </a:lnSpc>
               <a:buNone/>
             </a:pPr>
             <a:r>
-              <a:rPr lang="en-US" sz="1500" dirty="0">
-                <a:solidFill>
-                  <a:srgbClr val="2563EB"/>
-                </a:solidFill>
-                <a:latin typeface="Inter" pitchFamily="34" charset="0"/>
-                <a:ea typeface="Inter" pitchFamily="34" charset="-122"/>
-                <a:cs typeface="Inter" pitchFamily="34" charset="-120"/>
-              </a:rPr>
-              <a:t>•</a:t>
-            </a:r>
-            <a:endParaRPr lang="en-US" sz="1500" dirty="0"/>
+              <a:rPr lang="en-US" sz="1050" dirty="0">
+                <a:solidFill>
+                  <a:srgbClr val="000000"/>
+                </a:solidFill>
+                <a:latin typeface="Inter" pitchFamily="34" charset="0"/>
+                <a:ea typeface="Inter" pitchFamily="34" charset="-122"/>
+                <a:cs typeface="Inter" pitchFamily="34" charset="-120"/>
+              </a:rPr>
+              <a:t>extends the power module's fatigue lifetime, as cycles-to-failure scales with (ΔT</a:t>
+            </a:r>
+            <a:endParaRPr lang="en-US" sz="1050" dirty="0"/>
+          </a:p>
+        </p:txBody>
+      </p:sp>
+      <p:sp>
+        <p:nvSpPr>
+          <p:cNvPr id="26" name="Text 22"/>
+          <p:cNvSpPr/>
+          <p:nvPr/>
+        </p:nvSpPr>
+        <p:spPr>
+          <a:xfrm>
+            <a:off x="3732609" y="4394578"/>
+            <a:ext cx="28575" cy="144661"/>
+          </a:xfrm>
+          <a:prstGeom prst="rect">
+            <a:avLst/>
+          </a:prstGeom>
+          <a:noFill/>
+          <a:ln/>
+        </p:spPr>
+        <p:txBody>
+          <a:bodyPr wrap="none" lIns="0" tIns="0" rIns="0" bIns="0" rtlCol="0" anchor="t">
+            <a:spAutoFit/>
+          </a:bodyPr>
+          <a:lstStyle/>
+          <a:p>
+            <a:pPr algn="l" indent="0" marL="0">
+              <a:lnSpc>
+                <a:spcPct val="119976"/>
+              </a:lnSpc>
+              <a:buNone/>
+            </a:pPr>
+            <a:r>
+              <a:rPr lang="en-US" sz="850" baseline="-40000" dirty="0">
+                <a:solidFill>
+                  <a:srgbClr val="000000"/>
+                </a:solidFill>
+                <a:latin typeface="Inter" pitchFamily="34" charset="0"/>
+                <a:ea typeface="Inter" pitchFamily="34" charset="-122"/>
+                <a:cs typeface="Inter" pitchFamily="34" charset="-120"/>
+              </a:rPr>
+              <a:t>j</a:t>
+            </a:r>
+            <a:endParaRPr lang="en-US" sz="850" dirty="0"/>
+          </a:p>
+        </p:txBody>
+      </p:sp>
+      <p:sp>
+        <p:nvSpPr>
+          <p:cNvPr id="27" name="Text 23"/>
+          <p:cNvSpPr/>
+          <p:nvPr/>
+        </p:nvSpPr>
+        <p:spPr>
+          <a:xfrm>
+            <a:off x="3761184" y="4341000"/>
+            <a:ext cx="51792" cy="173236"/>
+          </a:xfrm>
+          <a:prstGeom prst="rect">
+            <a:avLst/>
+          </a:prstGeom>
+          <a:noFill/>
+          <a:ln/>
+        </p:spPr>
+        <p:txBody>
+          <a:bodyPr wrap="none" lIns="0" tIns="0" rIns="0" bIns="0" rtlCol="0" anchor="t">
+            <a:spAutoFit/>
+          </a:bodyPr>
+          <a:lstStyle/>
+          <a:p>
+            <a:pPr algn="l" indent="0" marL="0">
+              <a:lnSpc>
+                <a:spcPct val="120000"/>
+              </a:lnSpc>
+              <a:buNone/>
+            </a:pPr>
+            <a:r>
+              <a:rPr lang="en-US" sz="1050" dirty="0">
+                <a:solidFill>
+                  <a:srgbClr val="000000"/>
+                </a:solidFill>
+                <a:latin typeface="Inter" pitchFamily="34" charset="0"/>
+                <a:ea typeface="Inter" pitchFamily="34" charset="-122"/>
+                <a:cs typeface="Inter" pitchFamily="34" charset="-120"/>
+              </a:rPr>
+              <a:t>)</a:t>
+            </a:r>
+            <a:endParaRPr lang="en-US" sz="1050" dirty="0"/>
+          </a:p>
+        </p:txBody>
+      </p:sp>
+      <p:sp>
+        <p:nvSpPr>
+          <p:cNvPr id="28" name="Text 24"/>
+          <p:cNvSpPr/>
+          <p:nvPr/>
+        </p:nvSpPr>
+        <p:spPr>
+          <a:xfrm>
+            <a:off x="3812977" y="4314825"/>
+            <a:ext cx="148233" cy="144661"/>
+          </a:xfrm>
+          <a:prstGeom prst="rect">
+            <a:avLst/>
+          </a:prstGeom>
+          <a:noFill/>
+          <a:ln/>
+        </p:spPr>
+        <p:txBody>
+          <a:bodyPr wrap="none" lIns="0" tIns="0" rIns="0" bIns="0" rtlCol="0" anchor="t">
+            <a:spAutoFit/>
+          </a:bodyPr>
+          <a:lstStyle/>
+          <a:p>
+            <a:pPr algn="l" indent="0" marL="0">
+              <a:lnSpc>
+                <a:spcPct val="119976"/>
+              </a:lnSpc>
+              <a:buNone/>
+            </a:pPr>
+            <a:r>
+              <a:rPr lang="en-US" sz="850" baseline="30000" dirty="0">
+                <a:solidFill>
+                  <a:srgbClr val="000000"/>
+                </a:solidFill>
+                <a:latin typeface="Inter" pitchFamily="34" charset="0"/>
+                <a:ea typeface="Inter" pitchFamily="34" charset="-122"/>
+                <a:cs typeface="Inter" pitchFamily="34" charset="-120"/>
+              </a:rPr>
+              <a:t>−n</a:t>
+            </a:r>
+            <a:endParaRPr lang="en-US" sz="850" dirty="0"/>
+          </a:p>
+        </p:txBody>
+      </p:sp>
+      <p:sp>
+        <p:nvSpPr>
+          <p:cNvPr id="29" name="Text 25"/>
+          <p:cNvSpPr/>
+          <p:nvPr/>
+        </p:nvSpPr>
+        <p:spPr>
+          <a:xfrm>
+            <a:off x="771525" y="4341000"/>
+            <a:ext cx="3894962" cy="408980"/>
+          </a:xfrm>
+          <a:prstGeom prst="rect">
+            <a:avLst/>
+          </a:prstGeom>
+          <a:noFill/>
+          <a:ln/>
+        </p:spPr>
+        <p:txBody>
+          <a:bodyPr wrap="square" lIns="0" tIns="0" rIns="0" bIns="0" rtlCol="0" anchor="t">
+            <a:spAutoFit/>
+          </a:bodyPr>
+          <a:lstStyle/>
+          <a:p>
+            <a:pPr algn="l" indent="0" marL="0">
+              <a:lnSpc>
+                <a:spcPct val="120000"/>
+              </a:lnSpc>
+              <a:buNone/>
+            </a:pPr>
+            <a:r>
+              <a:rPr lang="en-US" sz="1050" dirty="0">
+                <a:solidFill>
+                  <a:srgbClr val="000000"/>
+                </a:solidFill>
+                <a:latin typeface="Inter" pitchFamily="34" charset="0"/>
+                <a:ea typeface="Inter" pitchFamily="34" charset="-122"/>
+                <a:cs typeface="Inter" pitchFamily="34" charset="-120"/>
+              </a:rPr>
+              <a:t>where n ≈ 4–5.</a:t>
+            </a:r>
+            <a:endParaRPr lang="en-US" sz="1050" dirty="0"/>
           </a:p>
         </p:txBody>
       </p:sp>
       <p:pic>
         <p:nvPicPr>
-          <p:cNvPr id="23" name="Image 1" descr="preencoded.png">    </p:cNvPr>
+          <p:cNvPr id="30" name="Image 1" descr="preencoded.png">    </p:cNvPr>
           <p:cNvPicPr>
             <a:picLocks noChangeAspect="1"/>
           </p:cNvPicPr>
@@ -4371,7 +4668,7 @@
       </p:pic>
       <p:sp>
         <p:nvSpPr>
-          <p:cNvPr id="24" name="Text 19"/>
+          <p:cNvPr id="31" name="Text 26"/>
           <p:cNvSpPr/>
           <p:nvPr/>
         </p:nvSpPr>
@@ -4594,7 +4891,7 @@
         <p:spPr>
           <a:xfrm>
             <a:off x="571500" y="1780580"/>
-            <a:ext cx="2428875" cy="857250"/>
+            <a:ext cx="2428875" cy="642938"/>
           </a:xfrm>
           <a:prstGeom prst="rect">
             <a:avLst/>
@@ -4623,7 +4920,7 @@
                 <a:ea typeface="Inter Bold" pitchFamily="34" charset="-122"/>
                 <a:cs typeface="Inter Bold" pitchFamily="34" charset="-120"/>
               </a:rPr>
-              <a:t>Pre-charge Sequence:</a:t>
+              <a:t>Pre-charge:</a:t>
             </a:r>
             <a:r>
               <a:rPr lang="en-US" sz="1050" dirty="0">
@@ -4634,7 +4931,7 @@
                 <a:ea typeface="Inter" pitchFamily="34" charset="-122"/>
                 <a:cs typeface="Inter" pitchFamily="34" charset="-120"/>
               </a:rPr>
-              <a:t> A 20ms linear ramp is implemented to prevent inrush currents during startup.</a:t>
+              <a:t> A 20 ms linear ramp prevents inrush currents during startup.</a:t>
             </a:r>
             <a:endParaRPr lang="en-US" sz="1000" dirty="0"/>
           </a:p>
@@ -4648,7 +4945,7 @@
         </p:nvSpPr>
         <p:spPr>
           <a:xfrm>
-            <a:off x="571500" y="2780705"/>
+            <a:off x="571500" y="2566392"/>
             <a:ext cx="2428875" cy="857250"/>
           </a:xfrm>
           <a:prstGeom prst="rect">
@@ -4689,7 +4986,7 @@
                 <a:ea typeface="Inter" pitchFamily="34" charset="-122"/>
                 <a:cs typeface="Inter" pitchFamily="34" charset="-120"/>
               </a:rPr>
-              <a:t> PD-PWM successfully keeps the flying capacitor voltage tightly regulated at exactly 400V.</a:t>
+              <a:t> PD-PWM maintains the flying capacitor voltage at 400V with a mean error &lt; 0.04V.</a:t>
             </a:r>
             <a:endParaRPr lang="en-US" sz="1000" dirty="0"/>
           </a:p>
@@ -4703,8 +5000,8 @@
         </p:nvSpPr>
         <p:spPr>
           <a:xfrm>
-            <a:off x="571500" y="3780830"/>
-            <a:ext cx="2428875" cy="857250"/>
+            <a:off x="571500" y="3566517"/>
+            <a:ext cx="2428875" cy="642938"/>
           </a:xfrm>
           <a:prstGeom prst="rect">
             <a:avLst/>
@@ -4744,7 +5041,7 @@
                 <a:ea typeface="Inter" pitchFamily="34" charset="-122"/>
                 <a:cs typeface="Inter" pitchFamily="34" charset="-120"/>
               </a:rPr>
-              <a:t> The peak-to-peak voltage ripple is 18.0V, successfully meeting the strict 5% (20V) design constraint.</a:t>
+              <a:t> Peak-to-peak ripple is 18.0V, within the 5% (20V) design constraint.</a:t>
             </a:r>
             <a:endParaRPr lang="en-US" sz="1000" dirty="0"/>
           </a:p>
@@ -4802,7 +5099,7 @@
         </p:nvSpPr>
         <p:spPr>
           <a:xfrm>
-            <a:off x="571500" y="2752130"/>
+            <a:off x="571500" y="2537817"/>
             <a:ext cx="112514" cy="300038"/>
           </a:xfrm>
           <a:prstGeom prst="rect">
@@ -4846,7 +5143,7 @@
         </p:nvSpPr>
         <p:spPr>
           <a:xfrm>
-            <a:off x="571500" y="3752255"/>
+            <a:off x="571500" y="3537942"/>
             <a:ext cx="112514" cy="300038"/>
           </a:xfrm>
           <a:prstGeom prst="rect">
@@ -4917,7 +5214,7 @@
                 <a:ea typeface="Inter Bold" pitchFamily="34" charset="-122"/>
                 <a:cs typeface="Inter Bold" pitchFamily="34" charset="-120"/>
               </a:rPr>
-              <a:t>THD Validation</a:t>
+              <a:t>THD Performance</a:t>
             </a:r>
             <a:endParaRPr lang="en-US" sz="1300" dirty="0"/>
           </a:p>
@@ -4932,7 +5229,7 @@
         <p:spPr>
           <a:xfrm>
             <a:off x="3357563" y="1780580"/>
-            <a:ext cx="2428875" cy="1071563"/>
+            <a:ext cx="2428875" cy="857250"/>
           </a:xfrm>
           <a:prstGeom prst="rect">
             <a:avLst/>
@@ -4961,7 +5258,7 @@
                 <a:ea typeface="Inter Bold" pitchFamily="34" charset="-122"/>
                 <a:cs typeface="Inter Bold" pitchFamily="34" charset="-120"/>
               </a:rPr>
-              <a:t>Harmonic Performance:</a:t>
+              <a:t>3-Level Output:</a:t>
             </a:r>
             <a:r>
               <a:rPr lang="en-US" sz="1050" dirty="0">
@@ -4972,7 +5269,7 @@
                 <a:ea typeface="Inter" pitchFamily="34" charset="-122"/>
                 <a:cs typeface="Inter" pitchFamily="34" charset="-120"/>
               </a:rPr>
-              <a:t> The 3-level output inherently reduces the voltage step size, significantly improving power quality.</a:t>
+              <a:t> The reduced voltage step size improves the harmonic spectrum relative to a 2-level inverter.</a:t>
             </a:r>
             <a:endParaRPr lang="en-US" sz="1000" dirty="0"/>
           </a:p>
@@ -4986,7 +5283,7 @@
         </p:nvSpPr>
         <p:spPr>
           <a:xfrm>
-            <a:off x="3357563" y="2995017"/>
+            <a:off x="3357563" y="2780705"/>
             <a:ext cx="2428875" cy="857250"/>
           </a:xfrm>
           <a:prstGeom prst="rect">
@@ -5016,7 +5313,7 @@
                 <a:ea typeface="Inter Bold" pitchFamily="34" charset="-122"/>
                 <a:cs typeface="Inter Bold" pitchFamily="34" charset="-120"/>
               </a:rPr>
-              <a:t>Urban Driving:</a:t>
+              <a:t>Urban (5 kHz):</a:t>
             </a:r>
             <a:r>
               <a:rPr lang="en-US" sz="1050" dirty="0">
@@ -5027,7 +5324,7 @@
                 <a:ea typeface="Inter" pitchFamily="34" charset="-122"/>
                 <a:cs typeface="Inter" pitchFamily="34" charset="-120"/>
               </a:rPr>
-              <a:t> At a 5 kHz switching frequency, the output Total Harmonic Distortion (THD) is 1.92%.</a:t>
+              <a:t> Simulated current THD = 1.92%. Note: this is an optimistic bound (ideal switching model).</a:t>
             </a:r>
             <a:endParaRPr lang="en-US" sz="1000" dirty="0"/>
           </a:p>
@@ -5041,7 +5338,7 @@
         </p:nvSpPr>
         <p:spPr>
           <a:xfrm>
-            <a:off x="3357563" y="3995142"/>
+            <a:off x="3357563" y="3780830"/>
             <a:ext cx="2428875" cy="642938"/>
           </a:xfrm>
           <a:prstGeom prst="rect">
@@ -5071,7 +5368,7 @@
                 <a:ea typeface="Inter Bold" pitchFamily="34" charset="-122"/>
                 <a:cs typeface="Inter Bold" pitchFamily="34" charset="-120"/>
               </a:rPr>
-              <a:t>Highway Driving:</a:t>
+              <a:t>Highway (20 kHz):</a:t>
             </a:r>
             <a:r>
               <a:rPr lang="en-US" sz="1050" dirty="0">
@@ -5082,7 +5379,7 @@
                 <a:ea typeface="Inter" pitchFamily="34" charset="-122"/>
                 <a:cs typeface="Inter" pitchFamily="34" charset="-120"/>
               </a:rPr>
-              <a:t> At a 20 kHz switching frequency, the output THD is 1.13%.</a:t>
+              <a:t> Simulated current THD = 1.13%. Literature range for hardware: 1.5–4%.</a:t>
             </a:r>
             <a:endParaRPr lang="en-US" sz="1000" dirty="0"/>
           </a:p>
@@ -5140,7 +5437,7 @@
         </p:nvSpPr>
         <p:spPr>
           <a:xfrm>
-            <a:off x="3357563" y="2966442"/>
+            <a:off x="3357563" y="2752130"/>
             <a:ext cx="112514" cy="300038"/>
           </a:xfrm>
           <a:prstGeom prst="rect">
@@ -5184,7 +5481,7 @@
         </p:nvSpPr>
         <p:spPr>
           <a:xfrm>
-            <a:off x="3357563" y="3966567"/>
+            <a:off x="3357563" y="3752255"/>
             <a:ext cx="112514" cy="300038"/>
           </a:xfrm>
           <a:prstGeom prst="rect">
@@ -5269,17 +5566,61 @@
         </p:nvSpPr>
         <p:spPr>
           <a:xfrm>
-            <a:off x="6143625" y="1780580"/>
-            <a:ext cx="2428875" cy="857250"/>
-          </a:xfrm>
-          <a:prstGeom prst="rect">
-            <a:avLst/>
-          </a:prstGeom>
-          <a:noFill/>
-          <a:ln/>
-        </p:spPr>
-        <p:txBody>
-          <a:bodyPr wrap="square" lIns="238125" tIns="0" rIns="0" bIns="0" rtlCol="0" anchor="t">
+            <a:off x="6143625" y="1752005"/>
+            <a:ext cx="112514" cy="300038"/>
+          </a:xfrm>
+          <a:prstGeom prst="rect">
+            <a:avLst/>
+          </a:prstGeom>
+          <a:noFill/>
+          <a:ln/>
+        </p:spPr>
+        <p:txBody>
+          <a:bodyPr wrap="none" lIns="0" tIns="0" rIns="0" bIns="0" rtlCol="0" anchor="t">
+            <a:spAutoFit/>
+          </a:bodyPr>
+          <a:lstStyle/>
+          <a:p>
+            <a:pPr algn="l" indent="0" marL="0">
+              <a:lnSpc>
+                <a:spcPct val="120000"/>
+              </a:lnSpc>
+              <a:buNone/>
+            </a:pPr>
+            <a:r>
+              <a:rPr lang="en-US" sz="1500" dirty="0">
+                <a:solidFill>
+                  <a:srgbClr val="2563EB"/>
+                </a:solidFill>
+                <a:latin typeface="Inter" pitchFamily="34" charset="0"/>
+                <a:ea typeface="Inter" pitchFamily="34" charset="-122"/>
+                <a:cs typeface="Inter" pitchFamily="34" charset="-120"/>
+              </a:rPr>
+              <a:t>•</a:t>
+            </a:r>
+            <a:endParaRPr lang="en-US" sz="1500" dirty="0"/>
+          </a:p>
+        </p:txBody>
+      </p:sp>
+      <p:sp>
+        <p:nvSpPr>
+          <p:cNvPr id="22" name="Text 18"/>
+          <p:cNvSpPr/>
+          <p:nvPr/>
+        </p:nvSpPr>
+        <p:spPr>
+          <a:xfrm>
+            <a:off x="6343650" y="1800225"/>
+            <a:ext cx="1125141" cy="173236"/>
+          </a:xfrm>
+          <a:prstGeom prst="rect">
+            <a:avLst/>
+          </a:prstGeom>
+          <a:noFill/>
+          <a:ln/>
+        </p:spPr>
+        <p:txBody>
+          <a:bodyPr wrap="none" lIns="0" tIns="0" rIns="0" bIns="0" rtlCol="0" anchor="t">
             <a:spAutoFit/>
           </a:bodyPr>
           <a:lstStyle/>
@@ -5301,6 +5642,39 @@
               </a:rPr>
               <a:t>Foster Network:</a:t>
             </a:r>
+            <a:endParaRPr lang="en-US" sz="1000" dirty="0"/>
+          </a:p>
+        </p:txBody>
+      </p:sp>
+      <p:sp>
+        <p:nvSpPr>
+          <p:cNvPr id="23" name="Text 19"/>
+          <p:cNvSpPr/>
+          <p:nvPr/>
+        </p:nvSpPr>
+        <p:spPr>
+          <a:xfrm>
+            <a:off x="6343650" y="1800225"/>
+            <a:ext cx="1791295" cy="387548"/>
+          </a:xfrm>
+          <a:prstGeom prst="rect">
+            <a:avLst/>
+          </a:prstGeom>
+          <a:noFill/>
+          <a:ln/>
+        </p:spPr>
+        <p:txBody>
+          <a:bodyPr wrap="square" lIns="0" tIns="0" rIns="0" bIns="0" rtlCol="0" anchor="t">
+            <a:spAutoFit/>
+          </a:bodyPr>
+          <a:lstStyle/>
+          <a:p>
+            <a:pPr algn="l" indent="0" marL="0">
+              <a:lnSpc>
+                <a:spcPct val="120000"/>
+              </a:lnSpc>
+              <a:buNone/>
+            </a:pPr>
             <a:r>
               <a:rPr lang="en-US" sz="1050" dirty="0">
                 <a:solidFill>
@@ -5310,21 +5684,109 @@
                 <a:ea typeface="Inter" pitchFamily="34" charset="-122"/>
                 <a:cs typeface="Inter" pitchFamily="34" charset="-120"/>
               </a:rPr>
-              <a:t> A 4-layer thermal model accurately captures the transient junction temperature dynamics.</a:t>
-            </a:r>
-            <a:endParaRPr lang="en-US" sz="1000" dirty="0"/>
-          </a:p>
-        </p:txBody>
-      </p:sp>
-      <p:sp>
-        <p:nvSpPr>
-          <p:cNvPr id="22" name="Text 18"/>
-          <p:cNvSpPr/>
-          <p:nvPr/>
-        </p:nvSpPr>
-        <p:spPr>
-          <a:xfrm>
-            <a:off x="6143625" y="1752005"/>
+              <a:t>A 4-layer model (R</a:t>
+            </a:r>
+            <a:endParaRPr lang="en-US" sz="1050" dirty="0"/>
+          </a:p>
+        </p:txBody>
+      </p:sp>
+      <p:sp>
+        <p:nvSpPr>
+          <p:cNvPr id="24" name="Text 20"/>
+          <p:cNvSpPr/>
+          <p:nvPr/>
+        </p:nvSpPr>
+        <p:spPr>
+          <a:xfrm>
+            <a:off x="6943725" y="2068116"/>
+            <a:ext cx="239316" cy="144661"/>
+          </a:xfrm>
+          <a:prstGeom prst="rect">
+            <a:avLst/>
+          </a:prstGeom>
+          <a:noFill/>
+          <a:ln/>
+        </p:spPr>
+        <p:txBody>
+          <a:bodyPr wrap="none" lIns="0" tIns="0" rIns="0" bIns="0" rtlCol="0" anchor="t">
+            <a:spAutoFit/>
+          </a:bodyPr>
+          <a:lstStyle/>
+          <a:p>
+            <a:pPr algn="l" indent="0" marL="0">
+              <a:lnSpc>
+                <a:spcPct val="119976"/>
+              </a:lnSpc>
+              <a:buNone/>
+            </a:pPr>
+            <a:r>
+              <a:rPr lang="en-US" sz="850" baseline="-40000" dirty="0">
+                <a:solidFill>
+                  <a:srgbClr val="000000"/>
+                </a:solidFill>
+                <a:latin typeface="Inter" pitchFamily="34" charset="0"/>
+                <a:ea typeface="Inter" pitchFamily="34" charset="-122"/>
+                <a:cs typeface="Inter" pitchFamily="34" charset="-120"/>
+              </a:rPr>
+              <a:t>th,jc</a:t>
+            </a:r>
+            <a:endParaRPr lang="en-US" sz="850" dirty="0"/>
+          </a:p>
+        </p:txBody>
+      </p:sp>
+      <p:sp>
+        <p:nvSpPr>
+          <p:cNvPr id="25" name="Text 21"/>
+          <p:cNvSpPr/>
+          <p:nvPr/>
+        </p:nvSpPr>
+        <p:spPr>
+          <a:xfrm>
+            <a:off x="6343650" y="2014538"/>
+            <a:ext cx="1862733" cy="623292"/>
+          </a:xfrm>
+          <a:prstGeom prst="rect">
+            <a:avLst/>
+          </a:prstGeom>
+          <a:noFill/>
+          <a:ln/>
+        </p:spPr>
+        <p:txBody>
+          <a:bodyPr wrap="square" lIns="0" tIns="0" rIns="0" bIns="0" rtlCol="0" anchor="t">
+            <a:spAutoFit/>
+          </a:bodyPr>
+          <a:lstStyle/>
+          <a:p>
+            <a:pPr algn="l" indent="0" marL="0">
+              <a:lnSpc>
+                <a:spcPct val="120000"/>
+              </a:lnSpc>
+              <a:buNone/>
+            </a:pPr>
+            <a:r>
+              <a:rPr lang="en-US" sz="1050" dirty="0">
+                <a:solidFill>
+                  <a:srgbClr val="000000"/>
+                </a:solidFill>
+                <a:latin typeface="Inter" pitchFamily="34" charset="0"/>
+                <a:ea typeface="Inter" pitchFamily="34" charset="-122"/>
+                <a:cs typeface="Inter" pitchFamily="34" charset="-120"/>
+              </a:rPr>
+              <a:t>= 0.094 °C/W) captures transient junction temperature dynamics.</a:t>
+            </a:r>
+            <a:endParaRPr lang="en-US" sz="1050" dirty="0"/>
+          </a:p>
+        </p:txBody>
+      </p:sp>
+      <p:sp>
+        <p:nvSpPr>
+          <p:cNvPr id="26" name="Text 22"/>
+          <p:cNvSpPr/>
+          <p:nvPr/>
+        </p:nvSpPr>
+        <p:spPr>
+          <a:xfrm>
+            <a:off x="6143625" y="2773561"/>
             <a:ext cx="112514" cy="300038"/>
           </a:xfrm>
           <a:prstGeom prst="rect">
@@ -5362,58 +5824,14 @@
       </p:sp>
       <p:sp>
         <p:nvSpPr>
-          <p:cNvPr id="23" name="Text 19"/>
-          <p:cNvSpPr/>
-          <p:nvPr/>
-        </p:nvSpPr>
-        <p:spPr>
-          <a:xfrm>
-            <a:off x="6143625" y="2752130"/>
-            <a:ext cx="112514" cy="300038"/>
-          </a:xfrm>
-          <a:prstGeom prst="rect">
-            <a:avLst/>
-          </a:prstGeom>
-          <a:noFill/>
-          <a:ln/>
-        </p:spPr>
-        <p:txBody>
-          <a:bodyPr wrap="none" lIns="0" tIns="0" rIns="0" bIns="0" rtlCol="0" anchor="t">
-            <a:spAutoFit/>
-          </a:bodyPr>
-          <a:lstStyle/>
-          <a:p>
-            <a:pPr algn="l" indent="0" marL="0">
-              <a:lnSpc>
-                <a:spcPct val="120000"/>
-              </a:lnSpc>
-              <a:buNone/>
-            </a:pPr>
-            <a:r>
-              <a:rPr lang="en-US" sz="1500" dirty="0">
-                <a:solidFill>
-                  <a:srgbClr val="2563EB"/>
-                </a:solidFill>
-                <a:latin typeface="Inter" pitchFamily="34" charset="0"/>
-                <a:ea typeface="Inter" pitchFamily="34" charset="-122"/>
-                <a:cs typeface="Inter" pitchFamily="34" charset="-120"/>
-              </a:rPr>
-              <a:t>•</a:t>
-            </a:r>
-            <a:endParaRPr lang="en-US" sz="1500" dirty="0"/>
-          </a:p>
-        </p:txBody>
-      </p:sp>
-      <p:sp>
-        <p:nvSpPr>
-          <p:cNvPr id="24" name="Text 20"/>
-          <p:cNvSpPr/>
-          <p:nvPr/>
-        </p:nvSpPr>
-        <p:spPr>
-          <a:xfrm>
-            <a:off x="6343650" y="2800350"/>
-            <a:ext cx="1321594" cy="173236"/>
+          <p:cNvPr id="27" name="Text 23"/>
+          <p:cNvSpPr/>
+          <p:nvPr/>
+        </p:nvSpPr>
+        <p:spPr>
+          <a:xfrm>
+            <a:off x="6343650" y="2821781"/>
+            <a:ext cx="471488" cy="173236"/>
           </a:xfrm>
           <a:prstGeom prst="rect">
             <a:avLst/>
@@ -5442,7 +5860,7 @@
                 <a:ea typeface="Inter Bold" pitchFamily="34" charset="-122"/>
                 <a:cs typeface="Inter Bold" pitchFamily="34" charset="-120"/>
               </a:rPr>
-              <a:t>Peak Temperature:</a:t>
+              <a:t>Peak T</a:t>
             </a:r>
             <a:endParaRPr lang="en-US" sz="1000" dirty="0"/>
           </a:p>
@@ -5450,58 +5868,14 @@
       </p:sp>
       <p:sp>
         <p:nvSpPr>
-          <p:cNvPr id="25" name="Text 21"/>
-          <p:cNvSpPr/>
-          <p:nvPr/>
-        </p:nvSpPr>
-        <p:spPr>
-          <a:xfrm>
-            <a:off x="6343650" y="2800350"/>
-            <a:ext cx="2198489" cy="387548"/>
-          </a:xfrm>
-          <a:prstGeom prst="rect">
-            <a:avLst/>
-          </a:prstGeom>
-          <a:noFill/>
-          <a:ln/>
-        </p:spPr>
-        <p:txBody>
-          <a:bodyPr wrap="square" lIns="0" tIns="0" rIns="0" bIns="0" rtlCol="0" anchor="t">
-            <a:spAutoFit/>
-          </a:bodyPr>
-          <a:lstStyle/>
-          <a:p>
-            <a:pPr algn="l" indent="0" marL="0">
-              <a:lnSpc>
-                <a:spcPct val="120000"/>
-              </a:lnSpc>
-              <a:buNone/>
-            </a:pPr>
-            <a:r>
-              <a:rPr lang="en-US" sz="1050" dirty="0">
-                <a:solidFill>
-                  <a:srgbClr val="000000"/>
-                </a:solidFill>
-                <a:latin typeface="Inter" pitchFamily="34" charset="0"/>
-                <a:ea typeface="Inter" pitchFamily="34" charset="-122"/>
-                <a:cs typeface="Inter" pitchFamily="34" charset="-120"/>
-              </a:rPr>
-              <a:t>The junction temperature (T</a:t>
-            </a:r>
-            <a:endParaRPr lang="en-US" sz="1050" dirty="0"/>
-          </a:p>
-        </p:txBody>
-      </p:sp>
-      <p:sp>
-        <p:nvSpPr>
-          <p:cNvPr id="26" name="Text 22"/>
-          <p:cNvSpPr/>
-          <p:nvPr/>
-        </p:nvSpPr>
-        <p:spPr>
-          <a:xfrm>
-            <a:off x="7354491" y="3068241"/>
-            <a:ext cx="28575" cy="144661"/>
+          <p:cNvPr id="28" name="Text 24"/>
+          <p:cNvSpPr/>
+          <p:nvPr/>
+        </p:nvSpPr>
+        <p:spPr>
+          <a:xfrm>
+            <a:off x="6815138" y="2875359"/>
+            <a:ext cx="32147" cy="144661"/>
           </a:xfrm>
           <a:prstGeom prst="rect">
             <a:avLst/>
@@ -5522,95 +5896,7 @@
               <a:buNone/>
             </a:pPr>
             <a:r>
-              <a:rPr lang="en-US" sz="850" baseline="-40000" dirty="0">
-                <a:solidFill>
-                  <a:srgbClr val="000000"/>
-                </a:solidFill>
-                <a:latin typeface="Inter" pitchFamily="34" charset="0"/>
-                <a:ea typeface="Inter" pitchFamily="34" charset="-122"/>
-                <a:cs typeface="Inter" pitchFamily="34" charset="-120"/>
-              </a:rPr>
-              <a:t>j</a:t>
-            </a:r>
-            <a:endParaRPr lang="en-US" sz="850" dirty="0"/>
-          </a:p>
-        </p:txBody>
-      </p:sp>
-      <p:sp>
-        <p:nvSpPr>
-          <p:cNvPr id="27" name="Text 23"/>
-          <p:cNvSpPr/>
-          <p:nvPr/>
-        </p:nvSpPr>
-        <p:spPr>
-          <a:xfrm>
-            <a:off x="6343650" y="3014663"/>
-            <a:ext cx="2032397" cy="623292"/>
-          </a:xfrm>
-          <a:prstGeom prst="rect">
-            <a:avLst/>
-          </a:prstGeom>
-          <a:noFill/>
-          <a:ln/>
-        </p:spPr>
-        <p:txBody>
-          <a:bodyPr wrap="square" lIns="0" tIns="0" rIns="0" bIns="0" rtlCol="0" anchor="t">
-            <a:spAutoFit/>
-          </a:bodyPr>
-          <a:lstStyle/>
-          <a:p>
-            <a:pPr algn="l" indent="0" marL="0">
-              <a:lnSpc>
-                <a:spcPct val="120000"/>
-              </a:lnSpc>
-              <a:buNone/>
-            </a:pPr>
-            <a:r>
-              <a:rPr lang="en-US" sz="1050" dirty="0">
-                <a:solidFill>
-                  <a:srgbClr val="000000"/>
-                </a:solidFill>
-                <a:latin typeface="Inter" pitchFamily="34" charset="0"/>
-                <a:ea typeface="Inter" pitchFamily="34" charset="-122"/>
-                <a:cs typeface="Inter" pitchFamily="34" charset="-120"/>
-              </a:rPr>
-              <a:t>) peaks at only 50.1°C under the adaptive schedule.</a:t>
-            </a:r>
-            <a:endParaRPr lang="en-US" sz="1050" dirty="0"/>
-          </a:p>
-        </p:txBody>
-      </p:sp>
-      <p:sp>
-        <p:nvSpPr>
-          <p:cNvPr id="28" name="Text 24"/>
-          <p:cNvSpPr/>
-          <p:nvPr/>
-        </p:nvSpPr>
-        <p:spPr>
-          <a:xfrm>
-            <a:off x="6143625" y="3802261"/>
-            <a:ext cx="2428875" cy="642938"/>
-          </a:xfrm>
-          <a:prstGeom prst="rect">
-            <a:avLst/>
-          </a:prstGeom>
-          <a:noFill/>
-          <a:ln/>
-        </p:spPr>
-        <p:txBody>
-          <a:bodyPr wrap="square" lIns="238125" tIns="0" rIns="0" bIns="0" rtlCol="0" anchor="t">
-            <a:spAutoFit/>
-          </a:bodyPr>
-          <a:lstStyle/>
-          <a:p>
-            <a:pPr algn="l" indent="0" marL="0">
-              <a:lnSpc>
-                <a:spcPct val="120000"/>
-              </a:lnSpc>
-              <a:buNone/>
-            </a:pPr>
-            <a:r>
-              <a:rPr lang="en-US" sz="1000" b="1" dirty="0">
+              <a:rPr lang="en-US" sz="800" b="1" baseline="-40000" dirty="0">
                 <a:solidFill>
                   <a:srgbClr val="000000"/>
                 </a:solidFill>
@@ -5618,6 +5904,226 @@
                 <a:ea typeface="Inter Bold" pitchFamily="34" charset="-122"/>
                 <a:cs typeface="Inter Bold" pitchFamily="34" charset="-120"/>
               </a:rPr>
+              <a:t>j</a:t>
+            </a:r>
+            <a:endParaRPr lang="en-US" sz="800" dirty="0"/>
+          </a:p>
+        </p:txBody>
+      </p:sp>
+      <p:sp>
+        <p:nvSpPr>
+          <p:cNvPr id="29" name="Text 25"/>
+          <p:cNvSpPr/>
+          <p:nvPr/>
+        </p:nvSpPr>
+        <p:spPr>
+          <a:xfrm>
+            <a:off x="6847284" y="2821781"/>
+            <a:ext cx="48220" cy="173236"/>
+          </a:xfrm>
+          <a:prstGeom prst="rect">
+            <a:avLst/>
+          </a:prstGeom>
+          <a:noFill/>
+          <a:ln/>
+        </p:spPr>
+        <p:txBody>
+          <a:bodyPr wrap="none" lIns="0" tIns="0" rIns="0" bIns="0" rtlCol="0" anchor="t">
+            <a:spAutoFit/>
+          </a:bodyPr>
+          <a:lstStyle/>
+          <a:p>
+            <a:pPr algn="l" indent="0" marL="0">
+              <a:lnSpc>
+                <a:spcPct val="120000"/>
+              </a:lnSpc>
+              <a:buNone/>
+            </a:pPr>
+            <a:r>
+              <a:rPr lang="en-US" sz="1000" b="1" dirty="0">
+                <a:solidFill>
+                  <a:srgbClr val="000000"/>
+                </a:solidFill>
+                <a:latin typeface="Inter Bold" pitchFamily="34" charset="0"/>
+                <a:ea typeface="Inter Bold" pitchFamily="34" charset="-122"/>
+                <a:cs typeface="Inter Bold" pitchFamily="34" charset="-120"/>
+              </a:rPr>
+              <a:t>:</a:t>
+            </a:r>
+            <a:endParaRPr lang="en-US" sz="1000" dirty="0"/>
+          </a:p>
+        </p:txBody>
+      </p:sp>
+      <p:sp>
+        <p:nvSpPr>
+          <p:cNvPr id="30" name="Text 26"/>
+          <p:cNvSpPr/>
+          <p:nvPr/>
+        </p:nvSpPr>
+        <p:spPr>
+          <a:xfrm>
+            <a:off x="6343650" y="2821781"/>
+            <a:ext cx="1955602" cy="837605"/>
+          </a:xfrm>
+          <a:prstGeom prst="rect">
+            <a:avLst/>
+          </a:prstGeom>
+          <a:noFill/>
+          <a:ln/>
+        </p:spPr>
+        <p:txBody>
+          <a:bodyPr wrap="square" lIns="0" tIns="0" rIns="0" bIns="0" rtlCol="0" anchor="t">
+            <a:spAutoFit/>
+          </a:bodyPr>
+          <a:lstStyle/>
+          <a:p>
+            <a:pPr algn="l" indent="0" marL="0">
+              <a:lnSpc>
+                <a:spcPct val="120000"/>
+              </a:lnSpc>
+              <a:buNone/>
+            </a:pPr>
+            <a:r>
+              <a:rPr lang="en-US" sz="1050" dirty="0">
+                <a:solidFill>
+                  <a:srgbClr val="000000"/>
+                </a:solidFill>
+                <a:latin typeface="Inter" pitchFamily="34" charset="0"/>
+                <a:ea typeface="Inter" pitchFamily="34" charset="-122"/>
+                <a:cs typeface="Inter" pitchFamily="34" charset="-120"/>
+              </a:rPr>
+              <a:t>Under the adaptive schedule, the junction temperature peaks at 46.4°C (T</a:t>
+            </a:r>
+            <a:endParaRPr lang="en-US" sz="1050" dirty="0"/>
+          </a:p>
+        </p:txBody>
+      </p:sp>
+      <p:sp>
+        <p:nvSpPr>
+          <p:cNvPr id="31" name="Text 27"/>
+          <p:cNvSpPr/>
+          <p:nvPr/>
+        </p:nvSpPr>
+        <p:spPr>
+          <a:xfrm>
+            <a:off x="6488311" y="3539728"/>
+            <a:ext cx="450056" cy="144661"/>
+          </a:xfrm>
+          <a:prstGeom prst="rect">
+            <a:avLst/>
+          </a:prstGeom>
+          <a:noFill/>
+          <a:ln/>
+        </p:spPr>
+        <p:txBody>
+          <a:bodyPr wrap="none" lIns="0" tIns="0" rIns="0" bIns="0" rtlCol="0" anchor="t">
+            <a:spAutoFit/>
+          </a:bodyPr>
+          <a:lstStyle/>
+          <a:p>
+            <a:pPr algn="l" indent="0" marL="0">
+              <a:lnSpc>
+                <a:spcPct val="119976"/>
+              </a:lnSpc>
+              <a:buNone/>
+            </a:pPr>
+            <a:r>
+              <a:rPr lang="en-US" sz="850" baseline="-40000" dirty="0">
+                <a:solidFill>
+                  <a:srgbClr val="000000"/>
+                </a:solidFill>
+                <a:latin typeface="Inter" pitchFamily="34" charset="0"/>
+                <a:ea typeface="Inter" pitchFamily="34" charset="-122"/>
+                <a:cs typeface="Inter" pitchFamily="34" charset="-120"/>
+              </a:rPr>
+              <a:t>ambient</a:t>
+            </a:r>
+            <a:endParaRPr lang="en-US" sz="850" dirty="0"/>
+          </a:p>
+        </p:txBody>
+      </p:sp>
+      <p:sp>
+        <p:nvSpPr>
+          <p:cNvPr id="32" name="Text 28"/>
+          <p:cNvSpPr/>
+          <p:nvPr/>
+        </p:nvSpPr>
+        <p:spPr>
+          <a:xfrm>
+            <a:off x="6938367" y="3486150"/>
+            <a:ext cx="617934" cy="173236"/>
+          </a:xfrm>
+          <a:prstGeom prst="rect">
+            <a:avLst/>
+          </a:prstGeom>
+          <a:noFill/>
+          <a:ln/>
+        </p:spPr>
+        <p:txBody>
+          <a:bodyPr wrap="none" lIns="0" tIns="0" rIns="0" bIns="0" rtlCol="0" anchor="t">
+            <a:spAutoFit/>
+          </a:bodyPr>
+          <a:lstStyle/>
+          <a:p>
+            <a:pPr algn="l" indent="0" marL="0">
+              <a:lnSpc>
+                <a:spcPct val="120000"/>
+              </a:lnSpc>
+              <a:buNone/>
+            </a:pPr>
+            <a:r>
+              <a:rPr lang="en-US" sz="1050" dirty="0">
+                <a:solidFill>
+                  <a:srgbClr val="000000"/>
+                </a:solidFill>
+                <a:latin typeface="Inter" pitchFamily="34" charset="0"/>
+                <a:ea typeface="Inter" pitchFamily="34" charset="-122"/>
+                <a:cs typeface="Inter" pitchFamily="34" charset="-120"/>
+              </a:rPr>
+              <a:t>= 40°C).</a:t>
+            </a:r>
+            <a:endParaRPr lang="en-US" sz="1050" dirty="0"/>
+          </a:p>
+        </p:txBody>
+      </p:sp>
+      <p:sp>
+        <p:nvSpPr>
+          <p:cNvPr id="33" name="Text 29"/>
+          <p:cNvSpPr/>
+          <p:nvPr/>
+        </p:nvSpPr>
+        <p:spPr>
+          <a:xfrm>
+            <a:off x="6143625" y="3845123"/>
+            <a:ext cx="2428875" cy="857250"/>
+          </a:xfrm>
+          <a:prstGeom prst="rect">
+            <a:avLst/>
+          </a:prstGeom>
+          <a:noFill/>
+          <a:ln/>
+        </p:spPr>
+        <p:txBody>
+          <a:bodyPr wrap="square" lIns="238125" tIns="0" rIns="0" bIns="0" rtlCol="0" anchor="t">
+            <a:spAutoFit/>
+          </a:bodyPr>
+          <a:lstStyle/>
+          <a:p>
+            <a:pPr algn="l" indent="0" marL="0">
+              <a:lnSpc>
+                <a:spcPct val="120000"/>
+              </a:lnSpc>
+              <a:buNone/>
+            </a:pPr>
+            <a:r>
+              <a:rPr lang="en-US" sz="1000" b="1" dirty="0">
+                <a:solidFill>
+                  <a:srgbClr val="000000"/>
+                </a:solidFill>
+                <a:latin typeface="Inter Bold" pitchFamily="34" charset="0"/>
+                <a:ea typeface="Inter Bold" pitchFamily="34" charset="-122"/>
+                <a:cs typeface="Inter Bold" pitchFamily="34" charset="-120"/>
+              </a:rPr>
               <a:t>Safety Margin:</a:t>
             </a:r>
             <a:r>
@@ -5629,7 +6135,7 @@
                 <a:ea typeface="Inter" pitchFamily="34" charset="-122"/>
                 <a:cs typeface="Inter" pitchFamily="34" charset="-120"/>
               </a:rPr>
-              <a:t> This provides a massive 124.9°C safety margin to the 175°C semiconductor limit.</a:t>
+              <a:t> 128.6°C below the 175°C device limit, confirming robust thermal headroom.</a:t>
             </a:r>
             <a:endParaRPr lang="en-US" sz="1000" dirty="0"/>
           </a:p>
@@ -5637,13 +6143,13 @@
       </p:sp>
       <p:sp>
         <p:nvSpPr>
-          <p:cNvPr id="29" name="Text 25"/>
-          <p:cNvSpPr/>
-          <p:nvPr/>
-        </p:nvSpPr>
-        <p:spPr>
-          <a:xfrm>
-            <a:off x="6143625" y="3773686"/>
+          <p:cNvPr id="34" name="Text 30"/>
+          <p:cNvSpPr/>
+          <p:nvPr/>
+        </p:nvSpPr>
+        <p:spPr>
+          <a:xfrm>
+            <a:off x="6143625" y="3816548"/>
             <a:ext cx="112514" cy="300038"/>
           </a:xfrm>
           <a:prstGeom prst="rect">
@@ -5860,7 +6366,7 @@
         <p:spPr>
           <a:xfrm>
             <a:off x="571500" y="1662708"/>
-            <a:ext cx="3786188" cy="857250"/>
+            <a:ext cx="3786188" cy="642938"/>
           </a:xfrm>
           <a:prstGeom prst="rect">
             <a:avLst/>
@@ -5900,7 +6406,7 @@
                 <a:ea typeface="Inter" pitchFamily="34" charset="-122"/>
                 <a:cs typeface="Inter" pitchFamily="34" charset="-120"/>
               </a:rPr>
-              <a:t> The 800V 3-Level Flying Capacitor topology successfully mitigates dv/dt stress and improves harmonic performance compared to 2L-VSI.</a:t>
+              <a:t> The 800V 3-Level Flying Capacitor topology reduces dv/dt stress by half and improves harmonic performance relative to 2L-VSI.</a:t>
             </a:r>
             <a:endParaRPr lang="en-US" sz="1000" dirty="0"/>
           </a:p>
@@ -5914,7 +6420,7 @@
         </p:nvSpPr>
         <p:spPr>
           <a:xfrm>
-            <a:off x="571500" y="2634258"/>
+            <a:off x="571500" y="2419945"/>
             <a:ext cx="3786188" cy="642938"/>
           </a:xfrm>
           <a:prstGeom prst="rect">
@@ -5955,7 +6461,7 @@
                 <a:ea typeface="Inter" pitchFamily="34" charset="-122"/>
                 <a:cs typeface="Inter" pitchFamily="34" charset="-120"/>
               </a:rPr>
-              <a:t> The simulated adaptive switching frequency schedule reduces urban switching losses by </a:t>
+              <a:t> Adaptive switching frequency reduces urban switching losses by </a:t>
             </a:r>
             <a:r>
               <a:rPr lang="en-US" sz="1000" b="1" dirty="0">
@@ -5977,7 +6483,7 @@
                 <a:ea typeface="Inter" pitchFamily="34" charset="-122"/>
                 <a:cs typeface="Inter" pitchFamily="34" charset="-120"/>
               </a:rPr>
-              <a:t> (from 84.3W to 21.1W per phase).</a:t>
+              <a:t> (84.3 → 21.1 W/phase), saving 190 W three-phase.</a:t>
             </a:r>
             <a:endParaRPr lang="en-US" sz="1000" dirty="0"/>
           </a:p>
@@ -5991,8 +6497,8 @@
         </p:nvSpPr>
         <p:spPr>
           <a:xfrm>
-            <a:off x="571500" y="3391495"/>
-            <a:ext cx="3786188" cy="857250"/>
+            <a:off x="571500" y="3177183"/>
+            <a:ext cx="3786188" cy="642938"/>
           </a:xfrm>
           <a:prstGeom prst="rect">
             <a:avLst/>
@@ -6032,7 +6538,7 @@
                 <a:ea typeface="Inter" pitchFamily="34" charset="-122"/>
                 <a:cs typeface="Inter" pitchFamily="34" charset="-120"/>
               </a:rPr>
-              <a:t> The adaptive schedule reduces thermal cycling amplitude by </a:t>
+              <a:t> Thermal cycling amplitude reduced by </a:t>
             </a:r>
             <a:r>
               <a:rPr lang="en-US" sz="1000" b="1" dirty="0">
@@ -6054,7 +6560,7 @@
                 <a:ea typeface="Inter" pitchFamily="34" charset="-122"/>
                 <a:cs typeface="Inter" pitchFamily="34" charset="-120"/>
               </a:rPr>
-              <a:t>, significantly extending the lifetime of the SiC power modules.</a:t>
+              <a:t> (16.4°C → 7.7°C), extending power module fatigue lifetime per Coffin-Manson.</a:t>
             </a:r>
             <a:endParaRPr lang="en-US" sz="1000" dirty="0"/>
           </a:p>
@@ -6112,7 +6618,7 @@
         </p:nvSpPr>
         <p:spPr>
           <a:xfrm>
-            <a:off x="571500" y="2605683"/>
+            <a:off x="571500" y="2391370"/>
             <a:ext cx="112514" cy="300038"/>
           </a:xfrm>
           <a:prstGeom prst="rect">
@@ -6156,7 +6662,7 @@
         </p:nvSpPr>
         <p:spPr>
           <a:xfrm>
-            <a:off x="571500" y="3362920"/>
+            <a:off x="571500" y="3148608"/>
             <a:ext cx="112514" cy="300038"/>
           </a:xfrm>
           <a:prstGeom prst="rect">
@@ -6352,7 +6858,7 @@
         <p:spPr>
           <a:xfrm>
             <a:off x="4786313" y="3177183"/>
-            <a:ext cx="3786188" cy="857250"/>
+            <a:ext cx="3786188" cy="642938"/>
           </a:xfrm>
           <a:prstGeom prst="rect">
             <a:avLst/>
@@ -6381,7 +6887,7 @@
                 <a:ea typeface="Inter Bold" pitchFamily="34" charset="-122"/>
                 <a:cs typeface="Inter Bold" pitchFamily="34" charset="-120"/>
               </a:rPr>
-              <a:t>Future Enhancements:</a:t>
+              <a:t>THD Caveat:</a:t>
             </a:r>
             <a:r>
               <a:rPr lang="en-US" sz="1050" dirty="0">
@@ -6392,7 +6898,7 @@
                 <a:ea typeface="Inter" pitchFamily="34" charset="-122"/>
                 <a:cs typeface="Inter" pitchFamily="34" charset="-120"/>
               </a:rPr>
-              <a:t> Incorporating these non-idealities in future iterations would yield more conservative and hardware-accurate THD and loss estimates.</a:t>
+              <a:t> Simulated THD (1.9%, 1.1%) represents an optimistic bound; literature reports 3–8% at 5 kHz in hardware implementations.</a:t>
             </a:r>
             <a:endParaRPr lang="en-US" sz="1000" dirty="0"/>
           </a:p>
@@ -10647,17 +11153,105 @@
         </p:nvSpPr>
         <p:spPr>
           <a:xfrm>
+            <a:off x="571500" y="1626989"/>
+            <a:ext cx="105370" cy="269286"/>
+          </a:xfrm>
+          <a:prstGeom prst="rect">
+            <a:avLst/>
+          </a:prstGeom>
+          <a:noFill/>
+          <a:ln/>
+        </p:spPr>
+        <p:txBody>
+          <a:bodyPr wrap="none" lIns="0" tIns="0" rIns="0" bIns="0" rtlCol="0" anchor="t">
+            <a:spAutoFit/>
+          </a:bodyPr>
+          <a:lstStyle/>
+          <a:p>
+            <a:pPr algn="l" indent="0" marL="0">
+              <a:lnSpc>
+                <a:spcPct val="116000"/>
+              </a:lnSpc>
+              <a:buNone/>
+            </a:pPr>
+            <a:r>
+              <a:rPr lang="en-US" sz="1400" dirty="0">
+                <a:solidFill>
+                  <a:srgbClr val="2563EB"/>
+                </a:solidFill>
+                <a:latin typeface="Inter" pitchFamily="34" charset="0"/>
+                <a:ea typeface="Inter" pitchFamily="34" charset="-122"/>
+                <a:cs typeface="Inter" pitchFamily="34" charset="-120"/>
+              </a:rPr>
+              <a:t>•</a:t>
+            </a:r>
+            <a:endParaRPr lang="en-US" sz="1400" dirty="0"/>
+          </a:p>
+        </p:txBody>
+      </p:sp>
+      <p:sp>
+        <p:nvSpPr>
+          <p:cNvPr id="9" name="Text 5"/>
+          <p:cNvSpPr/>
+          <p:nvPr/>
+        </p:nvSpPr>
+        <p:spPr>
+          <a:xfrm>
             <a:off x="571500" y="2211325"/>
-            <a:ext cx="3857625" cy="683623"/>
-          </a:xfrm>
-          <a:prstGeom prst="rect">
-            <a:avLst/>
-          </a:prstGeom>
-          <a:noFill/>
-          <a:ln/>
-        </p:spPr>
-        <p:txBody>
-          <a:bodyPr wrap="square" lIns="255143" tIns="0" rIns="0" bIns="0" rtlCol="0" anchor="t">
+            <a:ext cx="105370" cy="269286"/>
+          </a:xfrm>
+          <a:prstGeom prst="rect">
+            <a:avLst/>
+          </a:prstGeom>
+          <a:noFill/>
+          <a:ln/>
+        </p:spPr>
+        <p:txBody>
+          <a:bodyPr wrap="none" lIns="0" tIns="0" rIns="0" bIns="0" rtlCol="0" anchor="t">
+            <a:spAutoFit/>
+          </a:bodyPr>
+          <a:lstStyle/>
+          <a:p>
+            <a:pPr algn="l" indent="0" marL="0">
+              <a:lnSpc>
+                <a:spcPct val="116000"/>
+              </a:lnSpc>
+              <a:buNone/>
+            </a:pPr>
+            <a:r>
+              <a:rPr lang="en-US" sz="1400" dirty="0">
+                <a:solidFill>
+                  <a:srgbClr val="2563EB"/>
+                </a:solidFill>
+                <a:latin typeface="Inter" pitchFamily="34" charset="0"/>
+                <a:ea typeface="Inter" pitchFamily="34" charset="-122"/>
+                <a:cs typeface="Inter" pitchFamily="34" charset="-120"/>
+              </a:rPr>
+              <a:t>•</a:t>
+            </a:r>
+            <a:endParaRPr lang="en-US" sz="1400" dirty="0"/>
+          </a:p>
+        </p:txBody>
+      </p:sp>
+      <p:sp>
+        <p:nvSpPr>
+          <p:cNvPr id="10" name="Text 6"/>
+          <p:cNvSpPr/>
+          <p:nvPr/>
+        </p:nvSpPr>
+        <p:spPr>
+          <a:xfrm>
+            <a:off x="785813" y="2229185"/>
+            <a:ext cx="1866305" cy="189309"/>
+          </a:xfrm>
+          <a:prstGeom prst="rect">
+            <a:avLst/>
+          </a:prstGeom>
+          <a:noFill/>
+          <a:ln/>
+        </p:spPr>
+        <p:txBody>
+          <a:bodyPr wrap="none" lIns="0" tIns="0" rIns="0" bIns="0" rtlCol="0" anchor="t">
             <a:spAutoFit/>
           </a:bodyPr>
           <a:lstStyle/>
@@ -10679,6 +11273,39 @@
               </a:rPr>
               <a:t>Voltage Margin (1200V):</a:t>
             </a:r>
+            <a:endParaRPr lang="en-US" sz="1100" dirty="0"/>
+          </a:p>
+        </p:txBody>
+      </p:sp>
+      <p:sp>
+        <p:nvSpPr>
+          <p:cNvPr id="11" name="Text 7"/>
+          <p:cNvSpPr/>
+          <p:nvPr/>
+        </p:nvSpPr>
+        <p:spPr>
+          <a:xfrm>
+            <a:off x="785813" y="2229185"/>
+            <a:ext cx="3330773" cy="417184"/>
+          </a:xfrm>
+          <a:prstGeom prst="rect">
+            <a:avLst/>
+          </a:prstGeom>
+          <a:noFill/>
+          <a:ln/>
+        </p:spPr>
+        <p:txBody>
+          <a:bodyPr wrap="square" lIns="0" tIns="0" rIns="0" bIns="0" rtlCol="0" anchor="t">
+            <a:spAutoFit/>
+          </a:bodyPr>
+          <a:lstStyle/>
+          <a:p>
+            <a:pPr algn="l" indent="0" marL="0">
+              <a:lnSpc>
+                <a:spcPct val="116000"/>
+              </a:lnSpc>
+              <a:buNone/>
+            </a:pPr>
             <a:r>
               <a:rPr lang="en-US" sz="1150" dirty="0">
                 <a:solidFill>
@@ -10688,21 +11315,109 @@
                 <a:ea typeface="Inter" pitchFamily="34" charset="-122"/>
                 <a:cs typeface="Inter" pitchFamily="34" charset="-120"/>
               </a:rPr>
-              <a:t> Large safety margin over 400V stress; meets IPC-9592B derating at 33% use.</a:t>
-            </a:r>
-            <a:endParaRPr lang="en-US" sz="1100" dirty="0"/>
-          </a:p>
-        </p:txBody>
-      </p:sp>
-      <p:sp>
-        <p:nvSpPr>
-          <p:cNvPr id="9" name="Text 5"/>
-          <p:cNvSpPr/>
-          <p:nvPr/>
-        </p:nvSpPr>
-        <p:spPr>
-          <a:xfrm>
-            <a:off x="571500" y="3023536"/>
+              <a:t>Each switch blocks V</a:t>
+            </a:r>
+            <a:endParaRPr lang="en-US" sz="1150" dirty="0"/>
+          </a:p>
+        </p:txBody>
+      </p:sp>
+      <p:sp>
+        <p:nvSpPr>
+          <p:cNvPr id="12" name="Text 8"/>
+          <p:cNvSpPr/>
+          <p:nvPr/>
+        </p:nvSpPr>
+        <p:spPr>
+          <a:xfrm>
+            <a:off x="894755" y="2515270"/>
+            <a:ext cx="155377" cy="158948"/>
+          </a:xfrm>
+          <a:prstGeom prst="rect">
+            <a:avLst/>
+          </a:prstGeom>
+          <a:noFill/>
+          <a:ln/>
+        </p:spPr>
+        <p:txBody>
+          <a:bodyPr wrap="none" lIns="0" tIns="0" rIns="0" bIns="0" rtlCol="0" anchor="t">
+            <a:spAutoFit/>
+          </a:bodyPr>
+          <a:lstStyle/>
+          <a:p>
+            <a:pPr algn="l" indent="0" marL="0">
+              <a:lnSpc>
+                <a:spcPct val="116021"/>
+              </a:lnSpc>
+              <a:buNone/>
+            </a:pPr>
+            <a:r>
+              <a:rPr lang="en-US" sz="950" baseline="-40000" dirty="0">
+                <a:solidFill>
+                  <a:srgbClr val="000000"/>
+                </a:solidFill>
+                <a:latin typeface="Inter" pitchFamily="34" charset="0"/>
+                <a:ea typeface="Inter" pitchFamily="34" charset="-122"/>
+                <a:cs typeface="Inter" pitchFamily="34" charset="-120"/>
+              </a:rPr>
+              <a:t>dc</a:t>
+            </a:r>
+            <a:endParaRPr lang="en-US" sz="950" dirty="0"/>
+          </a:p>
+        </p:txBody>
+      </p:sp>
+      <p:sp>
+        <p:nvSpPr>
+          <p:cNvPr id="13" name="Text 9"/>
+          <p:cNvSpPr/>
+          <p:nvPr/>
+        </p:nvSpPr>
+        <p:spPr>
+          <a:xfrm>
+            <a:off x="785813" y="2457059"/>
+            <a:ext cx="3457575" cy="440959"/>
+          </a:xfrm>
+          <a:prstGeom prst="rect">
+            <a:avLst/>
+          </a:prstGeom>
+          <a:noFill/>
+          <a:ln/>
+        </p:spPr>
+        <p:txBody>
+          <a:bodyPr wrap="square" lIns="0" tIns="0" rIns="0" bIns="0" rtlCol="0" anchor="t">
+            <a:spAutoFit/>
+          </a:bodyPr>
+          <a:lstStyle/>
+          <a:p>
+            <a:pPr algn="l" indent="0" marL="0">
+              <a:lnSpc>
+                <a:spcPct val="116000"/>
+              </a:lnSpc>
+              <a:buNone/>
+            </a:pPr>
+            <a:r>
+              <a:rPr lang="en-US" sz="1150" dirty="0">
+                <a:solidFill>
+                  <a:srgbClr val="000000"/>
+                </a:solidFill>
+                <a:latin typeface="Inter" pitchFamily="34" charset="0"/>
+                <a:ea typeface="Inter" pitchFamily="34" charset="-122"/>
+                <a:cs typeface="Inter" pitchFamily="34" charset="-120"/>
+              </a:rPr>
+              <a:t>/2 = 400V; 33% voltage utilization per IPC-9592B derating.</a:t>
+            </a:r>
+            <a:endParaRPr lang="en-US" sz="1150" dirty="0"/>
+          </a:p>
+        </p:txBody>
+      </p:sp>
+      <p:sp>
+        <p:nvSpPr>
+          <p:cNvPr id="14" name="Text 10"/>
+          <p:cNvSpPr/>
+          <p:nvPr/>
+        </p:nvSpPr>
+        <p:spPr>
+          <a:xfrm>
+            <a:off x="571500" y="3047312"/>
             <a:ext cx="3857625" cy="455749"/>
           </a:xfrm>
           <a:prstGeom prst="rect">
@@ -10751,23 +11466,111 @@
       </p:sp>
       <p:sp>
         <p:nvSpPr>
-          <p:cNvPr id="10" name="Text 6"/>
-          <p:cNvSpPr/>
-          <p:nvPr/>
-        </p:nvSpPr>
-        <p:spPr>
-          <a:xfrm>
-            <a:off x="571500" y="3607873"/>
-            <a:ext cx="3857625" cy="683623"/>
-          </a:xfrm>
-          <a:prstGeom prst="rect">
-            <a:avLst/>
-          </a:prstGeom>
-          <a:noFill/>
-          <a:ln/>
-        </p:spPr>
-        <p:txBody>
-          <a:bodyPr wrap="square" lIns="255143" tIns="0" rIns="0" bIns="0" rtlCol="0" anchor="t">
+          <p:cNvPr id="15" name="Text 11"/>
+          <p:cNvSpPr/>
+          <p:nvPr/>
+        </p:nvSpPr>
+        <p:spPr>
+          <a:xfrm>
+            <a:off x="571500" y="3047312"/>
+            <a:ext cx="105370" cy="269286"/>
+          </a:xfrm>
+          <a:prstGeom prst="rect">
+            <a:avLst/>
+          </a:prstGeom>
+          <a:noFill/>
+          <a:ln/>
+        </p:spPr>
+        <p:txBody>
+          <a:bodyPr wrap="none" lIns="0" tIns="0" rIns="0" bIns="0" rtlCol="0" anchor="t">
+            <a:spAutoFit/>
+          </a:bodyPr>
+          <a:lstStyle/>
+          <a:p>
+            <a:pPr algn="l" indent="0" marL="0">
+              <a:lnSpc>
+                <a:spcPct val="116000"/>
+              </a:lnSpc>
+              <a:buNone/>
+            </a:pPr>
+            <a:r>
+              <a:rPr lang="en-US" sz="1400" dirty="0">
+                <a:solidFill>
+                  <a:srgbClr val="2563EB"/>
+                </a:solidFill>
+                <a:latin typeface="Inter" pitchFamily="34" charset="0"/>
+                <a:ea typeface="Inter" pitchFamily="34" charset="-122"/>
+                <a:cs typeface="Inter" pitchFamily="34" charset="-120"/>
+              </a:rPr>
+              <a:t>•</a:t>
+            </a:r>
+            <a:endParaRPr lang="en-US" sz="1400" dirty="0"/>
+          </a:p>
+        </p:txBody>
+      </p:sp>
+      <p:sp>
+        <p:nvSpPr>
+          <p:cNvPr id="16" name="Text 12"/>
+          <p:cNvSpPr/>
+          <p:nvPr/>
+        </p:nvSpPr>
+        <p:spPr>
+          <a:xfrm>
+            <a:off x="571500" y="3631648"/>
+            <a:ext cx="105370" cy="269286"/>
+          </a:xfrm>
+          <a:prstGeom prst="rect">
+            <a:avLst/>
+          </a:prstGeom>
+          <a:noFill/>
+          <a:ln/>
+        </p:spPr>
+        <p:txBody>
+          <a:bodyPr wrap="none" lIns="0" tIns="0" rIns="0" bIns="0" rtlCol="0" anchor="t">
+            <a:spAutoFit/>
+          </a:bodyPr>
+          <a:lstStyle/>
+          <a:p>
+            <a:pPr algn="l" indent="0" marL="0">
+              <a:lnSpc>
+                <a:spcPct val="116000"/>
+              </a:lnSpc>
+              <a:buNone/>
+            </a:pPr>
+            <a:r>
+              <a:rPr lang="en-US" sz="1400" dirty="0">
+                <a:solidFill>
+                  <a:srgbClr val="2563EB"/>
+                </a:solidFill>
+                <a:latin typeface="Inter" pitchFamily="34" charset="0"/>
+                <a:ea typeface="Inter" pitchFamily="34" charset="-122"/>
+                <a:cs typeface="Inter" pitchFamily="34" charset="-120"/>
+              </a:rPr>
+              <a:t>•</a:t>
+            </a:r>
+            <a:endParaRPr lang="en-US" sz="1400" dirty="0"/>
+          </a:p>
+        </p:txBody>
+      </p:sp>
+      <p:sp>
+        <p:nvSpPr>
+          <p:cNvPr id="17" name="Text 13"/>
+          <p:cNvSpPr/>
+          <p:nvPr/>
+        </p:nvSpPr>
+        <p:spPr>
+          <a:xfrm>
+            <a:off x="785813" y="3649507"/>
+            <a:ext cx="1362670" cy="189309"/>
+          </a:xfrm>
+          <a:prstGeom prst="rect">
+            <a:avLst/>
+          </a:prstGeom>
+          <a:noFill/>
+          <a:ln/>
+        </p:spPr>
+        <p:txBody>
+          <a:bodyPr wrap="none" lIns="0" tIns="0" rIns="0" bIns="0" rtlCol="0" anchor="t">
             <a:spAutoFit/>
           </a:bodyPr>
           <a:lstStyle/>
@@ -10789,6 +11592,39 @@
               </a:rPr>
               <a:t>Thermal Stability:</a:t>
             </a:r>
+            <a:endParaRPr lang="en-US" sz="1100" dirty="0"/>
+          </a:p>
+        </p:txBody>
+      </p:sp>
+      <p:sp>
+        <p:nvSpPr>
+          <p:cNvPr id="18" name="Text 14"/>
+          <p:cNvSpPr/>
+          <p:nvPr/>
+        </p:nvSpPr>
+        <p:spPr>
+          <a:xfrm>
+            <a:off x="785813" y="3649507"/>
+            <a:ext cx="3116461" cy="417184"/>
+          </a:xfrm>
+          <a:prstGeom prst="rect">
+            <a:avLst/>
+          </a:prstGeom>
+          <a:noFill/>
+          <a:ln/>
+        </p:spPr>
+        <p:txBody>
+          <a:bodyPr wrap="square" lIns="0" tIns="0" rIns="0" bIns="0" rtlCol="0" anchor="t">
+            <a:spAutoFit/>
+          </a:bodyPr>
+          <a:lstStyle/>
+          <a:p>
+            <a:pPr algn="l" indent="0" marL="0">
+              <a:lnSpc>
+                <a:spcPct val="116000"/>
+              </a:lnSpc>
+              <a:buNone/>
+            </a:pPr>
             <a:r>
               <a:rPr lang="en-US" sz="1150" dirty="0">
                 <a:solidFill>
@@ -10798,22 +11634,22 @@
                 <a:ea typeface="Inter" pitchFamily="34" charset="-122"/>
                 <a:cs typeface="Inter" pitchFamily="34" charset="-120"/>
               </a:rPr>
-              <a:t> Positive temp. coeff. of Rds_on (3.3→6.6mΩ) helps prevent thermal runaway.</a:t>
-            </a:r>
-            <a:endParaRPr lang="en-US" sz="1100" dirty="0"/>
-          </a:p>
-        </p:txBody>
-      </p:sp>
-      <p:sp>
-        <p:nvSpPr>
-          <p:cNvPr id="11" name="Text 7"/>
-          <p:cNvSpPr/>
-          <p:nvPr/>
-        </p:nvSpPr>
-        <p:spPr>
-          <a:xfrm>
-            <a:off x="571500" y="1626989"/>
-            <a:ext cx="105370" cy="269286"/>
+              <a:t>Positive temp. coeff. of R</a:t>
+            </a:r>
+            <a:endParaRPr lang="en-US" sz="1150" dirty="0"/>
+          </a:p>
+        </p:txBody>
+      </p:sp>
+      <p:sp>
+        <p:nvSpPr>
+          <p:cNvPr id="19" name="Text 15"/>
+          <p:cNvSpPr/>
+          <p:nvPr/>
+        </p:nvSpPr>
+        <p:spPr>
+          <a:xfrm>
+            <a:off x="887611" y="3935592"/>
+            <a:ext cx="400050" cy="158948"/>
           </a:xfrm>
           <a:prstGeom prst="rect">
             <a:avLst/>
@@ -10829,160 +11665,72 @@
           <a:p>
             <a:pPr algn="l" indent="0" marL="0">
               <a:lnSpc>
+                <a:spcPct val="116021"/>
+              </a:lnSpc>
+              <a:buNone/>
+            </a:pPr>
+            <a:r>
+              <a:rPr lang="en-US" sz="950" baseline="-40000" dirty="0">
+                <a:solidFill>
+                  <a:srgbClr val="000000"/>
+                </a:solidFill>
+                <a:latin typeface="Inter" pitchFamily="34" charset="0"/>
+                <a:ea typeface="Inter" pitchFamily="34" charset="-122"/>
+                <a:cs typeface="Inter" pitchFamily="34" charset="-120"/>
+              </a:rPr>
+              <a:t>ds(on)</a:t>
+            </a:r>
+            <a:endParaRPr lang="en-US" sz="950" dirty="0"/>
+          </a:p>
+        </p:txBody>
+      </p:sp>
+      <p:sp>
+        <p:nvSpPr>
+          <p:cNvPr id="20" name="Text 16"/>
+          <p:cNvSpPr/>
+          <p:nvPr/>
+        </p:nvSpPr>
+        <p:spPr>
+          <a:xfrm>
+            <a:off x="785813" y="3877382"/>
+            <a:ext cx="3564731" cy="440959"/>
+          </a:xfrm>
+          <a:prstGeom prst="rect">
+            <a:avLst/>
+          </a:prstGeom>
+          <a:noFill/>
+          <a:ln/>
+        </p:spPr>
+        <p:txBody>
+          <a:bodyPr wrap="square" lIns="0" tIns="0" rIns="0" bIns="0" rtlCol="0" anchor="t">
+            <a:spAutoFit/>
+          </a:bodyPr>
+          <a:lstStyle/>
+          <a:p>
+            <a:pPr algn="l" indent="0" marL="0">
+              <a:lnSpc>
                 <a:spcPct val="116000"/>
               </a:lnSpc>
               <a:buNone/>
             </a:pPr>
             <a:r>
-              <a:rPr lang="en-US" sz="1400" dirty="0">
-                <a:solidFill>
-                  <a:srgbClr val="2563EB"/>
-                </a:solidFill>
-                <a:latin typeface="Inter" pitchFamily="34" charset="0"/>
-                <a:ea typeface="Inter" pitchFamily="34" charset="-122"/>
-                <a:cs typeface="Inter" pitchFamily="34" charset="-120"/>
-              </a:rPr>
-              <a:t>•</a:t>
-            </a:r>
-            <a:endParaRPr lang="en-US" sz="1400" dirty="0"/>
-          </a:p>
-        </p:txBody>
-      </p:sp>
-      <p:sp>
-        <p:nvSpPr>
-          <p:cNvPr id="12" name="Text 8"/>
-          <p:cNvSpPr/>
-          <p:nvPr/>
-        </p:nvSpPr>
-        <p:spPr>
-          <a:xfrm>
-            <a:off x="571500" y="2211325"/>
-            <a:ext cx="105370" cy="269286"/>
-          </a:xfrm>
-          <a:prstGeom prst="rect">
-            <a:avLst/>
-          </a:prstGeom>
-          <a:noFill/>
-          <a:ln/>
-        </p:spPr>
-        <p:txBody>
-          <a:bodyPr wrap="none" lIns="0" tIns="0" rIns="0" bIns="0" rtlCol="0" anchor="t">
-            <a:spAutoFit/>
-          </a:bodyPr>
-          <a:lstStyle/>
-          <a:p>
-            <a:pPr algn="l" indent="0" marL="0">
-              <a:lnSpc>
-                <a:spcPct val="116000"/>
-              </a:lnSpc>
-              <a:buNone/>
-            </a:pPr>
-            <a:r>
-              <a:rPr lang="en-US" sz="1400" dirty="0">
-                <a:solidFill>
-                  <a:srgbClr val="2563EB"/>
-                </a:solidFill>
-                <a:latin typeface="Inter" pitchFamily="34" charset="0"/>
-                <a:ea typeface="Inter" pitchFamily="34" charset="-122"/>
-                <a:cs typeface="Inter" pitchFamily="34" charset="-120"/>
-              </a:rPr>
-              <a:t>•</a:t>
-            </a:r>
-            <a:endParaRPr lang="en-US" sz="1400" dirty="0"/>
-          </a:p>
-        </p:txBody>
-      </p:sp>
-      <p:sp>
-        <p:nvSpPr>
-          <p:cNvPr id="13" name="Text 9"/>
-          <p:cNvSpPr/>
-          <p:nvPr/>
-        </p:nvSpPr>
-        <p:spPr>
-          <a:xfrm>
-            <a:off x="571500" y="3023536"/>
-            <a:ext cx="105370" cy="269286"/>
-          </a:xfrm>
-          <a:prstGeom prst="rect">
-            <a:avLst/>
-          </a:prstGeom>
-          <a:noFill/>
-          <a:ln/>
-        </p:spPr>
-        <p:txBody>
-          <a:bodyPr wrap="none" lIns="0" tIns="0" rIns="0" bIns="0" rtlCol="0" anchor="t">
-            <a:spAutoFit/>
-          </a:bodyPr>
-          <a:lstStyle/>
-          <a:p>
-            <a:pPr algn="l" indent="0" marL="0">
-              <a:lnSpc>
-                <a:spcPct val="116000"/>
-              </a:lnSpc>
-              <a:buNone/>
-            </a:pPr>
-            <a:r>
-              <a:rPr lang="en-US" sz="1400" dirty="0">
-                <a:solidFill>
-                  <a:srgbClr val="2563EB"/>
-                </a:solidFill>
-                <a:latin typeface="Inter" pitchFamily="34" charset="0"/>
-                <a:ea typeface="Inter" pitchFamily="34" charset="-122"/>
-                <a:cs typeface="Inter" pitchFamily="34" charset="-120"/>
-              </a:rPr>
-              <a:t>•</a:t>
-            </a:r>
-            <a:endParaRPr lang="en-US" sz="1400" dirty="0"/>
-          </a:p>
-        </p:txBody>
-      </p:sp>
-      <p:sp>
-        <p:nvSpPr>
-          <p:cNvPr id="14" name="Text 10"/>
-          <p:cNvSpPr/>
-          <p:nvPr/>
-        </p:nvSpPr>
-        <p:spPr>
-          <a:xfrm>
-            <a:off x="571500" y="3607873"/>
-            <a:ext cx="105370" cy="269286"/>
-          </a:xfrm>
-          <a:prstGeom prst="rect">
-            <a:avLst/>
-          </a:prstGeom>
-          <a:noFill/>
-          <a:ln/>
-        </p:spPr>
-        <p:txBody>
-          <a:bodyPr wrap="none" lIns="0" tIns="0" rIns="0" bIns="0" rtlCol="0" anchor="t">
-            <a:spAutoFit/>
-          </a:bodyPr>
-          <a:lstStyle/>
-          <a:p>
-            <a:pPr algn="l" indent="0" marL="0">
-              <a:lnSpc>
-                <a:spcPct val="116000"/>
-              </a:lnSpc>
-              <a:buNone/>
-            </a:pPr>
-            <a:r>
-              <a:rPr lang="en-US" sz="1400" dirty="0">
-                <a:solidFill>
-                  <a:srgbClr val="2563EB"/>
-                </a:solidFill>
-                <a:latin typeface="Inter" pitchFamily="34" charset="0"/>
-                <a:ea typeface="Inter" pitchFamily="34" charset="-122"/>
-                <a:cs typeface="Inter" pitchFamily="34" charset="-120"/>
-              </a:rPr>
-              <a:t>•</a:t>
-            </a:r>
-            <a:endParaRPr lang="en-US" sz="1400" dirty="0"/>
-          </a:p>
-        </p:txBody>
-      </p:sp>
-      <p:sp>
-        <p:nvSpPr>
-          <p:cNvPr id="15" name="Text 11"/>
+              <a:rPr lang="en-US" sz="1150" dirty="0">
+                <a:solidFill>
+                  <a:srgbClr val="000000"/>
+                </a:solidFill>
+                <a:latin typeface="Inter" pitchFamily="34" charset="0"/>
+                <a:ea typeface="Inter" pitchFamily="34" charset="-122"/>
+                <a:cs typeface="Inter" pitchFamily="34" charset="-120"/>
+              </a:rPr>
+              <a:t>(die 2.6 + pkg 0.7 = 3.3 mΩ at 25°C, ~2× at 175°C) aids current sharing.</a:t>
+            </a:r>
+            <a:endParaRPr lang="en-US" sz="1150" dirty="0"/>
+          </a:p>
+        </p:txBody>
+      </p:sp>
+      <p:sp>
+        <p:nvSpPr>
+          <p:cNvPr id="21" name="Text 17"/>
           <p:cNvSpPr/>
           <p:nvPr/>
         </p:nvSpPr>
@@ -11023,7 +11771,7 @@
       </p:sp>
       <p:sp>
         <p:nvSpPr>
-          <p:cNvPr id="16" name="Text 12"/>
+          <p:cNvPr id="22" name="Text 18"/>
           <p:cNvSpPr/>
           <p:nvPr/>
         </p:nvSpPr>
@@ -11078,7 +11826,7 @@
       </p:sp>
       <p:sp>
         <p:nvSpPr>
-          <p:cNvPr id="17" name="Text 13"/>
+          <p:cNvPr id="23" name="Text 19"/>
           <p:cNvSpPr/>
           <p:nvPr/>
         </p:nvSpPr>
@@ -11133,7 +11881,7 @@
       </p:sp>
       <p:sp>
         <p:nvSpPr>
-          <p:cNvPr id="18" name="Text 14"/>
+          <p:cNvPr id="24" name="Text 20"/>
           <p:cNvSpPr/>
           <p:nvPr/>
         </p:nvSpPr>
@@ -11188,7 +11936,7 @@
       </p:sp>
       <p:sp>
         <p:nvSpPr>
-          <p:cNvPr id="19" name="Text 15"/>
+          <p:cNvPr id="25" name="Text 21"/>
           <p:cNvSpPr/>
           <p:nvPr/>
         </p:nvSpPr>
@@ -11232,7 +11980,7 @@
       </p:sp>
       <p:sp>
         <p:nvSpPr>
-          <p:cNvPr id="20" name="Text 16"/>
+          <p:cNvPr id="26" name="Text 22"/>
           <p:cNvSpPr/>
           <p:nvPr/>
         </p:nvSpPr>
@@ -11276,7 +12024,7 @@
       </p:sp>
       <p:sp>
         <p:nvSpPr>
-          <p:cNvPr id="21" name="Text 17"/>
+          <p:cNvPr id="27" name="Text 23"/>
           <p:cNvSpPr/>
           <p:nvPr/>
         </p:nvSpPr>

</xml_diff>

<commit_message>
Update PDF and PPTX exports with new title
</commit_message>
<xml_diff>
--- a/FC_Inverter_Presentation.pptx
+++ b/FC_Inverter_Presentation.pptx
@@ -2009,8 +2009,8 @@
         </p:nvSpPr>
         <p:spPr>
           <a:xfrm>
-            <a:off x="857250" y="1380027"/>
-            <a:ext cx="7429500" cy="2383445"/>
+            <a:off x="857250" y="1791491"/>
+            <a:ext cx="7429500" cy="1560519"/>
           </a:xfrm>
           <a:prstGeom prst="rect">
             <a:avLst/>
@@ -2031,8 +2031,8 @@
         </p:nvSpPr>
         <p:spPr>
           <a:xfrm>
-            <a:off x="857250" y="1380027"/>
-            <a:ext cx="42863" cy="2383445"/>
+            <a:off x="857250" y="1791491"/>
+            <a:ext cx="42863" cy="1560519"/>
           </a:xfrm>
           <a:prstGeom prst="rect">
             <a:avLst/>
@@ -2051,8 +2051,8 @@
         </p:nvSpPr>
         <p:spPr>
           <a:xfrm>
-            <a:off x="1143000" y="1380027"/>
-            <a:ext cx="7143750" cy="1645853"/>
+            <a:off x="1143000" y="1791491"/>
+            <a:ext cx="7143750" cy="822927"/>
           </a:xfrm>
           <a:prstGeom prst="rect">
             <a:avLst/>
@@ -2081,7 +2081,7 @@
                 <a:ea typeface="Inter Bold" pitchFamily="34" charset="-122"/>
                 <a:cs typeface="Inter Bold" pitchFamily="34" charset="-120"/>
               </a:rPr>
-              <a:t>Vehicle Architecture-Driven Design and Comprehensive Loss Analysis of an 800V Three-Level Flying Capacitor Traction Inverter</a:t>
+              <a:t>Design and Loss Analysis of an 800V Flying Capacitor Traction Inverter</a:t>
             </a:r>
             <a:endParaRPr lang="en-US" sz="2450" dirty="0"/>
           </a:p>
@@ -2095,7 +2095,7 @@
         </p:nvSpPr>
         <p:spPr>
           <a:xfrm>
-            <a:off x="1143000" y="3311630"/>
+            <a:off x="1143000" y="2900167"/>
             <a:ext cx="7143750" cy="207169"/>
           </a:xfrm>
           <a:prstGeom prst="rect">
@@ -2136,7 +2136,7 @@
         </p:nvSpPr>
         <p:spPr>
           <a:xfrm>
-            <a:off x="1143000" y="3590237"/>
+            <a:off x="1143000" y="3178773"/>
             <a:ext cx="7143750" cy="173236"/>
           </a:xfrm>
           <a:prstGeom prst="rect">

</xml_diff>